<commit_message>
docs: clarify POC validation title
</commit_message>
<xml_diff>
--- a/PPT与商业计划书/Blocky-Studio-息壤杯-AI+教育.pptx
+++ b/PPT与商业计划书/Blocky-Studio-息壤杯-AI+教育.pptx
@@ -2,26 +2,26 @@
 <file path=ppt/presentation.xml><?xml version="1.0" encoding="utf-8"?>
 <p:presentation xmlns:p="http://schemas.openxmlformats.org/presentationml/2006/main">
   <p:sldMasterIdLst>
-    <p:sldMasterId xmlns:r="http://schemas.openxmlformats.org/officeDocument/2006/relationships" id="2147483648" r:id="R6d525115cff9401a"/>
+    <p:sldMasterId xmlns:r="http://schemas.openxmlformats.org/officeDocument/2006/relationships" id="2147483648" r:id="Rde35ff7ffae1430b"/>
   </p:sldMasterIdLst>
   <p:notesMasterIdLst>
-    <p:notesMasterId xmlns:r="http://schemas.openxmlformats.org/officeDocument/2006/relationships" r:id="Rc420a5b7078a4492"/>
+    <p:notesMasterId xmlns:r="http://schemas.openxmlformats.org/officeDocument/2006/relationships" r:id="Rc27fb4a24a0d45f2"/>
   </p:notesMasterIdLst>
   <p:sldIdLst>
-    <p:sldId xmlns:r="http://schemas.openxmlformats.org/officeDocument/2006/relationships" id="256" r:id="R20a5c8222613429f"/>
-    <p:sldId xmlns:r="http://schemas.openxmlformats.org/officeDocument/2006/relationships" id="257" r:id="R6f4cda7a47524c62"/>
-    <p:sldId xmlns:r="http://schemas.openxmlformats.org/officeDocument/2006/relationships" id="258" r:id="R3e5dcdce89a5415d"/>
-    <p:sldId xmlns:r="http://schemas.openxmlformats.org/officeDocument/2006/relationships" id="259" r:id="R60950b960db64cfa"/>
-    <p:sldId xmlns:r="http://schemas.openxmlformats.org/officeDocument/2006/relationships" id="260" r:id="R1d32df65d88a4bd7"/>
-    <p:sldId xmlns:r="http://schemas.openxmlformats.org/officeDocument/2006/relationships" id="261" r:id="Rf0a5a0d04a504123"/>
-    <p:sldId xmlns:r="http://schemas.openxmlformats.org/officeDocument/2006/relationships" id="262" r:id="Re26c2556229b4574"/>
-    <p:sldId xmlns:r="http://schemas.openxmlformats.org/officeDocument/2006/relationships" id="263" r:id="Rf1a22c5944174b7d"/>
-    <p:sldId xmlns:r="http://schemas.openxmlformats.org/officeDocument/2006/relationships" id="264" r:id="R0ef8e49f4f1f4d5a"/>
-    <p:sldId xmlns:r="http://schemas.openxmlformats.org/officeDocument/2006/relationships" id="265" r:id="Ra829baa9b1e6473c"/>
-    <p:sldId xmlns:r="http://schemas.openxmlformats.org/officeDocument/2006/relationships" id="266" r:id="R7d0109094eca4a5a"/>
-    <p:sldId xmlns:r="http://schemas.openxmlformats.org/officeDocument/2006/relationships" id="267" r:id="R3113ea846d084474"/>
-    <p:sldId xmlns:r="http://schemas.openxmlformats.org/officeDocument/2006/relationships" id="268" r:id="R12c59fb77d894473"/>
-    <p:sldId xmlns:r="http://schemas.openxmlformats.org/officeDocument/2006/relationships" id="269" r:id="R901842bb94af40af"/>
+    <p:sldId xmlns:r="http://schemas.openxmlformats.org/officeDocument/2006/relationships" id="256" r:id="R10c64306cabf4662"/>
+    <p:sldId xmlns:r="http://schemas.openxmlformats.org/officeDocument/2006/relationships" id="257" r:id="Rd21e93471985493c"/>
+    <p:sldId xmlns:r="http://schemas.openxmlformats.org/officeDocument/2006/relationships" id="258" r:id="R4eb0474bf03d4e58"/>
+    <p:sldId xmlns:r="http://schemas.openxmlformats.org/officeDocument/2006/relationships" id="259" r:id="R9979e7700f4d424e"/>
+    <p:sldId xmlns:r="http://schemas.openxmlformats.org/officeDocument/2006/relationships" id="260" r:id="R82e2582e03ee4e70"/>
+    <p:sldId xmlns:r="http://schemas.openxmlformats.org/officeDocument/2006/relationships" id="261" r:id="R3d5dc212f0604521"/>
+    <p:sldId xmlns:r="http://schemas.openxmlformats.org/officeDocument/2006/relationships" id="262" r:id="R843d249ba35d4fd7"/>
+    <p:sldId xmlns:r="http://schemas.openxmlformats.org/officeDocument/2006/relationships" id="263" r:id="R9423d834aa4c4445"/>
+    <p:sldId xmlns:r="http://schemas.openxmlformats.org/officeDocument/2006/relationships" id="264" r:id="R41d902ce156b4a1f"/>
+    <p:sldId xmlns:r="http://schemas.openxmlformats.org/officeDocument/2006/relationships" id="265" r:id="Rfd2e87dbe2cf4ad9"/>
+    <p:sldId xmlns:r="http://schemas.openxmlformats.org/officeDocument/2006/relationships" id="266" r:id="Rb54be52d68d04fce"/>
+    <p:sldId xmlns:r="http://schemas.openxmlformats.org/officeDocument/2006/relationships" id="267" r:id="R0de6a947a84a4d27"/>
+    <p:sldId xmlns:r="http://schemas.openxmlformats.org/officeDocument/2006/relationships" id="268" r:id="Ra17a7e31c29047d5"/>
+    <p:sldId xmlns:r="http://schemas.openxmlformats.org/officeDocument/2006/relationships" id="269" r:id="R0c2548bc795145aa"/>
   </p:sldIdLst>
   <p:sldSz cx="12192000" cy="6858000"/>
   <p:notesSz cx="6858000" cy="9144000"/>
@@ -1808,7 +1808,7 @@
   </p:cSld>
   <p:clrMap bg1="lt1" tx1="dk1" bg2="lt2" tx2="dk2" accent1="accent1" accent2="accent2" accent3="accent3" accent4="accent4" accent5="accent5" accent6="accent6" hlink="hlink" folHlink="folHlink"/>
   <p:sldLayoutIdLst>
-    <p:sldLayoutId xmlns:r="http://schemas.openxmlformats.org/officeDocument/2006/relationships" id="2147483649" r:id="Raf76eae031a84a29"/>
+    <p:sldLayoutId xmlns:r="http://schemas.openxmlformats.org/officeDocument/2006/relationships" id="2147483649" r:id="R9d5a0cffc8994a79"/>
   </p:sldLayoutIdLst>
   <p:txStyles>
     <p:titleStyle>
@@ -2449,14 +2449,14 @@
       </p:sp>
       <p:pic>
         <p:nvPicPr>
-          <p:cNvPr id="17" name=""/>
+          <p:cNvPr id="19" name=""/>
           <p:cNvPicPr>
             <a:picLocks xmlns:a="http://schemas.openxmlformats.org/drawingml/2006/main" noChangeAspect="1"/>
           </p:cNvPicPr>
           <p:nvPr/>
         </p:nvPicPr>
         <p:blipFill>
-          <a:blip xmlns:r="http://schemas.openxmlformats.org/officeDocument/2006/relationships" xmlns:a="http://schemas.openxmlformats.org/drawingml/2006/main" r:embed="Rc56fa8ab4cde4856"/>
+          <a:blip xmlns:r="http://schemas.openxmlformats.org/officeDocument/2006/relationships" xmlns:a="http://schemas.openxmlformats.org/drawingml/2006/main" r:embed="R750be9d05fd7468f"/>
           <a:stretch xmlns:a="http://schemas.openxmlformats.org/drawingml/2006/main"/>
         </p:blipFill>
         <p:spPr>
@@ -2502,6 +2502,7 @@
           <a:lstStyle xmlns:a="http://schemas.openxmlformats.org/drawingml/2006/main"/>
           <a:p xmlns:a="http://schemas.openxmlformats.org/drawingml/2006/main">
             <a:pPr algn="l">
+              <a:buNone/>
               <a:defRPr sz="1200" b="1" i="0">
                 <a:solidFill>
                   <a:srgbClr val="176BFF"/>
@@ -2558,6 +2559,7 @@
           <a:lstStyle xmlns:a="http://schemas.openxmlformats.org/drawingml/2006/main"/>
           <a:p xmlns:a="http://schemas.openxmlformats.org/drawingml/2006/main">
             <a:pPr algn="l">
+              <a:buNone/>
               <a:defRPr sz="4050" b="1" i="0">
                 <a:solidFill>
                   <a:srgbClr val="111827"/>
@@ -2614,6 +2616,7 @@
           <a:lstStyle xmlns:a="http://schemas.openxmlformats.org/drawingml/2006/main"/>
           <a:p xmlns:a="http://schemas.openxmlformats.org/drawingml/2006/main">
             <a:pPr algn="l">
+              <a:buNone/>
               <a:defRPr sz="4050" b="1" i="0">
                 <a:solidFill>
                   <a:srgbClr val="176BFF"/>
@@ -2670,6 +2673,7 @@
           <a:lstStyle xmlns:a="http://schemas.openxmlformats.org/drawingml/2006/main"/>
           <a:p xmlns:a="http://schemas.openxmlformats.org/drawingml/2006/main">
             <a:pPr algn="l">
+              <a:buNone/>
               <a:defRPr sz="2100" b="1" i="0">
                 <a:solidFill>
                   <a:srgbClr val="111827"/>
@@ -2726,6 +2730,7 @@
           <a:lstStyle xmlns:a="http://schemas.openxmlformats.org/drawingml/2006/main"/>
           <a:p xmlns:a="http://schemas.openxmlformats.org/drawingml/2006/main">
             <a:pPr algn="l">
+              <a:buNone/>
               <a:defRPr sz="1725" b="0" i="0">
                 <a:solidFill>
                   <a:srgbClr val="667085"/>
@@ -2815,6 +2820,7 @@
           <a:lstStyle xmlns:a="http://schemas.openxmlformats.org/drawingml/2006/main"/>
           <a:p xmlns:a="http://schemas.openxmlformats.org/drawingml/2006/main">
             <a:pPr algn="ctr">
+              <a:buNone/>
               <a:defRPr sz="1050" b="1" i="0">
                 <a:solidFill>
                   <a:srgbClr val="176BFF"/>
@@ -2871,6 +2877,7 @@
           <a:lstStyle xmlns:a="http://schemas.openxmlformats.org/drawingml/2006/main"/>
           <a:p xmlns:a="http://schemas.openxmlformats.org/drawingml/2006/main">
             <a:pPr algn="l">
+              <a:buNone/>
               <a:defRPr sz="1500" b="0" i="0">
                 <a:solidFill>
                   <a:srgbClr val="667085"/>
@@ -2927,6 +2934,7 @@
           <a:lstStyle xmlns:a="http://schemas.openxmlformats.org/drawingml/2006/main"/>
           <a:p xmlns:a="http://schemas.openxmlformats.org/drawingml/2006/main">
             <a:pPr algn="ctr">
+              <a:buNone/>
               <a:defRPr sz="1050" b="1" i="0">
                 <a:solidFill>
                   <a:srgbClr val="FFFFFF"/>
@@ -3012,6 +3020,7 @@
           <a:lstStyle xmlns:a="http://schemas.openxmlformats.org/drawingml/2006/main"/>
           <a:p xmlns:a="http://schemas.openxmlformats.org/drawingml/2006/main">
             <a:pPr algn="l">
+              <a:buNone/>
               <a:defRPr sz="1200" b="1" i="0">
                 <a:solidFill>
                   <a:srgbClr val="176BFF"/>
@@ -3068,6 +3077,7 @@
           <a:lstStyle xmlns:a="http://schemas.openxmlformats.org/drawingml/2006/main"/>
           <a:p xmlns:a="http://schemas.openxmlformats.org/drawingml/2006/main">
             <a:pPr algn="l">
+              <a:buNone/>
               <a:defRPr sz="3150" b="1" i="0">
                 <a:solidFill>
                   <a:srgbClr val="111827"/>
@@ -3086,7 +3096,7 @@
                 <a:ea typeface="Microsoft YaHei"/>
                 <a:cs typeface="Microsoft YaHei"/>
               </a:rPr>
-              <a:t>评委可以在 3 分钟内验证 4 个学习结果</a:t>
+              <a:t>POC 可以在 3 分钟内验证 4 个学习结果</a:t>
             </a:r>
           </a:p>
         </p:txBody>
@@ -3124,6 +3134,7 @@
           <a:lstStyle xmlns:a="http://schemas.openxmlformats.org/drawingml/2006/main"/>
           <a:p xmlns:a="http://schemas.openxmlformats.org/drawingml/2006/main">
             <a:pPr algn="l">
+              <a:buNone/>
               <a:defRPr sz="1500" b="0" i="0">
                 <a:solidFill>
                   <a:srgbClr val="667085"/>
@@ -3213,6 +3224,7 @@
           <a:lstStyle xmlns:a="http://schemas.openxmlformats.org/drawingml/2006/main"/>
           <a:p xmlns:a="http://schemas.openxmlformats.org/drawingml/2006/main">
             <a:pPr algn="l">
+              <a:buNone/>
               <a:defRPr sz="1200" b="1" i="0">
                 <a:solidFill>
                   <a:srgbClr val="FFFFFF"/>
@@ -3269,6 +3281,7 @@
           <a:lstStyle xmlns:a="http://schemas.openxmlformats.org/drawingml/2006/main"/>
           <a:p xmlns:a="http://schemas.openxmlformats.org/drawingml/2006/main">
             <a:pPr algn="l">
+              <a:buNone/>
               <a:defRPr sz="2550" b="1" i="0">
                 <a:solidFill>
                   <a:srgbClr val="FFFFFF"/>
@@ -3325,6 +3338,7 @@
           <a:lstStyle xmlns:a="http://schemas.openxmlformats.org/drawingml/2006/main"/>
           <a:p xmlns:a="http://schemas.openxmlformats.org/drawingml/2006/main">
             <a:pPr algn="l">
+              <a:buNone/>
               <a:defRPr sz="1500" b="0" i="0">
                 <a:solidFill>
                   <a:srgbClr val="FFFFFF"/>
@@ -3414,6 +3428,7 @@
           <a:lstStyle xmlns:a="http://schemas.openxmlformats.org/drawingml/2006/main"/>
           <a:p xmlns:a="http://schemas.openxmlformats.org/drawingml/2006/main">
             <a:pPr algn="l">
+              <a:buNone/>
               <a:defRPr sz="1200" b="1" i="0">
                 <a:solidFill>
                   <a:srgbClr val="176BFF"/>
@@ -3470,6 +3485,7 @@
           <a:lstStyle xmlns:a="http://schemas.openxmlformats.org/drawingml/2006/main"/>
           <a:p xmlns:a="http://schemas.openxmlformats.org/drawingml/2006/main">
             <a:pPr algn="l">
+              <a:buNone/>
               <a:defRPr sz="2550" b="1" i="0">
                 <a:solidFill>
                   <a:srgbClr val="111827"/>
@@ -3526,6 +3542,7 @@
           <a:lstStyle xmlns:a="http://schemas.openxmlformats.org/drawingml/2006/main"/>
           <a:p xmlns:a="http://schemas.openxmlformats.org/drawingml/2006/main">
             <a:pPr algn="l">
+              <a:buNone/>
               <a:defRPr sz="1500" b="0" i="0">
                 <a:solidFill>
                   <a:srgbClr val="667085"/>
@@ -3615,6 +3632,7 @@
           <a:lstStyle xmlns:a="http://schemas.openxmlformats.org/drawingml/2006/main"/>
           <a:p xmlns:a="http://schemas.openxmlformats.org/drawingml/2006/main">
             <a:pPr algn="l">
+              <a:buNone/>
               <a:defRPr sz="1200" b="1" i="0">
                 <a:solidFill>
                   <a:srgbClr val="176BFF"/>
@@ -3671,6 +3689,7 @@
           <a:lstStyle xmlns:a="http://schemas.openxmlformats.org/drawingml/2006/main"/>
           <a:p xmlns:a="http://schemas.openxmlformats.org/drawingml/2006/main">
             <a:pPr algn="l">
+              <a:buNone/>
               <a:defRPr sz="2550" b="1" i="0">
                 <a:solidFill>
                   <a:srgbClr val="111827"/>
@@ -3727,6 +3746,7 @@
           <a:lstStyle xmlns:a="http://schemas.openxmlformats.org/drawingml/2006/main"/>
           <a:p xmlns:a="http://schemas.openxmlformats.org/drawingml/2006/main">
             <a:pPr algn="l">
+              <a:buNone/>
               <a:defRPr sz="1500" b="0" i="0">
                 <a:solidFill>
                   <a:srgbClr val="667085"/>
@@ -3816,6 +3836,7 @@
           <a:lstStyle xmlns:a="http://schemas.openxmlformats.org/drawingml/2006/main"/>
           <a:p xmlns:a="http://schemas.openxmlformats.org/drawingml/2006/main">
             <a:pPr algn="l">
+              <a:buNone/>
               <a:defRPr sz="1200" b="1" i="0">
                 <a:solidFill>
                   <a:srgbClr val="176BFF"/>
@@ -3872,6 +3893,7 @@
           <a:lstStyle xmlns:a="http://schemas.openxmlformats.org/drawingml/2006/main"/>
           <a:p xmlns:a="http://schemas.openxmlformats.org/drawingml/2006/main">
             <a:pPr algn="l">
+              <a:buNone/>
               <a:defRPr sz="2550" b="1" i="0">
                 <a:solidFill>
                   <a:srgbClr val="111827"/>
@@ -3928,6 +3950,7 @@
           <a:lstStyle xmlns:a="http://schemas.openxmlformats.org/drawingml/2006/main"/>
           <a:p xmlns:a="http://schemas.openxmlformats.org/drawingml/2006/main">
             <a:pPr algn="l">
+              <a:buNone/>
               <a:defRPr sz="1500" b="0" i="0">
                 <a:solidFill>
                   <a:srgbClr val="667085"/>
@@ -4017,6 +4040,7 @@
           <a:lstStyle xmlns:a="http://schemas.openxmlformats.org/drawingml/2006/main"/>
           <a:p xmlns:a="http://schemas.openxmlformats.org/drawingml/2006/main">
             <a:pPr algn="ctr">
+              <a:buNone/>
               <a:defRPr sz="1575" b="1" i="0">
                 <a:solidFill>
                   <a:srgbClr val="F79009"/>
@@ -4104,6 +4128,7 @@
           <a:lstStyle xmlns:a="http://schemas.openxmlformats.org/drawingml/2006/main"/>
           <a:p xmlns:a="http://schemas.openxmlformats.org/drawingml/2006/main">
             <a:pPr algn="l">
+              <a:buNone/>
               <a:defRPr sz="975" b="0" i="0">
                 <a:solidFill>
                   <a:srgbClr val="98A2B3"/>
@@ -4160,6 +4185,7 @@
           <a:lstStyle xmlns:a="http://schemas.openxmlformats.org/drawingml/2006/main"/>
           <a:p xmlns:a="http://schemas.openxmlformats.org/drawingml/2006/main">
             <a:pPr algn="r">
+              <a:buNone/>
               <a:defRPr sz="975" b="0" i="0">
                 <a:solidFill>
                   <a:srgbClr val="98A2B3"/>
@@ -4245,6 +4271,7 @@
           <a:lstStyle xmlns:a="http://schemas.openxmlformats.org/drawingml/2006/main"/>
           <a:p xmlns:a="http://schemas.openxmlformats.org/drawingml/2006/main">
             <a:pPr algn="l">
+              <a:buNone/>
               <a:defRPr sz="1200" b="1" i="0">
                 <a:solidFill>
                   <a:srgbClr val="176BFF"/>
@@ -4301,6 +4328,7 @@
           <a:lstStyle xmlns:a="http://schemas.openxmlformats.org/drawingml/2006/main"/>
           <a:p xmlns:a="http://schemas.openxmlformats.org/drawingml/2006/main">
             <a:pPr algn="l">
+              <a:buNone/>
               <a:defRPr sz="3150" b="1" i="0">
                 <a:solidFill>
                   <a:srgbClr val="111827"/>
@@ -4390,6 +4418,7 @@
           <a:lstStyle xmlns:a="http://schemas.openxmlformats.org/drawingml/2006/main"/>
           <a:p xmlns:a="http://schemas.openxmlformats.org/drawingml/2006/main">
             <a:pPr algn="l">
+              <a:buNone/>
               <a:defRPr sz="1200" b="1" i="0">
                 <a:solidFill>
                   <a:srgbClr val="176BFF"/>
@@ -4446,6 +4475,7 @@
           <a:lstStyle xmlns:a="http://schemas.openxmlformats.org/drawingml/2006/main"/>
           <a:p xmlns:a="http://schemas.openxmlformats.org/drawingml/2006/main">
             <a:pPr algn="l">
+              <a:buNone/>
               <a:defRPr sz="2025" b="1" i="0">
                 <a:solidFill>
                   <a:srgbClr val="111827"/>
@@ -4502,6 +4532,7 @@
           <a:lstStyle xmlns:a="http://schemas.openxmlformats.org/drawingml/2006/main"/>
           <a:p xmlns:a="http://schemas.openxmlformats.org/drawingml/2006/main">
             <a:pPr algn="l">
+              <a:buNone/>
               <a:defRPr sz="1425" b="1" i="0">
                 <a:solidFill>
                   <a:srgbClr val="176BFF"/>
@@ -4558,6 +4589,7 @@
           <a:lstStyle xmlns:a="http://schemas.openxmlformats.org/drawingml/2006/main"/>
           <a:p xmlns:a="http://schemas.openxmlformats.org/drawingml/2006/main">
             <a:pPr algn="l">
+              <a:buNone/>
               <a:defRPr sz="1425" b="0" i="0">
                 <a:solidFill>
                   <a:srgbClr val="667085"/>
@@ -4581,6 +4613,7 @@
           </a:p>
           <a:p xmlns:a="http://schemas.openxmlformats.org/drawingml/2006/main">
             <a:pPr algn="l">
+              <a:buNone/>
               <a:defRPr sz="1425" b="0" i="0">
                 <a:solidFill>
                   <a:srgbClr val="667085"/>
@@ -4670,6 +4703,7 @@
           <a:lstStyle xmlns:a="http://schemas.openxmlformats.org/drawingml/2006/main"/>
           <a:p xmlns:a="http://schemas.openxmlformats.org/drawingml/2006/main">
             <a:pPr algn="l">
+              <a:buNone/>
               <a:defRPr sz="1200" b="1" i="0">
                 <a:solidFill>
                   <a:srgbClr val="F79009"/>
@@ -4726,6 +4760,7 @@
           <a:lstStyle xmlns:a="http://schemas.openxmlformats.org/drawingml/2006/main"/>
           <a:p xmlns:a="http://schemas.openxmlformats.org/drawingml/2006/main">
             <a:pPr algn="l">
+              <a:buNone/>
               <a:defRPr sz="2025" b="1" i="0">
                 <a:solidFill>
                   <a:srgbClr val="111827"/>
@@ -4782,6 +4817,7 @@
           <a:lstStyle xmlns:a="http://schemas.openxmlformats.org/drawingml/2006/main"/>
           <a:p xmlns:a="http://schemas.openxmlformats.org/drawingml/2006/main">
             <a:pPr algn="l">
+              <a:buNone/>
               <a:defRPr sz="1425" b="1" i="0">
                 <a:solidFill>
                   <a:srgbClr val="F79009"/>
@@ -4838,6 +4874,7 @@
           <a:lstStyle xmlns:a="http://schemas.openxmlformats.org/drawingml/2006/main"/>
           <a:p xmlns:a="http://schemas.openxmlformats.org/drawingml/2006/main">
             <a:pPr algn="l">
+              <a:buNone/>
               <a:defRPr sz="1425" b="0" i="0">
                 <a:solidFill>
                   <a:srgbClr val="667085"/>
@@ -4861,6 +4898,7 @@
           </a:p>
           <a:p xmlns:a="http://schemas.openxmlformats.org/drawingml/2006/main">
             <a:pPr algn="l">
+              <a:buNone/>
               <a:defRPr sz="1425" b="0" i="0">
                 <a:solidFill>
                   <a:srgbClr val="667085"/>
@@ -4950,6 +4988,7 @@
           <a:lstStyle xmlns:a="http://schemas.openxmlformats.org/drawingml/2006/main"/>
           <a:p xmlns:a="http://schemas.openxmlformats.org/drawingml/2006/main">
             <a:pPr algn="l">
+              <a:buNone/>
               <a:defRPr sz="1200" b="1" i="0">
                 <a:solidFill>
                   <a:srgbClr val="17A673"/>
@@ -5006,6 +5045,7 @@
           <a:lstStyle xmlns:a="http://schemas.openxmlformats.org/drawingml/2006/main"/>
           <a:p xmlns:a="http://schemas.openxmlformats.org/drawingml/2006/main">
             <a:pPr algn="l">
+              <a:buNone/>
               <a:defRPr sz="2025" b="1" i="0">
                 <a:solidFill>
                   <a:srgbClr val="111827"/>
@@ -5062,6 +5102,7 @@
           <a:lstStyle xmlns:a="http://schemas.openxmlformats.org/drawingml/2006/main"/>
           <a:p xmlns:a="http://schemas.openxmlformats.org/drawingml/2006/main">
             <a:pPr algn="l">
+              <a:buNone/>
               <a:defRPr sz="1425" b="1" i="0">
                 <a:solidFill>
                   <a:srgbClr val="17A673"/>
@@ -5118,6 +5159,7 @@
           <a:lstStyle xmlns:a="http://schemas.openxmlformats.org/drawingml/2006/main"/>
           <a:p xmlns:a="http://schemas.openxmlformats.org/drawingml/2006/main">
             <a:pPr algn="l">
+              <a:buNone/>
               <a:defRPr sz="1425" b="0" i="0">
                 <a:solidFill>
                   <a:srgbClr val="667085"/>
@@ -5141,6 +5183,7 @@
           </a:p>
           <a:p xmlns:a="http://schemas.openxmlformats.org/drawingml/2006/main">
             <a:pPr algn="l">
+              <a:buNone/>
               <a:defRPr sz="1425" b="0" i="0">
                 <a:solidFill>
                   <a:srgbClr val="667085"/>
@@ -5197,6 +5240,7 @@
           <a:lstStyle xmlns:a="http://schemas.openxmlformats.org/drawingml/2006/main"/>
           <a:p xmlns:a="http://schemas.openxmlformats.org/drawingml/2006/main">
             <a:pPr algn="ctr">
+              <a:buNone/>
               <a:defRPr sz="1350" b="0" i="0">
                 <a:solidFill>
                   <a:srgbClr val="667085"/>
@@ -5284,6 +5328,7 @@
           <a:lstStyle xmlns:a="http://schemas.openxmlformats.org/drawingml/2006/main"/>
           <a:p xmlns:a="http://schemas.openxmlformats.org/drawingml/2006/main">
             <a:pPr algn="l">
+              <a:buNone/>
               <a:defRPr sz="975" b="0" i="0">
                 <a:solidFill>
                   <a:srgbClr val="98A2B3"/>
@@ -5340,6 +5385,7 @@
           <a:lstStyle xmlns:a="http://schemas.openxmlformats.org/drawingml/2006/main"/>
           <a:p xmlns:a="http://schemas.openxmlformats.org/drawingml/2006/main">
             <a:pPr algn="r">
+              <a:buNone/>
               <a:defRPr sz="975" b="0" i="0">
                 <a:solidFill>
                   <a:srgbClr val="98A2B3"/>
@@ -5425,6 +5471,7 @@
           <a:lstStyle xmlns:a="http://schemas.openxmlformats.org/drawingml/2006/main"/>
           <a:p xmlns:a="http://schemas.openxmlformats.org/drawingml/2006/main">
             <a:pPr algn="l">
+              <a:buNone/>
               <a:defRPr sz="1200" b="1" i="0">
                 <a:solidFill>
                   <a:srgbClr val="176BFF"/>
@@ -5481,6 +5528,7 @@
           <a:lstStyle xmlns:a="http://schemas.openxmlformats.org/drawingml/2006/main"/>
           <a:p xmlns:a="http://schemas.openxmlformats.org/drawingml/2006/main">
             <a:pPr algn="l">
+              <a:buNone/>
               <a:defRPr sz="3150" b="1" i="0">
                 <a:solidFill>
                   <a:srgbClr val="111827"/>
@@ -5601,6 +5649,7 @@
           <a:lstStyle xmlns:a="http://schemas.openxmlformats.org/drawingml/2006/main"/>
           <a:p xmlns:a="http://schemas.openxmlformats.org/drawingml/2006/main">
             <a:pPr algn="ctr">
+              <a:buNone/>
               <a:defRPr sz="1275" b="1" i="0">
                 <a:solidFill>
                   <a:srgbClr val="FFFFFF"/>
@@ -5657,6 +5706,7 @@
           <a:lstStyle xmlns:a="http://schemas.openxmlformats.org/drawingml/2006/main"/>
           <a:p xmlns:a="http://schemas.openxmlformats.org/drawingml/2006/main">
             <a:pPr algn="l">
+              <a:buNone/>
               <a:defRPr sz="1725" b="1" i="0">
                 <a:solidFill>
                   <a:srgbClr val="111827"/>
@@ -5713,6 +5763,7 @@
           <a:lstStyle xmlns:a="http://schemas.openxmlformats.org/drawingml/2006/main"/>
           <a:p xmlns:a="http://schemas.openxmlformats.org/drawingml/2006/main">
             <a:pPr algn="l">
+              <a:buNone/>
               <a:defRPr sz="1350" b="0" i="0">
                 <a:solidFill>
                   <a:srgbClr val="667085"/>
@@ -5833,6 +5884,7 @@
           <a:lstStyle xmlns:a="http://schemas.openxmlformats.org/drawingml/2006/main"/>
           <a:p xmlns:a="http://schemas.openxmlformats.org/drawingml/2006/main">
             <a:pPr algn="ctr">
+              <a:buNone/>
               <a:defRPr sz="1275" b="1" i="0">
                 <a:solidFill>
                   <a:srgbClr val="FFFFFF"/>
@@ -5889,6 +5941,7 @@
           <a:lstStyle xmlns:a="http://schemas.openxmlformats.org/drawingml/2006/main"/>
           <a:p xmlns:a="http://schemas.openxmlformats.org/drawingml/2006/main">
             <a:pPr algn="l">
+              <a:buNone/>
               <a:defRPr sz="1725" b="1" i="0">
                 <a:solidFill>
                   <a:srgbClr val="111827"/>
@@ -5945,6 +5998,7 @@
           <a:lstStyle xmlns:a="http://schemas.openxmlformats.org/drawingml/2006/main"/>
           <a:p xmlns:a="http://schemas.openxmlformats.org/drawingml/2006/main">
             <a:pPr algn="l">
+              <a:buNone/>
               <a:defRPr sz="1350" b="0" i="0">
                 <a:solidFill>
                   <a:srgbClr val="667085"/>
@@ -6065,6 +6119,7 @@
           <a:lstStyle xmlns:a="http://schemas.openxmlformats.org/drawingml/2006/main"/>
           <a:p xmlns:a="http://schemas.openxmlformats.org/drawingml/2006/main">
             <a:pPr algn="ctr">
+              <a:buNone/>
               <a:defRPr sz="1275" b="1" i="0">
                 <a:solidFill>
                   <a:srgbClr val="FFFFFF"/>
@@ -6121,6 +6176,7 @@
           <a:lstStyle xmlns:a="http://schemas.openxmlformats.org/drawingml/2006/main"/>
           <a:p xmlns:a="http://schemas.openxmlformats.org/drawingml/2006/main">
             <a:pPr algn="l">
+              <a:buNone/>
               <a:defRPr sz="1725" b="1" i="0">
                 <a:solidFill>
                   <a:srgbClr val="111827"/>
@@ -6177,6 +6233,7 @@
           <a:lstStyle xmlns:a="http://schemas.openxmlformats.org/drawingml/2006/main"/>
           <a:p xmlns:a="http://schemas.openxmlformats.org/drawingml/2006/main">
             <a:pPr algn="l">
+              <a:buNone/>
               <a:defRPr sz="1350" b="0" i="0">
                 <a:solidFill>
                   <a:srgbClr val="667085"/>
@@ -6297,6 +6354,7 @@
           <a:lstStyle xmlns:a="http://schemas.openxmlformats.org/drawingml/2006/main"/>
           <a:p xmlns:a="http://schemas.openxmlformats.org/drawingml/2006/main">
             <a:pPr algn="ctr">
+              <a:buNone/>
               <a:defRPr sz="1275" b="1" i="0">
                 <a:solidFill>
                   <a:srgbClr val="FFFFFF"/>
@@ -6353,6 +6411,7 @@
           <a:lstStyle xmlns:a="http://schemas.openxmlformats.org/drawingml/2006/main"/>
           <a:p xmlns:a="http://schemas.openxmlformats.org/drawingml/2006/main">
             <a:pPr algn="l">
+              <a:buNone/>
               <a:defRPr sz="1725" b="1" i="0">
                 <a:solidFill>
                   <a:srgbClr val="111827"/>
@@ -6409,6 +6468,7 @@
           <a:lstStyle xmlns:a="http://schemas.openxmlformats.org/drawingml/2006/main"/>
           <a:p xmlns:a="http://schemas.openxmlformats.org/drawingml/2006/main">
             <a:pPr algn="l">
+              <a:buNone/>
               <a:defRPr sz="1350" b="0" i="0">
                 <a:solidFill>
                   <a:srgbClr val="667085"/>
@@ -6498,6 +6558,7 @@
           <a:lstStyle xmlns:a="http://schemas.openxmlformats.org/drawingml/2006/main"/>
           <a:p xmlns:a="http://schemas.openxmlformats.org/drawingml/2006/main">
             <a:pPr algn="ctr">
+              <a:buNone/>
               <a:defRPr sz="1650" b="1" i="0">
                 <a:solidFill>
                   <a:srgbClr val="FFFFFF"/>
@@ -6585,6 +6646,7 @@
           <a:lstStyle xmlns:a="http://schemas.openxmlformats.org/drawingml/2006/main"/>
           <a:p xmlns:a="http://schemas.openxmlformats.org/drawingml/2006/main">
             <a:pPr algn="l">
+              <a:buNone/>
               <a:defRPr sz="975" b="0" i="0">
                 <a:solidFill>
                   <a:srgbClr val="98A2B3"/>
@@ -6641,6 +6703,7 @@
           <a:lstStyle xmlns:a="http://schemas.openxmlformats.org/drawingml/2006/main"/>
           <a:p xmlns:a="http://schemas.openxmlformats.org/drawingml/2006/main">
             <a:pPr algn="r">
+              <a:buNone/>
               <a:defRPr sz="975" b="0" i="0">
                 <a:solidFill>
                   <a:srgbClr val="98A2B3"/>
@@ -6726,6 +6789,7 @@
           <a:lstStyle xmlns:a="http://schemas.openxmlformats.org/drawingml/2006/main"/>
           <a:p xmlns:a="http://schemas.openxmlformats.org/drawingml/2006/main">
             <a:pPr algn="l">
+              <a:buNone/>
               <a:defRPr sz="1200" b="1" i="0">
                 <a:solidFill>
                   <a:srgbClr val="176BFF"/>
@@ -6782,6 +6846,7 @@
           <a:lstStyle xmlns:a="http://schemas.openxmlformats.org/drawingml/2006/main"/>
           <a:p xmlns:a="http://schemas.openxmlformats.org/drawingml/2006/main">
             <a:pPr algn="l">
+              <a:buNone/>
               <a:defRPr sz="3150" b="1" i="0">
                 <a:solidFill>
                   <a:srgbClr val="111827"/>
@@ -6838,6 +6903,7 @@
           <a:lstStyle xmlns:a="http://schemas.openxmlformats.org/drawingml/2006/main"/>
           <a:p xmlns:a="http://schemas.openxmlformats.org/drawingml/2006/main">
             <a:pPr algn="l">
+              <a:buNone/>
               <a:defRPr sz="1500" b="0" i="0">
                 <a:solidFill>
                   <a:srgbClr val="667085"/>
@@ -6991,6 +7057,7 @@
           <a:lstStyle xmlns:a="http://schemas.openxmlformats.org/drawingml/2006/main"/>
           <a:p xmlns:a="http://schemas.openxmlformats.org/drawingml/2006/main">
             <a:pPr algn="ctr">
+              <a:buNone/>
               <a:defRPr sz="1050" b="1" i="0">
                 <a:solidFill>
                   <a:srgbClr val="176BFF"/>
@@ -7047,6 +7114,7 @@
           <a:lstStyle xmlns:a="http://schemas.openxmlformats.org/drawingml/2006/main"/>
           <a:p xmlns:a="http://schemas.openxmlformats.org/drawingml/2006/main">
             <a:pPr algn="l">
+              <a:buNone/>
               <a:defRPr sz="2100" b="1" i="0">
                 <a:solidFill>
                   <a:srgbClr val="FFFFFF"/>
@@ -7103,6 +7171,7 @@
           <a:lstStyle xmlns:a="http://schemas.openxmlformats.org/drawingml/2006/main"/>
           <a:p xmlns:a="http://schemas.openxmlformats.org/drawingml/2006/main">
             <a:pPr algn="l">
+              <a:buNone/>
               <a:defRPr sz="1500" b="0" i="0">
                 <a:solidFill>
                   <a:srgbClr val="FFFFFF"/>
@@ -7126,6 +7195,7 @@
           </a:p>
           <a:p xmlns:a="http://schemas.openxmlformats.org/drawingml/2006/main">
             <a:pPr algn="l">
+              <a:buNone/>
               <a:defRPr sz="1500" b="0" i="0">
                 <a:solidFill>
                   <a:srgbClr val="FFFFFF"/>
@@ -7215,6 +7285,7 @@
           <a:lstStyle xmlns:a="http://schemas.openxmlformats.org/drawingml/2006/main"/>
           <a:p xmlns:a="http://schemas.openxmlformats.org/drawingml/2006/main">
             <a:pPr algn="ctr">
+              <a:buNone/>
               <a:defRPr sz="1125" b="1" i="0">
                 <a:solidFill>
                   <a:srgbClr val="FFFFFF"/>
@@ -7337,6 +7408,7 @@
           <a:lstStyle xmlns:a="http://schemas.openxmlformats.org/drawingml/2006/main"/>
           <a:p xmlns:a="http://schemas.openxmlformats.org/drawingml/2006/main">
             <a:pPr algn="ctr">
+              <a:buNone/>
               <a:defRPr sz="1050" b="1" i="0">
                 <a:solidFill>
                   <a:srgbClr val="176BFF"/>
@@ -7393,6 +7465,7 @@
           <a:lstStyle xmlns:a="http://schemas.openxmlformats.org/drawingml/2006/main"/>
           <a:p xmlns:a="http://schemas.openxmlformats.org/drawingml/2006/main">
             <a:pPr algn="l">
+              <a:buNone/>
               <a:defRPr sz="2100" b="1" i="0">
                 <a:solidFill>
                   <a:srgbClr val="111827"/>
@@ -7449,6 +7522,7 @@
           <a:lstStyle xmlns:a="http://schemas.openxmlformats.org/drawingml/2006/main"/>
           <a:p xmlns:a="http://schemas.openxmlformats.org/drawingml/2006/main">
             <a:pPr algn="l">
+              <a:buNone/>
               <a:defRPr sz="1500" b="0" i="0">
                 <a:solidFill>
                   <a:srgbClr val="667085"/>
@@ -7472,6 +7546,7 @@
           </a:p>
           <a:p xmlns:a="http://schemas.openxmlformats.org/drawingml/2006/main">
             <a:pPr algn="l">
+              <a:buNone/>
               <a:defRPr sz="1500" b="0" i="0">
                 <a:solidFill>
                   <a:srgbClr val="667085"/>
@@ -7561,6 +7636,7 @@
           <a:lstStyle xmlns:a="http://schemas.openxmlformats.org/drawingml/2006/main"/>
           <a:p xmlns:a="http://schemas.openxmlformats.org/drawingml/2006/main">
             <a:pPr algn="ctr">
+              <a:buNone/>
               <a:defRPr sz="1125" b="1" i="0">
                 <a:solidFill>
                   <a:srgbClr val="111827"/>
@@ -7683,6 +7759,7 @@
           <a:lstStyle xmlns:a="http://schemas.openxmlformats.org/drawingml/2006/main"/>
           <a:p xmlns:a="http://schemas.openxmlformats.org/drawingml/2006/main">
             <a:pPr algn="ctr">
+              <a:buNone/>
               <a:defRPr sz="1050" b="1" i="0">
                 <a:solidFill>
                   <a:srgbClr val="176BFF"/>
@@ -7739,6 +7816,7 @@
           <a:lstStyle xmlns:a="http://schemas.openxmlformats.org/drawingml/2006/main"/>
           <a:p xmlns:a="http://schemas.openxmlformats.org/drawingml/2006/main">
             <a:pPr algn="l">
+              <a:buNone/>
               <a:defRPr sz="2100" b="1" i="0">
                 <a:solidFill>
                   <a:srgbClr val="111827"/>
@@ -7795,6 +7873,7 @@
           <a:lstStyle xmlns:a="http://schemas.openxmlformats.org/drawingml/2006/main"/>
           <a:p xmlns:a="http://schemas.openxmlformats.org/drawingml/2006/main">
             <a:pPr algn="l">
+              <a:buNone/>
               <a:defRPr sz="1500" b="0" i="0">
                 <a:solidFill>
                   <a:srgbClr val="667085"/>
@@ -7818,6 +7897,7 @@
           </a:p>
           <a:p xmlns:a="http://schemas.openxmlformats.org/drawingml/2006/main">
             <a:pPr algn="l">
+              <a:buNone/>
               <a:defRPr sz="1500" b="0" i="0">
                 <a:solidFill>
                   <a:srgbClr val="667085"/>
@@ -7907,6 +7987,7 @@
           <a:lstStyle xmlns:a="http://schemas.openxmlformats.org/drawingml/2006/main"/>
           <a:p xmlns:a="http://schemas.openxmlformats.org/drawingml/2006/main">
             <a:pPr algn="ctr">
+              <a:buNone/>
               <a:defRPr sz="1125" b="1" i="0">
                 <a:solidFill>
                   <a:srgbClr val="111827"/>
@@ -7963,6 +8044,7 @@
           <a:lstStyle xmlns:a="http://schemas.openxmlformats.org/drawingml/2006/main"/>
           <a:p xmlns:a="http://schemas.openxmlformats.org/drawingml/2006/main">
             <a:pPr algn="ctr">
+              <a:buNone/>
               <a:defRPr sz="1125" b="0" i="0">
                 <a:solidFill>
                   <a:srgbClr val="98A2B3"/>
@@ -8050,6 +8132,7 @@
           <a:lstStyle xmlns:a="http://schemas.openxmlformats.org/drawingml/2006/main"/>
           <a:p xmlns:a="http://schemas.openxmlformats.org/drawingml/2006/main">
             <a:pPr algn="l">
+              <a:buNone/>
               <a:defRPr sz="975" b="0" i="0">
                 <a:solidFill>
                   <a:srgbClr val="98A2B3"/>
@@ -8106,6 +8189,7 @@
           <a:lstStyle xmlns:a="http://schemas.openxmlformats.org/drawingml/2006/main"/>
           <a:p xmlns:a="http://schemas.openxmlformats.org/drawingml/2006/main">
             <a:pPr algn="r">
+              <a:buNone/>
               <a:defRPr sz="975" b="0" i="0">
                 <a:solidFill>
                   <a:srgbClr val="98A2B3"/>
@@ -8191,6 +8275,7 @@
           <a:lstStyle xmlns:a="http://schemas.openxmlformats.org/drawingml/2006/main"/>
           <a:p xmlns:a="http://schemas.openxmlformats.org/drawingml/2006/main">
             <a:pPr algn="l">
+              <a:buNone/>
               <a:defRPr sz="1200" b="1" i="0">
                 <a:solidFill>
                   <a:srgbClr val="FFD447"/>
@@ -8247,6 +8332,7 @@
           <a:lstStyle xmlns:a="http://schemas.openxmlformats.org/drawingml/2006/main"/>
           <a:p xmlns:a="http://schemas.openxmlformats.org/drawingml/2006/main">
             <a:pPr algn="l">
+              <a:buNone/>
               <a:defRPr sz="3600" b="1" i="0">
                 <a:solidFill>
                   <a:srgbClr val="FFFFFF"/>
@@ -8303,6 +8389,7 @@
           <a:lstStyle xmlns:a="http://schemas.openxmlformats.org/drawingml/2006/main"/>
           <a:p xmlns:a="http://schemas.openxmlformats.org/drawingml/2006/main">
             <a:pPr algn="l">
+              <a:buNone/>
               <a:defRPr sz="3600" b="1" i="0">
                 <a:solidFill>
                   <a:srgbClr val="FFD447"/>
@@ -8394,6 +8481,7 @@
           <a:lstStyle xmlns:a="http://schemas.openxmlformats.org/drawingml/2006/main"/>
           <a:p xmlns:a="http://schemas.openxmlformats.org/drawingml/2006/main">
             <a:pPr algn="l">
+              <a:buNone/>
               <a:defRPr sz="1425" b="1" i="0">
                 <a:solidFill>
                   <a:srgbClr val="FFD447"/>
@@ -8450,6 +8538,7 @@
           <a:lstStyle xmlns:a="http://schemas.openxmlformats.org/drawingml/2006/main"/>
           <a:p xmlns:a="http://schemas.openxmlformats.org/drawingml/2006/main">
             <a:pPr algn="l">
+              <a:buNone/>
               <a:defRPr sz="1275" b="0" i="0">
                 <a:solidFill>
                   <a:srgbClr val="FFFFFF"/>
@@ -8541,6 +8630,7 @@
           <a:lstStyle xmlns:a="http://schemas.openxmlformats.org/drawingml/2006/main"/>
           <a:p xmlns:a="http://schemas.openxmlformats.org/drawingml/2006/main">
             <a:pPr algn="l">
+              <a:buNone/>
               <a:defRPr sz="1425" b="1" i="0">
                 <a:solidFill>
                   <a:srgbClr val="FFD447"/>
@@ -8597,6 +8687,7 @@
           <a:lstStyle xmlns:a="http://schemas.openxmlformats.org/drawingml/2006/main"/>
           <a:p xmlns:a="http://schemas.openxmlformats.org/drawingml/2006/main">
             <a:pPr algn="l">
+              <a:buNone/>
               <a:defRPr sz="1275" b="0" i="0">
                 <a:solidFill>
                   <a:srgbClr val="FFFFFF"/>
@@ -8688,6 +8779,7 @@
           <a:lstStyle xmlns:a="http://schemas.openxmlformats.org/drawingml/2006/main"/>
           <a:p xmlns:a="http://schemas.openxmlformats.org/drawingml/2006/main">
             <a:pPr algn="l">
+              <a:buNone/>
               <a:defRPr sz="1425" b="1" i="0">
                 <a:solidFill>
                   <a:srgbClr val="FFD447"/>
@@ -8744,6 +8836,7 @@
           <a:lstStyle xmlns:a="http://schemas.openxmlformats.org/drawingml/2006/main"/>
           <a:p xmlns:a="http://schemas.openxmlformats.org/drawingml/2006/main">
             <a:pPr algn="l">
+              <a:buNone/>
               <a:defRPr sz="1275" b="0" i="0">
                 <a:solidFill>
                   <a:srgbClr val="FFFFFF"/>
@@ -8835,6 +8928,7 @@
           <a:lstStyle xmlns:a="http://schemas.openxmlformats.org/drawingml/2006/main"/>
           <a:p xmlns:a="http://schemas.openxmlformats.org/drawingml/2006/main">
             <a:pPr algn="l">
+              <a:buNone/>
               <a:defRPr sz="1425" b="1" i="0">
                 <a:solidFill>
                   <a:srgbClr val="FFD447"/>
@@ -8891,6 +8985,7 @@
           <a:lstStyle xmlns:a="http://schemas.openxmlformats.org/drawingml/2006/main"/>
           <a:p xmlns:a="http://schemas.openxmlformats.org/drawingml/2006/main">
             <a:pPr algn="l">
+              <a:buNone/>
               <a:defRPr sz="1275" b="0" i="0">
                 <a:solidFill>
                   <a:srgbClr val="FFFFFF"/>
@@ -8982,6 +9077,7 @@
           <a:lstStyle xmlns:a="http://schemas.openxmlformats.org/drawingml/2006/main"/>
           <a:p xmlns:a="http://schemas.openxmlformats.org/drawingml/2006/main">
             <a:pPr algn="l">
+              <a:buNone/>
               <a:defRPr sz="1425" b="1" i="0">
                 <a:solidFill>
                   <a:srgbClr val="FFD447"/>
@@ -9038,6 +9134,7 @@
           <a:lstStyle xmlns:a="http://schemas.openxmlformats.org/drawingml/2006/main"/>
           <a:p xmlns:a="http://schemas.openxmlformats.org/drawingml/2006/main">
             <a:pPr algn="l">
+              <a:buNone/>
               <a:defRPr sz="1275" b="0" i="0">
                 <a:solidFill>
                   <a:srgbClr val="FFFFFF"/>
@@ -9127,6 +9224,7 @@
           <a:lstStyle xmlns:a="http://schemas.openxmlformats.org/drawingml/2006/main"/>
           <a:p xmlns:a="http://schemas.openxmlformats.org/drawingml/2006/main">
             <a:pPr algn="ctr">
+              <a:buNone/>
               <a:defRPr sz="1575" b="1" i="0">
                 <a:solidFill>
                   <a:srgbClr val="FFFFFF"/>
@@ -9183,6 +9281,7 @@
           <a:lstStyle xmlns:a="http://schemas.openxmlformats.org/drawingml/2006/main"/>
           <a:p xmlns:a="http://schemas.openxmlformats.org/drawingml/2006/main">
             <a:pPr algn="l">
+              <a:buNone/>
               <a:defRPr sz="1050" b="0" i="0">
                 <a:solidFill>
                   <a:srgbClr val="98A2B3"/>
@@ -9268,6 +9367,7 @@
           <a:lstStyle xmlns:a="http://schemas.openxmlformats.org/drawingml/2006/main"/>
           <a:p xmlns:a="http://schemas.openxmlformats.org/drawingml/2006/main">
             <a:pPr algn="l">
+              <a:buNone/>
               <a:defRPr sz="1200" b="1" i="0">
                 <a:solidFill>
                   <a:srgbClr val="176BFF"/>
@@ -9324,6 +9424,7 @@
           <a:lstStyle xmlns:a="http://schemas.openxmlformats.org/drawingml/2006/main"/>
           <a:p xmlns:a="http://schemas.openxmlformats.org/drawingml/2006/main">
             <a:pPr algn="l">
+              <a:buNone/>
               <a:defRPr sz="3150" b="1" i="0">
                 <a:solidFill>
                   <a:srgbClr val="111827"/>
@@ -9380,6 +9481,7 @@
           <a:lstStyle xmlns:a="http://schemas.openxmlformats.org/drawingml/2006/main"/>
           <a:p xmlns:a="http://schemas.openxmlformats.org/drawingml/2006/main">
             <a:pPr algn="l">
+              <a:buNone/>
               <a:defRPr sz="1500" b="0" i="0">
                 <a:solidFill>
                   <a:srgbClr val="667085"/>
@@ -9502,6 +9604,7 @@
           <a:lstStyle xmlns:a="http://schemas.openxmlformats.org/drawingml/2006/main"/>
           <a:p xmlns:a="http://schemas.openxmlformats.org/drawingml/2006/main">
             <a:pPr algn="ctr">
+              <a:buNone/>
               <a:defRPr sz="1050" b="1" i="0">
                 <a:solidFill>
                   <a:srgbClr val="176BFF"/>
@@ -9558,6 +9661,7 @@
           <a:lstStyle xmlns:a="http://schemas.openxmlformats.org/drawingml/2006/main"/>
           <a:p xmlns:a="http://schemas.openxmlformats.org/drawingml/2006/main">
             <a:pPr algn="l">
+              <a:buNone/>
               <a:defRPr sz="2025" b="1" i="0">
                 <a:solidFill>
                   <a:srgbClr val="111827"/>
@@ -9614,6 +9718,7 @@
           <a:lstStyle xmlns:a="http://schemas.openxmlformats.org/drawingml/2006/main"/>
           <a:p xmlns:a="http://schemas.openxmlformats.org/drawingml/2006/main">
             <a:pPr algn="l">
+              <a:buNone/>
               <a:defRPr sz="1500" b="0" i="0">
                 <a:solidFill>
                   <a:srgbClr val="667085"/>
@@ -9736,6 +9841,7 @@
           <a:lstStyle xmlns:a="http://schemas.openxmlformats.org/drawingml/2006/main"/>
           <a:p xmlns:a="http://schemas.openxmlformats.org/drawingml/2006/main">
             <a:pPr algn="ctr">
+              <a:buNone/>
               <a:defRPr sz="1050" b="1" i="0">
                 <a:solidFill>
                   <a:srgbClr val="F79009"/>
@@ -9792,6 +9898,7 @@
           <a:lstStyle xmlns:a="http://schemas.openxmlformats.org/drawingml/2006/main"/>
           <a:p xmlns:a="http://schemas.openxmlformats.org/drawingml/2006/main">
             <a:pPr algn="l">
+              <a:buNone/>
               <a:defRPr sz="2025" b="1" i="0">
                 <a:solidFill>
                   <a:srgbClr val="111827"/>
@@ -9848,6 +9955,7 @@
           <a:lstStyle xmlns:a="http://schemas.openxmlformats.org/drawingml/2006/main"/>
           <a:p xmlns:a="http://schemas.openxmlformats.org/drawingml/2006/main">
             <a:pPr algn="l">
+              <a:buNone/>
               <a:defRPr sz="1500" b="0" i="0">
                 <a:solidFill>
                   <a:srgbClr val="667085"/>
@@ -9970,6 +10078,7 @@
           <a:lstStyle xmlns:a="http://schemas.openxmlformats.org/drawingml/2006/main"/>
           <a:p xmlns:a="http://schemas.openxmlformats.org/drawingml/2006/main">
             <a:pPr algn="ctr">
+              <a:buNone/>
               <a:defRPr sz="1050" b="1" i="0">
                 <a:solidFill>
                   <a:srgbClr val="17A673"/>
@@ -10026,6 +10135,7 @@
           <a:lstStyle xmlns:a="http://schemas.openxmlformats.org/drawingml/2006/main"/>
           <a:p xmlns:a="http://schemas.openxmlformats.org/drawingml/2006/main">
             <a:pPr algn="l">
+              <a:buNone/>
               <a:defRPr sz="2025" b="1" i="0">
                 <a:solidFill>
                   <a:srgbClr val="111827"/>
@@ -10082,6 +10192,7 @@
           <a:lstStyle xmlns:a="http://schemas.openxmlformats.org/drawingml/2006/main"/>
           <a:p xmlns:a="http://schemas.openxmlformats.org/drawingml/2006/main">
             <a:pPr algn="l">
+              <a:buNone/>
               <a:defRPr sz="1500" b="0" i="0">
                 <a:solidFill>
                   <a:srgbClr val="667085"/>
@@ -10171,6 +10282,7 @@
           <a:lstStyle xmlns:a="http://schemas.openxmlformats.org/drawingml/2006/main"/>
           <a:p xmlns:a="http://schemas.openxmlformats.org/drawingml/2006/main">
             <a:pPr algn="ctr">
+              <a:buNone/>
               <a:defRPr sz="1800" b="1" i="0">
                 <a:solidFill>
                   <a:srgbClr val="FFFFFF"/>
@@ -10258,6 +10370,7 @@
           <a:lstStyle xmlns:a="http://schemas.openxmlformats.org/drawingml/2006/main"/>
           <a:p xmlns:a="http://schemas.openxmlformats.org/drawingml/2006/main">
             <a:pPr algn="l">
+              <a:buNone/>
               <a:defRPr sz="975" b="0" i="0">
                 <a:solidFill>
                   <a:srgbClr val="98A2B3"/>
@@ -10314,6 +10427,7 @@
           <a:lstStyle xmlns:a="http://schemas.openxmlformats.org/drawingml/2006/main"/>
           <a:p xmlns:a="http://schemas.openxmlformats.org/drawingml/2006/main">
             <a:pPr algn="r">
+              <a:buNone/>
               <a:defRPr sz="975" b="0" i="0">
                 <a:solidFill>
                   <a:srgbClr val="98A2B3"/>
@@ -10399,6 +10513,7 @@
           <a:lstStyle xmlns:a="http://schemas.openxmlformats.org/drawingml/2006/main"/>
           <a:p xmlns:a="http://schemas.openxmlformats.org/drawingml/2006/main">
             <a:pPr algn="l">
+              <a:buNone/>
               <a:defRPr sz="1200" b="1" i="0">
                 <a:solidFill>
                   <a:srgbClr val="176BFF"/>
@@ -10455,6 +10570,7 @@
           <a:lstStyle xmlns:a="http://schemas.openxmlformats.org/drawingml/2006/main"/>
           <a:p xmlns:a="http://schemas.openxmlformats.org/drawingml/2006/main">
             <a:pPr algn="l">
+              <a:buNone/>
               <a:defRPr sz="3150" b="1" i="0">
                 <a:solidFill>
                   <a:srgbClr val="111827"/>
@@ -10544,6 +10660,7 @@
           <a:lstStyle xmlns:a="http://schemas.openxmlformats.org/drawingml/2006/main"/>
           <a:p xmlns:a="http://schemas.openxmlformats.org/drawingml/2006/main">
             <a:pPr algn="ctr">
+              <a:buNone/>
               <a:defRPr sz="2700" b="1" i="0">
                 <a:solidFill>
                   <a:srgbClr val="111827"/>
@@ -10600,6 +10717,7 @@
           <a:lstStyle xmlns:a="http://schemas.openxmlformats.org/drawingml/2006/main"/>
           <a:p xmlns:a="http://schemas.openxmlformats.org/drawingml/2006/main">
             <a:pPr algn="ctr">
+              <a:buNone/>
               <a:defRPr sz="1275" b="0" i="0">
                 <a:solidFill>
                   <a:srgbClr val="667085"/>
@@ -10689,6 +10807,7 @@
           <a:lstStyle xmlns:a="http://schemas.openxmlformats.org/drawingml/2006/main"/>
           <a:p xmlns:a="http://schemas.openxmlformats.org/drawingml/2006/main">
             <a:pPr algn="ctr">
+              <a:buNone/>
               <a:defRPr sz="2700" b="1" i="0">
                 <a:solidFill>
                   <a:srgbClr val="FFFFFF"/>
@@ -10745,6 +10864,7 @@
           <a:lstStyle xmlns:a="http://schemas.openxmlformats.org/drawingml/2006/main"/>
           <a:p xmlns:a="http://schemas.openxmlformats.org/drawingml/2006/main">
             <a:pPr algn="ctr">
+              <a:buNone/>
               <a:defRPr sz="1275" b="0" i="0">
                 <a:solidFill>
                   <a:srgbClr val="FFFFFF"/>
@@ -10834,6 +10954,7 @@
           <a:lstStyle xmlns:a="http://schemas.openxmlformats.org/drawingml/2006/main"/>
           <a:p xmlns:a="http://schemas.openxmlformats.org/drawingml/2006/main">
             <a:pPr algn="ctr">
+              <a:buNone/>
               <a:defRPr sz="2700" b="1" i="0">
                 <a:solidFill>
                   <a:srgbClr val="111827"/>
@@ -10890,6 +11011,7 @@
           <a:lstStyle xmlns:a="http://schemas.openxmlformats.org/drawingml/2006/main"/>
           <a:p xmlns:a="http://schemas.openxmlformats.org/drawingml/2006/main">
             <a:pPr algn="ctr">
+              <a:buNone/>
               <a:defRPr sz="1275" b="0" i="0">
                 <a:solidFill>
                   <a:srgbClr val="667085"/>
@@ -10946,6 +11068,7 @@
           <a:lstStyle xmlns:a="http://schemas.openxmlformats.org/drawingml/2006/main"/>
           <a:p xmlns:a="http://schemas.openxmlformats.org/drawingml/2006/main">
             <a:pPr algn="ctr">
+              <a:buNone/>
               <a:defRPr sz="1125" b="0" i="0">
                 <a:solidFill>
                   <a:srgbClr val="98A2B3"/>
@@ -11035,6 +11158,7 @@
           <a:lstStyle xmlns:a="http://schemas.openxmlformats.org/drawingml/2006/main"/>
           <a:p xmlns:a="http://schemas.openxmlformats.org/drawingml/2006/main">
             <a:pPr algn="l">
+              <a:buNone/>
               <a:defRPr sz="1950" b="1" i="0">
                 <a:solidFill>
                   <a:srgbClr val="176BFF"/>
@@ -11091,6 +11215,7 @@
           <a:lstStyle xmlns:a="http://schemas.openxmlformats.org/drawingml/2006/main"/>
           <a:p xmlns:a="http://schemas.openxmlformats.org/drawingml/2006/main">
             <a:pPr algn="l">
+              <a:buNone/>
               <a:defRPr sz="1500" b="0" i="0">
                 <a:solidFill>
                   <a:srgbClr val="111827"/>
@@ -11114,6 +11239,7 @@
           </a:p>
           <a:p xmlns:a="http://schemas.openxmlformats.org/drawingml/2006/main">
             <a:pPr algn="l">
+              <a:buNone/>
               <a:defRPr sz="1500" b="0" i="0">
                 <a:solidFill>
                   <a:srgbClr val="111827"/>
@@ -11137,6 +11263,7 @@
           </a:p>
           <a:p xmlns:a="http://schemas.openxmlformats.org/drawingml/2006/main">
             <a:pPr algn="l">
+              <a:buNone/>
               <a:defRPr sz="1500" b="0" i="0">
                 <a:solidFill>
                   <a:srgbClr val="111827"/>
@@ -11160,6 +11287,7 @@
           </a:p>
           <a:p xmlns:a="http://schemas.openxmlformats.org/drawingml/2006/main">
             <a:pPr algn="l">
+              <a:buNone/>
               <a:defRPr sz="1500" b="0" i="0">
                 <a:solidFill>
                   <a:srgbClr val="111827"/>
@@ -11249,6 +11377,7 @@
           <a:lstStyle xmlns:a="http://schemas.openxmlformats.org/drawingml/2006/main"/>
           <a:p xmlns:a="http://schemas.openxmlformats.org/drawingml/2006/main">
             <a:pPr algn="l">
+              <a:buNone/>
               <a:defRPr sz="1950" b="1" i="0">
                 <a:solidFill>
                   <a:srgbClr val="F79009"/>
@@ -11305,6 +11434,7 @@
           <a:lstStyle xmlns:a="http://schemas.openxmlformats.org/drawingml/2006/main"/>
           <a:p xmlns:a="http://schemas.openxmlformats.org/drawingml/2006/main">
             <a:pPr algn="l">
+              <a:buNone/>
               <a:defRPr sz="1650" b="1" i="0">
                 <a:solidFill>
                   <a:srgbClr val="111827"/>
@@ -11328,6 +11458,7 @@
           </a:p>
           <a:p xmlns:a="http://schemas.openxmlformats.org/drawingml/2006/main">
             <a:pPr algn="l">
+              <a:buNone/>
               <a:defRPr sz="1650" b="1" i="0">
                 <a:solidFill>
                   <a:srgbClr val="111827"/>
@@ -11351,6 +11482,7 @@
           </a:p>
           <a:p xmlns:a="http://schemas.openxmlformats.org/drawingml/2006/main">
             <a:pPr algn="l">
+              <a:buNone/>
               <a:defRPr sz="1650" b="1" i="0">
                 <a:solidFill>
                   <a:srgbClr val="111827"/>
@@ -11438,6 +11570,7 @@
           <a:lstStyle xmlns:a="http://schemas.openxmlformats.org/drawingml/2006/main"/>
           <a:p xmlns:a="http://schemas.openxmlformats.org/drawingml/2006/main">
             <a:pPr algn="l">
+              <a:buNone/>
               <a:defRPr sz="975" b="0" i="0">
                 <a:solidFill>
                   <a:srgbClr val="98A2B3"/>
@@ -11494,6 +11627,7 @@
           <a:lstStyle xmlns:a="http://schemas.openxmlformats.org/drawingml/2006/main"/>
           <a:p xmlns:a="http://schemas.openxmlformats.org/drawingml/2006/main">
             <a:pPr algn="r">
+              <a:buNone/>
               <a:defRPr sz="975" b="0" i="0">
                 <a:solidFill>
                   <a:srgbClr val="98A2B3"/>
@@ -11579,6 +11713,7 @@
           <a:lstStyle xmlns:a="http://schemas.openxmlformats.org/drawingml/2006/main"/>
           <a:p xmlns:a="http://schemas.openxmlformats.org/drawingml/2006/main">
             <a:pPr algn="l">
+              <a:buNone/>
               <a:defRPr sz="1200" b="1" i="0">
                 <a:solidFill>
                   <a:srgbClr val="176BFF"/>
@@ -11635,6 +11770,7 @@
           <a:lstStyle xmlns:a="http://schemas.openxmlformats.org/drawingml/2006/main"/>
           <a:p xmlns:a="http://schemas.openxmlformats.org/drawingml/2006/main">
             <a:pPr algn="l">
+              <a:buNone/>
               <a:defRPr sz="3150" b="1" i="0">
                 <a:solidFill>
                   <a:srgbClr val="111827"/>
@@ -11691,6 +11827,7 @@
           <a:lstStyle xmlns:a="http://schemas.openxmlformats.org/drawingml/2006/main"/>
           <a:p xmlns:a="http://schemas.openxmlformats.org/drawingml/2006/main">
             <a:pPr algn="l">
+              <a:buNone/>
               <a:defRPr sz="1500" b="0" i="0">
                 <a:solidFill>
                   <a:srgbClr val="667085"/>
@@ -11749,14 +11886,14 @@
       </p:sp>
       <p:pic>
         <p:nvPicPr>
-          <p:cNvPr id="32" name=""/>
+          <p:cNvPr id="34" name=""/>
           <p:cNvPicPr>
             <a:picLocks xmlns:a="http://schemas.openxmlformats.org/drawingml/2006/main" noChangeAspect="1"/>
           </p:cNvPicPr>
           <p:nvPr/>
         </p:nvPicPr>
         <p:blipFill>
-          <a:blip xmlns:r="http://schemas.openxmlformats.org/officeDocument/2006/relationships" xmlns:a="http://schemas.openxmlformats.org/drawingml/2006/main" r:embed="Re3c5de34acd54d09"/>
+          <a:blip xmlns:r="http://schemas.openxmlformats.org/officeDocument/2006/relationships" xmlns:a="http://schemas.openxmlformats.org/drawingml/2006/main" r:embed="R623b3a3d385042a7"/>
           <a:srcRect xmlns:a="http://schemas.openxmlformats.org/drawingml/2006/main" l="0" t="2671" r="0" b="2671"/>
           <a:stretch xmlns:a="http://schemas.openxmlformats.org/drawingml/2006/main">
             <a:fillRect l="0" t="0" r="0" b="0"/>
@@ -11840,6 +11977,7 @@
           <a:lstStyle xmlns:a="http://schemas.openxmlformats.org/drawingml/2006/main"/>
           <a:p xmlns:a="http://schemas.openxmlformats.org/drawingml/2006/main">
             <a:pPr algn="ctr">
+              <a:buNone/>
               <a:defRPr sz="1050" b="1" i="0">
                 <a:solidFill>
                   <a:srgbClr val="FFFFFF"/>
@@ -11896,6 +12034,7 @@
           <a:lstStyle xmlns:a="http://schemas.openxmlformats.org/drawingml/2006/main"/>
           <a:p xmlns:a="http://schemas.openxmlformats.org/drawingml/2006/main">
             <a:pPr algn="l">
+              <a:buNone/>
               <a:defRPr sz="1875" b="1" i="0">
                 <a:solidFill>
                   <a:srgbClr val="111827"/>
@@ -11985,6 +12124,7 @@
           <a:lstStyle xmlns:a="http://schemas.openxmlformats.org/drawingml/2006/main"/>
           <a:p xmlns:a="http://schemas.openxmlformats.org/drawingml/2006/main">
             <a:pPr algn="ctr">
+              <a:buNone/>
               <a:defRPr sz="1350" b="1" i="0">
                 <a:solidFill>
                   <a:srgbClr val="111827"/>
@@ -12074,6 +12214,7 @@
           <a:lstStyle xmlns:a="http://schemas.openxmlformats.org/drawingml/2006/main"/>
           <a:p xmlns:a="http://schemas.openxmlformats.org/drawingml/2006/main">
             <a:pPr algn="ctr">
+              <a:buNone/>
               <a:defRPr sz="1350" b="1" i="0">
                 <a:solidFill>
                   <a:srgbClr val="111827"/>
@@ -12163,6 +12304,7 @@
           <a:lstStyle xmlns:a="http://schemas.openxmlformats.org/drawingml/2006/main"/>
           <a:p xmlns:a="http://schemas.openxmlformats.org/drawingml/2006/main">
             <a:pPr algn="ctr">
+              <a:buNone/>
               <a:defRPr sz="1350" b="1" i="0">
                 <a:solidFill>
                   <a:srgbClr val="111827"/>
@@ -12252,6 +12394,7 @@
           <a:lstStyle xmlns:a="http://schemas.openxmlformats.org/drawingml/2006/main"/>
           <a:p xmlns:a="http://schemas.openxmlformats.org/drawingml/2006/main">
             <a:pPr algn="ctr">
+              <a:buNone/>
               <a:defRPr sz="1350" b="1" i="0">
                 <a:solidFill>
                   <a:srgbClr val="111827"/>
@@ -12341,6 +12484,7 @@
           <a:lstStyle xmlns:a="http://schemas.openxmlformats.org/drawingml/2006/main"/>
           <a:p xmlns:a="http://schemas.openxmlformats.org/drawingml/2006/main">
             <a:pPr algn="ctr">
+              <a:buNone/>
               <a:defRPr sz="1350" b="1" i="0">
                 <a:solidFill>
                   <a:srgbClr val="111827"/>
@@ -12430,6 +12574,7 @@
           <a:lstStyle xmlns:a="http://schemas.openxmlformats.org/drawingml/2006/main"/>
           <a:p xmlns:a="http://schemas.openxmlformats.org/drawingml/2006/main">
             <a:pPr algn="ctr">
+              <a:buNone/>
               <a:defRPr sz="1350" b="1" i="0">
                 <a:solidFill>
                   <a:srgbClr val="111827"/>
@@ -12519,6 +12664,7 @@
           <a:lstStyle xmlns:a="http://schemas.openxmlformats.org/drawingml/2006/main"/>
           <a:p xmlns:a="http://schemas.openxmlformats.org/drawingml/2006/main">
             <a:pPr algn="ctr">
+              <a:buNone/>
               <a:defRPr sz="1350" b="1" i="0">
                 <a:solidFill>
                   <a:srgbClr val="FFFFFF"/>
@@ -12608,6 +12754,7 @@
           <a:lstStyle xmlns:a="http://schemas.openxmlformats.org/drawingml/2006/main"/>
           <a:p xmlns:a="http://schemas.openxmlformats.org/drawingml/2006/main">
             <a:pPr algn="ctr">
+              <a:buNone/>
               <a:defRPr sz="1275" b="1" i="0">
                 <a:solidFill>
                   <a:srgbClr val="111827"/>
@@ -12695,6 +12842,7 @@
           <a:lstStyle xmlns:a="http://schemas.openxmlformats.org/drawingml/2006/main"/>
           <a:p xmlns:a="http://schemas.openxmlformats.org/drawingml/2006/main">
             <a:pPr algn="l">
+              <a:buNone/>
               <a:defRPr sz="975" b="0" i="0">
                 <a:solidFill>
                   <a:srgbClr val="98A2B3"/>
@@ -12751,6 +12899,7 @@
           <a:lstStyle xmlns:a="http://schemas.openxmlformats.org/drawingml/2006/main"/>
           <a:p xmlns:a="http://schemas.openxmlformats.org/drawingml/2006/main">
             <a:pPr algn="r">
+              <a:buNone/>
               <a:defRPr sz="975" b="0" i="0">
                 <a:solidFill>
                   <a:srgbClr val="98A2B3"/>
@@ -12836,6 +12985,7 @@
           <a:lstStyle xmlns:a="http://schemas.openxmlformats.org/drawingml/2006/main"/>
           <a:p xmlns:a="http://schemas.openxmlformats.org/drawingml/2006/main">
             <a:pPr algn="l">
+              <a:buNone/>
               <a:defRPr sz="1200" b="1" i="0">
                 <a:solidFill>
                   <a:srgbClr val="176BFF"/>
@@ -12892,6 +13042,7 @@
           <a:lstStyle xmlns:a="http://schemas.openxmlformats.org/drawingml/2006/main"/>
           <a:p xmlns:a="http://schemas.openxmlformats.org/drawingml/2006/main">
             <a:pPr algn="l">
+              <a:buNone/>
               <a:defRPr sz="3150" b="1" i="0">
                 <a:solidFill>
                   <a:srgbClr val="111827"/>
@@ -12948,6 +13099,7 @@
           <a:lstStyle xmlns:a="http://schemas.openxmlformats.org/drawingml/2006/main"/>
           <a:p xmlns:a="http://schemas.openxmlformats.org/drawingml/2006/main">
             <a:pPr algn="l">
+              <a:buNone/>
               <a:defRPr sz="1500" b="0" i="0">
                 <a:solidFill>
                   <a:srgbClr val="667085"/>
@@ -13066,6 +13218,7 @@
           <a:lstStyle xmlns:a="http://schemas.openxmlformats.org/drawingml/2006/main"/>
           <a:p xmlns:a="http://schemas.openxmlformats.org/drawingml/2006/main">
             <a:pPr algn="ctr">
+              <a:buNone/>
               <a:defRPr sz="2100" b="1" i="0">
                 <a:solidFill>
                   <a:srgbClr val="FFFFFF"/>
@@ -13122,6 +13275,7 @@
           <a:lstStyle xmlns:a="http://schemas.openxmlformats.org/drawingml/2006/main"/>
           <a:p xmlns:a="http://schemas.openxmlformats.org/drawingml/2006/main">
             <a:pPr algn="ctr">
+              <a:buNone/>
               <a:defRPr sz="1875" b="1" i="0">
                 <a:solidFill>
                   <a:srgbClr val="111827"/>
@@ -13178,6 +13332,7 @@
           <a:lstStyle xmlns:a="http://schemas.openxmlformats.org/drawingml/2006/main"/>
           <a:p xmlns:a="http://schemas.openxmlformats.org/drawingml/2006/main">
             <a:pPr algn="ctr">
+              <a:buNone/>
               <a:defRPr sz="1425" b="0" i="0">
                 <a:solidFill>
                   <a:srgbClr val="667085"/>
@@ -13201,6 +13356,7 @@
           </a:p>
           <a:p xmlns:a="http://schemas.openxmlformats.org/drawingml/2006/main">
             <a:pPr algn="ctr">
+              <a:buNone/>
               <a:defRPr sz="1425" b="0" i="0">
                 <a:solidFill>
                   <a:srgbClr val="667085"/>
@@ -13288,6 +13444,7 @@
           <a:lstStyle xmlns:a="http://schemas.openxmlformats.org/drawingml/2006/main"/>
           <a:p xmlns:a="http://schemas.openxmlformats.org/drawingml/2006/main">
             <a:pPr algn="ctr">
+              <a:buNone/>
               <a:defRPr sz="2100" b="1" i="0">
                 <a:solidFill>
                   <a:srgbClr val="FFFFFF"/>
@@ -13344,6 +13501,7 @@
           <a:lstStyle xmlns:a="http://schemas.openxmlformats.org/drawingml/2006/main"/>
           <a:p xmlns:a="http://schemas.openxmlformats.org/drawingml/2006/main">
             <a:pPr algn="ctr">
+              <a:buNone/>
               <a:defRPr sz="1875" b="1" i="0">
                 <a:solidFill>
                   <a:srgbClr val="111827"/>
@@ -13400,6 +13558,7 @@
           <a:lstStyle xmlns:a="http://schemas.openxmlformats.org/drawingml/2006/main"/>
           <a:p xmlns:a="http://schemas.openxmlformats.org/drawingml/2006/main">
             <a:pPr algn="ctr">
+              <a:buNone/>
               <a:defRPr sz="1425" b="0" i="0">
                 <a:solidFill>
                   <a:srgbClr val="667085"/>
@@ -13423,6 +13582,7 @@
           </a:p>
           <a:p xmlns:a="http://schemas.openxmlformats.org/drawingml/2006/main">
             <a:pPr algn="ctr">
+              <a:buNone/>
               <a:defRPr sz="1425" b="0" i="0">
                 <a:solidFill>
                   <a:srgbClr val="667085"/>
@@ -13510,6 +13670,7 @@
           <a:lstStyle xmlns:a="http://schemas.openxmlformats.org/drawingml/2006/main"/>
           <a:p xmlns:a="http://schemas.openxmlformats.org/drawingml/2006/main">
             <a:pPr algn="ctr">
+              <a:buNone/>
               <a:defRPr sz="2100" b="1" i="0">
                 <a:solidFill>
                   <a:srgbClr val="FFFFFF"/>
@@ -13566,6 +13727,7 @@
           <a:lstStyle xmlns:a="http://schemas.openxmlformats.org/drawingml/2006/main"/>
           <a:p xmlns:a="http://schemas.openxmlformats.org/drawingml/2006/main">
             <a:pPr algn="ctr">
+              <a:buNone/>
               <a:defRPr sz="1875" b="1" i="0">
                 <a:solidFill>
                   <a:srgbClr val="111827"/>
@@ -13622,6 +13784,7 @@
           <a:lstStyle xmlns:a="http://schemas.openxmlformats.org/drawingml/2006/main"/>
           <a:p xmlns:a="http://schemas.openxmlformats.org/drawingml/2006/main">
             <a:pPr algn="ctr">
+              <a:buNone/>
               <a:defRPr sz="1425" b="0" i="0">
                 <a:solidFill>
                   <a:srgbClr val="667085"/>
@@ -13645,6 +13808,7 @@
           </a:p>
           <a:p xmlns:a="http://schemas.openxmlformats.org/drawingml/2006/main">
             <a:pPr algn="ctr">
+              <a:buNone/>
               <a:defRPr sz="1425" b="0" i="0">
                 <a:solidFill>
                   <a:srgbClr val="667085"/>
@@ -13732,6 +13896,7 @@
           <a:lstStyle xmlns:a="http://schemas.openxmlformats.org/drawingml/2006/main"/>
           <a:p xmlns:a="http://schemas.openxmlformats.org/drawingml/2006/main">
             <a:pPr algn="ctr">
+              <a:buNone/>
               <a:defRPr sz="2100" b="1" i="0">
                 <a:solidFill>
                   <a:srgbClr val="FFFFFF"/>
@@ -13788,6 +13953,7 @@
           <a:lstStyle xmlns:a="http://schemas.openxmlformats.org/drawingml/2006/main"/>
           <a:p xmlns:a="http://schemas.openxmlformats.org/drawingml/2006/main">
             <a:pPr algn="ctr">
+              <a:buNone/>
               <a:defRPr sz="1875" b="1" i="0">
                 <a:solidFill>
                   <a:srgbClr val="111827"/>
@@ -13844,6 +14010,7 @@
           <a:lstStyle xmlns:a="http://schemas.openxmlformats.org/drawingml/2006/main"/>
           <a:p xmlns:a="http://schemas.openxmlformats.org/drawingml/2006/main">
             <a:pPr algn="ctr">
+              <a:buNone/>
               <a:defRPr sz="1425" b="0" i="0">
                 <a:solidFill>
                   <a:srgbClr val="667085"/>
@@ -13867,6 +14034,7 @@
           </a:p>
           <a:p xmlns:a="http://schemas.openxmlformats.org/drawingml/2006/main">
             <a:pPr algn="ctr">
+              <a:buNone/>
               <a:defRPr sz="1425" b="0" i="0">
                 <a:solidFill>
                   <a:srgbClr val="667085"/>
@@ -13956,6 +14124,7 @@
           <a:lstStyle xmlns:a="http://schemas.openxmlformats.org/drawingml/2006/main"/>
           <a:p xmlns:a="http://schemas.openxmlformats.org/drawingml/2006/main">
             <a:pPr algn="ctr">
+              <a:buNone/>
               <a:defRPr sz="2025" b="1" i="0">
                 <a:solidFill>
                   <a:srgbClr val="FFFFFF"/>
@@ -14043,6 +14212,7 @@
           <a:lstStyle xmlns:a="http://schemas.openxmlformats.org/drawingml/2006/main"/>
           <a:p xmlns:a="http://schemas.openxmlformats.org/drawingml/2006/main">
             <a:pPr algn="l">
+              <a:buNone/>
               <a:defRPr sz="975" b="0" i="0">
                 <a:solidFill>
                   <a:srgbClr val="98A2B3"/>
@@ -14099,6 +14269,7 @@
           <a:lstStyle xmlns:a="http://schemas.openxmlformats.org/drawingml/2006/main"/>
           <a:p xmlns:a="http://schemas.openxmlformats.org/drawingml/2006/main">
             <a:pPr algn="r">
+              <a:buNone/>
               <a:defRPr sz="975" b="0" i="0">
                 <a:solidFill>
                   <a:srgbClr val="98A2B3"/>
@@ -14184,6 +14355,7 @@
           <a:lstStyle xmlns:a="http://schemas.openxmlformats.org/drawingml/2006/main"/>
           <a:p xmlns:a="http://schemas.openxmlformats.org/drawingml/2006/main">
             <a:pPr algn="l">
+              <a:buNone/>
               <a:defRPr sz="1200" b="1" i="0">
                 <a:solidFill>
                   <a:srgbClr val="176BFF"/>
@@ -14240,6 +14412,7 @@
           <a:lstStyle xmlns:a="http://schemas.openxmlformats.org/drawingml/2006/main"/>
           <a:p xmlns:a="http://schemas.openxmlformats.org/drawingml/2006/main">
             <a:pPr algn="l">
+              <a:buNone/>
               <a:defRPr sz="3150" b="1" i="0">
                 <a:solidFill>
                   <a:srgbClr val="111827"/>
@@ -14296,6 +14469,7 @@
           <a:lstStyle xmlns:a="http://schemas.openxmlformats.org/drawingml/2006/main"/>
           <a:p xmlns:a="http://schemas.openxmlformats.org/drawingml/2006/main">
             <a:pPr algn="l">
+              <a:buNone/>
               <a:defRPr sz="1500" b="0" i="0">
                 <a:solidFill>
                   <a:srgbClr val="667085"/>
@@ -14509,6 +14683,7 @@
           <a:lstStyle xmlns:a="http://schemas.openxmlformats.org/drawingml/2006/main"/>
           <a:p xmlns:a="http://schemas.openxmlformats.org/drawingml/2006/main">
             <a:pPr algn="l">
+              <a:buNone/>
               <a:defRPr sz="1125" b="1" i="0">
                 <a:solidFill>
                   <a:srgbClr val="176BFF"/>
@@ -14565,6 +14740,7 @@
           <a:lstStyle xmlns:a="http://schemas.openxmlformats.org/drawingml/2006/main"/>
           <a:p xmlns:a="http://schemas.openxmlformats.org/drawingml/2006/main">
             <a:pPr algn="ctr">
+              <a:buNone/>
               <a:defRPr sz="1650" b="1" i="0">
                 <a:solidFill>
                   <a:srgbClr val="111827"/>
@@ -14621,6 +14797,7 @@
           <a:lstStyle xmlns:a="http://schemas.openxmlformats.org/drawingml/2006/main"/>
           <a:p xmlns:a="http://schemas.openxmlformats.org/drawingml/2006/main">
             <a:pPr algn="ctr">
+              <a:buNone/>
               <a:defRPr sz="1200" b="0" i="0">
                 <a:solidFill>
                   <a:srgbClr val="667085"/>
@@ -14710,6 +14887,7 @@
           <a:lstStyle xmlns:a="http://schemas.openxmlformats.org/drawingml/2006/main"/>
           <a:p xmlns:a="http://schemas.openxmlformats.org/drawingml/2006/main">
             <a:pPr algn="l">
+              <a:buNone/>
               <a:defRPr sz="1125" b="1" i="0">
                 <a:solidFill>
                   <a:srgbClr val="176BFF"/>
@@ -14766,6 +14944,7 @@
           <a:lstStyle xmlns:a="http://schemas.openxmlformats.org/drawingml/2006/main"/>
           <a:p xmlns:a="http://schemas.openxmlformats.org/drawingml/2006/main">
             <a:pPr algn="ctr">
+              <a:buNone/>
               <a:defRPr sz="1650" b="1" i="0">
                 <a:solidFill>
                   <a:srgbClr val="111827"/>
@@ -14822,6 +15001,7 @@
           <a:lstStyle xmlns:a="http://schemas.openxmlformats.org/drawingml/2006/main"/>
           <a:p xmlns:a="http://schemas.openxmlformats.org/drawingml/2006/main">
             <a:pPr algn="ctr">
+              <a:buNone/>
               <a:defRPr sz="1200" b="0" i="0">
                 <a:solidFill>
                   <a:srgbClr val="667085"/>
@@ -14911,6 +15091,7 @@
           <a:lstStyle xmlns:a="http://schemas.openxmlformats.org/drawingml/2006/main"/>
           <a:p xmlns:a="http://schemas.openxmlformats.org/drawingml/2006/main">
             <a:pPr algn="l">
+              <a:buNone/>
               <a:defRPr sz="1125" b="1" i="0">
                 <a:solidFill>
                   <a:srgbClr val="FFFFFF"/>
@@ -14967,6 +15148,7 @@
           <a:lstStyle xmlns:a="http://schemas.openxmlformats.org/drawingml/2006/main"/>
           <a:p xmlns:a="http://schemas.openxmlformats.org/drawingml/2006/main">
             <a:pPr algn="ctr">
+              <a:buNone/>
               <a:defRPr sz="1650" b="1" i="0">
                 <a:solidFill>
                   <a:srgbClr val="FFFFFF"/>
@@ -15023,6 +15205,7 @@
           <a:lstStyle xmlns:a="http://schemas.openxmlformats.org/drawingml/2006/main"/>
           <a:p xmlns:a="http://schemas.openxmlformats.org/drawingml/2006/main">
             <a:pPr algn="ctr">
+              <a:buNone/>
               <a:defRPr sz="1200" b="0" i="0">
                 <a:solidFill>
                   <a:srgbClr val="FFFFFF"/>
@@ -15112,6 +15295,7 @@
           <a:lstStyle xmlns:a="http://schemas.openxmlformats.org/drawingml/2006/main"/>
           <a:p xmlns:a="http://schemas.openxmlformats.org/drawingml/2006/main">
             <a:pPr algn="l">
+              <a:buNone/>
               <a:defRPr sz="1125" b="1" i="0">
                 <a:solidFill>
                   <a:srgbClr val="176BFF"/>
@@ -15168,6 +15352,7 @@
           <a:lstStyle xmlns:a="http://schemas.openxmlformats.org/drawingml/2006/main"/>
           <a:p xmlns:a="http://schemas.openxmlformats.org/drawingml/2006/main">
             <a:pPr algn="ctr">
+              <a:buNone/>
               <a:defRPr sz="1650" b="1" i="0">
                 <a:solidFill>
                   <a:srgbClr val="111827"/>
@@ -15224,6 +15409,7 @@
           <a:lstStyle xmlns:a="http://schemas.openxmlformats.org/drawingml/2006/main"/>
           <a:p xmlns:a="http://schemas.openxmlformats.org/drawingml/2006/main">
             <a:pPr algn="ctr">
+              <a:buNone/>
               <a:defRPr sz="1200" b="0" i="0">
                 <a:solidFill>
                   <a:srgbClr val="667085"/>
@@ -15313,6 +15499,7 @@
           <a:lstStyle xmlns:a="http://schemas.openxmlformats.org/drawingml/2006/main"/>
           <a:p xmlns:a="http://schemas.openxmlformats.org/drawingml/2006/main">
             <a:pPr algn="l">
+              <a:buNone/>
               <a:defRPr sz="1125" b="1" i="0">
                 <a:solidFill>
                   <a:srgbClr val="176BFF"/>
@@ -15369,6 +15556,7 @@
           <a:lstStyle xmlns:a="http://schemas.openxmlformats.org/drawingml/2006/main"/>
           <a:p xmlns:a="http://schemas.openxmlformats.org/drawingml/2006/main">
             <a:pPr algn="ctr">
+              <a:buNone/>
               <a:defRPr sz="1650" b="1" i="0">
                 <a:solidFill>
                   <a:srgbClr val="111827"/>
@@ -15425,6 +15613,7 @@
           <a:lstStyle xmlns:a="http://schemas.openxmlformats.org/drawingml/2006/main"/>
           <a:p xmlns:a="http://schemas.openxmlformats.org/drawingml/2006/main">
             <a:pPr algn="ctr">
+              <a:buNone/>
               <a:defRPr sz="1200" b="0" i="0">
                 <a:solidFill>
                   <a:srgbClr val="667085"/>
@@ -15547,6 +15736,7 @@
           <a:lstStyle xmlns:a="http://schemas.openxmlformats.org/drawingml/2006/main"/>
           <a:p xmlns:a="http://schemas.openxmlformats.org/drawingml/2006/main">
             <a:pPr algn="ctr">
+              <a:buNone/>
               <a:defRPr sz="1200" b="1" i="0">
                 <a:solidFill>
                   <a:srgbClr val="FFFFFF"/>
@@ -15603,6 +15793,7 @@
           <a:lstStyle xmlns:a="http://schemas.openxmlformats.org/drawingml/2006/main"/>
           <a:p xmlns:a="http://schemas.openxmlformats.org/drawingml/2006/main">
             <a:pPr algn="l">
+              <a:buNone/>
               <a:defRPr sz="1575" b="1" i="0">
                 <a:solidFill>
                   <a:srgbClr val="111827"/>
@@ -15659,6 +15850,7 @@
           <a:lstStyle xmlns:a="http://schemas.openxmlformats.org/drawingml/2006/main"/>
           <a:p xmlns:a="http://schemas.openxmlformats.org/drawingml/2006/main">
             <a:pPr algn="l">
+              <a:buNone/>
               <a:defRPr sz="1200" b="0" i="0">
                 <a:solidFill>
                   <a:srgbClr val="667085"/>
@@ -15781,6 +15973,7 @@
           <a:lstStyle xmlns:a="http://schemas.openxmlformats.org/drawingml/2006/main"/>
           <a:p xmlns:a="http://schemas.openxmlformats.org/drawingml/2006/main">
             <a:pPr algn="ctr">
+              <a:buNone/>
               <a:defRPr sz="1200" b="1" i="0">
                 <a:solidFill>
                   <a:srgbClr val="FFFFFF"/>
@@ -15837,6 +16030,7 @@
           <a:lstStyle xmlns:a="http://schemas.openxmlformats.org/drawingml/2006/main"/>
           <a:p xmlns:a="http://schemas.openxmlformats.org/drawingml/2006/main">
             <a:pPr algn="l">
+              <a:buNone/>
               <a:defRPr sz="1575" b="1" i="0">
                 <a:solidFill>
                   <a:srgbClr val="111827"/>
@@ -15893,6 +16087,7 @@
           <a:lstStyle xmlns:a="http://schemas.openxmlformats.org/drawingml/2006/main"/>
           <a:p xmlns:a="http://schemas.openxmlformats.org/drawingml/2006/main">
             <a:pPr algn="l">
+              <a:buNone/>
               <a:defRPr sz="1200" b="0" i="0">
                 <a:solidFill>
                   <a:srgbClr val="667085"/>
@@ -16015,6 +16210,7 @@
           <a:lstStyle xmlns:a="http://schemas.openxmlformats.org/drawingml/2006/main"/>
           <a:p xmlns:a="http://schemas.openxmlformats.org/drawingml/2006/main">
             <a:pPr algn="ctr">
+              <a:buNone/>
               <a:defRPr sz="1200" b="1" i="0">
                 <a:solidFill>
                   <a:srgbClr val="FFFFFF"/>
@@ -16071,6 +16267,7 @@
           <a:lstStyle xmlns:a="http://schemas.openxmlformats.org/drawingml/2006/main"/>
           <a:p xmlns:a="http://schemas.openxmlformats.org/drawingml/2006/main">
             <a:pPr algn="l">
+              <a:buNone/>
               <a:defRPr sz="1575" b="1" i="0">
                 <a:solidFill>
                   <a:srgbClr val="111827"/>
@@ -16127,6 +16324,7 @@
           <a:lstStyle xmlns:a="http://schemas.openxmlformats.org/drawingml/2006/main"/>
           <a:p xmlns:a="http://schemas.openxmlformats.org/drawingml/2006/main">
             <a:pPr algn="l">
+              <a:buNone/>
               <a:defRPr sz="1200" b="0" i="0">
                 <a:solidFill>
                   <a:srgbClr val="667085"/>
@@ -16216,6 +16414,7 @@
           <a:lstStyle xmlns:a="http://schemas.openxmlformats.org/drawingml/2006/main"/>
           <a:p xmlns:a="http://schemas.openxmlformats.org/drawingml/2006/main">
             <a:pPr algn="ctr">
+              <a:buNone/>
               <a:defRPr sz="1050" b="1" i="0">
                 <a:solidFill>
                   <a:srgbClr val="E5484D"/>
@@ -16303,6 +16502,7 @@
           <a:lstStyle xmlns:a="http://schemas.openxmlformats.org/drawingml/2006/main"/>
           <a:p xmlns:a="http://schemas.openxmlformats.org/drawingml/2006/main">
             <a:pPr algn="l">
+              <a:buNone/>
               <a:defRPr sz="975" b="0" i="0">
                 <a:solidFill>
                   <a:srgbClr val="98A2B3"/>
@@ -16359,6 +16559,7 @@
           <a:lstStyle xmlns:a="http://schemas.openxmlformats.org/drawingml/2006/main"/>
           <a:p xmlns:a="http://schemas.openxmlformats.org/drawingml/2006/main">
             <a:pPr algn="r">
+              <a:buNone/>
               <a:defRPr sz="975" b="0" i="0">
                 <a:solidFill>
                   <a:srgbClr val="98A2B3"/>
@@ -16444,6 +16645,7 @@
           <a:lstStyle xmlns:a="http://schemas.openxmlformats.org/drawingml/2006/main"/>
           <a:p xmlns:a="http://schemas.openxmlformats.org/drawingml/2006/main">
             <a:pPr algn="l">
+              <a:buNone/>
               <a:defRPr sz="1200" b="1" i="0">
                 <a:solidFill>
                   <a:srgbClr val="176BFF"/>
@@ -16500,6 +16702,7 @@
           <a:lstStyle xmlns:a="http://schemas.openxmlformats.org/drawingml/2006/main"/>
           <a:p xmlns:a="http://schemas.openxmlformats.org/drawingml/2006/main">
             <a:pPr algn="l">
+              <a:buNone/>
               <a:defRPr sz="3150" b="1" i="0">
                 <a:solidFill>
                   <a:srgbClr val="111827"/>
@@ -16556,6 +16759,7 @@
           <a:lstStyle xmlns:a="http://schemas.openxmlformats.org/drawingml/2006/main"/>
           <a:p xmlns:a="http://schemas.openxmlformats.org/drawingml/2006/main">
             <a:pPr algn="l">
+              <a:buNone/>
               <a:defRPr sz="1500" b="0" i="0">
                 <a:solidFill>
                   <a:srgbClr val="667085"/>
@@ -16643,6 +16847,7 @@
           <a:lstStyle xmlns:a="http://schemas.openxmlformats.org/drawingml/2006/main"/>
           <a:p xmlns:a="http://schemas.openxmlformats.org/drawingml/2006/main">
             <a:pPr algn="ctr">
+              <a:buNone/>
               <a:defRPr sz="2025" b="1" i="0">
                 <a:solidFill>
                   <a:srgbClr val="176BFF"/>
@@ -16730,6 +16935,7 @@
           <a:lstStyle xmlns:a="http://schemas.openxmlformats.org/drawingml/2006/main"/>
           <a:p xmlns:a="http://schemas.openxmlformats.org/drawingml/2006/main">
             <a:pPr algn="ctr">
+              <a:buNone/>
               <a:defRPr sz="2025" b="1" i="0">
                 <a:solidFill>
                   <a:srgbClr val="176BFF"/>
@@ -16817,6 +17023,7 @@
           <a:lstStyle xmlns:a="http://schemas.openxmlformats.org/drawingml/2006/main"/>
           <a:p xmlns:a="http://schemas.openxmlformats.org/drawingml/2006/main">
             <a:pPr algn="ctr">
+              <a:buNone/>
               <a:defRPr sz="2025" b="1" i="0">
                 <a:solidFill>
                   <a:srgbClr val="176BFF"/>
@@ -16904,6 +17111,7 @@
           <a:lstStyle xmlns:a="http://schemas.openxmlformats.org/drawingml/2006/main"/>
           <a:p xmlns:a="http://schemas.openxmlformats.org/drawingml/2006/main">
             <a:pPr algn="ctr">
+              <a:buNone/>
               <a:defRPr sz="2025" b="1" i="0">
                 <a:solidFill>
                   <a:srgbClr val="176BFF"/>
@@ -16993,6 +17201,7 @@
           <a:lstStyle xmlns:a="http://schemas.openxmlformats.org/drawingml/2006/main"/>
           <a:p xmlns:a="http://schemas.openxmlformats.org/drawingml/2006/main">
             <a:pPr algn="ctr">
+              <a:buNone/>
               <a:defRPr sz="1725" b="1" i="0">
                 <a:solidFill>
                   <a:srgbClr val="FFFFFF"/>
@@ -17049,6 +17258,7 @@
           <a:lstStyle xmlns:a="http://schemas.openxmlformats.org/drawingml/2006/main"/>
           <a:p xmlns:a="http://schemas.openxmlformats.org/drawingml/2006/main">
             <a:pPr algn="ctr">
+              <a:buNone/>
               <a:defRPr sz="1275" b="0" i="0">
                 <a:solidFill>
                   <a:srgbClr val="FFFFFF"/>
@@ -17138,6 +17348,7 @@
           <a:lstStyle xmlns:a="http://schemas.openxmlformats.org/drawingml/2006/main"/>
           <a:p xmlns:a="http://schemas.openxmlformats.org/drawingml/2006/main">
             <a:pPr algn="ctr">
+              <a:buNone/>
               <a:defRPr sz="1725" b="1" i="0">
                 <a:solidFill>
                   <a:srgbClr val="111827"/>
@@ -17194,6 +17405,7 @@
           <a:lstStyle xmlns:a="http://schemas.openxmlformats.org/drawingml/2006/main"/>
           <a:p xmlns:a="http://schemas.openxmlformats.org/drawingml/2006/main">
             <a:pPr algn="ctr">
+              <a:buNone/>
               <a:defRPr sz="1275" b="0" i="0">
                 <a:solidFill>
                   <a:srgbClr val="667085"/>
@@ -17283,6 +17495,7 @@
           <a:lstStyle xmlns:a="http://schemas.openxmlformats.org/drawingml/2006/main"/>
           <a:p xmlns:a="http://schemas.openxmlformats.org/drawingml/2006/main">
             <a:pPr algn="ctr">
+              <a:buNone/>
               <a:defRPr sz="1725" b="1" i="0">
                 <a:solidFill>
                   <a:srgbClr val="111827"/>
@@ -17339,6 +17552,7 @@
           <a:lstStyle xmlns:a="http://schemas.openxmlformats.org/drawingml/2006/main"/>
           <a:p xmlns:a="http://schemas.openxmlformats.org/drawingml/2006/main">
             <a:pPr algn="ctr">
+              <a:buNone/>
               <a:defRPr sz="1275" b="0" i="0">
                 <a:solidFill>
                   <a:srgbClr val="667085"/>
@@ -17428,6 +17642,7 @@
           <a:lstStyle xmlns:a="http://schemas.openxmlformats.org/drawingml/2006/main"/>
           <a:p xmlns:a="http://schemas.openxmlformats.org/drawingml/2006/main">
             <a:pPr algn="ctr">
+              <a:buNone/>
               <a:defRPr sz="1725" b="1" i="0">
                 <a:solidFill>
                   <a:srgbClr val="FFFFFF"/>
@@ -17484,6 +17699,7 @@
           <a:lstStyle xmlns:a="http://schemas.openxmlformats.org/drawingml/2006/main"/>
           <a:p xmlns:a="http://schemas.openxmlformats.org/drawingml/2006/main">
             <a:pPr algn="ctr">
+              <a:buNone/>
               <a:defRPr sz="1275" b="0" i="0">
                 <a:solidFill>
                   <a:srgbClr val="FFFFFF"/>
@@ -17573,6 +17789,7 @@
           <a:lstStyle xmlns:a="http://schemas.openxmlformats.org/drawingml/2006/main"/>
           <a:p xmlns:a="http://schemas.openxmlformats.org/drawingml/2006/main">
             <a:pPr algn="ctr">
+              <a:buNone/>
               <a:defRPr sz="1725" b="1" i="0">
                 <a:solidFill>
                   <a:srgbClr val="111827"/>
@@ -17629,6 +17846,7 @@
           <a:lstStyle xmlns:a="http://schemas.openxmlformats.org/drawingml/2006/main"/>
           <a:p xmlns:a="http://schemas.openxmlformats.org/drawingml/2006/main">
             <a:pPr algn="ctr">
+              <a:buNone/>
               <a:defRPr sz="1275" b="0" i="0">
                 <a:solidFill>
                   <a:srgbClr val="667085"/>
@@ -17718,6 +17936,7 @@
           <a:lstStyle xmlns:a="http://schemas.openxmlformats.org/drawingml/2006/main"/>
           <a:p xmlns:a="http://schemas.openxmlformats.org/drawingml/2006/main">
             <a:pPr algn="ctr">
+              <a:buNone/>
               <a:defRPr sz="2025" b="1" i="0">
                 <a:solidFill>
                   <a:srgbClr val="F79009"/>
@@ -17774,6 +17993,7 @@
           <a:lstStyle xmlns:a="http://schemas.openxmlformats.org/drawingml/2006/main"/>
           <a:p xmlns:a="http://schemas.openxmlformats.org/drawingml/2006/main">
             <a:pPr algn="ctr">
+              <a:buNone/>
               <a:defRPr sz="1650" b="0" i="0">
                 <a:solidFill>
                   <a:srgbClr val="111827"/>
@@ -17861,6 +18081,7 @@
           <a:lstStyle xmlns:a="http://schemas.openxmlformats.org/drawingml/2006/main"/>
           <a:p xmlns:a="http://schemas.openxmlformats.org/drawingml/2006/main">
             <a:pPr algn="l">
+              <a:buNone/>
               <a:defRPr sz="975" b="0" i="0">
                 <a:solidFill>
                   <a:srgbClr val="98A2B3"/>
@@ -17917,6 +18138,7 @@
           <a:lstStyle xmlns:a="http://schemas.openxmlformats.org/drawingml/2006/main"/>
           <a:p xmlns:a="http://schemas.openxmlformats.org/drawingml/2006/main">
             <a:pPr algn="r">
+              <a:buNone/>
               <a:defRPr sz="975" b="0" i="0">
                 <a:solidFill>
                   <a:srgbClr val="98A2B3"/>
@@ -18002,6 +18224,7 @@
           <a:lstStyle xmlns:a="http://schemas.openxmlformats.org/drawingml/2006/main"/>
           <a:p xmlns:a="http://schemas.openxmlformats.org/drawingml/2006/main">
             <a:pPr algn="l">
+              <a:buNone/>
               <a:defRPr sz="1200" b="1" i="0">
                 <a:solidFill>
                   <a:srgbClr val="176BFF"/>
@@ -18058,6 +18281,7 @@
           <a:lstStyle xmlns:a="http://schemas.openxmlformats.org/drawingml/2006/main"/>
           <a:p xmlns:a="http://schemas.openxmlformats.org/drawingml/2006/main">
             <a:pPr algn="l">
+              <a:buNone/>
               <a:defRPr sz="3150" b="1" i="0">
                 <a:solidFill>
                   <a:srgbClr val="111827"/>
@@ -18271,6 +18495,7 @@
           <a:lstStyle xmlns:a="http://schemas.openxmlformats.org/drawingml/2006/main"/>
           <a:p xmlns:a="http://schemas.openxmlformats.org/drawingml/2006/main">
             <a:pPr algn="l">
+              <a:buNone/>
               <a:defRPr sz="1200" b="1" i="0">
                 <a:solidFill>
                   <a:srgbClr val="667085"/>
@@ -18327,6 +18552,7 @@
           <a:lstStyle xmlns:a="http://schemas.openxmlformats.org/drawingml/2006/main"/>
           <a:p xmlns:a="http://schemas.openxmlformats.org/drawingml/2006/main">
             <a:pPr algn="l">
+              <a:buNone/>
               <a:defRPr sz="1200" b="1" i="0">
                 <a:solidFill>
                   <a:srgbClr val="667085"/>
@@ -18414,6 +18640,7 @@
           <a:lstStyle xmlns:a="http://schemas.openxmlformats.org/drawingml/2006/main"/>
           <a:p xmlns:a="http://schemas.openxmlformats.org/drawingml/2006/main">
             <a:pPr algn="ctr">
+              <a:buNone/>
               <a:defRPr sz="1200" b="0" i="0">
                 <a:solidFill>
                   <a:srgbClr val="667085"/>
@@ -18501,6 +18728,7 @@
           <a:lstStyle xmlns:a="http://schemas.openxmlformats.org/drawingml/2006/main"/>
           <a:p xmlns:a="http://schemas.openxmlformats.org/drawingml/2006/main">
             <a:pPr algn="ctr">
+              <a:buNone/>
               <a:defRPr sz="1200" b="0" i="0">
                 <a:solidFill>
                   <a:srgbClr val="667085"/>
@@ -18588,6 +18816,7 @@
           <a:lstStyle xmlns:a="http://schemas.openxmlformats.org/drawingml/2006/main"/>
           <a:p xmlns:a="http://schemas.openxmlformats.org/drawingml/2006/main">
             <a:pPr algn="ctr">
+              <a:buNone/>
               <a:defRPr sz="1200" b="0" i="0">
                 <a:solidFill>
                   <a:srgbClr val="667085"/>
@@ -18675,6 +18904,7 @@
           <a:lstStyle xmlns:a="http://schemas.openxmlformats.org/drawingml/2006/main"/>
           <a:p xmlns:a="http://schemas.openxmlformats.org/drawingml/2006/main">
             <a:pPr algn="ctr">
+              <a:buNone/>
               <a:defRPr sz="1425" b="1" i="0">
                 <a:solidFill>
                   <a:srgbClr val="176BFF"/>
@@ -18764,6 +18994,7 @@
           <a:lstStyle xmlns:a="http://schemas.openxmlformats.org/drawingml/2006/main"/>
           <a:p xmlns:a="http://schemas.openxmlformats.org/drawingml/2006/main">
             <a:pPr algn="ctr">
+              <a:buNone/>
               <a:defRPr sz="1800" b="1" i="0">
                 <a:solidFill>
                   <a:srgbClr val="176BFF"/>
@@ -18787,6 +19018,7 @@
           </a:p>
           <a:p xmlns:a="http://schemas.openxmlformats.org/drawingml/2006/main">
             <a:pPr algn="ctr">
+              <a:buNone/>
               <a:defRPr sz="1800" b="1" i="0">
                 <a:solidFill>
                   <a:srgbClr val="176BFF"/>
@@ -18843,6 +19075,7 @@
           <a:lstStyle xmlns:a="http://schemas.openxmlformats.org/drawingml/2006/main"/>
           <a:p xmlns:a="http://schemas.openxmlformats.org/drawingml/2006/main">
             <a:pPr algn="ctr">
+              <a:buNone/>
               <a:defRPr sz="1500" b="1" i="0">
                 <a:solidFill>
                   <a:srgbClr val="111827"/>
@@ -18866,6 +19099,7 @@
           </a:p>
           <a:p xmlns:a="http://schemas.openxmlformats.org/drawingml/2006/main">
             <a:pPr algn="ctr">
+              <a:buNone/>
               <a:defRPr sz="1500" b="1" i="0">
                 <a:solidFill>
                   <a:srgbClr val="111827"/>
@@ -18889,6 +19123,7 @@
           </a:p>
           <a:p xmlns:a="http://schemas.openxmlformats.org/drawingml/2006/main">
             <a:pPr algn="ctr">
+              <a:buNone/>
               <a:defRPr sz="1500" b="1" i="0">
                 <a:solidFill>
                   <a:srgbClr val="111827"/>
@@ -18912,6 +19147,7 @@
           </a:p>
           <a:p xmlns:a="http://schemas.openxmlformats.org/drawingml/2006/main">
             <a:pPr algn="ctr">
+              <a:buNone/>
               <a:defRPr sz="1500" b="1" i="0">
                 <a:solidFill>
                   <a:srgbClr val="111827"/>
@@ -18935,6 +19171,7 @@
           </a:p>
           <a:p xmlns:a="http://schemas.openxmlformats.org/drawingml/2006/main">
             <a:pPr algn="ctr">
+              <a:buNone/>
               <a:defRPr sz="1500" b="1" i="0">
                 <a:solidFill>
                   <a:srgbClr val="111827"/>
@@ -18958,6 +19195,7 @@
           </a:p>
           <a:p xmlns:a="http://schemas.openxmlformats.org/drawingml/2006/main">
             <a:pPr algn="ctr">
+              <a:buNone/>
               <a:defRPr sz="1500" b="1" i="0">
                 <a:solidFill>
                   <a:srgbClr val="111827"/>
@@ -18981,6 +19219,7 @@
           </a:p>
           <a:p xmlns:a="http://schemas.openxmlformats.org/drawingml/2006/main">
             <a:pPr algn="ctr">
+              <a:buNone/>
               <a:defRPr sz="1500" b="1" i="0">
                 <a:solidFill>
                   <a:srgbClr val="111827"/>
@@ -19037,6 +19276,7 @@
           <a:lstStyle xmlns:a="http://schemas.openxmlformats.org/drawingml/2006/main"/>
           <a:p xmlns:a="http://schemas.openxmlformats.org/drawingml/2006/main">
             <a:pPr algn="ctr">
+              <a:buNone/>
               <a:defRPr sz="1050" b="0" i="0">
                 <a:solidFill>
                   <a:srgbClr val="98A2B3"/>
@@ -19124,6 +19364,7 @@
           <a:lstStyle xmlns:a="http://schemas.openxmlformats.org/drawingml/2006/main"/>
           <a:p xmlns:a="http://schemas.openxmlformats.org/drawingml/2006/main">
             <a:pPr algn="l">
+              <a:buNone/>
               <a:defRPr sz="975" b="0" i="0">
                 <a:solidFill>
                   <a:srgbClr val="98A2B3"/>
@@ -19180,6 +19421,7 @@
           <a:lstStyle xmlns:a="http://schemas.openxmlformats.org/drawingml/2006/main"/>
           <a:p xmlns:a="http://schemas.openxmlformats.org/drawingml/2006/main">
             <a:pPr algn="r">
+              <a:buNone/>
               <a:defRPr sz="975" b="0" i="0">
                 <a:solidFill>
                   <a:srgbClr val="98A2B3"/>
@@ -19265,6 +19507,7 @@
           <a:lstStyle xmlns:a="http://schemas.openxmlformats.org/drawingml/2006/main"/>
           <a:p xmlns:a="http://schemas.openxmlformats.org/drawingml/2006/main">
             <a:pPr algn="l">
+              <a:buNone/>
               <a:defRPr sz="1200" b="1" i="0">
                 <a:solidFill>
                   <a:srgbClr val="176BFF"/>
@@ -19321,6 +19564,7 @@
           <a:lstStyle xmlns:a="http://schemas.openxmlformats.org/drawingml/2006/main"/>
           <a:p xmlns:a="http://schemas.openxmlformats.org/drawingml/2006/main">
             <a:pPr algn="l">
+              <a:buNone/>
               <a:defRPr sz="3150" b="1" i="0">
                 <a:solidFill>
                   <a:srgbClr val="111827"/>
@@ -19377,6 +19621,7 @@
           <a:lstStyle xmlns:a="http://schemas.openxmlformats.org/drawingml/2006/main"/>
           <a:p xmlns:a="http://schemas.openxmlformats.org/drawingml/2006/main">
             <a:pPr algn="l">
+              <a:buNone/>
               <a:defRPr sz="1500" b="0" i="0">
                 <a:solidFill>
                   <a:srgbClr val="667085"/>
@@ -19499,6 +19744,7 @@
           <a:lstStyle xmlns:a="http://schemas.openxmlformats.org/drawingml/2006/main"/>
           <a:p xmlns:a="http://schemas.openxmlformats.org/drawingml/2006/main">
             <a:pPr algn="ctr">
+              <a:buNone/>
               <a:defRPr sz="1050" b="1" i="0">
                 <a:solidFill>
                   <a:srgbClr val="17A673"/>
@@ -19555,6 +19801,7 @@
           <a:lstStyle xmlns:a="http://schemas.openxmlformats.org/drawingml/2006/main"/>
           <a:p xmlns:a="http://schemas.openxmlformats.org/drawingml/2006/main">
             <a:pPr algn="l">
+              <a:buNone/>
               <a:defRPr sz="1500" b="0" i="0">
                 <a:solidFill>
                   <a:srgbClr val="111827"/>
@@ -19578,6 +19825,7 @@
           </a:p>
           <a:p xmlns:a="http://schemas.openxmlformats.org/drawingml/2006/main">
             <a:pPr algn="l">
+              <a:buNone/>
               <a:defRPr sz="1500" b="0" i="0">
                 <a:solidFill>
                   <a:srgbClr val="111827"/>
@@ -19601,6 +19849,7 @@
           </a:p>
           <a:p xmlns:a="http://schemas.openxmlformats.org/drawingml/2006/main">
             <a:pPr algn="l">
+              <a:buNone/>
               <a:defRPr sz="1500" b="0" i="0">
                 <a:solidFill>
                   <a:srgbClr val="111827"/>
@@ -19624,6 +19873,7 @@
           </a:p>
           <a:p xmlns:a="http://schemas.openxmlformats.org/drawingml/2006/main">
             <a:pPr algn="l">
+              <a:buNone/>
               <a:defRPr sz="1500" b="0" i="0">
                 <a:solidFill>
                   <a:srgbClr val="111827"/>
@@ -19647,6 +19897,7 @@
           </a:p>
           <a:p xmlns:a="http://schemas.openxmlformats.org/drawingml/2006/main">
             <a:pPr algn="l">
+              <a:buNone/>
               <a:defRPr sz="1500" b="0" i="0">
                 <a:solidFill>
                   <a:srgbClr val="111827"/>
@@ -19703,6 +19954,7 @@
           <a:lstStyle xmlns:a="http://schemas.openxmlformats.org/drawingml/2006/main"/>
           <a:p xmlns:a="http://schemas.openxmlformats.org/drawingml/2006/main">
             <a:pPr algn="l">
+              <a:buNone/>
               <a:defRPr sz="1350" b="1" i="0">
                 <a:solidFill>
                   <a:srgbClr val="17A673"/>
@@ -19825,6 +20077,7 @@
           <a:lstStyle xmlns:a="http://schemas.openxmlformats.org/drawingml/2006/main"/>
           <a:p xmlns:a="http://schemas.openxmlformats.org/drawingml/2006/main">
             <a:pPr algn="ctr">
+              <a:buNone/>
               <a:defRPr sz="1050" b="1" i="0">
                 <a:solidFill>
                   <a:srgbClr val="E5484D"/>
@@ -19881,6 +20134,7 @@
           <a:lstStyle xmlns:a="http://schemas.openxmlformats.org/drawingml/2006/main"/>
           <a:p xmlns:a="http://schemas.openxmlformats.org/drawingml/2006/main">
             <a:pPr algn="l">
+              <a:buNone/>
               <a:defRPr sz="1500" b="0" i="0">
                 <a:solidFill>
                   <a:srgbClr val="111827"/>
@@ -19904,6 +20158,7 @@
           </a:p>
           <a:p xmlns:a="http://schemas.openxmlformats.org/drawingml/2006/main">
             <a:pPr algn="l">
+              <a:buNone/>
               <a:defRPr sz="1500" b="0" i="0">
                 <a:solidFill>
                   <a:srgbClr val="111827"/>
@@ -19927,6 +20182,7 @@
           </a:p>
           <a:p xmlns:a="http://schemas.openxmlformats.org/drawingml/2006/main">
             <a:pPr algn="l">
+              <a:buNone/>
               <a:defRPr sz="1500" b="0" i="0">
                 <a:solidFill>
                   <a:srgbClr val="111827"/>
@@ -19950,6 +20206,7 @@
           </a:p>
           <a:p xmlns:a="http://schemas.openxmlformats.org/drawingml/2006/main">
             <a:pPr algn="l">
+              <a:buNone/>
               <a:defRPr sz="1500" b="0" i="0">
                 <a:solidFill>
                   <a:srgbClr val="111827"/>
@@ -19973,6 +20230,7 @@
           </a:p>
           <a:p xmlns:a="http://schemas.openxmlformats.org/drawingml/2006/main">
             <a:pPr algn="l">
+              <a:buNone/>
               <a:defRPr sz="1500" b="0" i="0">
                 <a:solidFill>
                   <a:srgbClr val="111827"/>
@@ -19998,14 +20256,14 @@
       </p:sp>
       <p:pic>
         <p:nvPicPr>
-          <p:cNvPr id="31" name=""/>
+          <p:cNvPr id="33" name=""/>
           <p:cNvPicPr>
             <a:picLocks xmlns:a="http://schemas.openxmlformats.org/drawingml/2006/main" noChangeAspect="1"/>
           </p:cNvPicPr>
           <p:nvPr/>
         </p:nvPicPr>
         <p:blipFill>
-          <a:blip xmlns:r="http://schemas.openxmlformats.org/officeDocument/2006/relationships" xmlns:a="http://schemas.openxmlformats.org/drawingml/2006/main" r:embed="R835d7976bc4247fb"/>
+          <a:blip xmlns:r="http://schemas.openxmlformats.org/officeDocument/2006/relationships" xmlns:a="http://schemas.openxmlformats.org/drawingml/2006/main" r:embed="Rb591936ae1414535"/>
           <a:srcRect xmlns:a="http://schemas.openxmlformats.org/drawingml/2006/main" l="0" t="11290" r="0" b="11290"/>
           <a:stretch xmlns:a="http://schemas.openxmlformats.org/drawingml/2006/main">
             <a:fillRect l="0" t="0" r="0" b="0"/>
@@ -20089,6 +20347,7 @@
           <a:lstStyle xmlns:a="http://schemas.openxmlformats.org/drawingml/2006/main"/>
           <a:p xmlns:a="http://schemas.openxmlformats.org/drawingml/2006/main">
             <a:pPr algn="ctr">
+              <a:buNone/>
               <a:defRPr sz="1050" b="1" i="0">
                 <a:solidFill>
                   <a:srgbClr val="FFFFFF"/>
@@ -20176,6 +20435,7 @@
           <a:lstStyle xmlns:a="http://schemas.openxmlformats.org/drawingml/2006/main"/>
           <a:p xmlns:a="http://schemas.openxmlformats.org/drawingml/2006/main">
             <a:pPr algn="l">
+              <a:buNone/>
               <a:defRPr sz="975" b="0" i="0">
                 <a:solidFill>
                   <a:srgbClr val="98A2B3"/>
@@ -20232,6 +20492,7 @@
           <a:lstStyle xmlns:a="http://schemas.openxmlformats.org/drawingml/2006/main"/>
           <a:p xmlns:a="http://schemas.openxmlformats.org/drawingml/2006/main">
             <a:pPr algn="r">
+              <a:buNone/>
               <a:defRPr sz="975" b="0" i="0">
                 <a:solidFill>
                   <a:srgbClr val="98A2B3"/>

</xml_diff>

<commit_message>
docs: center comparison card text
</commit_message>
<xml_diff>
--- a/PPT与商业计划书/Blocky-Studio-息壤杯-AI+教育.pptx
+++ b/PPT与商业计划书/Blocky-Studio-息壤杯-AI+教育.pptx
@@ -2,26 +2,26 @@
 <file path=ppt/presentation.xml><?xml version="1.0" encoding="utf-8"?>
 <p:presentation xmlns:p="http://schemas.openxmlformats.org/presentationml/2006/main">
   <p:sldMasterIdLst>
-    <p:sldMasterId xmlns:r="http://schemas.openxmlformats.org/officeDocument/2006/relationships" id="2147483648" r:id="Rde35ff7ffae1430b"/>
+    <p:sldMasterId xmlns:r="http://schemas.openxmlformats.org/officeDocument/2006/relationships" id="2147483648" r:id="R5d1829d4cbbb4c03"/>
   </p:sldMasterIdLst>
   <p:notesMasterIdLst>
-    <p:notesMasterId xmlns:r="http://schemas.openxmlformats.org/officeDocument/2006/relationships" r:id="Rc27fb4a24a0d45f2"/>
+    <p:notesMasterId xmlns:r="http://schemas.openxmlformats.org/officeDocument/2006/relationships" r:id="R5f795b05718740fa"/>
   </p:notesMasterIdLst>
   <p:sldIdLst>
-    <p:sldId xmlns:r="http://schemas.openxmlformats.org/officeDocument/2006/relationships" id="256" r:id="R10c64306cabf4662"/>
-    <p:sldId xmlns:r="http://schemas.openxmlformats.org/officeDocument/2006/relationships" id="257" r:id="Rd21e93471985493c"/>
-    <p:sldId xmlns:r="http://schemas.openxmlformats.org/officeDocument/2006/relationships" id="258" r:id="R4eb0474bf03d4e58"/>
-    <p:sldId xmlns:r="http://schemas.openxmlformats.org/officeDocument/2006/relationships" id="259" r:id="R9979e7700f4d424e"/>
-    <p:sldId xmlns:r="http://schemas.openxmlformats.org/officeDocument/2006/relationships" id="260" r:id="R82e2582e03ee4e70"/>
-    <p:sldId xmlns:r="http://schemas.openxmlformats.org/officeDocument/2006/relationships" id="261" r:id="R3d5dc212f0604521"/>
-    <p:sldId xmlns:r="http://schemas.openxmlformats.org/officeDocument/2006/relationships" id="262" r:id="R843d249ba35d4fd7"/>
-    <p:sldId xmlns:r="http://schemas.openxmlformats.org/officeDocument/2006/relationships" id="263" r:id="R9423d834aa4c4445"/>
-    <p:sldId xmlns:r="http://schemas.openxmlformats.org/officeDocument/2006/relationships" id="264" r:id="R41d902ce156b4a1f"/>
-    <p:sldId xmlns:r="http://schemas.openxmlformats.org/officeDocument/2006/relationships" id="265" r:id="Rfd2e87dbe2cf4ad9"/>
-    <p:sldId xmlns:r="http://schemas.openxmlformats.org/officeDocument/2006/relationships" id="266" r:id="Rb54be52d68d04fce"/>
-    <p:sldId xmlns:r="http://schemas.openxmlformats.org/officeDocument/2006/relationships" id="267" r:id="R0de6a947a84a4d27"/>
-    <p:sldId xmlns:r="http://schemas.openxmlformats.org/officeDocument/2006/relationships" id="268" r:id="Ra17a7e31c29047d5"/>
-    <p:sldId xmlns:r="http://schemas.openxmlformats.org/officeDocument/2006/relationships" id="269" r:id="R0c2548bc795145aa"/>
+    <p:sldId xmlns:r="http://schemas.openxmlformats.org/officeDocument/2006/relationships" id="256" r:id="R172f975f21264b74"/>
+    <p:sldId xmlns:r="http://schemas.openxmlformats.org/officeDocument/2006/relationships" id="257" r:id="R17adb4b382cc4aa3"/>
+    <p:sldId xmlns:r="http://schemas.openxmlformats.org/officeDocument/2006/relationships" id="258" r:id="Rc054695ce80b49cd"/>
+    <p:sldId xmlns:r="http://schemas.openxmlformats.org/officeDocument/2006/relationships" id="259" r:id="R34a502912e6a4242"/>
+    <p:sldId xmlns:r="http://schemas.openxmlformats.org/officeDocument/2006/relationships" id="260" r:id="R916dfa9d347a46e1"/>
+    <p:sldId xmlns:r="http://schemas.openxmlformats.org/officeDocument/2006/relationships" id="261" r:id="Ra8b60386b03a41ae"/>
+    <p:sldId xmlns:r="http://schemas.openxmlformats.org/officeDocument/2006/relationships" id="262" r:id="Rf8f47416929d4993"/>
+    <p:sldId xmlns:r="http://schemas.openxmlformats.org/officeDocument/2006/relationships" id="263" r:id="Rd14d80da36024db7"/>
+    <p:sldId xmlns:r="http://schemas.openxmlformats.org/officeDocument/2006/relationships" id="264" r:id="R172c26050f41489b"/>
+    <p:sldId xmlns:r="http://schemas.openxmlformats.org/officeDocument/2006/relationships" id="265" r:id="Ra0fb83e35bac411d"/>
+    <p:sldId xmlns:r="http://schemas.openxmlformats.org/officeDocument/2006/relationships" id="266" r:id="Ra84d2581db2a4ae8"/>
+    <p:sldId xmlns:r="http://schemas.openxmlformats.org/officeDocument/2006/relationships" id="267" r:id="R62475d8a531943dc"/>
+    <p:sldId xmlns:r="http://schemas.openxmlformats.org/officeDocument/2006/relationships" id="268" r:id="R5805efffa6074af6"/>
+    <p:sldId xmlns:r="http://schemas.openxmlformats.org/officeDocument/2006/relationships" id="269" r:id="Rff63d31554bd4c92"/>
   </p:sldIdLst>
   <p:sldSz cx="12192000" cy="6858000"/>
   <p:notesSz cx="6858000" cy="9144000"/>
@@ -1808,7 +1808,7 @@
   </p:cSld>
   <p:clrMap bg1="lt1" tx1="dk1" bg2="lt2" tx2="dk2" accent1="accent1" accent2="accent2" accent3="accent3" accent4="accent4" accent5="accent5" accent6="accent6" hlink="hlink" folHlink="folHlink"/>
   <p:sldLayoutIdLst>
-    <p:sldLayoutId xmlns:r="http://schemas.openxmlformats.org/officeDocument/2006/relationships" id="2147483649" r:id="R9d5a0cffc8994a79"/>
+    <p:sldLayoutId xmlns:r="http://schemas.openxmlformats.org/officeDocument/2006/relationships" id="2147483649" r:id="R1d7c2a99d1714ab0"/>
   </p:sldLayoutIdLst>
   <p:txStyles>
     <p:titleStyle>
@@ -2456,7 +2456,7 @@
           <p:nvPr/>
         </p:nvPicPr>
         <p:blipFill>
-          <a:blip xmlns:r="http://schemas.openxmlformats.org/officeDocument/2006/relationships" xmlns:a="http://schemas.openxmlformats.org/drawingml/2006/main" r:embed="R750be9d05fd7468f"/>
+          <a:blip xmlns:r="http://schemas.openxmlformats.org/officeDocument/2006/relationships" xmlns:a="http://schemas.openxmlformats.org/drawingml/2006/main" r:embed="R5bff68be09f74600"/>
           <a:stretch xmlns:a="http://schemas.openxmlformats.org/drawingml/2006/main"/>
         </p:blipFill>
         <p:spPr>
@@ -9660,7 +9660,7 @@
           <a:bodyPr xmlns:a="http://schemas.openxmlformats.org/drawingml/2006/main"/>
           <a:lstStyle xmlns:a="http://schemas.openxmlformats.org/drawingml/2006/main"/>
           <a:p xmlns:a="http://schemas.openxmlformats.org/drawingml/2006/main">
-            <a:pPr algn="l">
+            <a:pPr algn="ctr">
               <a:buNone/>
               <a:defRPr sz="2025" b="1" i="0">
                 <a:solidFill>
@@ -9717,7 +9717,7 @@
           <a:bodyPr xmlns:a="http://schemas.openxmlformats.org/drawingml/2006/main"/>
           <a:lstStyle xmlns:a="http://schemas.openxmlformats.org/drawingml/2006/main"/>
           <a:p xmlns:a="http://schemas.openxmlformats.org/drawingml/2006/main">
-            <a:pPr algn="l">
+            <a:pPr algn="ctr">
               <a:buNone/>
               <a:defRPr sz="1500" b="0" i="0">
                 <a:solidFill>
@@ -9897,7 +9897,7 @@
           <a:bodyPr xmlns:a="http://schemas.openxmlformats.org/drawingml/2006/main"/>
           <a:lstStyle xmlns:a="http://schemas.openxmlformats.org/drawingml/2006/main"/>
           <a:p xmlns:a="http://schemas.openxmlformats.org/drawingml/2006/main">
-            <a:pPr algn="l">
+            <a:pPr algn="ctr">
               <a:buNone/>
               <a:defRPr sz="2025" b="1" i="0">
                 <a:solidFill>
@@ -9917,7 +9917,7 @@
                 <a:ea typeface="Microsoft YaHei"/>
                 <a:cs typeface="Microsoft YaHei"/>
               </a:rPr>
-              <a:t>节点工作流</a:t>
+              <a:t>连线式工作流</a:t>
             </a:r>
           </a:p>
         </p:txBody>
@@ -9954,7 +9954,7 @@
           <a:bodyPr xmlns:a="http://schemas.openxmlformats.org/drawingml/2006/main"/>
           <a:lstStyle xmlns:a="http://schemas.openxmlformats.org/drawingml/2006/main"/>
           <a:p xmlns:a="http://schemas.openxmlformats.org/drawingml/2006/main">
-            <a:pPr algn="l">
+            <a:pPr algn="ctr">
               <a:buNone/>
               <a:defRPr sz="1500" b="0" i="0">
                 <a:solidFill>
@@ -9974,7 +9974,9 @@
                 <a:ea typeface="Microsoft YaHei"/>
                 <a:cs typeface="Microsoft YaHei"/>
               </a:rPr>
-              <a:t>把复杂度换成连线、参数和调试面板，仍然不适合作为第一门 AI 创作语言。</a:t>
+              <a:t>通过节点与连线组织流程
+参数复杂，初学者门槛高
+本产品不采用这种交互</a:t>
             </a:r>
           </a:p>
         </p:txBody>
@@ -10134,7 +10136,7 @@
           <a:bodyPr xmlns:a="http://schemas.openxmlformats.org/drawingml/2006/main"/>
           <a:lstStyle xmlns:a="http://schemas.openxmlformats.org/drawingml/2006/main"/>
           <a:p xmlns:a="http://schemas.openxmlformats.org/drawingml/2006/main">
-            <a:pPr algn="l">
+            <a:pPr algn="ctr">
               <a:buNone/>
               <a:defRPr sz="2025" b="1" i="0">
                 <a:solidFill>
@@ -10191,7 +10193,7 @@
           <a:bodyPr xmlns:a="http://schemas.openxmlformats.org/drawingml/2006/main"/>
           <a:lstStyle xmlns:a="http://schemas.openxmlformats.org/drawingml/2006/main"/>
           <a:p xmlns:a="http://schemas.openxmlformats.org/drawingml/2006/main">
-            <a:pPr algn="l">
+            <a:pPr algn="ctr">
               <a:buNone/>
               <a:defRPr sz="1500" b="0" i="0">
                 <a:solidFill>
@@ -10211,7 +10213,9 @@
                 <a:ea typeface="Microsoft YaHei"/>
                 <a:cs typeface="Microsoft YaHei"/>
               </a:rPr>
-              <a:t>表达力强，但首次创造门槛高，课堂时间容易耗在环境与语法上。</a:t>
+              <a:t>表达力强，但入门门槛高
+课堂时间易耗在
+环境配置与语法上</a:t>
             </a:r>
           </a:p>
         </p:txBody>
@@ -11893,7 +11897,7 @@
           <p:nvPr/>
         </p:nvPicPr>
         <p:blipFill>
-          <a:blip xmlns:r="http://schemas.openxmlformats.org/officeDocument/2006/relationships" xmlns:a="http://schemas.openxmlformats.org/drawingml/2006/main" r:embed="R623b3a3d385042a7"/>
+          <a:blip xmlns:r="http://schemas.openxmlformats.org/officeDocument/2006/relationships" xmlns:a="http://schemas.openxmlformats.org/drawingml/2006/main" r:embed="R7521a99cb6154abc"/>
           <a:srcRect xmlns:a="http://schemas.openxmlformats.org/drawingml/2006/main" l="0" t="2671" r="0" b="2671"/>
           <a:stretch xmlns:a="http://schemas.openxmlformats.org/drawingml/2006/main">
             <a:fillRect l="0" t="0" r="0" b="0"/>
@@ -18747,7 +18751,7 @@
                 <a:ea typeface="Microsoft YaHei"/>
                 <a:cs typeface="Microsoft YaHei"/>
               </a:rPr>
-              <a:t>节点工作流</a:t>
+              <a:t>连线式工作流</a:t>
             </a:r>
           </a:p>
         </p:txBody>
@@ -20263,7 +20267,7 @@
           <p:nvPr/>
         </p:nvPicPr>
         <p:blipFill>
-          <a:blip xmlns:r="http://schemas.openxmlformats.org/officeDocument/2006/relationships" xmlns:a="http://schemas.openxmlformats.org/drawingml/2006/main" r:embed="Rb591936ae1414535"/>
+          <a:blip xmlns:r="http://schemas.openxmlformats.org/officeDocument/2006/relationships" xmlns:a="http://schemas.openxmlformats.org/drawingml/2006/main" r:embed="R09032676287c4392"/>
           <a:srcRect xmlns:a="http://schemas.openxmlformats.org/drawingml/2006/main" l="0" t="11290" r="0" b="11290"/>
           <a:stretch xmlns:a="http://schemas.openxmlformats.org/drawingml/2006/main">
             <a:fillRect l="0" t="0" r="0" b="0"/>

</xml_diff>

<commit_message>
docs: redesign differentiation slide
</commit_message>
<xml_diff>
--- a/PPT与商业计划书/Blocky-Studio-息壤杯-AI+教育.pptx
+++ b/PPT与商业计划书/Blocky-Studio-息壤杯-AI+教育.pptx
@@ -2,26 +2,26 @@
 <file path=ppt/presentation.xml><?xml version="1.0" encoding="utf-8"?>
 <p:presentation xmlns:p="http://schemas.openxmlformats.org/presentationml/2006/main">
   <p:sldMasterIdLst>
-    <p:sldMasterId xmlns:r="http://schemas.openxmlformats.org/officeDocument/2006/relationships" id="2147483648" r:id="R5d1829d4cbbb4c03"/>
+    <p:sldMasterId xmlns:r="http://schemas.openxmlformats.org/officeDocument/2006/relationships" id="2147483648" r:id="Rb38cf3cd41b747c9"/>
   </p:sldMasterIdLst>
   <p:notesMasterIdLst>
-    <p:notesMasterId xmlns:r="http://schemas.openxmlformats.org/officeDocument/2006/relationships" r:id="R5f795b05718740fa"/>
+    <p:notesMasterId xmlns:r="http://schemas.openxmlformats.org/officeDocument/2006/relationships" r:id="R92269446842447b6"/>
   </p:notesMasterIdLst>
   <p:sldIdLst>
-    <p:sldId xmlns:r="http://schemas.openxmlformats.org/officeDocument/2006/relationships" id="256" r:id="R172f975f21264b74"/>
-    <p:sldId xmlns:r="http://schemas.openxmlformats.org/officeDocument/2006/relationships" id="257" r:id="R17adb4b382cc4aa3"/>
-    <p:sldId xmlns:r="http://schemas.openxmlformats.org/officeDocument/2006/relationships" id="258" r:id="Rc054695ce80b49cd"/>
-    <p:sldId xmlns:r="http://schemas.openxmlformats.org/officeDocument/2006/relationships" id="259" r:id="R34a502912e6a4242"/>
-    <p:sldId xmlns:r="http://schemas.openxmlformats.org/officeDocument/2006/relationships" id="260" r:id="R916dfa9d347a46e1"/>
-    <p:sldId xmlns:r="http://schemas.openxmlformats.org/officeDocument/2006/relationships" id="261" r:id="Ra8b60386b03a41ae"/>
-    <p:sldId xmlns:r="http://schemas.openxmlformats.org/officeDocument/2006/relationships" id="262" r:id="Rf8f47416929d4993"/>
-    <p:sldId xmlns:r="http://schemas.openxmlformats.org/officeDocument/2006/relationships" id="263" r:id="Rd14d80da36024db7"/>
-    <p:sldId xmlns:r="http://schemas.openxmlformats.org/officeDocument/2006/relationships" id="264" r:id="R172c26050f41489b"/>
-    <p:sldId xmlns:r="http://schemas.openxmlformats.org/officeDocument/2006/relationships" id="265" r:id="Ra0fb83e35bac411d"/>
-    <p:sldId xmlns:r="http://schemas.openxmlformats.org/officeDocument/2006/relationships" id="266" r:id="Ra84d2581db2a4ae8"/>
-    <p:sldId xmlns:r="http://schemas.openxmlformats.org/officeDocument/2006/relationships" id="267" r:id="R62475d8a531943dc"/>
-    <p:sldId xmlns:r="http://schemas.openxmlformats.org/officeDocument/2006/relationships" id="268" r:id="R5805efffa6074af6"/>
-    <p:sldId xmlns:r="http://schemas.openxmlformats.org/officeDocument/2006/relationships" id="269" r:id="Rff63d31554bd4c92"/>
+    <p:sldId xmlns:r="http://schemas.openxmlformats.org/officeDocument/2006/relationships" id="256" r:id="Rc077f957c1364baa"/>
+    <p:sldId xmlns:r="http://schemas.openxmlformats.org/officeDocument/2006/relationships" id="257" r:id="R333461dcb8574925"/>
+    <p:sldId xmlns:r="http://schemas.openxmlformats.org/officeDocument/2006/relationships" id="258" r:id="Ra90c99912a3f469b"/>
+    <p:sldId xmlns:r="http://schemas.openxmlformats.org/officeDocument/2006/relationships" id="259" r:id="Ra12601cea7f24044"/>
+    <p:sldId xmlns:r="http://schemas.openxmlformats.org/officeDocument/2006/relationships" id="260" r:id="R47f4763504664008"/>
+    <p:sldId xmlns:r="http://schemas.openxmlformats.org/officeDocument/2006/relationships" id="261" r:id="Rcb72d89e8e654667"/>
+    <p:sldId xmlns:r="http://schemas.openxmlformats.org/officeDocument/2006/relationships" id="262" r:id="R67c9839dd4b0472b"/>
+    <p:sldId xmlns:r="http://schemas.openxmlformats.org/officeDocument/2006/relationships" id="263" r:id="R8ebaa03d2e674b83"/>
+    <p:sldId xmlns:r="http://schemas.openxmlformats.org/officeDocument/2006/relationships" id="264" r:id="Rc572149091ff4e90"/>
+    <p:sldId xmlns:r="http://schemas.openxmlformats.org/officeDocument/2006/relationships" id="265" r:id="Re5a63f3d3ec14482"/>
+    <p:sldId xmlns:r="http://schemas.openxmlformats.org/officeDocument/2006/relationships" id="266" r:id="R46fcd5f4140f4c5c"/>
+    <p:sldId xmlns:r="http://schemas.openxmlformats.org/officeDocument/2006/relationships" id="267" r:id="R3489dbc45ed74a13"/>
+    <p:sldId xmlns:r="http://schemas.openxmlformats.org/officeDocument/2006/relationships" id="268" r:id="R6a91bb3e07db447c"/>
+    <p:sldId xmlns:r="http://schemas.openxmlformats.org/officeDocument/2006/relationships" id="269" r:id="R4128dcc4bc804896"/>
   </p:sldIdLst>
   <p:sldSz cx="12192000" cy="6858000"/>
   <p:notesSz cx="6858000" cy="9144000"/>
@@ -1808,7 +1808,7 @@
   </p:cSld>
   <p:clrMap bg1="lt1" tx1="dk1" bg2="lt2" tx2="dk2" accent1="accent1" accent2="accent2" accent3="accent3" accent4="accent4" accent5="accent5" accent6="accent6" hlink="hlink" folHlink="folHlink"/>
   <p:sldLayoutIdLst>
-    <p:sldLayoutId xmlns:r="http://schemas.openxmlformats.org/officeDocument/2006/relationships" id="2147483649" r:id="R1d7c2a99d1714ab0"/>
+    <p:sldLayoutId xmlns:r="http://schemas.openxmlformats.org/officeDocument/2006/relationships" id="2147483649" r:id="Rd98a0285cc4748d5"/>
   </p:sldLayoutIdLst>
   <p:txStyles>
     <p:titleStyle>
@@ -2456,7 +2456,7 @@
           <p:nvPr/>
         </p:nvPicPr>
         <p:blipFill>
-          <a:blip xmlns:r="http://schemas.openxmlformats.org/officeDocument/2006/relationships" xmlns:a="http://schemas.openxmlformats.org/drawingml/2006/main" r:embed="R5bff68be09f74600"/>
+          <a:blip xmlns:r="http://schemas.openxmlformats.org/officeDocument/2006/relationships" xmlns:a="http://schemas.openxmlformats.org/drawingml/2006/main" r:embed="R1ca2c2e4eae24f45"/>
           <a:stretch xmlns:a="http://schemas.openxmlformats.org/drawingml/2006/main"/>
         </p:blipFill>
         <p:spPr>
@@ -11897,7 +11897,7 @@
           <p:nvPr/>
         </p:nvPicPr>
         <p:blipFill>
-          <a:blip xmlns:r="http://schemas.openxmlformats.org/officeDocument/2006/relationships" xmlns:a="http://schemas.openxmlformats.org/drawingml/2006/main" r:embed="R7521a99cb6154abc"/>
+          <a:blip xmlns:r="http://schemas.openxmlformats.org/officeDocument/2006/relationships" xmlns:a="http://schemas.openxmlformats.org/drawingml/2006/main" r:embed="Rff3ad4091e354018"/>
           <a:srcRect xmlns:a="http://schemas.openxmlformats.org/drawingml/2006/main" l="0" t="2671" r="0" b="2671"/>
           <a:stretch xmlns:a="http://schemas.openxmlformats.org/drawingml/2006/main">
             <a:fillRect l="0" t="0" r="0" b="0"/>
@@ -18304,7 +18304,7 @@
                 <a:ea typeface="Microsoft YaHei"/>
                 <a:cs typeface="Microsoft YaHei"/>
               </a:rPr>
-              <a:t>在“易上手”和“可成长”之间，Blocky 不必二选一</a:t>
+              <a:t>Blocky 用积木降低上手门槛，也保留能力成长空间</a:t>
             </a:r>
           </a:p>
         </p:txBody>
@@ -18518,7 +18518,7 @@
                 <a:ea typeface="Microsoft YaHei"/>
                 <a:cs typeface="Microsoft YaHei"/>
               </a:rPr>
-              <a:t>解释与可观察性 ↑</a:t>
+              <a:t>创作能力与可解释性 ↑</a:t>
             </a:r>
           </a:p>
         </p:txBody>
@@ -18539,8 +18539,8 @@
         </p:nvSpPr>
         <p:spPr>
           <a:xfrm xmlns:a="http://schemas.openxmlformats.org/drawingml/2006/main">
-            <a:off x="7429500" y="5067300"/>
-            <a:ext cx="1524000" cy="228600"/>
+            <a:off x="5524500" y="5067300"/>
+            <a:ext cx="3429000" cy="228600"/>
           </a:xfrm>
           <a:prstGeom xmlns:a="http://schemas.openxmlformats.org/drawingml/2006/main" prst="rect">
             <a:avLst/>
@@ -18575,7 +18575,7 @@
                 <a:ea typeface="Microsoft YaHei"/>
                 <a:cs typeface="Microsoft YaHei"/>
               </a:rPr>
-              <a:t>首次创造门槛 →</a:t>
+              <a:t>上手难度：低（易上手）→ 高（需编程）</a:t>
             </a:r>
           </a:p>
         </p:txBody>
@@ -18596,7 +18596,7 @@
         </p:nvSpPr>
         <p:spPr>
           <a:xfrm xmlns:a="http://schemas.openxmlformats.org/drawingml/2006/main">
-            <a:off x="3333750" y="4267200"/>
+            <a:off x="3333750" y="4038600"/>
             <a:ext cx="400050" cy="400050"/>
           </a:xfrm>
           <a:prstGeom xmlns:a="http://schemas.openxmlformats.org/drawingml/2006/main" prst="ellipse">
@@ -18627,8 +18627,8 @@
         </p:nvSpPr>
         <p:spPr>
           <a:xfrm xmlns:a="http://schemas.openxmlformats.org/drawingml/2006/main">
-            <a:off x="2933700" y="4743450"/>
-            <a:ext cx="1371600" cy="247650"/>
+            <a:off x="2819400" y="4514850"/>
+            <a:ext cx="1428750" cy="247650"/>
           </a:xfrm>
           <a:prstGeom xmlns:a="http://schemas.openxmlformats.org/drawingml/2006/main" prst="rect">
             <a:avLst/>
@@ -18684,7 +18684,7 @@
         </p:nvSpPr>
         <p:spPr>
           <a:xfrm xmlns:a="http://schemas.openxmlformats.org/drawingml/2006/main">
-            <a:off x="5476875" y="3686175"/>
+            <a:off x="5476875" y="3781425"/>
             <a:ext cx="457200" cy="457200"/>
           </a:xfrm>
           <a:prstGeom xmlns:a="http://schemas.openxmlformats.org/drawingml/2006/main" prst="ellipse">
@@ -18715,7 +18715,7 @@
         </p:nvSpPr>
         <p:spPr>
           <a:xfrm xmlns:a="http://schemas.openxmlformats.org/drawingml/2006/main">
-            <a:off x="5076825" y="4219575"/>
+            <a:off x="5019675" y="4314825"/>
             <a:ext cx="1371600" cy="247650"/>
           </a:xfrm>
           <a:prstGeom xmlns:a="http://schemas.openxmlformats.org/drawingml/2006/main" prst="rect">
@@ -19017,7 +19017,7 @@
                 <a:ea typeface="Microsoft YaHei"/>
                 <a:cs typeface="Microsoft YaHei"/>
               </a:rPr>
-              <a:t>同一底座</a:t>
+              <a:t>易上手</a:t>
             </a:r>
           </a:p>
           <a:p xmlns:a="http://schemas.openxmlformats.org/drawingml/2006/main">
@@ -19041,7 +19041,7 @@
                 <a:ea typeface="Microsoft YaHei"/>
                 <a:cs typeface="Microsoft YaHei"/>
               </a:rPr>
-              <a:t>逐步成长</a:t>
+              <a:t>可成长</a:t>
             </a:r>
           </a:p>
         </p:txBody>
@@ -19194,7 +19194,7 @@
                 <a:ea typeface="Microsoft YaHei"/>
                 <a:cs typeface="Microsoft YaHei"/>
               </a:rPr>
-              <a:t>蓝图与代码</a:t>
+              <a:t>蓝图 / 代码</a:t>
             </a:r>
           </a:p>
           <a:p xmlns:a="http://schemas.openxmlformats.org/drawingml/2006/main">
@@ -19242,7 +19242,7 @@
                 <a:ea typeface="Microsoft YaHei"/>
                 <a:cs typeface="Microsoft YaHei"/>
               </a:rPr>
-              <a:t>真实运行轨迹</a:t>
+              <a:t>运行轨迹</a:t>
             </a:r>
           </a:p>
         </p:txBody>
@@ -19299,7 +19299,7 @@
                 <a:ea typeface="Microsoft YaHei"/>
                 <a:cs typeface="Microsoft YaHei"/>
               </a:rPr>
-              <a:t>定位示意：比较的是产品交互范式，不代表对单一竞品的测评结论。</a:t>
+              <a:t>同一项目格式与运行内核，支持从入门视图平滑进阶到专业视图。</a:t>
             </a:r>
           </a:p>
         </p:txBody>
@@ -20267,7 +20267,7 @@
           <p:nvPr/>
         </p:nvPicPr>
         <p:blipFill>
-          <a:blip xmlns:r="http://schemas.openxmlformats.org/officeDocument/2006/relationships" xmlns:a="http://schemas.openxmlformats.org/drawingml/2006/main" r:embed="R09032676287c4392"/>
+          <a:blip xmlns:r="http://schemas.openxmlformats.org/officeDocument/2006/relationships" xmlns:a="http://schemas.openxmlformats.org/drawingml/2006/main" r:embed="R11607b52ed294fd9"/>
           <a:srcRect xmlns:a="http://schemas.openxmlformats.org/drawingml/2006/main" l="0" t="11290" r="0" b="11290"/>
           <a:stretch xmlns:a="http://schemas.openxmlformats.org/drawingml/2006/main">
             <a:fillRect l="0" t="0" r="0" b="0"/>

</xml_diff>

<commit_message>
docs: enrich Blocky contest deck with compatibility templates
</commit_message>
<xml_diff>
--- a/PPT与商业计划书/Blocky-Studio-息壤杯-AI+教育.pptx
+++ b/PPT与商业计划书/Blocky-Studio-息壤杯-AI+教育.pptx
@@ -2,26 +2,26 @@
 <file path=ppt/presentation.xml><?xml version="1.0" encoding="utf-8"?>
 <p:presentation xmlns:p="http://schemas.openxmlformats.org/presentationml/2006/main">
   <p:sldMasterIdLst>
-    <p:sldMasterId xmlns:r="http://schemas.openxmlformats.org/officeDocument/2006/relationships" id="2147483648" r:id="Rb38cf3cd41b747c9"/>
+    <p:sldMasterId xmlns:r="http://schemas.openxmlformats.org/officeDocument/2006/relationships" id="2147483648" r:id="Rb220d6a136f241f5"/>
   </p:sldMasterIdLst>
   <p:notesMasterIdLst>
-    <p:notesMasterId xmlns:r="http://schemas.openxmlformats.org/officeDocument/2006/relationships" r:id="R92269446842447b6"/>
+    <p:notesMasterId xmlns:r="http://schemas.openxmlformats.org/officeDocument/2006/relationships" r:id="R6d8de98c84414067"/>
   </p:notesMasterIdLst>
   <p:sldIdLst>
-    <p:sldId xmlns:r="http://schemas.openxmlformats.org/officeDocument/2006/relationships" id="256" r:id="Rc077f957c1364baa"/>
-    <p:sldId xmlns:r="http://schemas.openxmlformats.org/officeDocument/2006/relationships" id="257" r:id="R333461dcb8574925"/>
-    <p:sldId xmlns:r="http://schemas.openxmlformats.org/officeDocument/2006/relationships" id="258" r:id="Ra90c99912a3f469b"/>
-    <p:sldId xmlns:r="http://schemas.openxmlformats.org/officeDocument/2006/relationships" id="259" r:id="Ra12601cea7f24044"/>
-    <p:sldId xmlns:r="http://schemas.openxmlformats.org/officeDocument/2006/relationships" id="260" r:id="R47f4763504664008"/>
-    <p:sldId xmlns:r="http://schemas.openxmlformats.org/officeDocument/2006/relationships" id="261" r:id="Rcb72d89e8e654667"/>
-    <p:sldId xmlns:r="http://schemas.openxmlformats.org/officeDocument/2006/relationships" id="262" r:id="R67c9839dd4b0472b"/>
-    <p:sldId xmlns:r="http://schemas.openxmlformats.org/officeDocument/2006/relationships" id="263" r:id="R8ebaa03d2e674b83"/>
-    <p:sldId xmlns:r="http://schemas.openxmlformats.org/officeDocument/2006/relationships" id="264" r:id="Rc572149091ff4e90"/>
-    <p:sldId xmlns:r="http://schemas.openxmlformats.org/officeDocument/2006/relationships" id="265" r:id="Re5a63f3d3ec14482"/>
-    <p:sldId xmlns:r="http://schemas.openxmlformats.org/officeDocument/2006/relationships" id="266" r:id="R46fcd5f4140f4c5c"/>
-    <p:sldId xmlns:r="http://schemas.openxmlformats.org/officeDocument/2006/relationships" id="267" r:id="R3489dbc45ed74a13"/>
-    <p:sldId xmlns:r="http://schemas.openxmlformats.org/officeDocument/2006/relationships" id="268" r:id="R6a91bb3e07db447c"/>
-    <p:sldId xmlns:r="http://schemas.openxmlformats.org/officeDocument/2006/relationships" id="269" r:id="R4128dcc4bc804896"/>
+    <p:sldId xmlns:r="http://schemas.openxmlformats.org/officeDocument/2006/relationships" id="256" r:id="Re87813326975443a"/>
+    <p:sldId xmlns:r="http://schemas.openxmlformats.org/officeDocument/2006/relationships" id="257" r:id="R3d2316e7e9b14cef"/>
+    <p:sldId xmlns:r="http://schemas.openxmlformats.org/officeDocument/2006/relationships" id="258" r:id="R0284ec97fb814956"/>
+    <p:sldId xmlns:r="http://schemas.openxmlformats.org/officeDocument/2006/relationships" id="259" r:id="R9d9a4a126b104ea0"/>
+    <p:sldId xmlns:r="http://schemas.openxmlformats.org/officeDocument/2006/relationships" id="260" r:id="Ra91923d7b9c54943"/>
+    <p:sldId xmlns:r="http://schemas.openxmlformats.org/officeDocument/2006/relationships" id="261" r:id="R65486dbdb898408b"/>
+    <p:sldId xmlns:r="http://schemas.openxmlformats.org/officeDocument/2006/relationships" id="262" r:id="Rd45a86d3b1ef41c5"/>
+    <p:sldId xmlns:r="http://schemas.openxmlformats.org/officeDocument/2006/relationships" id="263" r:id="R95e92944edf14a8e"/>
+    <p:sldId xmlns:r="http://schemas.openxmlformats.org/officeDocument/2006/relationships" id="264" r:id="R2ef8df90b4214fd8"/>
+    <p:sldId xmlns:r="http://schemas.openxmlformats.org/officeDocument/2006/relationships" id="265" r:id="R533e2f8e5fb14cd3"/>
+    <p:sldId xmlns:r="http://schemas.openxmlformats.org/officeDocument/2006/relationships" id="266" r:id="R6aa1164f1ff74b68"/>
+    <p:sldId xmlns:r="http://schemas.openxmlformats.org/officeDocument/2006/relationships" id="267" r:id="Ree83d49e100c4a43"/>
+    <p:sldId xmlns:r="http://schemas.openxmlformats.org/officeDocument/2006/relationships" id="268" r:id="R9aa1057f86c94737"/>
+    <p:sldId xmlns:r="http://schemas.openxmlformats.org/officeDocument/2006/relationships" id="269" r:id="R8f9dbc920fac418d"/>
   </p:sldIdLst>
   <p:sldSz cx="12192000" cy="6858000"/>
   <p:notesSz cx="6858000" cy="9144000"/>
@@ -840,7 +840,7 @@
           <a:lstStyle xmlns:a="http://schemas.openxmlformats.org/drawingml/2006/main"/>
           <a:p xmlns:a="http://schemas.openxmlformats.org/drawingml/2006/main">
             <a:r>
-              <a:t>官方赛程是 7 月报名、8 月初赛、9 月复赛、11 月初总决赛。项目路线按此拟定，但不绕过既有阶段门禁。</a:t>
+              <a:t>赛事节奏用于安排展示与试点，不改变 Blocky 的正式阶段门禁。复赛优先验证真实 RAG/模型和教师共创；总决赛可输出 Pi/Codex 只读兼容报告，但六个正式适配器仍在阶段 8、四个官方 Skills 与 Codex 插件仍在阶段 9。</a:t>
             </a:r>
           </a:p>
           <a:p xmlns:a="http://schemas.openxmlformats.org/drawingml/2006/main">
@@ -860,7 +860,12 @@
           </a:p>
           <a:p xmlns:a="http://schemas.openxmlformats.org/drawingml/2006/main">
             <a:r>
-              <a:t>- D:\1Folder\Blocky-AI\doc\执行计划\2026-08-23-Blocky-竞品驱动完整开发计划.md (阶段 1、阶段 3–7 与阶段 10 门禁)</a:t>
+              <a:t>- D:\1Folder\Blocky-AI\doc\执行计划\2026-08-23-Blocky-竞品驱动完整开发计划.md (阶段 1、3–10 门禁)</a:t>
+            </a:r>
+          </a:p>
+          <a:p xmlns:a="http://schemas.openxmlformats.org/drawingml/2006/main">
+            <a:r>
+              <a:t>- D:\1Folder\Blocky-AI\doc\产品设计\Blocky-内置兼容模板.md (六模板独立兼容矩阵)</a:t>
             </a:r>
           </a:p>
           <a:p xmlns:a="http://schemas.openxmlformats.org/drawingml/2006/main">
@@ -935,7 +940,7 @@
           <a:lstStyle xmlns:a="http://schemas.openxmlformats.org/drawingml/2006/main"/>
           <a:p xmlns:a="http://schemas.openxmlformats.org/drawingml/2006/main">
             <a:r>
-              <a:t>收束到赛事五个评估维度，并给出明确资源诉求。</a:t>
+              <a:t>收束到赛事五个评估维度：可见积木到可逆映射构成创新性；免费教育底座、个人扩展、机构授权构成商业路径；教育价值聚焦创造与负责；3 分钟闭环对应可验收成效；六模板、CLI/四 Skills、社区和多端构成阶段化孵化空间。</a:t>
             </a:r>
           </a:p>
           <a:p xmlns:a="http://schemas.openxmlformats.org/drawingml/2006/main">
@@ -950,12 +955,17 @@
           </a:p>
           <a:p xmlns:a="http://schemas.openxmlformats.org/drawingml/2006/main">
             <a:r>
-              <a:t>- https://js.news.cn/20260717/59d330ba6357464babb402e9c1907680/c.html (创新性、商业模式、社会价值、应用成效、孵化推广潜力等评估维度与赛事资源)</a:t>
-            </a:r>
-          </a:p>
-          <a:p xmlns:a="http://schemas.openxmlformats.org/drawingml/2006/main">
-            <a:r>
-              <a:t>- D:\1Folder\Blocky-AI\README.md (Blocky 产品愿景与当前阶段)</a:t>
+              <a:t>- https://js.news.cn/20260717/59d330ba6357464babb402e9c1907680/c.html (赛事评估维度与孵化资源)</a:t>
+            </a:r>
+          </a:p>
+          <a:p xmlns:a="http://schemas.openxmlformats.org/drawingml/2006/main">
+            <a:r>
+              <a:t>- D:\1Folder\Blocky-AI\README.md (产品愿景、六模板与当前阶段)</a:t>
+            </a:r>
+          </a:p>
+          <a:p xmlns:a="http://schemas.openxmlformats.org/drawingml/2006/main">
+            <a:r>
+              <a:t>- D:\1Folder\Blocky-AI\doc\执行计划\2026-08-23-Blocky-竞品驱动完整开发计划.md (CLI、Skills、社区与多端阶段)</a:t>
             </a:r>
           </a:p>
           <a:p xmlns:a="http://schemas.openxmlformats.org/drawingml/2006/main">
@@ -1225,7 +1235,7 @@
           <a:lstStyle xmlns:a="http://schemas.openxmlformats.org/drawingml/2006/main"/>
           <a:p xmlns:a="http://schemas.openxmlformats.org/drawingml/2006/main">
             <a:r>
-              <a:t>七类词汇要按学习任务来讲。专业能力不是另一套产品，而是同一语义逐步解锁。</a:t>
+              <a:t>这一页讲清完整桌面形态：左侧积木库、中间多画布与浏览器标签、右侧构建助手与运行 Agent、底部问题/日志/终端/输出。入门七类与专业十二类不是两套产品，而是共享项目格式、Workspace、IR、运行内核和安全模型。</a:t>
             </a:r>
           </a:p>
           <a:p xmlns:a="http://schemas.openxmlformats.org/drawingml/2006/main">
@@ -1236,6 +1246,11 @@
           <a:p xmlns:a="http://schemas.openxmlformats.org/drawingml/2006/main">
             <a:r>
               <a:t>[Sources]</a:t>
+            </a:r>
+          </a:p>
+          <a:p xmlns:a="http://schemas.openxmlformats.org/drawingml/2006/main">
+            <a:r>
+              <a:t>- D:\1Folder\Blocky-AI\doc\产品设计\Blocky-初版产品方案.md (桌面核心界面与教育/专业共享内核)</a:t>
             </a:r>
           </a:p>
           <a:p xmlns:a="http://schemas.openxmlformats.org/drawingml/2006/main">
@@ -1510,7 +1525,7 @@
           <a:lstStyle xmlns:a="http://schemas.openxmlformats.org/drawingml/2006/main"/>
           <a:p xmlns:a="http://schemas.openxmlformats.org/drawingml/2006/main">
             <a:r>
-              <a:t>这一页是 Blocky 的技术护城河：教育交互与工程确定性是一条链，不是两套故事。</a:t>
+              <a:t>技术壁垒是从可见积木到稳定 IR、受控 Runtime、可回放 Trace，再到模板与原生配置可逆映射。四个官方 Skills、CLI、桌面画布和六个兼容模板共用同一积木目录、Build Spec、权限和运行事件，不建立隐藏语言。</a:t>
             </a:r>
           </a:p>
           <a:p xmlns:a="http://schemas.openxmlformats.org/drawingml/2006/main">
@@ -1525,17 +1540,17 @@
           </a:p>
           <a:p xmlns:a="http://schemas.openxmlformats.org/drawingml/2006/main">
             <a:r>
-              <a:t>- D:\1Folder\Blocky-AI\doc\产品设计\Blocky-完整积木与Agent兼容设计.md (积木语义与项目格式)</a:t>
-            </a:r>
-          </a:p>
-          <a:p xmlns:a="http://schemas.openxmlformats.org/drawingml/2006/main">
-            <a:r>
-              <a:t>- D:\1Folder\Blocky-AI\doc\技术设计\Windows-Core技术尖峰报告.md (稳定 IR、运行时与轨迹验证)</a:t>
-            </a:r>
-          </a:p>
-          <a:p xmlns:a="http://schemas.openxmlformats.org/drawingml/2006/main">
-            <a:r>
-              <a:t>- D:\1Folder\Blocky-AI\doc\产品设计\Blocky-GitHub项目积木化与Agent组件设计.md (可解释转换与来源证据)</a:t>
+              <a:t>- D:\1Folder\Blocky-AI\doc\执行计划\2026-08-23-Blocky-竞品驱动完整开发计划.md (产品墙、四层创作与阶段门禁)</a:t>
+            </a:r>
+          </a:p>
+          <a:p xmlns:a="http://schemas.openxmlformats.org/drawingml/2006/main">
+            <a:r>
+              <a:t>- D:\1Folder\Blocky-AI\doc\产品设计\CLI与官方Agent-Skill.md (四个官方 Skills 与共享 CLI 边界)</a:t>
+            </a:r>
+          </a:p>
+          <a:p xmlns:a="http://schemas.openxmlformats.org/drawingml/2006/main">
+            <a:r>
+              <a:t>- D:\1Folder\Blocky-AI\doc\技术设计\ADR-002-原生Agent兼容运行时.md (版本化适配器与可逆投影)</a:t>
             </a:r>
           </a:p>
           <a:p xmlns:a="http://schemas.openxmlformats.org/drawingml/2006/main">
@@ -1610,7 +1625,7 @@
           <a:lstStyle xmlns:a="http://schemas.openxmlformats.org/drawingml/2006/main"/>
           <a:p xmlns:a="http://schemas.openxmlformats.org/drawingml/2006/main">
             <a:r>
-              <a:t>这是一张定位图，不使用未经验证的竞品打分。Blocky 的核心是同一底座覆盖入门到专业。</a:t>
+              <a:t>六个模板都是可继续增删积木的普通 Blocky 项目起点，不是六种封闭模式。官方运行时继续作为行为事实源；Blocky 通过锁定上游版本、进程外运行时、版本化适配器和可逆投影完成结构映射、配置往返与行为对照。当前这些是阶段 8 设计，正式适配器尚未实现。</a:t>
             </a:r>
           </a:p>
           <a:p xmlns:a="http://schemas.openxmlformats.org/drawingml/2006/main">
@@ -1625,12 +1640,17 @@
           </a:p>
           <a:p xmlns:a="http://schemas.openxmlformats.org/drawingml/2006/main">
             <a:r>
-              <a:t>- D:\1Folder\Blocky-AI\doc\执行计划\2026-08-23-Blocky-竞品驱动完整开发计划.md (竞品交互范式研究与产品边界)</a:t>
-            </a:r>
-          </a:p>
-          <a:p xmlns:a="http://schemas.openxmlformats.org/drawingml/2006/main">
-            <a:r>
-              <a:t>- D:\1Folder\Blocky-AI\doc\产品设计\Blocky-完整积木与Agent兼容设计.md (教育/专业同一 Workspace、IR 与项目格式)</a:t>
+              <a:t>- D:\1Folder\Blocky-AI\doc\产品设计\Blocky-内置兼容模板.md (六个模板、用户任务名、兼容等级与独立门禁)</a:t>
+            </a:r>
+          </a:p>
+          <a:p xmlns:a="http://schemas.openxmlformats.org/drawingml/2006/main">
+            <a:r>
+              <a:t>- D:\1Folder\Blocky-AI\doc\技术设计\ADR-002-原生Agent兼容运行时.md (固定上游版本、进程外运行时、版本化适配器、可逆投影)</a:t>
+            </a:r>
+          </a:p>
+          <a:p xmlns:a="http://schemas.openxmlformats.org/drawingml/2006/main">
+            <a:r>
+              <a:t>- D:\1Folder\Blocky-AI\doc\产品设计\Blocky-状态与阶段替换账本.md (六个正式适配器尚未实现)</a:t>
             </a:r>
           </a:p>
           <a:p xmlns:a="http://schemas.openxmlformats.org/drawingml/2006/main">
@@ -1705,7 +1725,7 @@
           <a:lstStyle xmlns:a="http://schemas.openxmlformats.org/drawingml/2006/main"/>
           <a:p xmlns:a="http://schemas.openxmlformats.org/drawingml/2006/main">
             <a:r>
-              <a:t>长稳数据绑定到原精确提交，不描述成当前版本重跑。阶段 1 仍是下一步。</a:t>
+              <a:t>左侧只陈述 Windows Core 技术尖峰已经验证的底座事实；右侧按正式开发计划列出尚未实现的阶段能力。长稳数据绑定原精确提交。六模板属于阶段 8，CLI、四个官方 Skills 与 Codex 插件属于阶段 9，教育工作区属于阶段 10。</a:t>
             </a:r>
           </a:p>
           <a:p xmlns:a="http://schemas.openxmlformats.org/drawingml/2006/main">
@@ -1725,12 +1745,7 @@
           </a:p>
           <a:p xmlns:a="http://schemas.openxmlformats.org/drawingml/2006/main">
             <a:r>
-              <a:t>- D:\1Folder\Blocky-AI\doc\验收\归档\2026-08-10\验收-Windows-Core技术尖峰.md (L3 尖峰验收)</a:t>
-            </a:r>
-          </a:p>
-          <a:p xmlns:a="http://schemas.openxmlformats.org/drawingml/2006/main">
-            <a:r>
-              <a:t>- D:\1Folder\Blocky-AI\doc\验收\归档\2026-08-23\验收-Blocky阶段0契约冻结.md (阶段 0 v1alpha1 契约验收)</a:t>
+              <a:t>- D:\1Folder\Blocky-AI\doc\执行计划\2026-08-23-Blocky-竞品驱动完整开发计划.md (阶段 1–10 实施顺序)</a:t>
             </a:r>
           </a:p>
           <a:p xmlns:a="http://schemas.openxmlformats.org/drawingml/2006/main">
@@ -1808,7 +1823,7 @@
   </p:cSld>
   <p:clrMap bg1="lt1" tx1="dk1" bg2="lt2" tx2="dk2" accent1="accent1" accent2="accent2" accent3="accent3" accent4="accent4" accent5="accent5" accent6="accent6" hlink="hlink" folHlink="folHlink"/>
   <p:sldLayoutIdLst>
-    <p:sldLayoutId xmlns:r="http://schemas.openxmlformats.org/officeDocument/2006/relationships" id="2147483649" r:id="Rd98a0285cc4748d5"/>
+    <p:sldLayoutId xmlns:r="http://schemas.openxmlformats.org/officeDocument/2006/relationships" id="2147483649" r:id="Rc62fcc91a5e24768"/>
   </p:sldLayoutIdLst>
   <p:txStyles>
     <p:titleStyle>
@@ -2456,7 +2471,7 @@
           <p:nvPr/>
         </p:nvPicPr>
         <p:blipFill>
-          <a:blip xmlns:r="http://schemas.openxmlformats.org/officeDocument/2006/relationships" xmlns:a="http://schemas.openxmlformats.org/drawingml/2006/main" r:embed="R1ca2c2e4eae24f45"/>
+          <a:blip xmlns:r="http://schemas.openxmlformats.org/officeDocument/2006/relationships" xmlns:a="http://schemas.openxmlformats.org/drawingml/2006/main" r:embed="Rac6c41fa6e0547d4"/>
           <a:stretch xmlns:a="http://schemas.openxmlformats.org/drawingml/2006/main"/>
         </p:blipFill>
         <p:spPr>
@@ -6899,30 +6914,32 @@
           </a:ln>
         </p:spPr>
         <p:txBody>
-          <a:bodyPr xmlns:a="http://schemas.openxmlformats.org/drawingml/2006/main"/>
+          <a:bodyPr xmlns:a="http://schemas.openxmlformats.org/drawingml/2006/main" wrap="square" lIns="0" tIns="0" rIns="0" bIns="0" anchor="ctr">
+            <a:normAutofit fontScale="100000"/>
+          </a:bodyPr>
           <a:lstStyle xmlns:a="http://schemas.openxmlformats.org/drawingml/2006/main"/>
           <a:p xmlns:a="http://schemas.openxmlformats.org/drawingml/2006/main">
             <a:pPr algn="l">
               <a:buNone/>
-              <a:defRPr sz="1500" b="0" i="0">
-                <a:solidFill>
-                  <a:srgbClr val="667085"/>
-                </a:solidFill>
-                <a:latin typeface="Microsoft YaHei"/>
-                <a:ea typeface="Microsoft YaHei"/>
-                <a:cs typeface="Microsoft YaHei"/>
-              </a:defRPr>
-            </a:pPr>
-            <a:r>
-              <a:rPr sz="1500" b="0" i="0">
-                <a:solidFill>
-                  <a:srgbClr val="667085"/>
-                </a:solidFill>
-                <a:latin typeface="Microsoft YaHei"/>
-                <a:ea typeface="Microsoft YaHei"/>
-                <a:cs typeface="Microsoft YaHei"/>
-              </a:rPr>
-              <a:t>跟随赛事迭代：初赛证明闭环，复赛进入试点，总决赛用真实数据回答价值。</a:t>
+              <a:defRPr sz="1425" b="0" i="0">
+                <a:solidFill>
+                  <a:srgbClr val="64748B"/>
+                </a:solidFill>
+                <a:latin typeface="Microsoft YaHei"/>
+                <a:ea typeface="Microsoft YaHei"/>
+                <a:cs typeface="Microsoft YaHei"/>
+              </a:defRPr>
+            </a:pPr>
+            <a:r>
+              <a:rPr sz="1425" b="0" i="0">
+                <a:solidFill>
+                  <a:srgbClr val="64748B"/>
+                </a:solidFill>
+                <a:latin typeface="Microsoft YaHei"/>
+                <a:ea typeface="Microsoft YaHei"/>
+                <a:cs typeface="Microsoft YaHei"/>
+              </a:rPr>
+              <a:t>赛事节点验证教育闭环；正式研发按阶段门禁推进，不把六模板与 CLI 伪装成当前 POC。</a:t>
             </a:r>
           </a:p>
         </p:txBody>
@@ -7518,54 +7535,80 @@
           </a:ln>
         </p:spPr>
         <p:txBody>
-          <a:bodyPr xmlns:a="http://schemas.openxmlformats.org/drawingml/2006/main"/>
+          <a:bodyPr xmlns:a="http://schemas.openxmlformats.org/drawingml/2006/main" wrap="square" lIns="0" tIns="0" rIns="0" bIns="0" anchor="ctr">
+            <a:normAutofit fontScale="100000"/>
+          </a:bodyPr>
           <a:lstStyle xmlns:a="http://schemas.openxmlformats.org/drawingml/2006/main"/>
           <a:p xmlns:a="http://schemas.openxmlformats.org/drawingml/2006/main">
             <a:pPr algn="l">
               <a:buNone/>
-              <a:defRPr sz="1500" b="0" i="0">
-                <a:solidFill>
-                  <a:srgbClr val="667085"/>
-                </a:solidFill>
-                <a:latin typeface="Microsoft YaHei"/>
-                <a:ea typeface="Microsoft YaHei"/>
-                <a:cs typeface="Microsoft YaHei"/>
-              </a:defRPr>
-            </a:pPr>
-            <a:r>
-              <a:rPr sz="1500" b="0" i="0">
-                <a:solidFill>
-                  <a:srgbClr val="667085"/>
-                </a:solidFill>
-                <a:latin typeface="Microsoft YaHei"/>
-                <a:ea typeface="Microsoft YaHei"/>
-                <a:cs typeface="Microsoft YaHei"/>
-              </a:rPr>
-              <a:t>接入真实 RAG 与模型</a:t>
+              <a:defRPr sz="1275" b="0" i="0">
+                <a:solidFill>
+                  <a:srgbClr val="64748B"/>
+                </a:solidFill>
+                <a:latin typeface="Microsoft YaHei"/>
+                <a:ea typeface="Microsoft YaHei"/>
+                <a:cs typeface="Microsoft YaHei"/>
+              </a:defRPr>
+            </a:pPr>
+            <a:r>
+              <a:rPr sz="1275" b="0" i="0">
+                <a:solidFill>
+                  <a:srgbClr val="64748B"/>
+                </a:solidFill>
+                <a:latin typeface="Microsoft YaHei"/>
+                <a:ea typeface="Microsoft YaHei"/>
+                <a:cs typeface="Microsoft YaHei"/>
+              </a:rPr>
+              <a:t>接入真实 RAG / 模型</a:t>
             </a:r>
           </a:p>
           <a:p xmlns:a="http://schemas.openxmlformats.org/drawingml/2006/main">
             <a:pPr algn="l">
               <a:buNone/>
-              <a:defRPr sz="1500" b="0" i="0">
-                <a:solidFill>
-                  <a:srgbClr val="667085"/>
-                </a:solidFill>
-                <a:latin typeface="Microsoft YaHei"/>
-                <a:ea typeface="Microsoft YaHei"/>
-                <a:cs typeface="Microsoft YaHei"/>
-              </a:defRPr>
-            </a:pPr>
-            <a:r>
-              <a:rPr sz="1500" b="0" i="0">
-                <a:solidFill>
-                  <a:srgbClr val="667085"/>
+              <a:defRPr sz="1275" b="0" i="0">
+                <a:solidFill>
+                  <a:srgbClr val="64748B"/>
+                </a:solidFill>
+                <a:latin typeface="Microsoft YaHei"/>
+                <a:ea typeface="Microsoft YaHei"/>
+                <a:cs typeface="Microsoft YaHei"/>
+              </a:defRPr>
+            </a:pPr>
+            <a:r>
+              <a:rPr sz="1275" b="0" i="0">
+                <a:solidFill>
+                  <a:srgbClr val="64748B"/>
                 </a:solidFill>
                 <a:latin typeface="Microsoft YaHei"/>
                 <a:ea typeface="Microsoft YaHei"/>
                 <a:cs typeface="Microsoft YaHei"/>
               </a:rPr>
               <a:t>邀请 3–5 位教师共创</a:t>
+            </a:r>
+          </a:p>
+          <a:p xmlns:a="http://schemas.openxmlformats.org/drawingml/2006/main">
+            <a:pPr algn="l">
+              <a:buNone/>
+              <a:defRPr sz="1275" b="0" i="0">
+                <a:solidFill>
+                  <a:srgbClr val="64748B"/>
+                </a:solidFill>
+                <a:latin typeface="Microsoft YaHei"/>
+                <a:ea typeface="Microsoft YaHei"/>
+                <a:cs typeface="Microsoft YaHei"/>
+              </a:defRPr>
+            </a:pPr>
+            <a:r>
+              <a:rPr sz="1275" b="0" i="0">
+                <a:solidFill>
+                  <a:srgbClr val="64748B"/>
+                </a:solidFill>
+                <a:latin typeface="Microsoft YaHei"/>
+                <a:ea typeface="Microsoft YaHei"/>
+                <a:cs typeface="Microsoft YaHei"/>
+              </a:rPr>
+              <a:t>记录完成率与解释率</a:t>
             </a:r>
           </a:p>
         </p:txBody>
@@ -7812,12 +7855,14 @@
           </a:ln>
         </p:spPr>
         <p:txBody>
-          <a:bodyPr xmlns:a="http://schemas.openxmlformats.org/drawingml/2006/main"/>
+          <a:bodyPr xmlns:a="http://schemas.openxmlformats.org/drawingml/2006/main" wrap="square" lIns="0" tIns="0" rIns="0" bIns="0" anchor="ctr">
+            <a:normAutofit fontScale="100000"/>
+          </a:bodyPr>
           <a:lstStyle xmlns:a="http://schemas.openxmlformats.org/drawingml/2006/main"/>
           <a:p xmlns:a="http://schemas.openxmlformats.org/drawingml/2006/main">
             <a:pPr algn="l">
               <a:buNone/>
-              <a:defRPr sz="2100" b="1" i="0">
+              <a:defRPr sz="1950" b="1" i="0">
                 <a:solidFill>
                   <a:srgbClr val="111827"/>
                 </a:solidFill>
@@ -7827,7 +7872,7 @@
               </a:defRPr>
             </a:pPr>
             <a:r>
-              <a:rPr sz="2100" b="1" i="0">
+              <a:rPr sz="1950" b="1" i="0">
                 <a:solidFill>
                   <a:srgbClr val="111827"/>
                 </a:solidFill>
@@ -7835,7 +7880,7 @@
                 <a:ea typeface="Microsoft YaHei"/>
                 <a:cs typeface="Microsoft YaHei"/>
               </a:rPr>
-              <a:t>产品与商业验证</a:t>
+              <a:t>产品 / 兼容 / 商业验证</a:t>
             </a:r>
           </a:p>
         </p:txBody>
@@ -7869,24 +7914,26 @@
           </a:ln>
         </p:spPr>
         <p:txBody>
-          <a:bodyPr xmlns:a="http://schemas.openxmlformats.org/drawingml/2006/main"/>
+          <a:bodyPr xmlns:a="http://schemas.openxmlformats.org/drawingml/2006/main" wrap="square" lIns="0" tIns="0" rIns="0" bIns="0" anchor="ctr">
+            <a:normAutofit fontScale="100000"/>
+          </a:bodyPr>
           <a:lstStyle xmlns:a="http://schemas.openxmlformats.org/drawingml/2006/main"/>
           <a:p xmlns:a="http://schemas.openxmlformats.org/drawingml/2006/main">
             <a:pPr algn="l">
               <a:buNone/>
-              <a:defRPr sz="1500" b="0" i="0">
-                <a:solidFill>
-                  <a:srgbClr val="667085"/>
-                </a:solidFill>
-                <a:latin typeface="Microsoft YaHei"/>
-                <a:ea typeface="Microsoft YaHei"/>
-                <a:cs typeface="Microsoft YaHei"/>
-              </a:defRPr>
-            </a:pPr>
-            <a:r>
-              <a:rPr sz="1500" b="0" i="0">
-                <a:solidFill>
-                  <a:srgbClr val="667085"/>
+              <a:defRPr sz="1275" b="0" i="0">
+                <a:solidFill>
+                  <a:srgbClr val="64748B"/>
+                </a:solidFill>
+                <a:latin typeface="Microsoft YaHei"/>
+                <a:ea typeface="Microsoft YaHei"/>
+                <a:cs typeface="Microsoft YaHei"/>
+              </a:defRPr>
+            </a:pPr>
+            <a:r>
+              <a:rPr sz="1275" b="0" i="0">
+                <a:solidFill>
+                  <a:srgbClr val="64748B"/>
                 </a:solidFill>
                 <a:latin typeface="Microsoft YaHei"/>
                 <a:ea typeface="Microsoft YaHei"/>
@@ -7898,19 +7945,43 @@
           <a:p xmlns:a="http://schemas.openxmlformats.org/drawingml/2006/main">
             <a:pPr algn="l">
               <a:buNone/>
-              <a:defRPr sz="1500" b="0" i="0">
-                <a:solidFill>
-                  <a:srgbClr val="667085"/>
-                </a:solidFill>
-                <a:latin typeface="Microsoft YaHei"/>
-                <a:ea typeface="Microsoft YaHei"/>
-                <a:cs typeface="Microsoft YaHei"/>
-              </a:defRPr>
-            </a:pPr>
-            <a:r>
-              <a:rPr sz="1500" b="0" i="0">
-                <a:solidFill>
-                  <a:srgbClr val="667085"/>
+              <a:defRPr sz="1275" b="0" i="0">
+                <a:solidFill>
+                  <a:srgbClr val="64748B"/>
+                </a:solidFill>
+                <a:latin typeface="Microsoft YaHei"/>
+                <a:ea typeface="Microsoft YaHei"/>
+                <a:cs typeface="Microsoft YaHei"/>
+              </a:defRPr>
+            </a:pPr>
+            <a:r>
+              <a:rPr sz="1275" b="0" i="0">
+                <a:solidFill>
+                  <a:srgbClr val="64748B"/>
+                </a:solidFill>
+                <a:latin typeface="Microsoft YaHei"/>
+                <a:ea typeface="Microsoft YaHei"/>
+                <a:cs typeface="Microsoft YaHei"/>
+              </a:rPr>
+              <a:t>Pi / Codex 只读兼容报告</a:t>
+            </a:r>
+          </a:p>
+          <a:p xmlns:a="http://schemas.openxmlformats.org/drawingml/2006/main">
+            <a:pPr algn="l">
+              <a:buNone/>
+              <a:defRPr sz="1275" b="0" i="0">
+                <a:solidFill>
+                  <a:srgbClr val="64748B"/>
+                </a:solidFill>
+                <a:latin typeface="Microsoft YaHei"/>
+                <a:ea typeface="Microsoft YaHei"/>
+                <a:cs typeface="Microsoft YaHei"/>
+              </a:defRPr>
+            </a:pPr>
+            <a:r>
+              <a:rPr sz="1275" b="0" i="0">
+                <a:solidFill>
+                  <a:srgbClr val="64748B"/>
                 </a:solidFill>
                 <a:latin typeface="Microsoft YaHei"/>
                 <a:ea typeface="Microsoft YaHei"/>
@@ -7983,7 +8054,9 @@
           </a:ln>
         </p:spPr>
         <p:txBody>
-          <a:bodyPr xmlns:a="http://schemas.openxmlformats.org/drawingml/2006/main"/>
+          <a:bodyPr xmlns:a="http://schemas.openxmlformats.org/drawingml/2006/main" wrap="square" lIns="0" tIns="0" rIns="0" bIns="0" anchor="ctr">
+            <a:normAutofit fontScale="100000"/>
+          </a:bodyPr>
           <a:lstStyle xmlns:a="http://schemas.openxmlformats.org/drawingml/2006/main"/>
           <a:p xmlns:a="http://schemas.openxmlformats.org/drawingml/2006/main">
             <a:pPr algn="ctr">
@@ -8006,7 +8079,7 @@
                 <a:ea typeface="Microsoft YaHei"/>
                 <a:cs typeface="Microsoft YaHei"/>
               </a:rPr>
-              <a:t>门禁：教师复用、付费试点、部署可行</a:t>
+              <a:t>门禁：教师复用、兼容边界、付费试点</a:t>
             </a:r>
           </a:p>
         </p:txBody>
@@ -8040,14 +8113,16 @@
           </a:ln>
         </p:spPr>
         <p:txBody>
-          <a:bodyPr xmlns:a="http://schemas.openxmlformats.org/drawingml/2006/main"/>
+          <a:bodyPr xmlns:a="http://schemas.openxmlformats.org/drawingml/2006/main" wrap="square" lIns="0" tIns="0" rIns="0" bIns="0" anchor="ctr">
+            <a:normAutofit fontScale="100000"/>
+          </a:bodyPr>
           <a:lstStyle xmlns:a="http://schemas.openxmlformats.org/drawingml/2006/main"/>
           <a:p xmlns:a="http://schemas.openxmlformats.org/drawingml/2006/main">
             <a:pPr algn="ctr">
               <a:buNone/>
               <a:defRPr sz="1125" b="0" i="0">
                 <a:solidFill>
-                  <a:srgbClr val="98A2B3"/>
+                  <a:srgbClr val="94A3B8"/>
                 </a:solidFill>
                 <a:latin typeface="Microsoft YaHei"/>
                 <a:ea typeface="Microsoft YaHei"/>
@@ -8057,13 +8132,13 @@
             <a:r>
               <a:rPr sz="1125" b="0" i="0">
                 <a:solidFill>
-                  <a:srgbClr val="98A2B3"/>
-                </a:solidFill>
-                <a:latin typeface="Microsoft YaHei"/>
-                <a:ea typeface="Microsoft YaHei"/>
-                <a:cs typeface="Microsoft YaHei"/>
-              </a:rPr>
-              <a:t>时间与试点规模为参赛执行建议；正式研发仍受 Blocky 阶段门禁约束。</a:t>
+                  <a:srgbClr val="94A3B8"/>
+                </a:solidFill>
+                <a:latin typeface="Microsoft YaHei"/>
+                <a:ea typeface="Microsoft YaHei"/>
+                <a:cs typeface="Microsoft YaHei"/>
+              </a:rPr>
+              <a:t>六个正式适配器与四个官方 Skills 仍依阶段 8/9 推进，不作为当前 POC 已实现能力。</a:t>
             </a:r>
           </a:p>
         </p:txBody>
@@ -8534,12 +8609,14 @@
           </a:ln>
         </p:spPr>
         <p:txBody>
-          <a:bodyPr xmlns:a="http://schemas.openxmlformats.org/drawingml/2006/main"/>
+          <a:bodyPr xmlns:a="http://schemas.openxmlformats.org/drawingml/2006/main" wrap="square" lIns="0" tIns="0" rIns="0" bIns="0" anchor="ctr">
+            <a:normAutofit fontScale="92783"/>
+          </a:bodyPr>
           <a:lstStyle xmlns:a="http://schemas.openxmlformats.org/drawingml/2006/main"/>
           <a:p xmlns:a="http://schemas.openxmlformats.org/drawingml/2006/main">
             <a:pPr algn="l">
               <a:buNone/>
-              <a:defRPr sz="1275" b="0" i="0">
+              <a:defRPr sz="1125" b="0" i="0">
                 <a:solidFill>
                   <a:srgbClr val="FFFFFF"/>
                 </a:solidFill>
@@ -8549,7 +8626,7 @@
               </a:defRPr>
             </a:pPr>
             <a:r>
-              <a:rPr sz="1275" b="0" i="0">
+              <a:rPr sz="1125" b="0" i="0">
                 <a:solidFill>
                   <a:srgbClr val="FFFFFF"/>
                 </a:solidFill>
@@ -8557,7 +8634,7 @@
                 <a:ea typeface="Microsoft YaHei"/>
                 <a:cs typeface="Microsoft YaHei"/>
               </a:rPr>
-              <a:t>可见积木 → 稳定 IR → 可回放轨迹</a:t>
+              <a:t>可见积木 → 稳定 IR → 可回放 Trace → 可逆映射</a:t>
             </a:r>
           </a:p>
         </p:txBody>
@@ -9130,7 +9207,9 @@
           </a:ln>
         </p:spPr>
         <p:txBody>
-          <a:bodyPr xmlns:a="http://schemas.openxmlformats.org/drawingml/2006/main"/>
+          <a:bodyPr xmlns:a="http://schemas.openxmlformats.org/drawingml/2006/main" wrap="square" lIns="0" tIns="0" rIns="0" bIns="0" anchor="ctr">
+            <a:normAutofit fontScale="100000"/>
+          </a:bodyPr>
           <a:lstStyle xmlns:a="http://schemas.openxmlformats.org/drawingml/2006/main"/>
           <a:p xmlns:a="http://schemas.openxmlformats.org/drawingml/2006/main">
             <a:pPr algn="l">
@@ -9153,7 +9232,7 @@
                 <a:ea typeface="Microsoft YaHei"/>
                 <a:cs typeface="Microsoft YaHei"/>
               </a:rPr>
-              <a:t>同一项目格式与内核，逐阶段扩展</a:t>
+              <a:t>六模板 → CLI / 四 Skills → 社区与多端</a:t>
             </a:r>
           </a:p>
         </p:txBody>
@@ -11770,7 +11849,9 @@
           </a:ln>
         </p:spPr>
         <p:txBody>
-          <a:bodyPr xmlns:a="http://schemas.openxmlformats.org/drawingml/2006/main"/>
+          <a:bodyPr xmlns:a="http://schemas.openxmlformats.org/drawingml/2006/main" wrap="square" lIns="0" tIns="0" rIns="0" bIns="0" anchor="ctr">
+            <a:normAutofit fontScale="100000"/>
+          </a:bodyPr>
           <a:lstStyle xmlns:a="http://schemas.openxmlformats.org/drawingml/2006/main"/>
           <a:p xmlns:a="http://schemas.openxmlformats.org/drawingml/2006/main">
             <a:pPr algn="l">
@@ -11793,7 +11874,7 @@
                 <a:ea typeface="Microsoft YaHei"/>
                 <a:cs typeface="Microsoft YaHei"/>
               </a:rPr>
-              <a:t>Blocky 把 AI 系统变成学生看得见的积木语言</a:t>
+              <a:t>一套 Scratch 式语言，贯通入门视图与专业创作</a:t>
             </a:r>
           </a:p>
         </p:txBody>
@@ -11827,30 +11908,32 @@
           </a:ln>
         </p:spPr>
         <p:txBody>
-          <a:bodyPr xmlns:a="http://schemas.openxmlformats.org/drawingml/2006/main"/>
+          <a:bodyPr xmlns:a="http://schemas.openxmlformats.org/drawingml/2006/main" wrap="square" lIns="0" tIns="0" rIns="0" bIns="0" anchor="ctr">
+            <a:normAutofit fontScale="100000"/>
+          </a:bodyPr>
           <a:lstStyle xmlns:a="http://schemas.openxmlformats.org/drawingml/2006/main"/>
           <a:p xmlns:a="http://schemas.openxmlformats.org/drawingml/2006/main">
             <a:pPr algn="l">
               <a:buNone/>
-              <a:defRPr sz="1500" b="0" i="0">
-                <a:solidFill>
-                  <a:srgbClr val="667085"/>
-                </a:solidFill>
-                <a:latin typeface="Microsoft YaHei"/>
-                <a:ea typeface="Microsoft YaHei"/>
-                <a:cs typeface="Microsoft YaHei"/>
-              </a:defRPr>
-            </a:pPr>
-            <a:r>
-              <a:rPr sz="1500" b="0" i="0">
-                <a:solidFill>
-                  <a:srgbClr val="667085"/>
-                </a:solidFill>
-                <a:latin typeface="Microsoft YaHei"/>
-                <a:ea typeface="Microsoft YaHei"/>
-                <a:cs typeface="Microsoft YaHei"/>
-              </a:rPr>
-              <a:t>不是节点连线壳，也不是提示词黑箱；每个能力都能被选择、组合、运行和解释。</a:t>
+              <a:defRPr sz="1425" b="0" i="0">
+                <a:solidFill>
+                  <a:srgbClr val="64748B"/>
+                </a:solidFill>
+                <a:latin typeface="Microsoft YaHei"/>
+                <a:ea typeface="Microsoft YaHei"/>
+                <a:cs typeface="Microsoft YaHei"/>
+              </a:defRPr>
+            </a:pPr>
+            <a:r>
+              <a:rPr sz="1425" b="0" i="0">
+                <a:solidFill>
+                  <a:srgbClr val="64748B"/>
+                </a:solidFill>
+                <a:latin typeface="Microsoft YaHei"/>
+                <a:ea typeface="Microsoft YaHei"/>
+                <a:cs typeface="Microsoft YaHei"/>
+              </a:rPr>
+              <a:t>左：积木库｜中：多画布 / 浏览器｜右：构建助手 / 运行 Agent｜下：问题 / 日志 / 终端 / 输出</a:t>
             </a:r>
           </a:p>
         </p:txBody>
@@ -11897,7 +11980,7 @@
           <p:nvPr/>
         </p:nvPicPr>
         <p:blipFill>
-          <a:blip xmlns:r="http://schemas.openxmlformats.org/officeDocument/2006/relationships" xmlns:a="http://schemas.openxmlformats.org/drawingml/2006/main" r:embed="Rff3ad4091e354018"/>
+          <a:blip xmlns:r="http://schemas.openxmlformats.org/officeDocument/2006/relationships" xmlns:a="http://schemas.openxmlformats.org/drawingml/2006/main" r:embed="Rd418696b11a34a98"/>
           <a:srcRect xmlns:a="http://schemas.openxmlformats.org/drawingml/2006/main" l="0" t="2671" r="0" b="2671"/>
           <a:stretch xmlns:a="http://schemas.openxmlformats.org/drawingml/2006/main">
             <a:fillRect l="0" t="0" r="0" b="0"/>
@@ -12034,7 +12117,9 @@
           </a:ln>
         </p:spPr>
         <p:txBody>
-          <a:bodyPr xmlns:a="http://schemas.openxmlformats.org/drawingml/2006/main"/>
+          <a:bodyPr xmlns:a="http://schemas.openxmlformats.org/drawingml/2006/main" wrap="square" lIns="0" tIns="0" rIns="0" bIns="0" anchor="ctr">
+            <a:normAutofit fontScale="100000"/>
+          </a:bodyPr>
           <a:lstStyle xmlns:a="http://schemas.openxmlformats.org/drawingml/2006/main"/>
           <a:p xmlns:a="http://schemas.openxmlformats.org/drawingml/2006/main">
             <a:pPr algn="l">
@@ -12057,7 +12142,7 @@
                 <a:ea typeface="Microsoft YaHei"/>
                 <a:cs typeface="Microsoft YaHei"/>
               </a:rPr>
-              <a:t>入门视图：七类任务语言</a:t>
+              <a:t>入门七类 → 专业十二类</a:t>
             </a:r>
           </a:p>
         </p:txBody>
@@ -12741,25 +12826,27 @@
         </p:nvSpPr>
         <p:spPr>
           <a:xfrm xmlns:a="http://schemas.openxmlformats.org/drawingml/2006/main">
-            <a:off x="7924800" y="5324475"/>
-            <a:ext cx="2857500" cy="304800"/>
-          </a:xfrm>
-          <a:prstGeom xmlns:a="http://schemas.openxmlformats.org/drawingml/2006/main" prst="rect">
-            <a:avLst/>
-          </a:prstGeom>
-          <a:noFill xmlns:a="http://schemas.openxmlformats.org/drawingml/2006/main"/>
-          <a:ln xmlns:a="http://schemas.openxmlformats.org/drawingml/2006/main" w="0">
-            <a:noFill/>
-            <a:prstDash val="solid"/>
-          </a:ln>
-        </p:spPr>
-        <p:txBody>
-          <a:bodyPr xmlns:a="http://schemas.openxmlformats.org/drawingml/2006/main"/>
+            <a:off x="7867650" y="5229225"/>
+            <a:ext cx="2971800" cy="438150"/>
+          </a:xfrm>
+          <a:prstGeom xmlns:a="http://schemas.openxmlformats.org/drawingml/2006/main" prst="rect">
+            <a:avLst/>
+          </a:prstGeom>
+          <a:noFill xmlns:a="http://schemas.openxmlformats.org/drawingml/2006/main"/>
+          <a:ln xmlns:a="http://schemas.openxmlformats.org/drawingml/2006/main" w="0">
+            <a:noFill/>
+            <a:prstDash val="solid"/>
+          </a:ln>
+        </p:spPr>
+        <p:txBody>
+          <a:bodyPr xmlns:a="http://schemas.openxmlformats.org/drawingml/2006/main" wrap="square" lIns="0" tIns="0" rIns="0" bIns="0" anchor="ctr">
+            <a:normAutofit fontScale="100000"/>
+          </a:bodyPr>
           <a:lstStyle xmlns:a="http://schemas.openxmlformats.org/drawingml/2006/main"/>
           <a:p xmlns:a="http://schemas.openxmlformats.org/drawingml/2006/main">
             <a:pPr algn="ctr">
               <a:buNone/>
-              <a:defRPr sz="1275" b="1" i="0">
+              <a:defRPr sz="1050" b="1" i="0">
                 <a:solidFill>
                   <a:srgbClr val="111827"/>
                 </a:solidFill>
@@ -12769,7 +12856,7 @@
               </a:defRPr>
             </a:pPr>
             <a:r>
-              <a:rPr sz="1275" b="1" i="0">
+              <a:rPr sz="1050" b="1" i="0">
                 <a:solidFill>
                   <a:srgbClr val="111827"/>
                 </a:solidFill>
@@ -12777,7 +12864,31 @@
                 <a:ea typeface="Microsoft YaHei"/>
                 <a:cs typeface="Microsoft YaHei"/>
               </a:rPr>
-              <a:t>教育视图与专业视图共享项目格式、运行内核和安全模型</a:t>
+              <a:t>同一 Project Manifest / Workspace / IR</a:t>
+            </a:r>
+          </a:p>
+          <a:p xmlns:a="http://schemas.openxmlformats.org/drawingml/2006/main">
+            <a:pPr algn="ctr">
+              <a:buNone/>
+              <a:defRPr sz="1050" b="1" i="0">
+                <a:solidFill>
+                  <a:srgbClr val="111827"/>
+                </a:solidFill>
+                <a:latin typeface="Microsoft YaHei"/>
+                <a:ea typeface="Microsoft YaHei"/>
+                <a:cs typeface="Microsoft YaHei"/>
+              </a:defRPr>
+            </a:pPr>
+            <a:r>
+              <a:rPr sz="1050" b="1" i="0">
+                <a:solidFill>
+                  <a:srgbClr val="111827"/>
+                </a:solidFill>
+                <a:latin typeface="Microsoft YaHei"/>
+                <a:ea typeface="Microsoft YaHei"/>
+                <a:cs typeface="Microsoft YaHei"/>
+              </a:rPr>
+              <a:t>共享运行内核、权限模型与项目格式</a:t>
             </a:r>
           </a:p>
         </p:txBody>
@@ -16702,7 +16813,9 @@
           </a:ln>
         </p:spPr>
         <p:txBody>
-          <a:bodyPr xmlns:a="http://schemas.openxmlformats.org/drawingml/2006/main"/>
+          <a:bodyPr xmlns:a="http://schemas.openxmlformats.org/drawingml/2006/main" wrap="square" lIns="0" tIns="0" rIns="0" bIns="0" anchor="ctr">
+            <a:normAutofit fontScale="100000"/>
+          </a:bodyPr>
           <a:lstStyle xmlns:a="http://schemas.openxmlformats.org/drawingml/2006/main"/>
           <a:p xmlns:a="http://schemas.openxmlformats.org/drawingml/2006/main">
             <a:pPr algn="l">
@@ -16725,7 +16838,7 @@
                 <a:ea typeface="Microsoft YaHei"/>
                 <a:cs typeface="Microsoft YaHei"/>
               </a:rPr>
-              <a:t>真正的创新不是积木外观，而是可验证的语义链</a:t>
+              <a:t>壁垒不是积木数量，而是可验证、可回放、可逆的语义链</a:t>
             </a:r>
           </a:p>
         </p:txBody>
@@ -16759,14 +16872,16 @@
           </a:ln>
         </p:spPr>
         <p:txBody>
-          <a:bodyPr xmlns:a="http://schemas.openxmlformats.org/drawingml/2006/main"/>
+          <a:bodyPr xmlns:a="http://schemas.openxmlformats.org/drawingml/2006/main" wrap="square" lIns="0" tIns="0" rIns="0" bIns="0" anchor="ctr">
+            <a:normAutofit fontScale="100000"/>
+          </a:bodyPr>
           <a:lstStyle xmlns:a="http://schemas.openxmlformats.org/drawingml/2006/main"/>
           <a:p xmlns:a="http://schemas.openxmlformats.org/drawingml/2006/main">
             <a:pPr algn="l">
               <a:buNone/>
               <a:defRPr sz="1500" b="0" i="0">
                 <a:solidFill>
-                  <a:srgbClr val="667085"/>
+                  <a:srgbClr val="64748B"/>
                 </a:solidFill>
                 <a:latin typeface="Microsoft YaHei"/>
                 <a:ea typeface="Microsoft YaHei"/>
@@ -16776,13 +16891,13 @@
             <a:r>
               <a:rPr sz="1500" b="0" i="0">
                 <a:solidFill>
-                  <a:srgbClr val="667085"/>
-                </a:solidFill>
-                <a:latin typeface="Microsoft YaHei"/>
-                <a:ea typeface="Microsoft YaHei"/>
-                <a:cs typeface="Microsoft YaHei"/>
-              </a:rPr>
-              <a:t>从学生能理解的表达，贯通到系统能执行、老师能复核的证据。</a:t>
+                  <a:srgbClr val="64748B"/>
+                </a:solidFill>
+                <a:latin typeface="Microsoft YaHei"/>
+                <a:ea typeface="Microsoft YaHei"/>
+                <a:cs typeface="Microsoft YaHei"/>
+              </a:rPr>
+              <a:t>一条语义链同时服务学生理解、系统执行、教师复核与主流 Agent 兼容。</a:t>
             </a:r>
           </a:p>
         </p:txBody>
@@ -17789,7 +17904,9 @@
           </a:ln>
         </p:spPr>
         <p:txBody>
-          <a:bodyPr xmlns:a="http://schemas.openxmlformats.org/drawingml/2006/main"/>
+          <a:bodyPr xmlns:a="http://schemas.openxmlformats.org/drawingml/2006/main" wrap="square" lIns="0" tIns="0" rIns="0" bIns="0" anchor="ctr">
+            <a:normAutofit fontScale="100000"/>
+          </a:bodyPr>
           <a:lstStyle xmlns:a="http://schemas.openxmlformats.org/drawingml/2006/main"/>
           <a:p xmlns:a="http://schemas.openxmlformats.org/drawingml/2006/main">
             <a:pPr algn="ctr">
@@ -17812,7 +17929,7 @@
                 <a:ea typeface="Microsoft YaHei"/>
                 <a:cs typeface="Microsoft YaHei"/>
               </a:rPr>
-              <a:t>可逆映射</a:t>
+              <a:t>适配器可逆</a:t>
             </a:r>
           </a:p>
         </p:txBody>
@@ -17846,30 +17963,32 @@
           </a:ln>
         </p:spPr>
         <p:txBody>
-          <a:bodyPr xmlns:a="http://schemas.openxmlformats.org/drawingml/2006/main"/>
+          <a:bodyPr xmlns:a="http://schemas.openxmlformats.org/drawingml/2006/main" wrap="square" lIns="0" tIns="0" rIns="0" bIns="0" anchor="ctr">
+            <a:normAutofit fontScale="100000"/>
+          </a:bodyPr>
           <a:lstStyle xmlns:a="http://schemas.openxmlformats.org/drawingml/2006/main"/>
           <a:p xmlns:a="http://schemas.openxmlformats.org/drawingml/2006/main">
             <a:pPr algn="ctr">
               <a:buNone/>
-              <a:defRPr sz="1275" b="0" i="0">
-                <a:solidFill>
-                  <a:srgbClr val="667085"/>
-                </a:solidFill>
-                <a:latin typeface="Microsoft YaHei"/>
-                <a:ea typeface="Microsoft YaHei"/>
-                <a:cs typeface="Microsoft YaHei"/>
-              </a:defRPr>
-            </a:pPr>
-            <a:r>
-              <a:rPr sz="1275" b="0" i="0">
-                <a:solidFill>
-                  <a:srgbClr val="667085"/>
-                </a:solidFill>
-                <a:latin typeface="Microsoft YaHei"/>
-                <a:ea typeface="Microsoft YaHei"/>
-                <a:cs typeface="Microsoft YaHei"/>
-              </a:rPr>
-              <a:t>蓝图 / 代码可成长</a:t>
+              <a:defRPr sz="1200" b="0" i="0">
+                <a:solidFill>
+                  <a:srgbClr val="64748B"/>
+                </a:solidFill>
+                <a:latin typeface="Microsoft YaHei"/>
+                <a:ea typeface="Microsoft YaHei"/>
+                <a:cs typeface="Microsoft YaHei"/>
+              </a:defRPr>
+            </a:pPr>
+            <a:r>
+              <a:rPr sz="1200" b="0" i="0">
+                <a:solidFill>
+                  <a:srgbClr val="64748B"/>
+                </a:solidFill>
+                <a:latin typeface="Microsoft YaHei"/>
+                <a:ea typeface="Microsoft YaHei"/>
+                <a:cs typeface="Microsoft YaHei"/>
+              </a:rPr>
+              <a:t>模板 / 原生写回</a:t>
             </a:r>
           </a:p>
         </p:txBody>
@@ -17936,30 +18055,32 @@
           </a:ln>
         </p:spPr>
         <p:txBody>
-          <a:bodyPr xmlns:a="http://schemas.openxmlformats.org/drawingml/2006/main"/>
+          <a:bodyPr xmlns:a="http://schemas.openxmlformats.org/drawingml/2006/main" wrap="square" lIns="0" tIns="0" rIns="0" bIns="0" anchor="ctr">
+            <a:normAutofit fontScale="100000"/>
+          </a:bodyPr>
           <a:lstStyle xmlns:a="http://schemas.openxmlformats.org/drawingml/2006/main"/>
           <a:p xmlns:a="http://schemas.openxmlformats.org/drawingml/2006/main">
             <a:pPr algn="ctr">
               <a:buNone/>
-              <a:defRPr sz="2025" b="1" i="0">
-                <a:solidFill>
-                  <a:srgbClr val="F79009"/>
-                </a:solidFill>
-                <a:latin typeface="Microsoft YaHei"/>
-                <a:ea typeface="Microsoft YaHei"/>
-                <a:cs typeface="Microsoft YaHei"/>
-              </a:defRPr>
-            </a:pPr>
-            <a:r>
-              <a:rPr sz="2025" b="1" i="0">
-                <a:solidFill>
-                  <a:srgbClr val="F79009"/>
-                </a:solidFill>
-                <a:latin typeface="Microsoft YaHei"/>
-                <a:ea typeface="Microsoft YaHei"/>
-                <a:cs typeface="Microsoft YaHei"/>
-              </a:rPr>
-              <a:t>可解释性不是运行结束后的“作文”</a:t>
+              <a:defRPr sz="1875" b="1" i="0">
+                <a:solidFill>
+                  <a:srgbClr val="FF8A00"/>
+                </a:solidFill>
+                <a:latin typeface="Microsoft YaHei"/>
+                <a:ea typeface="Microsoft YaHei"/>
+                <a:cs typeface="Microsoft YaHei"/>
+              </a:defRPr>
+            </a:pPr>
+            <a:r>
+              <a:rPr sz="1875" b="1" i="0">
+                <a:solidFill>
+                  <a:srgbClr val="FF8A00"/>
+                </a:solidFill>
+                <a:latin typeface="Microsoft YaHei"/>
+                <a:ea typeface="Microsoft YaHei"/>
+                <a:cs typeface="Microsoft YaHei"/>
+              </a:rPr>
+              <a:t>同一语义链服务桌面、CLI、四个官方 Skills 与六个兼容模板</a:t>
             </a:r>
           </a:p>
         </p:txBody>
@@ -17980,25 +18101,27 @@
         </p:nvSpPr>
         <p:spPr>
           <a:xfrm xmlns:a="http://schemas.openxmlformats.org/drawingml/2006/main">
-            <a:off x="1828800" y="5219700"/>
-            <a:ext cx="8534400" cy="285750"/>
-          </a:xfrm>
-          <a:prstGeom xmlns:a="http://schemas.openxmlformats.org/drawingml/2006/main" prst="rect">
-            <a:avLst/>
-          </a:prstGeom>
-          <a:noFill xmlns:a="http://schemas.openxmlformats.org/drawingml/2006/main"/>
-          <a:ln xmlns:a="http://schemas.openxmlformats.org/drawingml/2006/main" w="0">
-            <a:noFill/>
-            <a:prstDash val="solid"/>
-          </a:ln>
-        </p:spPr>
-        <p:txBody>
-          <a:bodyPr xmlns:a="http://schemas.openxmlformats.org/drawingml/2006/main"/>
+            <a:off x="1828800" y="5143500"/>
+            <a:ext cx="8534400" cy="419100"/>
+          </a:xfrm>
+          <a:prstGeom xmlns:a="http://schemas.openxmlformats.org/drawingml/2006/main" prst="rect">
+            <a:avLst/>
+          </a:prstGeom>
+          <a:noFill xmlns:a="http://schemas.openxmlformats.org/drawingml/2006/main"/>
+          <a:ln xmlns:a="http://schemas.openxmlformats.org/drawingml/2006/main" w="0">
+            <a:noFill/>
+            <a:prstDash val="solid"/>
+          </a:ln>
+        </p:spPr>
+        <p:txBody>
+          <a:bodyPr xmlns:a="http://schemas.openxmlformats.org/drawingml/2006/main" wrap="square" lIns="0" tIns="0" rIns="0" bIns="0" anchor="ctr">
+            <a:normAutofit fontScale="100000"/>
+          </a:bodyPr>
           <a:lstStyle xmlns:a="http://schemas.openxmlformats.org/drawingml/2006/main"/>
           <a:p xmlns:a="http://schemas.openxmlformats.org/drawingml/2006/main">
             <a:pPr algn="ctr">
               <a:buNone/>
-              <a:defRPr sz="1650" b="0" i="0">
+              <a:defRPr sz="1200" b="0" i="0">
                 <a:solidFill>
                   <a:srgbClr val="111827"/>
                 </a:solidFill>
@@ -18008,7 +18131,7 @@
               </a:defRPr>
             </a:pPr>
             <a:r>
-              <a:rPr sz="1650" b="0" i="0">
+              <a:rPr sz="1200" b="0" i="0">
                 <a:solidFill>
                   <a:srgbClr val="111827"/>
                 </a:solidFill>
@@ -18016,7 +18139,31 @@
                 <a:ea typeface="Microsoft YaHei"/>
                 <a:cs typeface="Microsoft YaHei"/>
               </a:rPr>
-              <a:t>它来自积木、编译、权限与运行轨迹本身。</a:t>
+              <a:t>$build-blocky-agents · $create-blocky-blocks</a:t>
+            </a:r>
+          </a:p>
+          <a:p xmlns:a="http://schemas.openxmlformats.org/drawingml/2006/main">
+            <a:pPr algn="ctr">
+              <a:buNone/>
+              <a:defRPr sz="1200" b="0" i="0">
+                <a:solidFill>
+                  <a:srgbClr val="111827"/>
+                </a:solidFill>
+                <a:latin typeface="Microsoft YaHei"/>
+                <a:ea typeface="Microsoft YaHei"/>
+                <a:cs typeface="Microsoft YaHei"/>
+              </a:defRPr>
+            </a:pPr>
+            <a:r>
+              <a:rPr sz="1200" b="0" i="0">
+                <a:solidFill>
+                  <a:srgbClr val="111827"/>
+                </a:solidFill>
+                <a:latin typeface="Microsoft YaHei"/>
+                <a:ea typeface="Microsoft YaHei"/>
+                <a:cs typeface="Microsoft YaHei"/>
+              </a:rPr>
+              <a:t>$convert-github-project-to-blocky · $reverse-agent-to-blocky</a:t>
             </a:r>
           </a:p>
         </p:txBody>
@@ -18281,7 +18428,9 @@
           </a:ln>
         </p:spPr>
         <p:txBody>
-          <a:bodyPr xmlns:a="http://schemas.openxmlformats.org/drawingml/2006/main"/>
+          <a:bodyPr xmlns:a="http://schemas.openxmlformats.org/drawingml/2006/main" wrap="square" lIns="0" tIns="0" rIns="0" bIns="0" anchor="ctr">
+            <a:normAutofit fontScale="100000"/>
+          </a:bodyPr>
           <a:lstStyle xmlns:a="http://schemas.openxmlformats.org/drawingml/2006/main"/>
           <a:p xmlns:a="http://schemas.openxmlformats.org/drawingml/2006/main">
             <a:pPr algn="l">
@@ -18304,7 +18453,7 @@
                 <a:ea typeface="Microsoft YaHei"/>
                 <a:cs typeface="Microsoft YaHei"/>
               </a:rPr>
-              <a:t>Blocky 用积木降低上手门槛，也保留能力成长空间</a:t>
+              <a:t>六个兼容模板，把主流 Agent 变成可改造项目起点</a:t>
             </a:r>
           </a:p>
         </p:txBody>
@@ -18333,9 +18482,7 @@
               <a:gd name="adj" fmla="val 5556"/>
             </a:avLst>
           </a:prstGeom>
-          <a:solidFill xmlns:a="http://schemas.openxmlformats.org/drawingml/2006/main">
-            <a:srgbClr val="F4F7FB"/>
-          </a:solidFill>
+          <a:noFill xmlns:a="http://schemas.openxmlformats.org/drawingml/2006/main"/>
           <a:ln xmlns:a="http://schemas.openxmlformats.org/drawingml/2006/main" w="0">
             <a:noFill/>
             <a:prstDash val="solid"/>
@@ -18358,7 +18505,7 @@
         </p:nvSpPr>
         <p:spPr>
           <a:xfrm xmlns:a="http://schemas.openxmlformats.org/drawingml/2006/main">
-            <a:off x="2590800" y="2438400"/>
+            <a:off x="13335000" y="2438400"/>
             <a:ext cx="28575" cy="2476500"/>
           </a:xfrm>
           <a:prstGeom xmlns:a="http://schemas.openxmlformats.org/drawingml/2006/main" prst="rect">
@@ -18389,7 +18536,7 @@
         </p:nvSpPr>
         <p:spPr>
           <a:xfrm xmlns:a="http://schemas.openxmlformats.org/drawingml/2006/main">
-            <a:off x="2590800" y="4895850"/>
+            <a:off x="13373100" y="4895850"/>
             <a:ext cx="6191250" cy="28575"/>
           </a:xfrm>
           <a:prstGeom xmlns:a="http://schemas.openxmlformats.org/drawingml/2006/main" prst="rect">
@@ -18420,7 +18567,7 @@
         </p:nvSpPr>
         <p:spPr>
           <a:xfrm xmlns:a="http://schemas.openxmlformats.org/drawingml/2006/main">
-            <a:off x="2590800" y="3648075"/>
+            <a:off x="13411200" y="3648075"/>
             <a:ext cx="6191250" cy="9525"/>
           </a:xfrm>
           <a:prstGeom xmlns:a="http://schemas.openxmlformats.org/drawingml/2006/main" prst="rect">
@@ -18451,7 +18598,7 @@
         </p:nvSpPr>
         <p:spPr>
           <a:xfrm xmlns:a="http://schemas.openxmlformats.org/drawingml/2006/main">
-            <a:off x="5686425" y="2438400"/>
+            <a:off x="13449300" y="2438400"/>
             <a:ext cx="9525" cy="2476500"/>
           </a:xfrm>
           <a:prstGeom xmlns:a="http://schemas.openxmlformats.org/drawingml/2006/main" prst="rect">
@@ -18482,43 +18629,45 @@
         </p:nvSpPr>
         <p:spPr>
           <a:xfrm xmlns:a="http://schemas.openxmlformats.org/drawingml/2006/main">
-            <a:off x="1695450" y="2095500"/>
-            <a:ext cx="1714500" cy="228600"/>
-          </a:xfrm>
-          <a:prstGeom xmlns:a="http://schemas.openxmlformats.org/drawingml/2006/main" prst="rect">
-            <a:avLst/>
-          </a:prstGeom>
-          <a:noFill xmlns:a="http://schemas.openxmlformats.org/drawingml/2006/main"/>
-          <a:ln xmlns:a="http://schemas.openxmlformats.org/drawingml/2006/main" w="0">
-            <a:noFill/>
-            <a:prstDash val="solid"/>
-          </a:ln>
-        </p:spPr>
-        <p:txBody>
-          <a:bodyPr xmlns:a="http://schemas.openxmlformats.org/drawingml/2006/main"/>
+            <a:off x="685800" y="1428750"/>
+            <a:ext cx="10820400" cy="323850"/>
+          </a:xfrm>
+          <a:prstGeom xmlns:a="http://schemas.openxmlformats.org/drawingml/2006/main" prst="rect">
+            <a:avLst/>
+          </a:prstGeom>
+          <a:noFill xmlns:a="http://schemas.openxmlformats.org/drawingml/2006/main"/>
+          <a:ln xmlns:a="http://schemas.openxmlformats.org/drawingml/2006/main" w="0">
+            <a:noFill/>
+            <a:prstDash val="solid"/>
+          </a:ln>
+        </p:spPr>
+        <p:txBody>
+          <a:bodyPr xmlns:a="http://schemas.openxmlformats.org/drawingml/2006/main" wrap="square" lIns="0" tIns="0" rIns="0" bIns="0" anchor="ctr">
+            <a:normAutofit fontScale="100000"/>
+          </a:bodyPr>
           <a:lstStyle xmlns:a="http://schemas.openxmlformats.org/drawingml/2006/main"/>
           <a:p xmlns:a="http://schemas.openxmlformats.org/drawingml/2006/main">
             <a:pPr algn="l">
               <a:buNone/>
-              <a:defRPr sz="1200" b="1" i="0">
-                <a:solidFill>
-                  <a:srgbClr val="667085"/>
-                </a:solidFill>
-                <a:latin typeface="Microsoft YaHei"/>
-                <a:ea typeface="Microsoft YaHei"/>
-                <a:cs typeface="Microsoft YaHei"/>
-              </a:defRPr>
-            </a:pPr>
-            <a:r>
-              <a:rPr sz="1200" b="1" i="0">
-                <a:solidFill>
-                  <a:srgbClr val="667085"/>
-                </a:solidFill>
-                <a:latin typeface="Microsoft YaHei"/>
-                <a:ea typeface="Microsoft YaHei"/>
-                <a:cs typeface="Microsoft YaHei"/>
-              </a:rPr>
-              <a:t>创作能力与可解释性 ↑</a:t>
+              <a:defRPr sz="1425" b="1" i="0">
+                <a:solidFill>
+                  <a:srgbClr val="64748B"/>
+                </a:solidFill>
+                <a:latin typeface="Microsoft YaHei"/>
+                <a:ea typeface="Microsoft YaHei"/>
+                <a:cs typeface="Microsoft YaHei"/>
+              </a:defRPr>
+            </a:pPr>
+            <a:r>
+              <a:rPr sz="1425" b="1" i="0">
+                <a:solidFill>
+                  <a:srgbClr val="64748B"/>
+                </a:solidFill>
+                <a:latin typeface="Microsoft YaHei"/>
+                <a:ea typeface="Microsoft YaHei"/>
+                <a:cs typeface="Microsoft YaHei"/>
+              </a:rPr>
+              <a:t>完整项目起点，不是六种封闭模式；共享项目格式、积木语言、运行内核和安全模型。</a:t>
             </a:r>
           </a:p>
         </p:txBody>
@@ -18539,43 +18688,45 @@
         </p:nvSpPr>
         <p:spPr>
           <a:xfrm xmlns:a="http://schemas.openxmlformats.org/drawingml/2006/main">
-            <a:off x="5524500" y="5067300"/>
-            <a:ext cx="3429000" cy="228600"/>
-          </a:xfrm>
-          <a:prstGeom xmlns:a="http://schemas.openxmlformats.org/drawingml/2006/main" prst="rect">
-            <a:avLst/>
-          </a:prstGeom>
-          <a:noFill xmlns:a="http://schemas.openxmlformats.org/drawingml/2006/main"/>
-          <a:ln xmlns:a="http://schemas.openxmlformats.org/drawingml/2006/main" w="0">
-            <a:noFill/>
-            <a:prstDash val="solid"/>
-          </a:ln>
-        </p:spPr>
-        <p:txBody>
-          <a:bodyPr xmlns:a="http://schemas.openxmlformats.org/drawingml/2006/main"/>
-          <a:lstStyle xmlns:a="http://schemas.openxmlformats.org/drawingml/2006/main"/>
-          <a:p xmlns:a="http://schemas.openxmlformats.org/drawingml/2006/main">
-            <a:pPr algn="l">
-              <a:buNone/>
-              <a:defRPr sz="1200" b="1" i="0">
-                <a:solidFill>
-                  <a:srgbClr val="667085"/>
-                </a:solidFill>
-                <a:latin typeface="Microsoft YaHei"/>
-                <a:ea typeface="Microsoft YaHei"/>
-                <a:cs typeface="Microsoft YaHei"/>
-              </a:defRPr>
-            </a:pPr>
-            <a:r>
-              <a:rPr sz="1200" b="1" i="0">
-                <a:solidFill>
-                  <a:srgbClr val="667085"/>
-                </a:solidFill>
-                <a:latin typeface="Microsoft YaHei"/>
-                <a:ea typeface="Microsoft YaHei"/>
-                <a:cs typeface="Microsoft YaHei"/>
-              </a:rPr>
-              <a:t>上手难度：低（易上手）→ 高（需编程）</a:t>
+            <a:off x="876300" y="5105400"/>
+            <a:ext cx="10439400" cy="228600"/>
+          </a:xfrm>
+          <a:prstGeom xmlns:a="http://schemas.openxmlformats.org/drawingml/2006/main" prst="rect">
+            <a:avLst/>
+          </a:prstGeom>
+          <a:noFill xmlns:a="http://schemas.openxmlformats.org/drawingml/2006/main"/>
+          <a:ln xmlns:a="http://schemas.openxmlformats.org/drawingml/2006/main" w="0">
+            <a:noFill/>
+            <a:prstDash val="solid"/>
+          </a:ln>
+        </p:spPr>
+        <p:txBody>
+          <a:bodyPr xmlns:a="http://schemas.openxmlformats.org/drawingml/2006/main" wrap="square" lIns="0" tIns="0" rIns="0" bIns="0" anchor="ctr">
+            <a:normAutofit fontScale="100000"/>
+          </a:bodyPr>
+          <a:lstStyle xmlns:a="http://schemas.openxmlformats.org/drawingml/2006/main"/>
+          <a:p xmlns:a="http://schemas.openxmlformats.org/drawingml/2006/main">
+            <a:pPr algn="ctr">
+              <a:buNone/>
+              <a:defRPr sz="1125" b="1" i="0">
+                <a:solidFill>
+                  <a:srgbClr val="1456C7"/>
+                </a:solidFill>
+                <a:latin typeface="Microsoft YaHei"/>
+                <a:ea typeface="Microsoft YaHei"/>
+                <a:cs typeface="Microsoft YaHei"/>
+              </a:defRPr>
+            </a:pPr>
+            <a:r>
+              <a:rPr sz="1125" b="1" i="0">
+                <a:solidFill>
+                  <a:srgbClr val="1456C7"/>
+                </a:solidFill>
+                <a:latin typeface="Microsoft YaHei"/>
+                <a:ea typeface="Microsoft YaHei"/>
+                <a:cs typeface="Microsoft YaHei"/>
+              </a:rPr>
+              <a:t>固定上游版本 + 进程外原生运行时 + 版本化适配器 + 可逆积木投影</a:t>
             </a:r>
           </a:p>
         </p:txBody>
@@ -18596,7 +18747,7 @@
         </p:nvSpPr>
         <p:spPr>
           <a:xfrm xmlns:a="http://schemas.openxmlformats.org/drawingml/2006/main">
-            <a:off x="3333750" y="4038600"/>
+            <a:off x="13487400" y="4038600"/>
             <a:ext cx="400050" cy="400050"/>
           </a:xfrm>
           <a:prstGeom xmlns:a="http://schemas.openxmlformats.org/drawingml/2006/main" prst="ellipse">
@@ -18627,7 +18778,7 @@
         </p:nvSpPr>
         <p:spPr>
           <a:xfrm xmlns:a="http://schemas.openxmlformats.org/drawingml/2006/main">
-            <a:off x="2819400" y="4514850"/>
+            <a:off x="13525500" y="4514850"/>
             <a:ext cx="1428750" cy="247650"/>
           </a:xfrm>
           <a:prstGeom xmlns:a="http://schemas.openxmlformats.org/drawingml/2006/main" prst="rect">
@@ -18684,7 +18835,7 @@
         </p:nvSpPr>
         <p:spPr>
           <a:xfrm xmlns:a="http://schemas.openxmlformats.org/drawingml/2006/main">
-            <a:off x="5476875" y="3781425"/>
+            <a:off x="13563600" y="3781425"/>
             <a:ext cx="457200" cy="457200"/>
           </a:xfrm>
           <a:prstGeom xmlns:a="http://schemas.openxmlformats.org/drawingml/2006/main" prst="ellipse">
@@ -18715,7 +18866,7 @@
         </p:nvSpPr>
         <p:spPr>
           <a:xfrm xmlns:a="http://schemas.openxmlformats.org/drawingml/2006/main">
-            <a:off x="5019675" y="4314825"/>
+            <a:off x="13601700" y="4314825"/>
             <a:ext cx="1371600" cy="247650"/>
           </a:xfrm>
           <a:prstGeom xmlns:a="http://schemas.openxmlformats.org/drawingml/2006/main" prst="rect">
@@ -18772,7 +18923,7 @@
         </p:nvSpPr>
         <p:spPr>
           <a:xfrm xmlns:a="http://schemas.openxmlformats.org/drawingml/2006/main">
-            <a:off x="7667625" y="2762250"/>
+            <a:off x="13639800" y="2762250"/>
             <a:ext cx="495300" cy="495300"/>
           </a:xfrm>
           <a:prstGeom xmlns:a="http://schemas.openxmlformats.org/drawingml/2006/main" prst="ellipse">
@@ -18803,7 +18954,7 @@
         </p:nvSpPr>
         <p:spPr>
           <a:xfrm xmlns:a="http://schemas.openxmlformats.org/drawingml/2006/main">
-            <a:off x="7267575" y="3333750"/>
+            <a:off x="13677900" y="3333750"/>
             <a:ext cx="1371600" cy="247650"/>
           </a:xfrm>
           <a:prstGeom xmlns:a="http://schemas.openxmlformats.org/drawingml/2006/main" prst="rect">
@@ -18860,7 +19011,7 @@
         </p:nvSpPr>
         <p:spPr>
           <a:xfrm xmlns:a="http://schemas.openxmlformats.org/drawingml/2006/main">
-            <a:off x="3352800" y="2705100"/>
+            <a:off x="13716000" y="2705100"/>
             <a:ext cx="609600" cy="609600"/>
           </a:xfrm>
           <a:prstGeom xmlns:a="http://schemas.openxmlformats.org/drawingml/2006/main" prst="ellipse">
@@ -18891,7 +19042,7 @@
         </p:nvSpPr>
         <p:spPr>
           <a:xfrm xmlns:a="http://schemas.openxmlformats.org/drawingml/2006/main">
-            <a:off x="2952750" y="3390900"/>
+            <a:off x="13754100" y="3390900"/>
             <a:ext cx="1371600" cy="247650"/>
           </a:xfrm>
           <a:prstGeom xmlns:a="http://schemas.openxmlformats.org/drawingml/2006/main" prst="rect">
@@ -18956,6 +19107,1514 @@
               <a:gd name="adj" fmla="val 11905"/>
             </a:avLst>
           </a:prstGeom>
+          <a:noFill xmlns:a="http://schemas.openxmlformats.org/drawingml/2006/main"/>
+          <a:ln xmlns:a="http://schemas.openxmlformats.org/drawingml/2006/main" w="0">
+            <a:noFill/>
+            <a:prstDash val="solid"/>
+          </a:ln>
+        </p:spPr>
+      </p:sp>
+      <p:sp>
+        <p:nvSpPr>
+          <p:cNvPr id="19" name="">
+            <a:extLst xmlns:a="http://schemas.openxmlformats.org/drawingml/2006/main">
+              <a:ext uri="{FF2B5EF4-FFF2-40B4-BE49-F238E27FC236}">
+                <a16:creationId xmlns:a16="http://schemas.microsoft.com/office/drawing/2014/main" id="{24B3CED9-2289-46C4-878F-B09658EEEAAB}"/>
+              </a:ext>
+            </a:extLst>
+          </p:cNvPr>
+          <p:cNvSpPr>
+            <a:spLocks xmlns:a="http://schemas.openxmlformats.org/drawingml/2006/main" noGrp="1"/>
+          </p:cNvSpPr>
+          <p:nvPr/>
+        </p:nvSpPr>
+        <p:spPr>
+          <a:xfrm xmlns:a="http://schemas.openxmlformats.org/drawingml/2006/main">
+            <a:off x="13792200" y="2362200"/>
+            <a:ext cx="1219200" cy="609600"/>
+          </a:xfrm>
+          <a:prstGeom xmlns:a="http://schemas.openxmlformats.org/drawingml/2006/main" prst="rect">
+            <a:avLst/>
+          </a:prstGeom>
+          <a:noFill xmlns:a="http://schemas.openxmlformats.org/drawingml/2006/main"/>
+          <a:ln xmlns:a="http://schemas.openxmlformats.org/drawingml/2006/main" w="0">
+            <a:noFill/>
+            <a:prstDash val="solid"/>
+          </a:ln>
+        </p:spPr>
+        <p:txBody>
+          <a:bodyPr xmlns:a="http://schemas.openxmlformats.org/drawingml/2006/main"/>
+          <a:lstStyle xmlns:a="http://schemas.openxmlformats.org/drawingml/2006/main"/>
+          <a:p xmlns:a="http://schemas.openxmlformats.org/drawingml/2006/main">
+            <a:pPr algn="ctr">
+              <a:buNone/>
+              <a:defRPr sz="1800" b="1" i="0">
+                <a:solidFill>
+                  <a:srgbClr val="176BFF"/>
+                </a:solidFill>
+                <a:latin typeface="Microsoft YaHei"/>
+                <a:ea typeface="Microsoft YaHei"/>
+                <a:cs typeface="Microsoft YaHei"/>
+              </a:defRPr>
+            </a:pPr>
+            <a:r>
+              <a:rPr sz="1800" b="1" i="0">
+                <a:solidFill>
+                  <a:srgbClr val="176BFF"/>
+                </a:solidFill>
+                <a:latin typeface="Microsoft YaHei"/>
+                <a:ea typeface="Microsoft YaHei"/>
+                <a:cs typeface="Microsoft YaHei"/>
+              </a:rPr>
+              <a:t>易上手</a:t>
+            </a:r>
+          </a:p>
+          <a:p xmlns:a="http://schemas.openxmlformats.org/drawingml/2006/main">
+            <a:pPr algn="ctr">
+              <a:buNone/>
+              <a:defRPr sz="1800" b="1" i="0">
+                <a:solidFill>
+                  <a:srgbClr val="176BFF"/>
+                </a:solidFill>
+                <a:latin typeface="Microsoft YaHei"/>
+                <a:ea typeface="Microsoft YaHei"/>
+                <a:cs typeface="Microsoft YaHei"/>
+              </a:defRPr>
+            </a:pPr>
+            <a:r>
+              <a:rPr sz="1800" b="1" i="0">
+                <a:solidFill>
+                  <a:srgbClr val="176BFF"/>
+                </a:solidFill>
+                <a:latin typeface="Microsoft YaHei"/>
+                <a:ea typeface="Microsoft YaHei"/>
+                <a:cs typeface="Microsoft YaHei"/>
+              </a:rPr>
+              <a:t>可成长</a:t>
+            </a:r>
+          </a:p>
+        </p:txBody>
+      </p:sp>
+      <p:sp>
+        <p:nvSpPr>
+          <p:cNvPr id="20" name="">
+            <a:extLst xmlns:a="http://schemas.openxmlformats.org/drawingml/2006/main">
+              <a:ext uri="{FF2B5EF4-FFF2-40B4-BE49-F238E27FC236}">
+                <a16:creationId xmlns:a16="http://schemas.microsoft.com/office/drawing/2014/main" id="{E6DE07F1-2CE1-4A8A-BE82-360BF6C6E148}"/>
+              </a:ext>
+            </a:extLst>
+          </p:cNvPr>
+          <p:cNvSpPr>
+            <a:spLocks xmlns:a="http://schemas.openxmlformats.org/drawingml/2006/main" noGrp="1"/>
+          </p:cNvSpPr>
+          <p:nvPr/>
+        </p:nvSpPr>
+        <p:spPr>
+          <a:xfrm xmlns:a="http://schemas.openxmlformats.org/drawingml/2006/main">
+            <a:off x="13830300" y="3238500"/>
+            <a:ext cx="1219200" cy="1809750"/>
+          </a:xfrm>
+          <a:prstGeom xmlns:a="http://schemas.openxmlformats.org/drawingml/2006/main" prst="rect">
+            <a:avLst/>
+          </a:prstGeom>
+          <a:noFill xmlns:a="http://schemas.openxmlformats.org/drawingml/2006/main"/>
+          <a:ln xmlns:a="http://schemas.openxmlformats.org/drawingml/2006/main" w="0">
+            <a:noFill/>
+            <a:prstDash val="solid"/>
+          </a:ln>
+        </p:spPr>
+        <p:txBody>
+          <a:bodyPr xmlns:a="http://schemas.openxmlformats.org/drawingml/2006/main"/>
+          <a:lstStyle xmlns:a="http://schemas.openxmlformats.org/drawingml/2006/main"/>
+          <a:p xmlns:a="http://schemas.openxmlformats.org/drawingml/2006/main">
+            <a:pPr algn="ctr">
+              <a:buNone/>
+              <a:defRPr sz="1500" b="1" i="0">
+                <a:solidFill>
+                  <a:srgbClr val="111827"/>
+                </a:solidFill>
+                <a:latin typeface="Microsoft YaHei"/>
+                <a:ea typeface="Microsoft YaHei"/>
+                <a:cs typeface="Microsoft YaHei"/>
+              </a:defRPr>
+            </a:pPr>
+            <a:r>
+              <a:rPr sz="1500" b="1" i="0">
+                <a:solidFill>
+                  <a:srgbClr val="111827"/>
+                </a:solidFill>
+                <a:latin typeface="Microsoft YaHei"/>
+                <a:ea typeface="Microsoft YaHei"/>
+                <a:cs typeface="Microsoft YaHei"/>
+              </a:rPr>
+              <a:t>入门七类</a:t>
+            </a:r>
+          </a:p>
+          <a:p xmlns:a="http://schemas.openxmlformats.org/drawingml/2006/main">
+            <a:pPr algn="ctr">
+              <a:buNone/>
+              <a:defRPr sz="1500" b="1" i="0">
+                <a:solidFill>
+                  <a:srgbClr val="111827"/>
+                </a:solidFill>
+                <a:latin typeface="Microsoft YaHei"/>
+                <a:ea typeface="Microsoft YaHei"/>
+                <a:cs typeface="Microsoft YaHei"/>
+              </a:defRPr>
+            </a:pPr>
+            <a:r>
+              <a:rPr sz="1500" b="1" i="0">
+                <a:solidFill>
+                  <a:srgbClr val="111827"/>
+                </a:solidFill>
+                <a:latin typeface="Microsoft YaHei"/>
+                <a:ea typeface="Microsoft YaHei"/>
+                <a:cs typeface="Microsoft YaHei"/>
+              </a:rPr>
+              <a:t>↓</a:t>
+            </a:r>
+          </a:p>
+          <a:p xmlns:a="http://schemas.openxmlformats.org/drawingml/2006/main">
+            <a:pPr algn="ctr">
+              <a:buNone/>
+              <a:defRPr sz="1500" b="1" i="0">
+                <a:solidFill>
+                  <a:srgbClr val="111827"/>
+                </a:solidFill>
+                <a:latin typeface="Microsoft YaHei"/>
+                <a:ea typeface="Microsoft YaHei"/>
+                <a:cs typeface="Microsoft YaHei"/>
+              </a:defRPr>
+            </a:pPr>
+            <a:r>
+              <a:rPr sz="1500" b="1" i="0">
+                <a:solidFill>
+                  <a:srgbClr val="111827"/>
+                </a:solidFill>
+                <a:latin typeface="Microsoft YaHei"/>
+                <a:ea typeface="Microsoft YaHei"/>
+                <a:cs typeface="Microsoft YaHei"/>
+              </a:rPr>
+              <a:t>专业十二类</a:t>
+            </a:r>
+          </a:p>
+          <a:p xmlns:a="http://schemas.openxmlformats.org/drawingml/2006/main">
+            <a:pPr algn="ctr">
+              <a:buNone/>
+              <a:defRPr sz="1500" b="1" i="0">
+                <a:solidFill>
+                  <a:srgbClr val="111827"/>
+                </a:solidFill>
+                <a:latin typeface="Microsoft YaHei"/>
+                <a:ea typeface="Microsoft YaHei"/>
+                <a:cs typeface="Microsoft YaHei"/>
+              </a:defRPr>
+            </a:pPr>
+            <a:r>
+              <a:rPr sz="1500" b="1" i="0">
+                <a:solidFill>
+                  <a:srgbClr val="111827"/>
+                </a:solidFill>
+                <a:latin typeface="Microsoft YaHei"/>
+                <a:ea typeface="Microsoft YaHei"/>
+                <a:cs typeface="Microsoft YaHei"/>
+              </a:rPr>
+              <a:t>↓</a:t>
+            </a:r>
+          </a:p>
+          <a:p xmlns:a="http://schemas.openxmlformats.org/drawingml/2006/main">
+            <a:pPr algn="ctr">
+              <a:buNone/>
+              <a:defRPr sz="1500" b="1" i="0">
+                <a:solidFill>
+                  <a:srgbClr val="111827"/>
+                </a:solidFill>
+                <a:latin typeface="Microsoft YaHei"/>
+                <a:ea typeface="Microsoft YaHei"/>
+                <a:cs typeface="Microsoft YaHei"/>
+              </a:defRPr>
+            </a:pPr>
+            <a:r>
+              <a:rPr sz="1500" b="1" i="0">
+                <a:solidFill>
+                  <a:srgbClr val="111827"/>
+                </a:solidFill>
+                <a:latin typeface="Microsoft YaHei"/>
+                <a:ea typeface="Microsoft YaHei"/>
+                <a:cs typeface="Microsoft YaHei"/>
+              </a:rPr>
+              <a:t>蓝图 / 代码</a:t>
+            </a:r>
+          </a:p>
+          <a:p xmlns:a="http://schemas.openxmlformats.org/drawingml/2006/main">
+            <a:pPr algn="ctr">
+              <a:buNone/>
+              <a:defRPr sz="1500" b="1" i="0">
+                <a:solidFill>
+                  <a:srgbClr val="111827"/>
+                </a:solidFill>
+                <a:latin typeface="Microsoft YaHei"/>
+                <a:ea typeface="Microsoft YaHei"/>
+                <a:cs typeface="Microsoft YaHei"/>
+              </a:defRPr>
+            </a:pPr>
+            <a:r>
+              <a:rPr sz="1500" b="1" i="0">
+                <a:solidFill>
+                  <a:srgbClr val="111827"/>
+                </a:solidFill>
+                <a:latin typeface="Microsoft YaHei"/>
+                <a:ea typeface="Microsoft YaHei"/>
+                <a:cs typeface="Microsoft YaHei"/>
+              </a:rPr>
+              <a:t>↓</a:t>
+            </a:r>
+          </a:p>
+          <a:p xmlns:a="http://schemas.openxmlformats.org/drawingml/2006/main">
+            <a:pPr algn="ctr">
+              <a:buNone/>
+              <a:defRPr sz="1500" b="1" i="0">
+                <a:solidFill>
+                  <a:srgbClr val="111827"/>
+                </a:solidFill>
+                <a:latin typeface="Microsoft YaHei"/>
+                <a:ea typeface="Microsoft YaHei"/>
+                <a:cs typeface="Microsoft YaHei"/>
+              </a:defRPr>
+            </a:pPr>
+            <a:r>
+              <a:rPr sz="1500" b="1" i="0">
+                <a:solidFill>
+                  <a:srgbClr val="111827"/>
+                </a:solidFill>
+                <a:latin typeface="Microsoft YaHei"/>
+                <a:ea typeface="Microsoft YaHei"/>
+                <a:cs typeface="Microsoft YaHei"/>
+              </a:rPr>
+              <a:t>运行轨迹</a:t>
+            </a:r>
+          </a:p>
+        </p:txBody>
+      </p:sp>
+      <p:sp>
+        <p:nvSpPr>
+          <p:cNvPr id="21" name="">
+            <a:extLst xmlns:a="http://schemas.openxmlformats.org/drawingml/2006/main">
+              <a:ext uri="{FF2B5EF4-FFF2-40B4-BE49-F238E27FC236}">
+                <a16:creationId xmlns:a16="http://schemas.microsoft.com/office/drawing/2014/main" id="{5ACF8F47-F459-4EE8-AFFB-431D2346A884}"/>
+              </a:ext>
+            </a:extLst>
+          </p:cNvPr>
+          <p:cNvSpPr>
+            <a:spLocks xmlns:a="http://schemas.openxmlformats.org/drawingml/2006/main" noGrp="1"/>
+          </p:cNvSpPr>
+          <p:nvPr/>
+        </p:nvSpPr>
+        <p:spPr>
+          <a:xfrm xmlns:a="http://schemas.openxmlformats.org/drawingml/2006/main">
+            <a:off x="685800" y="5600700"/>
+            <a:ext cx="10820400" cy="304800"/>
+          </a:xfrm>
+          <a:prstGeom xmlns:a="http://schemas.openxmlformats.org/drawingml/2006/main" prst="rect">
+            <a:avLst/>
+          </a:prstGeom>
+          <a:noFill xmlns:a="http://schemas.openxmlformats.org/drawingml/2006/main"/>
+          <a:ln xmlns:a="http://schemas.openxmlformats.org/drawingml/2006/main" w="0">
+            <a:noFill/>
+            <a:prstDash val="solid"/>
+          </a:ln>
+        </p:spPr>
+        <p:txBody>
+          <a:bodyPr xmlns:a="http://schemas.openxmlformats.org/drawingml/2006/main" wrap="square" lIns="0" tIns="0" rIns="0" bIns="0" anchor="ctr">
+            <a:normAutofit fontScale="100000"/>
+          </a:bodyPr>
+          <a:lstStyle xmlns:a="http://schemas.openxmlformats.org/drawingml/2006/main"/>
+          <a:p xmlns:a="http://schemas.openxmlformats.org/drawingml/2006/main">
+            <a:pPr algn="ctr">
+              <a:buNone/>
+              <a:defRPr sz="1050" b="0" i="0">
+                <a:solidFill>
+                  <a:srgbClr val="64748B"/>
+                </a:solidFill>
+                <a:latin typeface="Microsoft YaHei"/>
+                <a:ea typeface="Microsoft YaHei"/>
+                <a:cs typeface="Microsoft YaHei"/>
+              </a:defRPr>
+            </a:pPr>
+            <a:r>
+              <a:rPr sz="1050" b="0" i="0">
+                <a:solidFill>
+                  <a:srgbClr val="64748B"/>
+                </a:solidFill>
+                <a:latin typeface="Microsoft YaHei"/>
+                <a:ea typeface="Microsoft YaHei"/>
+                <a:cs typeface="Microsoft YaHei"/>
+              </a:rPr>
+              <a:t>兼容等级：结构映射 → 配置往返 → 行为对照 → 指定版本完整兼容｜当前为阶段 8 设计，六个正式适配器尚未实现。</a:t>
+            </a:r>
+          </a:p>
+        </p:txBody>
+      </p:sp>
+      <p:sp>
+        <p:nvSpPr>
+          <p:cNvPr id="22" name="">
+            <a:extLst xmlns:a="http://schemas.openxmlformats.org/drawingml/2006/main">
+              <a:ext uri="{FF2B5EF4-FFF2-40B4-BE49-F238E27FC236}">
+                <a16:creationId xmlns:a16="http://schemas.microsoft.com/office/drawing/2014/main" id="{7CA2238B-6981-4EEF-9644-CAB79A1ED2D3}"/>
+              </a:ext>
+            </a:extLst>
+          </p:cNvPr>
+          <p:cNvSpPr>
+            <a:spLocks xmlns:a="http://schemas.openxmlformats.org/drawingml/2006/main" noGrp="1"/>
+          </p:cNvSpPr>
+          <p:nvPr/>
+        </p:nvSpPr>
+        <p:spPr>
+          <a:xfrm xmlns:a="http://schemas.openxmlformats.org/drawingml/2006/main">
+            <a:off x="685800" y="6496050"/>
+            <a:ext cx="10820400" cy="9525"/>
+          </a:xfrm>
+          <a:prstGeom xmlns:a="http://schemas.openxmlformats.org/drawingml/2006/main" prst="rect">
+            <a:avLst/>
+          </a:prstGeom>
+          <a:solidFill xmlns:a="http://schemas.openxmlformats.org/drawingml/2006/main">
+            <a:srgbClr val="DCE3EC"/>
+          </a:solidFill>
+          <a:ln xmlns:a="http://schemas.openxmlformats.org/drawingml/2006/main" w="0">
+            <a:noFill/>
+            <a:prstDash val="solid"/>
+          </a:ln>
+        </p:spPr>
+      </p:sp>
+      <p:sp>
+        <p:nvSpPr>
+          <p:cNvPr id="23" name="">
+            <a:extLst xmlns:a="http://schemas.openxmlformats.org/drawingml/2006/main">
+              <a:ext uri="{FF2B5EF4-FFF2-40B4-BE49-F238E27FC236}">
+                <a16:creationId xmlns:a16="http://schemas.microsoft.com/office/drawing/2014/main" id="{4EEEB512-B61D-4234-BF5B-E7FCE68FD363}"/>
+              </a:ext>
+            </a:extLst>
+          </p:cNvPr>
+          <p:cNvSpPr>
+            <a:spLocks xmlns:a="http://schemas.openxmlformats.org/drawingml/2006/main" noGrp="1"/>
+          </p:cNvSpPr>
+          <p:nvPr/>
+        </p:nvSpPr>
+        <p:spPr>
+          <a:xfrm xmlns:a="http://schemas.openxmlformats.org/drawingml/2006/main">
+            <a:off x="685800" y="6553200"/>
+            <a:ext cx="4762500" cy="190500"/>
+          </a:xfrm>
+          <a:prstGeom xmlns:a="http://schemas.openxmlformats.org/drawingml/2006/main" prst="rect">
+            <a:avLst/>
+          </a:prstGeom>
+          <a:noFill xmlns:a="http://schemas.openxmlformats.org/drawingml/2006/main"/>
+          <a:ln xmlns:a="http://schemas.openxmlformats.org/drawingml/2006/main" w="0">
+            <a:noFill/>
+            <a:prstDash val="solid"/>
+          </a:ln>
+        </p:spPr>
+        <p:txBody>
+          <a:bodyPr xmlns:a="http://schemas.openxmlformats.org/drawingml/2006/main"/>
+          <a:lstStyle xmlns:a="http://schemas.openxmlformats.org/drawingml/2006/main"/>
+          <a:p xmlns:a="http://schemas.openxmlformats.org/drawingml/2006/main">
+            <a:pPr algn="l">
+              <a:buNone/>
+              <a:defRPr sz="975" b="0" i="0">
+                <a:solidFill>
+                  <a:srgbClr val="98A2B3"/>
+                </a:solidFill>
+                <a:latin typeface="Microsoft YaHei"/>
+                <a:ea typeface="Microsoft YaHei"/>
+                <a:cs typeface="Microsoft YaHei"/>
+              </a:defRPr>
+            </a:pPr>
+            <a:r>
+              <a:rPr sz="975" b="0" i="0">
+                <a:solidFill>
+                  <a:srgbClr val="98A2B3"/>
+                </a:solidFill>
+                <a:latin typeface="Microsoft YaHei"/>
+                <a:ea typeface="Microsoft YaHei"/>
+                <a:cs typeface="Microsoft YaHei"/>
+              </a:rPr>
+              <a:t>Blocky Studio · 息壤杯 AI+教育</a:t>
+            </a:r>
+          </a:p>
+        </p:txBody>
+      </p:sp>
+      <p:sp>
+        <p:nvSpPr>
+          <p:cNvPr id="24" name="">
+            <a:extLst xmlns:a="http://schemas.openxmlformats.org/drawingml/2006/main">
+              <a:ext uri="{FF2B5EF4-FFF2-40B4-BE49-F238E27FC236}">
+                <a16:creationId xmlns:a16="http://schemas.microsoft.com/office/drawing/2014/main" id="{F36BBFE9-8C7C-4891-A36F-ED778245CE43}"/>
+              </a:ext>
+            </a:extLst>
+          </p:cNvPr>
+          <p:cNvSpPr>
+            <a:spLocks xmlns:a="http://schemas.openxmlformats.org/drawingml/2006/main" noGrp="1"/>
+          </p:cNvSpPr>
+          <p:nvPr/>
+        </p:nvSpPr>
+        <p:spPr>
+          <a:xfrm xmlns:a="http://schemas.openxmlformats.org/drawingml/2006/main">
+            <a:off x="10953750" y="6553200"/>
+            <a:ext cx="552450" cy="190500"/>
+          </a:xfrm>
+          <a:prstGeom xmlns:a="http://schemas.openxmlformats.org/drawingml/2006/main" prst="rect">
+            <a:avLst/>
+          </a:prstGeom>
+          <a:noFill xmlns:a="http://schemas.openxmlformats.org/drawingml/2006/main"/>
+          <a:ln xmlns:a="http://schemas.openxmlformats.org/drawingml/2006/main" w="0">
+            <a:noFill/>
+            <a:prstDash val="solid"/>
+          </a:ln>
+        </p:spPr>
+        <p:txBody>
+          <a:bodyPr xmlns:a="http://schemas.openxmlformats.org/drawingml/2006/main"/>
+          <a:lstStyle xmlns:a="http://schemas.openxmlformats.org/drawingml/2006/main"/>
+          <a:p xmlns:a="http://schemas.openxmlformats.org/drawingml/2006/main">
+            <a:pPr algn="r">
+              <a:buNone/>
+              <a:defRPr sz="975" b="0" i="0">
+                <a:solidFill>
+                  <a:srgbClr val="98A2B3"/>
+                </a:solidFill>
+                <a:latin typeface="Microsoft YaHei"/>
+                <a:ea typeface="Microsoft YaHei"/>
+                <a:cs typeface="Microsoft YaHei"/>
+              </a:defRPr>
+            </a:pPr>
+            <a:r>
+              <a:rPr sz="975" b="0" i="0">
+                <a:solidFill>
+                  <a:srgbClr val="98A2B3"/>
+                </a:solidFill>
+                <a:latin typeface="Microsoft YaHei"/>
+                <a:ea typeface="Microsoft YaHei"/>
+                <a:cs typeface="Microsoft YaHei"/>
+              </a:rPr>
+              <a:t>08</a:t>
+            </a:r>
+          </a:p>
+        </p:txBody>
+      </p:sp>
+      <p:sp>
+        <p:nvSpPr>
+          <p:cNvPr id="26" name="compat-card-fill-1-1">
+            <a:extLst xmlns:a="http://schemas.openxmlformats.org/drawingml/2006/main">
+              <a:ext uri="{FF2B5EF4-FFF2-40B4-BE49-F238E27FC236}">
+                <a16:creationId xmlns:a16="http://schemas.microsoft.com/office/drawing/2014/main" id="{F69DB481-5385-40C6-8BEA-8619F0A3E72B}"/>
+              </a:ext>
+            </a:extLst>
+          </p:cNvPr>
+          <p:cNvSpPr>
+            <a:spLocks xmlns:a="http://schemas.openxmlformats.org/drawingml/2006/main" noGrp="1"/>
+          </p:cNvSpPr>
+          <p:nvPr/>
+        </p:nvSpPr>
+        <p:spPr>
+          <a:xfrm xmlns:a="http://schemas.openxmlformats.org/drawingml/2006/main">
+            <a:off x="895350" y="2133600"/>
+            <a:ext cx="3162300" cy="381000"/>
+          </a:xfrm>
+          <a:prstGeom xmlns:a="http://schemas.openxmlformats.org/drawingml/2006/main" prst="rect">
+            <a:avLst/>
+          </a:prstGeom>
+          <a:solidFill xmlns:a="http://schemas.openxmlformats.org/drawingml/2006/main">
+            <a:srgbClr val="FFFFFF"/>
+          </a:solidFill>
+          <a:ln xmlns:a="http://schemas.openxmlformats.org/drawingml/2006/main" w="0">
+            <a:noFill/>
+            <a:prstDash val="solid"/>
+          </a:ln>
+        </p:spPr>
+      </p:sp>
+      <p:sp>
+        <p:nvSpPr>
+          <p:cNvPr id="27" name="compat-card-fill-1-2">
+            <a:extLst xmlns:a="http://schemas.openxmlformats.org/drawingml/2006/main">
+              <a:ext uri="{FF2B5EF4-FFF2-40B4-BE49-F238E27FC236}">
+                <a16:creationId xmlns:a16="http://schemas.microsoft.com/office/drawing/2014/main" id="{E4EF5A44-61F6-43D8-A716-C98483ED0778}"/>
+              </a:ext>
+            </a:extLst>
+          </p:cNvPr>
+          <p:cNvSpPr>
+            <a:spLocks xmlns:a="http://schemas.openxmlformats.org/drawingml/2006/main" noGrp="1"/>
+          </p:cNvSpPr>
+          <p:nvPr/>
+        </p:nvSpPr>
+        <p:spPr>
+          <a:xfrm xmlns:a="http://schemas.openxmlformats.org/drawingml/2006/main">
+            <a:off x="895350" y="2514600"/>
+            <a:ext cx="3162300" cy="381000"/>
+          </a:xfrm>
+          <a:prstGeom xmlns:a="http://schemas.openxmlformats.org/drawingml/2006/main" prst="rect">
+            <a:avLst/>
+          </a:prstGeom>
+          <a:solidFill xmlns:a="http://schemas.openxmlformats.org/drawingml/2006/main">
+            <a:srgbClr val="FFFFFF"/>
+          </a:solidFill>
+          <a:ln xmlns:a="http://schemas.openxmlformats.org/drawingml/2006/main" w="0">
+            <a:noFill/>
+            <a:prstDash val="solid"/>
+          </a:ln>
+        </p:spPr>
+      </p:sp>
+      <p:sp>
+        <p:nvSpPr>
+          <p:cNvPr id="28" name="compat-card-fill-1-3">
+            <a:extLst xmlns:a="http://schemas.openxmlformats.org/drawingml/2006/main">
+              <a:ext uri="{FF2B5EF4-FFF2-40B4-BE49-F238E27FC236}">
+                <a16:creationId xmlns:a16="http://schemas.microsoft.com/office/drawing/2014/main" id="{2D5C7F0A-2376-4FCC-B006-D475EB4611E7}"/>
+              </a:ext>
+            </a:extLst>
+          </p:cNvPr>
+          <p:cNvSpPr>
+            <a:spLocks xmlns:a="http://schemas.openxmlformats.org/drawingml/2006/main" noGrp="1"/>
+          </p:cNvSpPr>
+          <p:nvPr/>
+        </p:nvSpPr>
+        <p:spPr>
+          <a:xfrm xmlns:a="http://schemas.openxmlformats.org/drawingml/2006/main">
+            <a:off x="895350" y="2895600"/>
+            <a:ext cx="3162300" cy="476250"/>
+          </a:xfrm>
+          <a:prstGeom xmlns:a="http://schemas.openxmlformats.org/drawingml/2006/main" prst="rect">
+            <a:avLst/>
+          </a:prstGeom>
+          <a:solidFill xmlns:a="http://schemas.openxmlformats.org/drawingml/2006/main">
+            <a:srgbClr val="FFFFFF"/>
+          </a:solidFill>
+          <a:ln xmlns:a="http://schemas.openxmlformats.org/drawingml/2006/main" w="0">
+            <a:noFill/>
+            <a:prstDash val="solid"/>
+          </a:ln>
+        </p:spPr>
+      </p:sp>
+      <p:sp>
+        <p:nvSpPr>
+          <p:cNvPr id="29" name="compat-card-1">
+            <a:extLst xmlns:a="http://schemas.openxmlformats.org/drawingml/2006/main">
+              <a:ext uri="{FF2B5EF4-FFF2-40B4-BE49-F238E27FC236}">
+                <a16:creationId xmlns:a16="http://schemas.microsoft.com/office/drawing/2014/main" id="{6C151DE4-71A9-4FA2-9A44-BC594719616F}"/>
+              </a:ext>
+            </a:extLst>
+          </p:cNvPr>
+          <p:cNvSpPr>
+            <a:spLocks xmlns:a="http://schemas.openxmlformats.org/drawingml/2006/main" noGrp="1"/>
+          </p:cNvSpPr>
+          <p:nvPr/>
+        </p:nvSpPr>
+        <p:spPr>
+          <a:xfrm xmlns:a="http://schemas.openxmlformats.org/drawingml/2006/main">
+            <a:off x="838200" y="2076450"/>
+            <a:ext cx="3276600" cy="1352550"/>
+          </a:xfrm>
+          <a:prstGeom xmlns:a="http://schemas.openxmlformats.org/drawingml/2006/main" prst="roundRect">
+            <a:avLst>
+              <a:gd name="adj" fmla="val 5634"/>
+            </a:avLst>
+          </a:prstGeom>
+          <a:noFill xmlns:a="http://schemas.openxmlformats.org/drawingml/2006/main"/>
+          <a:ln xmlns:a="http://schemas.openxmlformats.org/drawingml/2006/main" w="9525">
+            <a:solidFill>
+              <a:srgbClr val="DDE7F5"/>
+            </a:solidFill>
+            <a:prstDash val="solid"/>
+          </a:ln>
+        </p:spPr>
+      </p:sp>
+      <p:sp>
+        <p:nvSpPr>
+          <p:cNvPr id="30" name="compat-accent-1">
+            <a:extLst xmlns:a="http://schemas.openxmlformats.org/drawingml/2006/main">
+              <a:ext uri="{FF2B5EF4-FFF2-40B4-BE49-F238E27FC236}">
+                <a16:creationId xmlns:a16="http://schemas.microsoft.com/office/drawing/2014/main" id="{4A5AF1A7-B885-4B88-B017-97B67775F82B}"/>
+              </a:ext>
+            </a:extLst>
+          </p:cNvPr>
+          <p:cNvSpPr>
+            <a:spLocks xmlns:a="http://schemas.openxmlformats.org/drawingml/2006/main" noGrp="1"/>
+          </p:cNvSpPr>
+          <p:nvPr/>
+        </p:nvSpPr>
+        <p:spPr>
+          <a:xfrm xmlns:a="http://schemas.openxmlformats.org/drawingml/2006/main">
+            <a:off x="838200" y="2228850"/>
+            <a:ext cx="47625" cy="1047750"/>
+          </a:xfrm>
+          <a:prstGeom xmlns:a="http://schemas.openxmlformats.org/drawingml/2006/main" prst="rect">
+            <a:avLst/>
+          </a:prstGeom>
+          <a:solidFill xmlns:a="http://schemas.openxmlformats.org/drawingml/2006/main">
+            <a:srgbClr val="00A875"/>
+          </a:solidFill>
+          <a:ln xmlns:a="http://schemas.openxmlformats.org/drawingml/2006/main" w="0">
+            <a:noFill/>
+            <a:prstDash val="solid"/>
+          </a:ln>
+        </p:spPr>
+      </p:sp>
+      <p:sp>
+        <p:nvSpPr>
+          <p:cNvPr id="31" name="compat-title-1">
+            <a:extLst xmlns:a="http://schemas.openxmlformats.org/drawingml/2006/main">
+              <a:ext uri="{FF2B5EF4-FFF2-40B4-BE49-F238E27FC236}">
+                <a16:creationId xmlns:a16="http://schemas.microsoft.com/office/drawing/2014/main" id="{34755EBE-93F0-4137-A1C0-A92B874AF4D1}"/>
+              </a:ext>
+            </a:extLst>
+          </p:cNvPr>
+          <p:cNvSpPr>
+            <a:spLocks xmlns:a="http://schemas.openxmlformats.org/drawingml/2006/main" noGrp="1"/>
+          </p:cNvSpPr>
+          <p:nvPr/>
+        </p:nvSpPr>
+        <p:spPr>
+          <a:xfrm xmlns:a="http://schemas.openxmlformats.org/drawingml/2006/main">
+            <a:off x="1066800" y="2247900"/>
+            <a:ext cx="2781300" cy="209550"/>
+          </a:xfrm>
+          <a:prstGeom xmlns:a="http://schemas.openxmlformats.org/drawingml/2006/main" prst="rect">
+            <a:avLst/>
+          </a:prstGeom>
+          <a:noFill xmlns:a="http://schemas.openxmlformats.org/drawingml/2006/main"/>
+          <a:ln xmlns:a="http://schemas.openxmlformats.org/drawingml/2006/main" w="0">
+            <a:noFill/>
+            <a:prstDash val="solid"/>
+          </a:ln>
+        </p:spPr>
+        <p:txBody>
+          <a:bodyPr xmlns:a="http://schemas.openxmlformats.org/drawingml/2006/main" wrap="square" lIns="0" tIns="0" rIns="0" bIns="0" anchor="ctr">
+            <a:normAutofit fontScale="100000"/>
+          </a:bodyPr>
+          <a:lstStyle xmlns:a="http://schemas.openxmlformats.org/drawingml/2006/main"/>
+          <a:p xmlns:a="http://schemas.openxmlformats.org/drawingml/2006/main">
+            <a:pPr algn="l">
+              <a:defRPr sz="1200" b="1">
+                <a:solidFill>
+                  <a:srgbClr val="176BFF"/>
+                </a:solidFill>
+                <a:latin typeface="Microsoft YaHei"/>
+                <a:ea typeface="Microsoft YaHei"/>
+                <a:cs typeface="Microsoft YaHei"/>
+              </a:defRPr>
+            </a:pPr>
+            <a:r>
+              <a:rPr sz="1200" b="1">
+                <a:solidFill>
+                  <a:srgbClr val="176BFF"/>
+                </a:solidFill>
+                <a:latin typeface="Microsoft YaHei"/>
+                <a:ea typeface="Microsoft YaHei"/>
+                <a:cs typeface="Microsoft YaHei"/>
+              </a:rPr>
+              <a:t>轻量代码助手</a:t>
+            </a:r>
+          </a:p>
+        </p:txBody>
+      </p:sp>
+      <p:sp>
+        <p:nvSpPr>
+          <p:cNvPr id="32" name="compat-name-1">
+            <a:extLst xmlns:a="http://schemas.openxmlformats.org/drawingml/2006/main">
+              <a:ext uri="{FF2B5EF4-FFF2-40B4-BE49-F238E27FC236}">
+                <a16:creationId xmlns:a16="http://schemas.microsoft.com/office/drawing/2014/main" id="{7B4D9A5C-E768-4DC4-A8BF-A0C0D3177F91}"/>
+              </a:ext>
+            </a:extLst>
+          </p:cNvPr>
+          <p:cNvSpPr>
+            <a:spLocks xmlns:a="http://schemas.openxmlformats.org/drawingml/2006/main" noGrp="1"/>
+          </p:cNvSpPr>
+          <p:nvPr/>
+        </p:nvSpPr>
+        <p:spPr>
+          <a:xfrm xmlns:a="http://schemas.openxmlformats.org/drawingml/2006/main">
+            <a:off x="1066800" y="2533650"/>
+            <a:ext cx="2781300" cy="323850"/>
+          </a:xfrm>
+          <a:prstGeom xmlns:a="http://schemas.openxmlformats.org/drawingml/2006/main" prst="rect">
+            <a:avLst/>
+          </a:prstGeom>
+          <a:noFill xmlns:a="http://schemas.openxmlformats.org/drawingml/2006/main"/>
+          <a:ln xmlns:a="http://schemas.openxmlformats.org/drawingml/2006/main" w="0">
+            <a:noFill/>
+            <a:prstDash val="solid"/>
+          </a:ln>
+        </p:spPr>
+        <p:txBody>
+          <a:bodyPr xmlns:a="http://schemas.openxmlformats.org/drawingml/2006/main" wrap="square" lIns="0" tIns="0" rIns="0" bIns="0" anchor="ctr">
+            <a:normAutofit fontScale="100000"/>
+          </a:bodyPr>
+          <a:lstStyle xmlns:a="http://schemas.openxmlformats.org/drawingml/2006/main"/>
+          <a:p xmlns:a="http://schemas.openxmlformats.org/drawingml/2006/main">
+            <a:pPr algn="l">
+              <a:defRPr sz="1950" b="1">
+                <a:solidFill>
+                  <a:srgbClr val="111827"/>
+                </a:solidFill>
+                <a:latin typeface="Microsoft YaHei"/>
+                <a:ea typeface="Microsoft YaHei"/>
+                <a:cs typeface="Microsoft YaHei"/>
+              </a:defRPr>
+            </a:pPr>
+            <a:r>
+              <a:rPr sz="1950" b="1">
+                <a:solidFill>
+                  <a:srgbClr val="111827"/>
+                </a:solidFill>
+                <a:latin typeface="Microsoft YaHei"/>
+                <a:ea typeface="Microsoft YaHei"/>
+                <a:cs typeface="Microsoft YaHei"/>
+              </a:rPr>
+              <a:t>Pi</a:t>
+            </a:r>
+          </a:p>
+        </p:txBody>
+      </p:sp>
+      <p:sp>
+        <p:nvSpPr>
+          <p:cNvPr id="33" name="compat-desc-1">
+            <a:extLst xmlns:a="http://schemas.openxmlformats.org/drawingml/2006/main">
+              <a:ext uri="{FF2B5EF4-FFF2-40B4-BE49-F238E27FC236}">
+                <a16:creationId xmlns:a16="http://schemas.microsoft.com/office/drawing/2014/main" id="{6EEF4EE7-6902-4F7D-979E-88501EA44802}"/>
+              </a:ext>
+            </a:extLst>
+          </p:cNvPr>
+          <p:cNvSpPr>
+            <a:spLocks xmlns:a="http://schemas.openxmlformats.org/drawingml/2006/main" noGrp="1"/>
+          </p:cNvSpPr>
+          <p:nvPr/>
+        </p:nvSpPr>
+        <p:spPr>
+          <a:xfrm xmlns:a="http://schemas.openxmlformats.org/drawingml/2006/main">
+            <a:off x="1066800" y="2952750"/>
+            <a:ext cx="2819400" cy="323850"/>
+          </a:xfrm>
+          <a:prstGeom xmlns:a="http://schemas.openxmlformats.org/drawingml/2006/main" prst="rect">
+            <a:avLst/>
+          </a:prstGeom>
+          <a:noFill xmlns:a="http://schemas.openxmlformats.org/drawingml/2006/main"/>
+          <a:ln xmlns:a="http://schemas.openxmlformats.org/drawingml/2006/main" w="0">
+            <a:noFill/>
+            <a:prstDash val="solid"/>
+          </a:ln>
+        </p:spPr>
+        <p:txBody>
+          <a:bodyPr xmlns:a="http://schemas.openxmlformats.org/drawingml/2006/main" wrap="square" lIns="0" tIns="0" rIns="0" bIns="0" anchor="ctr">
+            <a:normAutofit fontScale="100000"/>
+          </a:bodyPr>
+          <a:lstStyle xmlns:a="http://schemas.openxmlformats.org/drawingml/2006/main"/>
+          <a:p xmlns:a="http://schemas.openxmlformats.org/drawingml/2006/main">
+            <a:pPr algn="l">
+              <a:defRPr sz="1050">
+                <a:solidFill>
+                  <a:srgbClr val="64748B"/>
+                </a:solidFill>
+                <a:latin typeface="Microsoft YaHei"/>
+                <a:ea typeface="Microsoft YaHei"/>
+                <a:cs typeface="Microsoft YaHei"/>
+              </a:defRPr>
+            </a:pPr>
+            <a:r>
+              <a:rPr sz="1050">
+                <a:solidFill>
+                  <a:srgbClr val="64748B"/>
+                </a:solidFill>
+                <a:latin typeface="Microsoft YaHei"/>
+                <a:ea typeface="Microsoft YaHei"/>
+                <a:cs typeface="Microsoft YaHei"/>
+              </a:rPr>
+              <a:t>极简 Agent · read / write / edit / bash</a:t>
+            </a:r>
+          </a:p>
+        </p:txBody>
+      </p:sp>
+      <p:sp>
+        <p:nvSpPr>
+          <p:cNvPr id="34" name="compat-card-fill-2-1">
+            <a:extLst xmlns:a="http://schemas.openxmlformats.org/drawingml/2006/main">
+              <a:ext uri="{FF2B5EF4-FFF2-40B4-BE49-F238E27FC236}">
+                <a16:creationId xmlns:a16="http://schemas.microsoft.com/office/drawing/2014/main" id="{6678D41D-B7A4-47ED-A705-BC8B0F76C6AB}"/>
+              </a:ext>
+            </a:extLst>
+          </p:cNvPr>
+          <p:cNvSpPr>
+            <a:spLocks xmlns:a="http://schemas.openxmlformats.org/drawingml/2006/main" noGrp="1"/>
+          </p:cNvSpPr>
+          <p:nvPr/>
+        </p:nvSpPr>
+        <p:spPr>
+          <a:xfrm xmlns:a="http://schemas.openxmlformats.org/drawingml/2006/main">
+            <a:off x="4438650" y="2133600"/>
+            <a:ext cx="3162300" cy="381000"/>
+          </a:xfrm>
+          <a:prstGeom xmlns:a="http://schemas.openxmlformats.org/drawingml/2006/main" prst="rect">
+            <a:avLst/>
+          </a:prstGeom>
+          <a:solidFill xmlns:a="http://schemas.openxmlformats.org/drawingml/2006/main">
+            <a:srgbClr val="FFFFFF"/>
+          </a:solidFill>
+          <a:ln xmlns:a="http://schemas.openxmlformats.org/drawingml/2006/main" w="0">
+            <a:noFill/>
+            <a:prstDash val="solid"/>
+          </a:ln>
+        </p:spPr>
+      </p:sp>
+      <p:sp>
+        <p:nvSpPr>
+          <p:cNvPr id="35" name="compat-card-fill-2-2">
+            <a:extLst xmlns:a="http://schemas.openxmlformats.org/drawingml/2006/main">
+              <a:ext uri="{FF2B5EF4-FFF2-40B4-BE49-F238E27FC236}">
+                <a16:creationId xmlns:a16="http://schemas.microsoft.com/office/drawing/2014/main" id="{AF7B2C68-02AD-4AB9-9093-19F05DEF1A4B}"/>
+              </a:ext>
+            </a:extLst>
+          </p:cNvPr>
+          <p:cNvSpPr>
+            <a:spLocks xmlns:a="http://schemas.openxmlformats.org/drawingml/2006/main" noGrp="1"/>
+          </p:cNvSpPr>
+          <p:nvPr/>
+        </p:nvSpPr>
+        <p:spPr>
+          <a:xfrm xmlns:a="http://schemas.openxmlformats.org/drawingml/2006/main">
+            <a:off x="4438650" y="2514600"/>
+            <a:ext cx="3162300" cy="381000"/>
+          </a:xfrm>
+          <a:prstGeom xmlns:a="http://schemas.openxmlformats.org/drawingml/2006/main" prst="rect">
+            <a:avLst/>
+          </a:prstGeom>
+          <a:solidFill xmlns:a="http://schemas.openxmlformats.org/drawingml/2006/main">
+            <a:srgbClr val="FFFFFF"/>
+          </a:solidFill>
+          <a:ln xmlns:a="http://schemas.openxmlformats.org/drawingml/2006/main" w="0">
+            <a:noFill/>
+            <a:prstDash val="solid"/>
+          </a:ln>
+        </p:spPr>
+      </p:sp>
+      <p:sp>
+        <p:nvSpPr>
+          <p:cNvPr id="36" name="compat-card-fill-2-3">
+            <a:extLst xmlns:a="http://schemas.openxmlformats.org/drawingml/2006/main">
+              <a:ext uri="{FF2B5EF4-FFF2-40B4-BE49-F238E27FC236}">
+                <a16:creationId xmlns:a16="http://schemas.microsoft.com/office/drawing/2014/main" id="{E3636D79-096C-47D6-B78F-E30DAF504A34}"/>
+              </a:ext>
+            </a:extLst>
+          </p:cNvPr>
+          <p:cNvSpPr>
+            <a:spLocks xmlns:a="http://schemas.openxmlformats.org/drawingml/2006/main" noGrp="1"/>
+          </p:cNvSpPr>
+          <p:nvPr/>
+        </p:nvSpPr>
+        <p:spPr>
+          <a:xfrm xmlns:a="http://schemas.openxmlformats.org/drawingml/2006/main">
+            <a:off x="4438650" y="2895600"/>
+            <a:ext cx="3162300" cy="476250"/>
+          </a:xfrm>
+          <a:prstGeom xmlns:a="http://schemas.openxmlformats.org/drawingml/2006/main" prst="rect">
+            <a:avLst/>
+          </a:prstGeom>
+          <a:solidFill xmlns:a="http://schemas.openxmlformats.org/drawingml/2006/main">
+            <a:srgbClr val="FFFFFF"/>
+          </a:solidFill>
+          <a:ln xmlns:a="http://schemas.openxmlformats.org/drawingml/2006/main" w="0">
+            <a:noFill/>
+            <a:prstDash val="solid"/>
+          </a:ln>
+        </p:spPr>
+      </p:sp>
+      <p:sp>
+        <p:nvSpPr>
+          <p:cNvPr id="37" name="compat-card-2">
+            <a:extLst xmlns:a="http://schemas.openxmlformats.org/drawingml/2006/main">
+              <a:ext uri="{FF2B5EF4-FFF2-40B4-BE49-F238E27FC236}">
+                <a16:creationId xmlns:a16="http://schemas.microsoft.com/office/drawing/2014/main" id="{59DCAF35-0EEB-4DA4-B734-CCF9E9C4CFF7}"/>
+              </a:ext>
+            </a:extLst>
+          </p:cNvPr>
+          <p:cNvSpPr>
+            <a:spLocks xmlns:a="http://schemas.openxmlformats.org/drawingml/2006/main" noGrp="1"/>
+          </p:cNvSpPr>
+          <p:nvPr/>
+        </p:nvSpPr>
+        <p:spPr>
+          <a:xfrm xmlns:a="http://schemas.openxmlformats.org/drawingml/2006/main">
+            <a:off x="4381500" y="2076450"/>
+            <a:ext cx="3276600" cy="1352550"/>
+          </a:xfrm>
+          <a:prstGeom xmlns:a="http://schemas.openxmlformats.org/drawingml/2006/main" prst="roundRect">
+            <a:avLst>
+              <a:gd name="adj" fmla="val 5634"/>
+            </a:avLst>
+          </a:prstGeom>
+          <a:noFill xmlns:a="http://schemas.openxmlformats.org/drawingml/2006/main"/>
+          <a:ln xmlns:a="http://schemas.openxmlformats.org/drawingml/2006/main" w="9525">
+            <a:solidFill>
+              <a:srgbClr val="DDE7F5"/>
+            </a:solidFill>
+            <a:prstDash val="solid"/>
+          </a:ln>
+        </p:spPr>
+      </p:sp>
+      <p:sp>
+        <p:nvSpPr>
+          <p:cNvPr id="38" name="compat-accent-2">
+            <a:extLst xmlns:a="http://schemas.openxmlformats.org/drawingml/2006/main">
+              <a:ext uri="{FF2B5EF4-FFF2-40B4-BE49-F238E27FC236}">
+                <a16:creationId xmlns:a16="http://schemas.microsoft.com/office/drawing/2014/main" id="{6D379EDB-817E-4F0B-91DB-DF83E8488E25}"/>
+              </a:ext>
+            </a:extLst>
+          </p:cNvPr>
+          <p:cNvSpPr>
+            <a:spLocks xmlns:a="http://schemas.openxmlformats.org/drawingml/2006/main" noGrp="1"/>
+          </p:cNvSpPr>
+          <p:nvPr/>
+        </p:nvSpPr>
+        <p:spPr>
+          <a:xfrm xmlns:a="http://schemas.openxmlformats.org/drawingml/2006/main">
+            <a:off x="4381500" y="2228850"/>
+            <a:ext cx="47625" cy="1047750"/>
+          </a:xfrm>
+          <a:prstGeom xmlns:a="http://schemas.openxmlformats.org/drawingml/2006/main" prst="rect">
+            <a:avLst/>
+          </a:prstGeom>
+          <a:solidFill xmlns:a="http://schemas.openxmlformats.org/drawingml/2006/main">
+            <a:srgbClr val="176BFF"/>
+          </a:solidFill>
+          <a:ln xmlns:a="http://schemas.openxmlformats.org/drawingml/2006/main" w="0">
+            <a:noFill/>
+            <a:prstDash val="solid"/>
+          </a:ln>
+        </p:spPr>
+      </p:sp>
+      <p:sp>
+        <p:nvSpPr>
+          <p:cNvPr id="39" name="compat-title-2">
+            <a:extLst xmlns:a="http://schemas.openxmlformats.org/drawingml/2006/main">
+              <a:ext uri="{FF2B5EF4-FFF2-40B4-BE49-F238E27FC236}">
+                <a16:creationId xmlns:a16="http://schemas.microsoft.com/office/drawing/2014/main" id="{E6BC2108-034B-409A-ABE7-485519372F2C}"/>
+              </a:ext>
+            </a:extLst>
+          </p:cNvPr>
+          <p:cNvSpPr>
+            <a:spLocks xmlns:a="http://schemas.openxmlformats.org/drawingml/2006/main" noGrp="1"/>
+          </p:cNvSpPr>
+          <p:nvPr/>
+        </p:nvSpPr>
+        <p:spPr>
+          <a:xfrm xmlns:a="http://schemas.openxmlformats.org/drawingml/2006/main">
+            <a:off x="4610100" y="2247900"/>
+            <a:ext cx="2781300" cy="209550"/>
+          </a:xfrm>
+          <a:prstGeom xmlns:a="http://schemas.openxmlformats.org/drawingml/2006/main" prst="rect">
+            <a:avLst/>
+          </a:prstGeom>
+          <a:noFill xmlns:a="http://schemas.openxmlformats.org/drawingml/2006/main"/>
+          <a:ln xmlns:a="http://schemas.openxmlformats.org/drawingml/2006/main" w="0">
+            <a:noFill/>
+            <a:prstDash val="solid"/>
+          </a:ln>
+        </p:spPr>
+        <p:txBody>
+          <a:bodyPr xmlns:a="http://schemas.openxmlformats.org/drawingml/2006/main" wrap="square" lIns="0" tIns="0" rIns="0" bIns="0" anchor="ctr">
+            <a:normAutofit fontScale="100000"/>
+          </a:bodyPr>
+          <a:lstStyle xmlns:a="http://schemas.openxmlformats.org/drawingml/2006/main"/>
+          <a:p xmlns:a="http://schemas.openxmlformats.org/drawingml/2006/main">
+            <a:pPr algn="l">
+              <a:defRPr sz="1200" b="1">
+                <a:solidFill>
+                  <a:srgbClr val="176BFF"/>
+                </a:solidFill>
+                <a:latin typeface="Microsoft YaHei"/>
+                <a:ea typeface="Microsoft YaHei"/>
+                <a:cs typeface="Microsoft YaHei"/>
+              </a:defRPr>
+            </a:pPr>
+            <a:r>
+              <a:rPr sz="1200" b="1">
+                <a:solidFill>
+                  <a:srgbClr val="176BFF"/>
+                </a:solidFill>
+                <a:latin typeface="Microsoft YaHei"/>
+                <a:ea typeface="Microsoft YaHei"/>
+                <a:cs typeface="Microsoft YaHei"/>
+              </a:rPr>
+              <a:t>专业编程助手</a:t>
+            </a:r>
+          </a:p>
+        </p:txBody>
+      </p:sp>
+      <p:sp>
+        <p:nvSpPr>
+          <p:cNvPr id="40" name="compat-name-2">
+            <a:extLst xmlns:a="http://schemas.openxmlformats.org/drawingml/2006/main">
+              <a:ext uri="{FF2B5EF4-FFF2-40B4-BE49-F238E27FC236}">
+                <a16:creationId xmlns:a16="http://schemas.microsoft.com/office/drawing/2014/main" id="{53F45C2E-A901-407B-AAAB-6E9BA20F451C}"/>
+              </a:ext>
+            </a:extLst>
+          </p:cNvPr>
+          <p:cNvSpPr>
+            <a:spLocks xmlns:a="http://schemas.openxmlformats.org/drawingml/2006/main" noGrp="1"/>
+          </p:cNvSpPr>
+          <p:nvPr/>
+        </p:nvSpPr>
+        <p:spPr>
+          <a:xfrm xmlns:a="http://schemas.openxmlformats.org/drawingml/2006/main">
+            <a:off x="4610100" y="2533650"/>
+            <a:ext cx="2781300" cy="323850"/>
+          </a:xfrm>
+          <a:prstGeom xmlns:a="http://schemas.openxmlformats.org/drawingml/2006/main" prst="rect">
+            <a:avLst/>
+          </a:prstGeom>
+          <a:noFill xmlns:a="http://schemas.openxmlformats.org/drawingml/2006/main"/>
+          <a:ln xmlns:a="http://schemas.openxmlformats.org/drawingml/2006/main" w="0">
+            <a:noFill/>
+            <a:prstDash val="solid"/>
+          </a:ln>
+        </p:spPr>
+        <p:txBody>
+          <a:bodyPr xmlns:a="http://schemas.openxmlformats.org/drawingml/2006/main" wrap="square" lIns="0" tIns="0" rIns="0" bIns="0" anchor="ctr">
+            <a:normAutofit fontScale="100000"/>
+          </a:bodyPr>
+          <a:lstStyle xmlns:a="http://schemas.openxmlformats.org/drawingml/2006/main"/>
+          <a:p xmlns:a="http://schemas.openxmlformats.org/drawingml/2006/main">
+            <a:pPr algn="l">
+              <a:defRPr sz="1950" b="1">
+                <a:solidFill>
+                  <a:srgbClr val="111827"/>
+                </a:solidFill>
+                <a:latin typeface="Microsoft YaHei"/>
+                <a:ea typeface="Microsoft YaHei"/>
+                <a:cs typeface="Microsoft YaHei"/>
+              </a:defRPr>
+            </a:pPr>
+            <a:r>
+              <a:rPr sz="1950" b="1">
+                <a:solidFill>
+                  <a:srgbClr val="111827"/>
+                </a:solidFill>
+                <a:latin typeface="Microsoft YaHei"/>
+                <a:ea typeface="Microsoft YaHei"/>
+                <a:cs typeface="Microsoft YaHei"/>
+              </a:rPr>
+              <a:t>Codex</a:t>
+            </a:r>
+          </a:p>
+        </p:txBody>
+      </p:sp>
+      <p:sp>
+        <p:nvSpPr>
+          <p:cNvPr id="41" name="compat-desc-2">
+            <a:extLst xmlns:a="http://schemas.openxmlformats.org/drawingml/2006/main">
+              <a:ext uri="{FF2B5EF4-FFF2-40B4-BE49-F238E27FC236}">
+                <a16:creationId xmlns:a16="http://schemas.microsoft.com/office/drawing/2014/main" id="{7857053F-D439-4C53-B6DB-03E22CF16485}"/>
+              </a:ext>
+            </a:extLst>
+          </p:cNvPr>
+          <p:cNvSpPr>
+            <a:spLocks xmlns:a="http://schemas.openxmlformats.org/drawingml/2006/main" noGrp="1"/>
+          </p:cNvSpPr>
+          <p:nvPr/>
+        </p:nvSpPr>
+        <p:spPr>
+          <a:xfrm xmlns:a="http://schemas.openxmlformats.org/drawingml/2006/main">
+            <a:off x="4610100" y="2952750"/>
+            <a:ext cx="2819400" cy="323850"/>
+          </a:xfrm>
+          <a:prstGeom xmlns:a="http://schemas.openxmlformats.org/drawingml/2006/main" prst="rect">
+            <a:avLst/>
+          </a:prstGeom>
+          <a:noFill xmlns:a="http://schemas.openxmlformats.org/drawingml/2006/main"/>
+          <a:ln xmlns:a="http://schemas.openxmlformats.org/drawingml/2006/main" w="0">
+            <a:noFill/>
+            <a:prstDash val="solid"/>
+          </a:ln>
+        </p:spPr>
+        <p:txBody>
+          <a:bodyPr xmlns:a="http://schemas.openxmlformats.org/drawingml/2006/main" wrap="square" lIns="0" tIns="0" rIns="0" bIns="0" anchor="ctr">
+            <a:normAutofit fontScale="100000"/>
+          </a:bodyPr>
+          <a:lstStyle xmlns:a="http://schemas.openxmlformats.org/drawingml/2006/main"/>
+          <a:p xmlns:a="http://schemas.openxmlformats.org/drawingml/2006/main">
+            <a:pPr algn="l">
+              <a:defRPr sz="1050">
+                <a:solidFill>
+                  <a:srgbClr val="64748B"/>
+                </a:solidFill>
+                <a:latin typeface="Microsoft YaHei"/>
+                <a:ea typeface="Microsoft YaHei"/>
+                <a:cs typeface="Microsoft YaHei"/>
+              </a:defRPr>
+            </a:pPr>
+            <a:r>
+              <a:rPr sz="1050">
+                <a:solidFill>
+                  <a:srgbClr val="64748B"/>
+                </a:solidFill>
+                <a:latin typeface="Microsoft YaHei"/>
+                <a:ea typeface="Microsoft YaHei"/>
+                <a:cs typeface="Microsoft YaHei"/>
+              </a:rPr>
+              <a:t>AGENTS.md · Skills · MCP · 沙箱 / 审批</a:t>
+            </a:r>
+          </a:p>
+        </p:txBody>
+      </p:sp>
+      <p:sp>
+        <p:nvSpPr>
+          <p:cNvPr id="42" name="compat-card-fill-3-1">
+            <a:extLst xmlns:a="http://schemas.openxmlformats.org/drawingml/2006/main">
+              <a:ext uri="{FF2B5EF4-FFF2-40B4-BE49-F238E27FC236}">
+                <a16:creationId xmlns:a16="http://schemas.microsoft.com/office/drawing/2014/main" id="{D02C6BBE-B855-49E3-9FFF-F9AAB4710C1E}"/>
+              </a:ext>
+            </a:extLst>
+          </p:cNvPr>
+          <p:cNvSpPr>
+            <a:spLocks xmlns:a="http://schemas.openxmlformats.org/drawingml/2006/main" noGrp="1"/>
+          </p:cNvSpPr>
+          <p:nvPr/>
+        </p:nvSpPr>
+        <p:spPr>
+          <a:xfrm xmlns:a="http://schemas.openxmlformats.org/drawingml/2006/main">
+            <a:off x="7981950" y="2133600"/>
+            <a:ext cx="3162300" cy="381000"/>
+          </a:xfrm>
+          <a:prstGeom xmlns:a="http://schemas.openxmlformats.org/drawingml/2006/main" prst="rect">
+            <a:avLst/>
+          </a:prstGeom>
+          <a:solidFill xmlns:a="http://schemas.openxmlformats.org/drawingml/2006/main">
+            <a:srgbClr val="FFFFFF"/>
+          </a:solidFill>
+          <a:ln xmlns:a="http://schemas.openxmlformats.org/drawingml/2006/main" w="0">
+            <a:noFill/>
+            <a:prstDash val="solid"/>
+          </a:ln>
+        </p:spPr>
+      </p:sp>
+      <p:sp>
+        <p:nvSpPr>
+          <p:cNvPr id="43" name="compat-card-fill-3-2">
+            <a:extLst xmlns:a="http://schemas.openxmlformats.org/drawingml/2006/main">
+              <a:ext uri="{FF2B5EF4-FFF2-40B4-BE49-F238E27FC236}">
+                <a16:creationId xmlns:a16="http://schemas.microsoft.com/office/drawing/2014/main" id="{777F7FB1-AD1C-4E78-AC1C-0C013DEA09DB}"/>
+              </a:ext>
+            </a:extLst>
+          </p:cNvPr>
+          <p:cNvSpPr>
+            <a:spLocks xmlns:a="http://schemas.openxmlformats.org/drawingml/2006/main" noGrp="1"/>
+          </p:cNvSpPr>
+          <p:nvPr/>
+        </p:nvSpPr>
+        <p:spPr>
+          <a:xfrm xmlns:a="http://schemas.openxmlformats.org/drawingml/2006/main">
+            <a:off x="7981950" y="2514600"/>
+            <a:ext cx="3162300" cy="381000"/>
+          </a:xfrm>
+          <a:prstGeom xmlns:a="http://schemas.openxmlformats.org/drawingml/2006/main" prst="rect">
+            <a:avLst/>
+          </a:prstGeom>
+          <a:solidFill xmlns:a="http://schemas.openxmlformats.org/drawingml/2006/main">
+            <a:srgbClr val="FFFFFF"/>
+          </a:solidFill>
+          <a:ln xmlns:a="http://schemas.openxmlformats.org/drawingml/2006/main" w="0">
+            <a:noFill/>
+            <a:prstDash val="solid"/>
+          </a:ln>
+        </p:spPr>
+      </p:sp>
+      <p:sp>
+        <p:nvSpPr>
+          <p:cNvPr id="44" name="compat-card-fill-3-3">
+            <a:extLst xmlns:a="http://schemas.openxmlformats.org/drawingml/2006/main">
+              <a:ext uri="{FF2B5EF4-FFF2-40B4-BE49-F238E27FC236}">
+                <a16:creationId xmlns:a16="http://schemas.microsoft.com/office/drawing/2014/main" id="{45AFEE63-5A0B-450B-8AC2-1BF30F6BF4B6}"/>
+              </a:ext>
+            </a:extLst>
+          </p:cNvPr>
+          <p:cNvSpPr>
+            <a:spLocks xmlns:a="http://schemas.openxmlformats.org/drawingml/2006/main" noGrp="1"/>
+          </p:cNvSpPr>
+          <p:nvPr/>
+        </p:nvSpPr>
+        <p:spPr>
+          <a:xfrm xmlns:a="http://schemas.openxmlformats.org/drawingml/2006/main">
+            <a:off x="7981950" y="2895600"/>
+            <a:ext cx="3162300" cy="476250"/>
+          </a:xfrm>
+          <a:prstGeom xmlns:a="http://schemas.openxmlformats.org/drawingml/2006/main" prst="rect">
+            <a:avLst/>
+          </a:prstGeom>
+          <a:solidFill xmlns:a="http://schemas.openxmlformats.org/drawingml/2006/main">
+            <a:srgbClr val="FFFFFF"/>
+          </a:solidFill>
+          <a:ln xmlns:a="http://schemas.openxmlformats.org/drawingml/2006/main" w="0">
+            <a:noFill/>
+            <a:prstDash val="solid"/>
+          </a:ln>
+        </p:spPr>
+      </p:sp>
+      <p:sp>
+        <p:nvSpPr>
+          <p:cNvPr id="45" name="compat-card-3">
+            <a:extLst xmlns:a="http://schemas.openxmlformats.org/drawingml/2006/main">
+              <a:ext uri="{FF2B5EF4-FFF2-40B4-BE49-F238E27FC236}">
+                <a16:creationId xmlns:a16="http://schemas.microsoft.com/office/drawing/2014/main" id="{EFD30262-A6C0-4D53-A7BF-1B52ACFE3797}"/>
+              </a:ext>
+            </a:extLst>
+          </p:cNvPr>
+          <p:cNvSpPr>
+            <a:spLocks xmlns:a="http://schemas.openxmlformats.org/drawingml/2006/main" noGrp="1"/>
+          </p:cNvSpPr>
+          <p:nvPr/>
+        </p:nvSpPr>
+        <p:spPr>
+          <a:xfrm xmlns:a="http://schemas.openxmlformats.org/drawingml/2006/main">
+            <a:off x="7924800" y="2076450"/>
+            <a:ext cx="3276600" cy="1352550"/>
+          </a:xfrm>
+          <a:prstGeom xmlns:a="http://schemas.openxmlformats.org/drawingml/2006/main" prst="roundRect">
+            <a:avLst>
+              <a:gd name="adj" fmla="val 5634"/>
+            </a:avLst>
+          </a:prstGeom>
+          <a:noFill xmlns:a="http://schemas.openxmlformats.org/drawingml/2006/main"/>
+          <a:ln xmlns:a="http://schemas.openxmlformats.org/drawingml/2006/main" w="9525">
+            <a:solidFill>
+              <a:srgbClr val="DDE7F5"/>
+            </a:solidFill>
+            <a:prstDash val="solid"/>
+          </a:ln>
+        </p:spPr>
+      </p:sp>
+      <p:sp>
+        <p:nvSpPr>
+          <p:cNvPr id="46" name="compat-accent-3">
+            <a:extLst xmlns:a="http://schemas.openxmlformats.org/drawingml/2006/main">
+              <a:ext uri="{FF2B5EF4-FFF2-40B4-BE49-F238E27FC236}">
+                <a16:creationId xmlns:a16="http://schemas.microsoft.com/office/drawing/2014/main" id="{B425A560-FF61-42E2-8088-6874D276AB15}"/>
+              </a:ext>
+            </a:extLst>
+          </p:cNvPr>
+          <p:cNvSpPr>
+            <a:spLocks xmlns:a="http://schemas.openxmlformats.org/drawingml/2006/main" noGrp="1"/>
+          </p:cNvSpPr>
+          <p:nvPr/>
+        </p:nvSpPr>
+        <p:spPr>
+          <a:xfrm xmlns:a="http://schemas.openxmlformats.org/drawingml/2006/main">
+            <a:off x="7924800" y="2228850"/>
+            <a:ext cx="47625" cy="1047750"/>
+          </a:xfrm>
+          <a:prstGeom xmlns:a="http://schemas.openxmlformats.org/drawingml/2006/main" prst="rect">
+            <a:avLst/>
+          </a:prstGeom>
+          <a:solidFill xmlns:a="http://schemas.openxmlformats.org/drawingml/2006/main">
+            <a:srgbClr val="176BFF"/>
+          </a:solidFill>
+          <a:ln xmlns:a="http://schemas.openxmlformats.org/drawingml/2006/main" w="0">
+            <a:noFill/>
+            <a:prstDash val="solid"/>
+          </a:ln>
+        </p:spPr>
+      </p:sp>
+      <p:sp>
+        <p:nvSpPr>
+          <p:cNvPr id="47" name="compat-title-3">
+            <a:extLst xmlns:a="http://schemas.openxmlformats.org/drawingml/2006/main">
+              <a:ext uri="{FF2B5EF4-FFF2-40B4-BE49-F238E27FC236}">
+                <a16:creationId xmlns:a16="http://schemas.microsoft.com/office/drawing/2014/main" id="{DE4D6871-BF98-4AEC-B845-AFDCEC1FCA89}"/>
+              </a:ext>
+            </a:extLst>
+          </p:cNvPr>
+          <p:cNvSpPr>
+            <a:spLocks xmlns:a="http://schemas.openxmlformats.org/drawingml/2006/main" noGrp="1"/>
+          </p:cNvSpPr>
+          <p:nvPr/>
+        </p:nvSpPr>
+        <p:spPr>
+          <a:xfrm xmlns:a="http://schemas.openxmlformats.org/drawingml/2006/main">
+            <a:off x="8153400" y="2247900"/>
+            <a:ext cx="2781300" cy="209550"/>
+          </a:xfrm>
+          <a:prstGeom xmlns:a="http://schemas.openxmlformats.org/drawingml/2006/main" prst="rect">
+            <a:avLst/>
+          </a:prstGeom>
+          <a:noFill xmlns:a="http://schemas.openxmlformats.org/drawingml/2006/main"/>
+          <a:ln xmlns:a="http://schemas.openxmlformats.org/drawingml/2006/main" w="0">
+            <a:noFill/>
+            <a:prstDash val="solid"/>
+          </a:ln>
+        </p:spPr>
+        <p:txBody>
+          <a:bodyPr xmlns:a="http://schemas.openxmlformats.org/drawingml/2006/main" wrap="square" lIns="0" tIns="0" rIns="0" bIns="0" anchor="ctr">
+            <a:normAutofit fontScale="100000"/>
+          </a:bodyPr>
+          <a:lstStyle xmlns:a="http://schemas.openxmlformats.org/drawingml/2006/main"/>
+          <a:p xmlns:a="http://schemas.openxmlformats.org/drawingml/2006/main">
+            <a:pPr algn="l">
+              <a:defRPr sz="1200" b="1">
+                <a:solidFill>
+                  <a:srgbClr val="176BFF"/>
+                </a:solidFill>
+                <a:latin typeface="Microsoft YaHei"/>
+                <a:ea typeface="Microsoft YaHei"/>
+                <a:cs typeface="Microsoft YaHei"/>
+              </a:defRPr>
+            </a:pPr>
+            <a:r>
+              <a:rPr sz="1200" b="1">
+                <a:solidFill>
+                  <a:srgbClr val="176BFF"/>
+                </a:solidFill>
+                <a:latin typeface="Microsoft YaHei"/>
+                <a:ea typeface="Microsoft YaHei"/>
+                <a:cs typeface="Microsoft YaHei"/>
+              </a:rPr>
+              <a:t>个人全能助理</a:t>
+            </a:r>
+          </a:p>
+        </p:txBody>
+      </p:sp>
+      <p:sp>
+        <p:nvSpPr>
+          <p:cNvPr id="48" name="compat-name-3">
+            <a:extLst xmlns:a="http://schemas.openxmlformats.org/drawingml/2006/main">
+              <a:ext uri="{FF2B5EF4-FFF2-40B4-BE49-F238E27FC236}">
+                <a16:creationId xmlns:a16="http://schemas.microsoft.com/office/drawing/2014/main" id="{DED0F3A4-98EC-4B28-99FD-5C1D27931BB8}"/>
+              </a:ext>
+            </a:extLst>
+          </p:cNvPr>
+          <p:cNvSpPr>
+            <a:spLocks xmlns:a="http://schemas.openxmlformats.org/drawingml/2006/main" noGrp="1"/>
+          </p:cNvSpPr>
+          <p:nvPr/>
+        </p:nvSpPr>
+        <p:spPr>
+          <a:xfrm xmlns:a="http://schemas.openxmlformats.org/drawingml/2006/main">
+            <a:off x="8153400" y="2533650"/>
+            <a:ext cx="2781300" cy="323850"/>
+          </a:xfrm>
+          <a:prstGeom xmlns:a="http://schemas.openxmlformats.org/drawingml/2006/main" prst="rect">
+            <a:avLst/>
+          </a:prstGeom>
+          <a:noFill xmlns:a="http://schemas.openxmlformats.org/drawingml/2006/main"/>
+          <a:ln xmlns:a="http://schemas.openxmlformats.org/drawingml/2006/main" w="0">
+            <a:noFill/>
+            <a:prstDash val="solid"/>
+          </a:ln>
+        </p:spPr>
+        <p:txBody>
+          <a:bodyPr xmlns:a="http://schemas.openxmlformats.org/drawingml/2006/main" wrap="square" lIns="0" tIns="0" rIns="0" bIns="0" anchor="ctr">
+            <a:normAutofit fontScale="100000"/>
+          </a:bodyPr>
+          <a:lstStyle xmlns:a="http://schemas.openxmlformats.org/drawingml/2006/main"/>
+          <a:p xmlns:a="http://schemas.openxmlformats.org/drawingml/2006/main">
+            <a:pPr algn="l">
+              <a:defRPr sz="1950" b="1">
+                <a:solidFill>
+                  <a:srgbClr val="111827"/>
+                </a:solidFill>
+                <a:latin typeface="Microsoft YaHei"/>
+                <a:ea typeface="Microsoft YaHei"/>
+                <a:cs typeface="Microsoft YaHei"/>
+              </a:defRPr>
+            </a:pPr>
+            <a:r>
+              <a:rPr sz="1950" b="1">
+                <a:solidFill>
+                  <a:srgbClr val="111827"/>
+                </a:solidFill>
+                <a:latin typeface="Microsoft YaHei"/>
+                <a:ea typeface="Microsoft YaHei"/>
+                <a:cs typeface="Microsoft YaHei"/>
+              </a:rPr>
+              <a:t>OpenClaw</a:t>
+            </a:r>
+          </a:p>
+        </p:txBody>
+      </p:sp>
+      <p:sp>
+        <p:nvSpPr>
+          <p:cNvPr id="49" name="compat-desc-3">
+            <a:extLst xmlns:a="http://schemas.openxmlformats.org/drawingml/2006/main">
+              <a:ext uri="{FF2B5EF4-FFF2-40B4-BE49-F238E27FC236}">
+                <a16:creationId xmlns:a16="http://schemas.microsoft.com/office/drawing/2014/main" id="{18FAF0F3-633A-440E-8341-7797379702B4}"/>
+              </a:ext>
+            </a:extLst>
+          </p:cNvPr>
+          <p:cNvSpPr>
+            <a:spLocks xmlns:a="http://schemas.openxmlformats.org/drawingml/2006/main" noGrp="1"/>
+          </p:cNvSpPr>
+          <p:nvPr/>
+        </p:nvSpPr>
+        <p:spPr>
+          <a:xfrm xmlns:a="http://schemas.openxmlformats.org/drawingml/2006/main">
+            <a:off x="8153400" y="2952750"/>
+            <a:ext cx="2819400" cy="323850"/>
+          </a:xfrm>
+          <a:prstGeom xmlns:a="http://schemas.openxmlformats.org/drawingml/2006/main" prst="rect">
+            <a:avLst/>
+          </a:prstGeom>
+          <a:noFill xmlns:a="http://schemas.openxmlformats.org/drawingml/2006/main"/>
+          <a:ln xmlns:a="http://schemas.openxmlformats.org/drawingml/2006/main" w="0">
+            <a:noFill/>
+            <a:prstDash val="solid"/>
+          </a:ln>
+        </p:spPr>
+        <p:txBody>
+          <a:bodyPr xmlns:a="http://schemas.openxmlformats.org/drawingml/2006/main" wrap="square" lIns="0" tIns="0" rIns="0" bIns="0" anchor="ctr">
+            <a:normAutofit fontScale="100000"/>
+          </a:bodyPr>
+          <a:lstStyle xmlns:a="http://schemas.openxmlformats.org/drawingml/2006/main"/>
+          <a:p xmlns:a="http://schemas.openxmlformats.org/drawingml/2006/main">
+            <a:pPr algn="l">
+              <a:defRPr sz="1050">
+                <a:solidFill>
+                  <a:srgbClr val="64748B"/>
+                </a:solidFill>
+                <a:latin typeface="Microsoft YaHei"/>
+                <a:ea typeface="Microsoft YaHei"/>
+                <a:cs typeface="Microsoft YaHei"/>
+              </a:defRPr>
+            </a:pPr>
+            <a:r>
+              <a:rPr sz="1050">
+                <a:solidFill>
+                  <a:srgbClr val="64748B"/>
+                </a:solidFill>
+                <a:latin typeface="Microsoft YaHei"/>
+                <a:ea typeface="Microsoft YaHei"/>
+                <a:cs typeface="Microsoft YaHei"/>
+              </a:rPr>
+              <a:t>Gateway · 会话 · 记忆 · Channels</a:t>
+            </a:r>
+          </a:p>
+        </p:txBody>
+      </p:sp>
+      <p:sp>
+        <p:nvSpPr>
+          <p:cNvPr id="50" name="compat-card-fill-4-1">
+            <a:extLst xmlns:a="http://schemas.openxmlformats.org/drawingml/2006/main">
+              <a:ext uri="{FF2B5EF4-FFF2-40B4-BE49-F238E27FC236}">
+                <a16:creationId xmlns:a16="http://schemas.microsoft.com/office/drawing/2014/main" id="{E0562B3F-3B89-4B8F-A3C5-10385080D496}"/>
+              </a:ext>
+            </a:extLst>
+          </p:cNvPr>
+          <p:cNvSpPr>
+            <a:spLocks xmlns:a="http://schemas.openxmlformats.org/drawingml/2006/main" noGrp="1"/>
+          </p:cNvSpPr>
+          <p:nvPr/>
+        </p:nvSpPr>
+        <p:spPr>
+          <a:xfrm xmlns:a="http://schemas.openxmlformats.org/drawingml/2006/main">
+            <a:off x="895350" y="3695700"/>
+            <a:ext cx="3162300" cy="381000"/>
+          </a:xfrm>
+          <a:prstGeom xmlns:a="http://schemas.openxmlformats.org/drawingml/2006/main" prst="rect">
+            <a:avLst/>
+          </a:prstGeom>
           <a:solidFill xmlns:a="http://schemas.openxmlformats.org/drawingml/2006/main">
             <a:srgbClr val="EAF2FF"/>
           </a:solidFill>
@@ -18967,39 +20626,166 @@
       </p:sp>
       <p:sp>
         <p:nvSpPr>
-          <p:cNvPr id="19" name="">
-            <a:extLst xmlns:a="http://schemas.openxmlformats.org/drawingml/2006/main">
-              <a:ext uri="{FF2B5EF4-FFF2-40B4-BE49-F238E27FC236}">
-                <a16:creationId xmlns:a16="http://schemas.microsoft.com/office/drawing/2014/main" id="{24B3CED9-2289-46C4-878F-B09658EEEAAB}"/>
-              </a:ext>
-            </a:extLst>
-          </p:cNvPr>
-          <p:cNvSpPr>
-            <a:spLocks xmlns:a="http://schemas.openxmlformats.org/drawingml/2006/main" noGrp="1"/>
-          </p:cNvSpPr>
-          <p:nvPr/>
-        </p:nvSpPr>
-        <p:spPr>
-          <a:xfrm xmlns:a="http://schemas.openxmlformats.org/drawingml/2006/main">
-            <a:off x="10096500" y="2362200"/>
-            <a:ext cx="1219200" cy="609600"/>
-          </a:xfrm>
-          <a:prstGeom xmlns:a="http://schemas.openxmlformats.org/drawingml/2006/main" prst="rect">
-            <a:avLst/>
-          </a:prstGeom>
-          <a:noFill xmlns:a="http://schemas.openxmlformats.org/drawingml/2006/main"/>
-          <a:ln xmlns:a="http://schemas.openxmlformats.org/drawingml/2006/main" w="0">
-            <a:noFill/>
-            <a:prstDash val="solid"/>
-          </a:ln>
-        </p:spPr>
-        <p:txBody>
-          <a:bodyPr xmlns:a="http://schemas.openxmlformats.org/drawingml/2006/main"/>
-          <a:lstStyle xmlns:a="http://schemas.openxmlformats.org/drawingml/2006/main"/>
-          <a:p xmlns:a="http://schemas.openxmlformats.org/drawingml/2006/main">
-            <a:pPr algn="ctr">
-              <a:buNone/>
-              <a:defRPr sz="1800" b="1" i="0">
+          <p:cNvPr id="51" name="compat-card-fill-4-2">
+            <a:extLst xmlns:a="http://schemas.openxmlformats.org/drawingml/2006/main">
+              <a:ext uri="{FF2B5EF4-FFF2-40B4-BE49-F238E27FC236}">
+                <a16:creationId xmlns:a16="http://schemas.microsoft.com/office/drawing/2014/main" id="{48C12C69-CFB1-4C46-BBD9-D4625CCBA581}"/>
+              </a:ext>
+            </a:extLst>
+          </p:cNvPr>
+          <p:cNvSpPr>
+            <a:spLocks xmlns:a="http://schemas.openxmlformats.org/drawingml/2006/main" noGrp="1"/>
+          </p:cNvSpPr>
+          <p:nvPr/>
+        </p:nvSpPr>
+        <p:spPr>
+          <a:xfrm xmlns:a="http://schemas.openxmlformats.org/drawingml/2006/main">
+            <a:off x="895350" y="4076700"/>
+            <a:ext cx="3162300" cy="381000"/>
+          </a:xfrm>
+          <a:prstGeom xmlns:a="http://schemas.openxmlformats.org/drawingml/2006/main" prst="rect">
+            <a:avLst/>
+          </a:prstGeom>
+          <a:solidFill xmlns:a="http://schemas.openxmlformats.org/drawingml/2006/main">
+            <a:srgbClr val="EAF2FF"/>
+          </a:solidFill>
+          <a:ln xmlns:a="http://schemas.openxmlformats.org/drawingml/2006/main" w="0">
+            <a:noFill/>
+            <a:prstDash val="solid"/>
+          </a:ln>
+        </p:spPr>
+      </p:sp>
+      <p:sp>
+        <p:nvSpPr>
+          <p:cNvPr id="52" name="compat-card-fill-4-3">
+            <a:extLst xmlns:a="http://schemas.openxmlformats.org/drawingml/2006/main">
+              <a:ext uri="{FF2B5EF4-FFF2-40B4-BE49-F238E27FC236}">
+                <a16:creationId xmlns:a16="http://schemas.microsoft.com/office/drawing/2014/main" id="{B526D05E-C47D-49D2-A72B-7996334C26A3}"/>
+              </a:ext>
+            </a:extLst>
+          </p:cNvPr>
+          <p:cNvSpPr>
+            <a:spLocks xmlns:a="http://schemas.openxmlformats.org/drawingml/2006/main" noGrp="1"/>
+          </p:cNvSpPr>
+          <p:nvPr/>
+        </p:nvSpPr>
+        <p:spPr>
+          <a:xfrm xmlns:a="http://schemas.openxmlformats.org/drawingml/2006/main">
+            <a:off x="895350" y="4457700"/>
+            <a:ext cx="3162300" cy="476250"/>
+          </a:xfrm>
+          <a:prstGeom xmlns:a="http://schemas.openxmlformats.org/drawingml/2006/main" prst="rect">
+            <a:avLst/>
+          </a:prstGeom>
+          <a:solidFill xmlns:a="http://schemas.openxmlformats.org/drawingml/2006/main">
+            <a:srgbClr val="EAF2FF"/>
+          </a:solidFill>
+          <a:ln xmlns:a="http://schemas.openxmlformats.org/drawingml/2006/main" w="0">
+            <a:noFill/>
+            <a:prstDash val="solid"/>
+          </a:ln>
+        </p:spPr>
+      </p:sp>
+      <p:sp>
+        <p:nvSpPr>
+          <p:cNvPr id="53" name="compat-card-4">
+            <a:extLst xmlns:a="http://schemas.openxmlformats.org/drawingml/2006/main">
+              <a:ext uri="{FF2B5EF4-FFF2-40B4-BE49-F238E27FC236}">
+                <a16:creationId xmlns:a16="http://schemas.microsoft.com/office/drawing/2014/main" id="{78665501-39CF-43AB-A709-09CE61C4A59E}"/>
+              </a:ext>
+            </a:extLst>
+          </p:cNvPr>
+          <p:cNvSpPr>
+            <a:spLocks xmlns:a="http://schemas.openxmlformats.org/drawingml/2006/main" noGrp="1"/>
+          </p:cNvSpPr>
+          <p:nvPr/>
+        </p:nvSpPr>
+        <p:spPr>
+          <a:xfrm xmlns:a="http://schemas.openxmlformats.org/drawingml/2006/main">
+            <a:off x="838200" y="3638550"/>
+            <a:ext cx="3276600" cy="1352550"/>
+          </a:xfrm>
+          <a:prstGeom xmlns:a="http://schemas.openxmlformats.org/drawingml/2006/main" prst="roundRect">
+            <a:avLst>
+              <a:gd name="adj" fmla="val 5634"/>
+            </a:avLst>
+          </a:prstGeom>
+          <a:noFill xmlns:a="http://schemas.openxmlformats.org/drawingml/2006/main"/>
+          <a:ln xmlns:a="http://schemas.openxmlformats.org/drawingml/2006/main" w="9525">
+            <a:solidFill>
+              <a:srgbClr val="DDE7F5"/>
+            </a:solidFill>
+            <a:prstDash val="solid"/>
+          </a:ln>
+        </p:spPr>
+      </p:sp>
+      <p:sp>
+        <p:nvSpPr>
+          <p:cNvPr id="54" name="compat-accent-4">
+            <a:extLst xmlns:a="http://schemas.openxmlformats.org/drawingml/2006/main">
+              <a:ext uri="{FF2B5EF4-FFF2-40B4-BE49-F238E27FC236}">
+                <a16:creationId xmlns:a16="http://schemas.microsoft.com/office/drawing/2014/main" id="{49B9AA27-CD03-495D-9699-BB6DE584A024}"/>
+              </a:ext>
+            </a:extLst>
+          </p:cNvPr>
+          <p:cNvSpPr>
+            <a:spLocks xmlns:a="http://schemas.openxmlformats.org/drawingml/2006/main" noGrp="1"/>
+          </p:cNvSpPr>
+          <p:nvPr/>
+        </p:nvSpPr>
+        <p:spPr>
+          <a:xfrm xmlns:a="http://schemas.openxmlformats.org/drawingml/2006/main">
+            <a:off x="838200" y="3790950"/>
+            <a:ext cx="47625" cy="1047750"/>
+          </a:xfrm>
+          <a:prstGeom xmlns:a="http://schemas.openxmlformats.org/drawingml/2006/main" prst="rect">
+            <a:avLst/>
+          </a:prstGeom>
+          <a:solidFill xmlns:a="http://schemas.openxmlformats.org/drawingml/2006/main">
+            <a:srgbClr val="00A875"/>
+          </a:solidFill>
+          <a:ln xmlns:a="http://schemas.openxmlformats.org/drawingml/2006/main" w="0">
+            <a:noFill/>
+            <a:prstDash val="solid"/>
+          </a:ln>
+        </p:spPr>
+      </p:sp>
+      <p:sp>
+        <p:nvSpPr>
+          <p:cNvPr id="55" name="compat-title-4">
+            <a:extLst xmlns:a="http://schemas.openxmlformats.org/drawingml/2006/main">
+              <a:ext uri="{FF2B5EF4-FFF2-40B4-BE49-F238E27FC236}">
+                <a16:creationId xmlns:a16="http://schemas.microsoft.com/office/drawing/2014/main" id="{D90E428E-D28E-44FA-B3D2-A6261DEF9547}"/>
+              </a:ext>
+            </a:extLst>
+          </p:cNvPr>
+          <p:cNvSpPr>
+            <a:spLocks xmlns:a="http://schemas.openxmlformats.org/drawingml/2006/main" noGrp="1"/>
+          </p:cNvSpPr>
+          <p:nvPr/>
+        </p:nvSpPr>
+        <p:spPr>
+          <a:xfrm xmlns:a="http://schemas.openxmlformats.org/drawingml/2006/main">
+            <a:off x="1066800" y="3810000"/>
+            <a:ext cx="2781300" cy="209550"/>
+          </a:xfrm>
+          <a:prstGeom xmlns:a="http://schemas.openxmlformats.org/drawingml/2006/main" prst="rect">
+            <a:avLst/>
+          </a:prstGeom>
+          <a:noFill xmlns:a="http://schemas.openxmlformats.org/drawingml/2006/main"/>
+          <a:ln xmlns:a="http://schemas.openxmlformats.org/drawingml/2006/main" w="0">
+            <a:noFill/>
+            <a:prstDash val="solid"/>
+          </a:ln>
+        </p:spPr>
+        <p:txBody>
+          <a:bodyPr xmlns:a="http://schemas.openxmlformats.org/drawingml/2006/main" wrap="square" lIns="0" tIns="0" rIns="0" bIns="0" anchor="ctr">
+            <a:normAutofit fontScale="100000"/>
+          </a:bodyPr>
+          <a:lstStyle xmlns:a="http://schemas.openxmlformats.org/drawingml/2006/main"/>
+          <a:p xmlns:a="http://schemas.openxmlformats.org/drawingml/2006/main">
+            <a:pPr algn="l">
+              <a:defRPr sz="1200" b="1">
                 <a:solidFill>
                   <a:srgbClr val="176BFF"/>
                 </a:solidFill>
@@ -19009,7 +20795,7 @@
               </a:defRPr>
             </a:pPr>
             <a:r>
-              <a:rPr sz="1800" b="1" i="0">
+              <a:rPr sz="1200" b="1">
                 <a:solidFill>
                   <a:srgbClr val="176BFF"/>
                 </a:solidFill>
@@ -19017,13 +20803,320 @@
                 <a:ea typeface="Microsoft YaHei"/>
                 <a:cs typeface="Microsoft YaHei"/>
               </a:rPr>
-              <a:t>易上手</a:t>
-            </a:r>
-          </a:p>
-          <a:p xmlns:a="http://schemas.openxmlformats.org/drawingml/2006/main">
-            <a:pPr algn="ctr">
-              <a:buNone/>
-              <a:defRPr sz="1800" b="1" i="0">
+              <a:t>团队协作中枢</a:t>
+            </a:r>
+          </a:p>
+        </p:txBody>
+      </p:sp>
+      <p:sp>
+        <p:nvSpPr>
+          <p:cNvPr id="56" name="compat-name-4">
+            <a:extLst xmlns:a="http://schemas.openxmlformats.org/drawingml/2006/main">
+              <a:ext uri="{FF2B5EF4-FFF2-40B4-BE49-F238E27FC236}">
+                <a16:creationId xmlns:a16="http://schemas.microsoft.com/office/drawing/2014/main" id="{D67341F5-F649-4091-824C-34F94796A6D1}"/>
+              </a:ext>
+            </a:extLst>
+          </p:cNvPr>
+          <p:cNvSpPr>
+            <a:spLocks xmlns:a="http://schemas.openxmlformats.org/drawingml/2006/main" noGrp="1"/>
+          </p:cNvSpPr>
+          <p:nvPr/>
+        </p:nvSpPr>
+        <p:spPr>
+          <a:xfrm xmlns:a="http://schemas.openxmlformats.org/drawingml/2006/main">
+            <a:off x="1066800" y="4095750"/>
+            <a:ext cx="2781300" cy="323850"/>
+          </a:xfrm>
+          <a:prstGeom xmlns:a="http://schemas.openxmlformats.org/drawingml/2006/main" prst="rect">
+            <a:avLst/>
+          </a:prstGeom>
+          <a:noFill xmlns:a="http://schemas.openxmlformats.org/drawingml/2006/main"/>
+          <a:ln xmlns:a="http://schemas.openxmlformats.org/drawingml/2006/main" w="0">
+            <a:noFill/>
+            <a:prstDash val="solid"/>
+          </a:ln>
+        </p:spPr>
+        <p:txBody>
+          <a:bodyPr xmlns:a="http://schemas.openxmlformats.org/drawingml/2006/main" wrap="square" lIns="0" tIns="0" rIns="0" bIns="0" anchor="ctr">
+            <a:normAutofit fontScale="100000"/>
+          </a:bodyPr>
+          <a:lstStyle xmlns:a="http://schemas.openxmlformats.org/drawingml/2006/main"/>
+          <a:p xmlns:a="http://schemas.openxmlformats.org/drawingml/2006/main">
+            <a:pPr algn="l">
+              <a:defRPr sz="1950" b="1">
+                <a:solidFill>
+                  <a:srgbClr val="111827"/>
+                </a:solidFill>
+                <a:latin typeface="Microsoft YaHei"/>
+                <a:ea typeface="Microsoft YaHei"/>
+                <a:cs typeface="Microsoft YaHei"/>
+              </a:defRPr>
+            </a:pPr>
+            <a:r>
+              <a:rPr sz="1950" b="1">
+                <a:solidFill>
+                  <a:srgbClr val="111827"/>
+                </a:solidFill>
+                <a:latin typeface="Microsoft YaHei"/>
+                <a:ea typeface="Microsoft YaHei"/>
+                <a:cs typeface="Microsoft YaHei"/>
+              </a:rPr>
+              <a:t>Hermes</a:t>
+            </a:r>
+          </a:p>
+        </p:txBody>
+      </p:sp>
+      <p:sp>
+        <p:nvSpPr>
+          <p:cNvPr id="57" name="compat-desc-4">
+            <a:extLst xmlns:a="http://schemas.openxmlformats.org/drawingml/2006/main">
+              <a:ext uri="{FF2B5EF4-FFF2-40B4-BE49-F238E27FC236}">
+                <a16:creationId xmlns:a16="http://schemas.microsoft.com/office/drawing/2014/main" id="{47CDDB18-5D86-4CBA-8410-B9E666436D93}"/>
+              </a:ext>
+            </a:extLst>
+          </p:cNvPr>
+          <p:cNvSpPr>
+            <a:spLocks xmlns:a="http://schemas.openxmlformats.org/drawingml/2006/main" noGrp="1"/>
+          </p:cNvSpPr>
+          <p:nvPr/>
+        </p:nvSpPr>
+        <p:spPr>
+          <a:xfrm xmlns:a="http://schemas.openxmlformats.org/drawingml/2006/main">
+            <a:off x="1066800" y="4514850"/>
+            <a:ext cx="2819400" cy="323850"/>
+          </a:xfrm>
+          <a:prstGeom xmlns:a="http://schemas.openxmlformats.org/drawingml/2006/main" prst="rect">
+            <a:avLst/>
+          </a:prstGeom>
+          <a:noFill xmlns:a="http://schemas.openxmlformats.org/drawingml/2006/main"/>
+          <a:ln xmlns:a="http://schemas.openxmlformats.org/drawingml/2006/main" w="0">
+            <a:noFill/>
+            <a:prstDash val="solid"/>
+          </a:ln>
+        </p:spPr>
+        <p:txBody>
+          <a:bodyPr xmlns:a="http://schemas.openxmlformats.org/drawingml/2006/main" wrap="square" lIns="0" tIns="0" rIns="0" bIns="0" anchor="ctr">
+            <a:normAutofit fontScale="100000"/>
+          </a:bodyPr>
+          <a:lstStyle xmlns:a="http://schemas.openxmlformats.org/drawingml/2006/main"/>
+          <a:p xmlns:a="http://schemas.openxmlformats.org/drawingml/2006/main">
+            <a:pPr algn="l">
+              <a:defRPr sz="1050">
+                <a:solidFill>
+                  <a:srgbClr val="64748B"/>
+                </a:solidFill>
+                <a:latin typeface="Microsoft YaHei"/>
+                <a:ea typeface="Microsoft YaHei"/>
+                <a:cs typeface="Microsoft YaHei"/>
+              </a:defRPr>
+            </a:pPr>
+            <a:r>
+              <a:rPr sz="1050">
+                <a:solidFill>
+                  <a:srgbClr val="64748B"/>
+                </a:solidFill>
+                <a:latin typeface="Microsoft YaHei"/>
+                <a:ea typeface="Microsoft YaHei"/>
+                <a:cs typeface="Microsoft YaHei"/>
+              </a:rPr>
+              <a:t>团队协作 · 消息 · 任务 · 扩展</a:t>
+            </a:r>
+          </a:p>
+        </p:txBody>
+      </p:sp>
+      <p:sp>
+        <p:nvSpPr>
+          <p:cNvPr id="58" name="compat-card-fill-5-1">
+            <a:extLst xmlns:a="http://schemas.openxmlformats.org/drawingml/2006/main">
+              <a:ext uri="{FF2B5EF4-FFF2-40B4-BE49-F238E27FC236}">
+                <a16:creationId xmlns:a16="http://schemas.microsoft.com/office/drawing/2014/main" id="{396A1AB6-3033-43F3-ACA5-9A38A7DB0437}"/>
+              </a:ext>
+            </a:extLst>
+          </p:cNvPr>
+          <p:cNvSpPr>
+            <a:spLocks xmlns:a="http://schemas.openxmlformats.org/drawingml/2006/main" noGrp="1"/>
+          </p:cNvSpPr>
+          <p:nvPr/>
+        </p:nvSpPr>
+        <p:spPr>
+          <a:xfrm xmlns:a="http://schemas.openxmlformats.org/drawingml/2006/main">
+            <a:off x="4438650" y="3695700"/>
+            <a:ext cx="3162300" cy="381000"/>
+          </a:xfrm>
+          <a:prstGeom xmlns:a="http://schemas.openxmlformats.org/drawingml/2006/main" prst="rect">
+            <a:avLst/>
+          </a:prstGeom>
+          <a:solidFill xmlns:a="http://schemas.openxmlformats.org/drawingml/2006/main">
+            <a:srgbClr val="EAF2FF"/>
+          </a:solidFill>
+          <a:ln xmlns:a="http://schemas.openxmlformats.org/drawingml/2006/main" w="0">
+            <a:noFill/>
+            <a:prstDash val="solid"/>
+          </a:ln>
+        </p:spPr>
+      </p:sp>
+      <p:sp>
+        <p:nvSpPr>
+          <p:cNvPr id="59" name="compat-card-fill-5-2">
+            <a:extLst xmlns:a="http://schemas.openxmlformats.org/drawingml/2006/main">
+              <a:ext uri="{FF2B5EF4-FFF2-40B4-BE49-F238E27FC236}">
+                <a16:creationId xmlns:a16="http://schemas.microsoft.com/office/drawing/2014/main" id="{341658E3-D68B-4E28-80D8-EE43D6BFCBA3}"/>
+              </a:ext>
+            </a:extLst>
+          </p:cNvPr>
+          <p:cNvSpPr>
+            <a:spLocks xmlns:a="http://schemas.openxmlformats.org/drawingml/2006/main" noGrp="1"/>
+          </p:cNvSpPr>
+          <p:nvPr/>
+        </p:nvSpPr>
+        <p:spPr>
+          <a:xfrm xmlns:a="http://schemas.openxmlformats.org/drawingml/2006/main">
+            <a:off x="4438650" y="4076700"/>
+            <a:ext cx="3162300" cy="381000"/>
+          </a:xfrm>
+          <a:prstGeom xmlns:a="http://schemas.openxmlformats.org/drawingml/2006/main" prst="rect">
+            <a:avLst/>
+          </a:prstGeom>
+          <a:solidFill xmlns:a="http://schemas.openxmlformats.org/drawingml/2006/main">
+            <a:srgbClr val="EAF2FF"/>
+          </a:solidFill>
+          <a:ln xmlns:a="http://schemas.openxmlformats.org/drawingml/2006/main" w="0">
+            <a:noFill/>
+            <a:prstDash val="solid"/>
+          </a:ln>
+        </p:spPr>
+      </p:sp>
+      <p:sp>
+        <p:nvSpPr>
+          <p:cNvPr id="60" name="compat-card-fill-5-3">
+            <a:extLst xmlns:a="http://schemas.openxmlformats.org/drawingml/2006/main">
+              <a:ext uri="{FF2B5EF4-FFF2-40B4-BE49-F238E27FC236}">
+                <a16:creationId xmlns:a16="http://schemas.microsoft.com/office/drawing/2014/main" id="{F78F7300-8212-4596-BBCE-56316A9D76A8}"/>
+              </a:ext>
+            </a:extLst>
+          </p:cNvPr>
+          <p:cNvSpPr>
+            <a:spLocks xmlns:a="http://schemas.openxmlformats.org/drawingml/2006/main" noGrp="1"/>
+          </p:cNvSpPr>
+          <p:nvPr/>
+        </p:nvSpPr>
+        <p:spPr>
+          <a:xfrm xmlns:a="http://schemas.openxmlformats.org/drawingml/2006/main">
+            <a:off x="4438650" y="4457700"/>
+            <a:ext cx="3162300" cy="476250"/>
+          </a:xfrm>
+          <a:prstGeom xmlns:a="http://schemas.openxmlformats.org/drawingml/2006/main" prst="rect">
+            <a:avLst/>
+          </a:prstGeom>
+          <a:solidFill xmlns:a="http://schemas.openxmlformats.org/drawingml/2006/main">
+            <a:srgbClr val="EAF2FF"/>
+          </a:solidFill>
+          <a:ln xmlns:a="http://schemas.openxmlformats.org/drawingml/2006/main" w="0">
+            <a:noFill/>
+            <a:prstDash val="solid"/>
+          </a:ln>
+        </p:spPr>
+      </p:sp>
+      <p:sp>
+        <p:nvSpPr>
+          <p:cNvPr id="61" name="compat-card-5">
+            <a:extLst xmlns:a="http://schemas.openxmlformats.org/drawingml/2006/main">
+              <a:ext uri="{FF2B5EF4-FFF2-40B4-BE49-F238E27FC236}">
+                <a16:creationId xmlns:a16="http://schemas.microsoft.com/office/drawing/2014/main" id="{9ADA23D9-4B4A-410F-95B5-E660DEDA7FBD}"/>
+              </a:ext>
+            </a:extLst>
+          </p:cNvPr>
+          <p:cNvSpPr>
+            <a:spLocks xmlns:a="http://schemas.openxmlformats.org/drawingml/2006/main" noGrp="1"/>
+          </p:cNvSpPr>
+          <p:nvPr/>
+        </p:nvSpPr>
+        <p:spPr>
+          <a:xfrm xmlns:a="http://schemas.openxmlformats.org/drawingml/2006/main">
+            <a:off x="4381500" y="3638550"/>
+            <a:ext cx="3276600" cy="1352550"/>
+          </a:xfrm>
+          <a:prstGeom xmlns:a="http://schemas.openxmlformats.org/drawingml/2006/main" prst="roundRect">
+            <a:avLst>
+              <a:gd name="adj" fmla="val 5634"/>
+            </a:avLst>
+          </a:prstGeom>
+          <a:noFill xmlns:a="http://schemas.openxmlformats.org/drawingml/2006/main"/>
+          <a:ln xmlns:a="http://schemas.openxmlformats.org/drawingml/2006/main" w="9525">
+            <a:solidFill>
+              <a:srgbClr val="DDE7F5"/>
+            </a:solidFill>
+            <a:prstDash val="solid"/>
+          </a:ln>
+        </p:spPr>
+      </p:sp>
+      <p:sp>
+        <p:nvSpPr>
+          <p:cNvPr id="62" name="compat-accent-5">
+            <a:extLst xmlns:a="http://schemas.openxmlformats.org/drawingml/2006/main">
+              <a:ext uri="{FF2B5EF4-FFF2-40B4-BE49-F238E27FC236}">
+                <a16:creationId xmlns:a16="http://schemas.microsoft.com/office/drawing/2014/main" id="{211650E4-8E44-4E1D-B760-CDAD74E7CEF5}"/>
+              </a:ext>
+            </a:extLst>
+          </p:cNvPr>
+          <p:cNvSpPr>
+            <a:spLocks xmlns:a="http://schemas.openxmlformats.org/drawingml/2006/main" noGrp="1"/>
+          </p:cNvSpPr>
+          <p:nvPr/>
+        </p:nvSpPr>
+        <p:spPr>
+          <a:xfrm xmlns:a="http://schemas.openxmlformats.org/drawingml/2006/main">
+            <a:off x="4381500" y="3790950"/>
+            <a:ext cx="47625" cy="1047750"/>
+          </a:xfrm>
+          <a:prstGeom xmlns:a="http://schemas.openxmlformats.org/drawingml/2006/main" prst="rect">
+            <a:avLst/>
+          </a:prstGeom>
+          <a:solidFill xmlns:a="http://schemas.openxmlformats.org/drawingml/2006/main">
+            <a:srgbClr val="00A875"/>
+          </a:solidFill>
+          <a:ln xmlns:a="http://schemas.openxmlformats.org/drawingml/2006/main" w="0">
+            <a:noFill/>
+            <a:prstDash val="solid"/>
+          </a:ln>
+        </p:spPr>
+      </p:sp>
+      <p:sp>
+        <p:nvSpPr>
+          <p:cNvPr id="63" name="compat-title-5">
+            <a:extLst xmlns:a="http://schemas.openxmlformats.org/drawingml/2006/main">
+              <a:ext uri="{FF2B5EF4-FFF2-40B4-BE49-F238E27FC236}">
+                <a16:creationId xmlns:a16="http://schemas.microsoft.com/office/drawing/2014/main" id="{8E1DBBC4-BF46-47E4-A7DB-7D88F6BF0B25}"/>
+              </a:ext>
+            </a:extLst>
+          </p:cNvPr>
+          <p:cNvSpPr>
+            <a:spLocks xmlns:a="http://schemas.openxmlformats.org/drawingml/2006/main" noGrp="1"/>
+          </p:cNvSpPr>
+          <p:nvPr/>
+        </p:nvSpPr>
+        <p:spPr>
+          <a:xfrm xmlns:a="http://schemas.openxmlformats.org/drawingml/2006/main">
+            <a:off x="4610100" y="3810000"/>
+            <a:ext cx="2781300" cy="209550"/>
+          </a:xfrm>
+          <a:prstGeom xmlns:a="http://schemas.openxmlformats.org/drawingml/2006/main" prst="rect">
+            <a:avLst/>
+          </a:prstGeom>
+          <a:noFill xmlns:a="http://schemas.openxmlformats.org/drawingml/2006/main"/>
+          <a:ln xmlns:a="http://schemas.openxmlformats.org/drawingml/2006/main" w="0">
+            <a:noFill/>
+            <a:prstDash val="solid"/>
+          </a:ln>
+        </p:spPr>
+        <p:txBody>
+          <a:bodyPr xmlns:a="http://schemas.openxmlformats.org/drawingml/2006/main" wrap="square" lIns="0" tIns="0" rIns="0" bIns="0" anchor="ctr">
+            <a:normAutofit fontScale="100000"/>
+          </a:bodyPr>
+          <a:lstStyle xmlns:a="http://schemas.openxmlformats.org/drawingml/2006/main"/>
+          <a:p xmlns:a="http://schemas.openxmlformats.org/drawingml/2006/main">
+            <a:pPr algn="l">
+              <a:defRPr sz="1200" b="1">
                 <a:solidFill>
                   <a:srgbClr val="176BFF"/>
                 </a:solidFill>
@@ -19033,7 +21126,7 @@
               </a:defRPr>
             </a:pPr>
             <a:r>
-              <a:rPr sz="1800" b="1" i="0">
+              <a:rPr sz="1200" b="1">
                 <a:solidFill>
                   <a:srgbClr val="176BFF"/>
                 </a:solidFill>
@@ -19041,46 +21134,47 @@
                 <a:ea typeface="Microsoft YaHei"/>
                 <a:cs typeface="Microsoft YaHei"/>
               </a:rPr>
-              <a:t>可成长</a:t>
-            </a:r>
-          </a:p>
-        </p:txBody>
-      </p:sp>
-      <p:sp>
-        <p:nvSpPr>
-          <p:cNvPr id="20" name="">
-            <a:extLst xmlns:a="http://schemas.openxmlformats.org/drawingml/2006/main">
-              <a:ext uri="{FF2B5EF4-FFF2-40B4-BE49-F238E27FC236}">
-                <a16:creationId xmlns:a16="http://schemas.microsoft.com/office/drawing/2014/main" id="{E6DE07F1-2CE1-4A8A-BE82-360BF6C6E148}"/>
-              </a:ext>
-            </a:extLst>
-          </p:cNvPr>
-          <p:cNvSpPr>
-            <a:spLocks xmlns:a="http://schemas.openxmlformats.org/drawingml/2006/main" noGrp="1"/>
-          </p:cNvSpPr>
-          <p:nvPr/>
-        </p:nvSpPr>
-        <p:spPr>
-          <a:xfrm xmlns:a="http://schemas.openxmlformats.org/drawingml/2006/main">
-            <a:off x="10096500" y="3238500"/>
-            <a:ext cx="1219200" cy="1809750"/>
-          </a:xfrm>
-          <a:prstGeom xmlns:a="http://schemas.openxmlformats.org/drawingml/2006/main" prst="rect">
-            <a:avLst/>
-          </a:prstGeom>
-          <a:noFill xmlns:a="http://schemas.openxmlformats.org/drawingml/2006/main"/>
-          <a:ln xmlns:a="http://schemas.openxmlformats.org/drawingml/2006/main" w="0">
-            <a:noFill/>
-            <a:prstDash val="solid"/>
-          </a:ln>
-        </p:spPr>
-        <p:txBody>
-          <a:bodyPr xmlns:a="http://schemas.openxmlformats.org/drawingml/2006/main"/>
-          <a:lstStyle xmlns:a="http://schemas.openxmlformats.org/drawingml/2006/main"/>
-          <a:p xmlns:a="http://schemas.openxmlformats.org/drawingml/2006/main">
-            <a:pPr algn="ctr">
-              <a:buNone/>
-              <a:defRPr sz="1500" b="1" i="0">
+              <a:t>工程开发工作台</a:t>
+            </a:r>
+          </a:p>
+        </p:txBody>
+      </p:sp>
+      <p:sp>
+        <p:nvSpPr>
+          <p:cNvPr id="64" name="compat-name-5">
+            <a:extLst xmlns:a="http://schemas.openxmlformats.org/drawingml/2006/main">
+              <a:ext uri="{FF2B5EF4-FFF2-40B4-BE49-F238E27FC236}">
+                <a16:creationId xmlns:a16="http://schemas.microsoft.com/office/drawing/2014/main" id="{B47D0A35-7660-433A-889E-BA518CAD734D}"/>
+              </a:ext>
+            </a:extLst>
+          </p:cNvPr>
+          <p:cNvSpPr>
+            <a:spLocks xmlns:a="http://schemas.openxmlformats.org/drawingml/2006/main" noGrp="1"/>
+          </p:cNvSpPr>
+          <p:nvPr/>
+        </p:nvSpPr>
+        <p:spPr>
+          <a:xfrm xmlns:a="http://schemas.openxmlformats.org/drawingml/2006/main">
+            <a:off x="4610100" y="4095750"/>
+            <a:ext cx="2781300" cy="323850"/>
+          </a:xfrm>
+          <a:prstGeom xmlns:a="http://schemas.openxmlformats.org/drawingml/2006/main" prst="rect">
+            <a:avLst/>
+          </a:prstGeom>
+          <a:noFill xmlns:a="http://schemas.openxmlformats.org/drawingml/2006/main"/>
+          <a:ln xmlns:a="http://schemas.openxmlformats.org/drawingml/2006/main" w="0">
+            <a:noFill/>
+            <a:prstDash val="solid"/>
+          </a:ln>
+        </p:spPr>
+        <p:txBody>
+          <a:bodyPr xmlns:a="http://schemas.openxmlformats.org/drawingml/2006/main" wrap="square" lIns="0" tIns="0" rIns="0" bIns="0" anchor="ctr">
+            <a:normAutofit fontScale="100000"/>
+          </a:bodyPr>
+          <a:lstStyle xmlns:a="http://schemas.openxmlformats.org/drawingml/2006/main"/>
+          <a:p xmlns:a="http://schemas.openxmlformats.org/drawingml/2006/main">
+            <a:pPr algn="l">
+              <a:defRPr sz="1950" b="1">
                 <a:solidFill>
                   <a:srgbClr val="111827"/>
                 </a:solidFill>
@@ -19090,7 +21184,7 @@
               </a:defRPr>
             </a:pPr>
             <a:r>
-              <a:rPr sz="1500" b="1" i="0">
+              <a:rPr sz="1950" b="1">
                 <a:solidFill>
                   <a:srgbClr val="111827"/>
                 </a:solidFill>
@@ -19098,13 +21192,320 @@
                 <a:ea typeface="Microsoft YaHei"/>
                 <a:cs typeface="Microsoft YaHei"/>
               </a:rPr>
-              <a:t>入门七类</a:t>
-            </a:r>
-          </a:p>
-          <a:p xmlns:a="http://schemas.openxmlformats.org/drawingml/2006/main">
-            <a:pPr algn="ctr">
-              <a:buNone/>
-              <a:defRPr sz="1500" b="1" i="0">
+              <a:t>OpenCode</a:t>
+            </a:r>
+          </a:p>
+        </p:txBody>
+      </p:sp>
+      <p:sp>
+        <p:nvSpPr>
+          <p:cNvPr id="65" name="compat-desc-5">
+            <a:extLst xmlns:a="http://schemas.openxmlformats.org/drawingml/2006/main">
+              <a:ext uri="{FF2B5EF4-FFF2-40B4-BE49-F238E27FC236}">
+                <a16:creationId xmlns:a16="http://schemas.microsoft.com/office/drawing/2014/main" id="{31B375FF-D546-47FA-A589-63E7B6D57B05}"/>
+              </a:ext>
+            </a:extLst>
+          </p:cNvPr>
+          <p:cNvSpPr>
+            <a:spLocks xmlns:a="http://schemas.openxmlformats.org/drawingml/2006/main" noGrp="1"/>
+          </p:cNvSpPr>
+          <p:nvPr/>
+        </p:nvSpPr>
+        <p:spPr>
+          <a:xfrm xmlns:a="http://schemas.openxmlformats.org/drawingml/2006/main">
+            <a:off x="4610100" y="4514850"/>
+            <a:ext cx="2819400" cy="323850"/>
+          </a:xfrm>
+          <a:prstGeom xmlns:a="http://schemas.openxmlformats.org/drawingml/2006/main" prst="rect">
+            <a:avLst/>
+          </a:prstGeom>
+          <a:noFill xmlns:a="http://schemas.openxmlformats.org/drawingml/2006/main"/>
+          <a:ln xmlns:a="http://schemas.openxmlformats.org/drawingml/2006/main" w="0">
+            <a:noFill/>
+            <a:prstDash val="solid"/>
+          </a:ln>
+        </p:spPr>
+        <p:txBody>
+          <a:bodyPr xmlns:a="http://schemas.openxmlformats.org/drawingml/2006/main" wrap="square" lIns="0" tIns="0" rIns="0" bIns="0" anchor="ctr">
+            <a:normAutofit fontScale="100000"/>
+          </a:bodyPr>
+          <a:lstStyle xmlns:a="http://schemas.openxmlformats.org/drawingml/2006/main"/>
+          <a:p xmlns:a="http://schemas.openxmlformats.org/drawingml/2006/main">
+            <a:pPr algn="l">
+              <a:defRPr sz="1050">
+                <a:solidFill>
+                  <a:srgbClr val="64748B"/>
+                </a:solidFill>
+                <a:latin typeface="Microsoft YaHei"/>
+                <a:ea typeface="Microsoft YaHei"/>
+                <a:cs typeface="Microsoft YaHei"/>
+              </a:defRPr>
+            </a:pPr>
+            <a:r>
+              <a:rPr sz="1050">
+                <a:solidFill>
+                  <a:srgbClr val="64748B"/>
+                </a:solidFill>
+                <a:latin typeface="Microsoft YaHei"/>
+                <a:ea typeface="Microsoft YaHei"/>
+                <a:cs typeface="Microsoft YaHei"/>
+              </a:rPr>
+              <a:t>主 / 子 Agent · 工具权限 · MCP · 插件</a:t>
+            </a:r>
+          </a:p>
+        </p:txBody>
+      </p:sp>
+      <p:sp>
+        <p:nvSpPr>
+          <p:cNvPr id="66" name="compat-card-fill-6-1">
+            <a:extLst xmlns:a="http://schemas.openxmlformats.org/drawingml/2006/main">
+              <a:ext uri="{FF2B5EF4-FFF2-40B4-BE49-F238E27FC236}">
+                <a16:creationId xmlns:a16="http://schemas.microsoft.com/office/drawing/2014/main" id="{ECA9979D-C56C-4AA7-AA58-5B1AEACB7C9B}"/>
+              </a:ext>
+            </a:extLst>
+          </p:cNvPr>
+          <p:cNvSpPr>
+            <a:spLocks xmlns:a="http://schemas.openxmlformats.org/drawingml/2006/main" noGrp="1"/>
+          </p:cNvSpPr>
+          <p:nvPr/>
+        </p:nvSpPr>
+        <p:spPr>
+          <a:xfrm xmlns:a="http://schemas.openxmlformats.org/drawingml/2006/main">
+            <a:off x="7981950" y="3695700"/>
+            <a:ext cx="3162300" cy="381000"/>
+          </a:xfrm>
+          <a:prstGeom xmlns:a="http://schemas.openxmlformats.org/drawingml/2006/main" prst="rect">
+            <a:avLst/>
+          </a:prstGeom>
+          <a:solidFill xmlns:a="http://schemas.openxmlformats.org/drawingml/2006/main">
+            <a:srgbClr val="EAF2FF"/>
+          </a:solidFill>
+          <a:ln xmlns:a="http://schemas.openxmlformats.org/drawingml/2006/main" w="0">
+            <a:noFill/>
+            <a:prstDash val="solid"/>
+          </a:ln>
+        </p:spPr>
+      </p:sp>
+      <p:sp>
+        <p:nvSpPr>
+          <p:cNvPr id="67" name="compat-card-fill-6-2">
+            <a:extLst xmlns:a="http://schemas.openxmlformats.org/drawingml/2006/main">
+              <a:ext uri="{FF2B5EF4-FFF2-40B4-BE49-F238E27FC236}">
+                <a16:creationId xmlns:a16="http://schemas.microsoft.com/office/drawing/2014/main" id="{64024621-3F06-4AC9-9FF2-CF3E3393C103}"/>
+              </a:ext>
+            </a:extLst>
+          </p:cNvPr>
+          <p:cNvSpPr>
+            <a:spLocks xmlns:a="http://schemas.openxmlformats.org/drawingml/2006/main" noGrp="1"/>
+          </p:cNvSpPr>
+          <p:nvPr/>
+        </p:nvSpPr>
+        <p:spPr>
+          <a:xfrm xmlns:a="http://schemas.openxmlformats.org/drawingml/2006/main">
+            <a:off x="7981950" y="4076700"/>
+            <a:ext cx="3162300" cy="381000"/>
+          </a:xfrm>
+          <a:prstGeom xmlns:a="http://schemas.openxmlformats.org/drawingml/2006/main" prst="rect">
+            <a:avLst/>
+          </a:prstGeom>
+          <a:solidFill xmlns:a="http://schemas.openxmlformats.org/drawingml/2006/main">
+            <a:srgbClr val="EAF2FF"/>
+          </a:solidFill>
+          <a:ln xmlns:a="http://schemas.openxmlformats.org/drawingml/2006/main" w="0">
+            <a:noFill/>
+            <a:prstDash val="solid"/>
+          </a:ln>
+        </p:spPr>
+      </p:sp>
+      <p:sp>
+        <p:nvSpPr>
+          <p:cNvPr id="68" name="compat-card-fill-6-3">
+            <a:extLst xmlns:a="http://schemas.openxmlformats.org/drawingml/2006/main">
+              <a:ext uri="{FF2B5EF4-FFF2-40B4-BE49-F238E27FC236}">
+                <a16:creationId xmlns:a16="http://schemas.microsoft.com/office/drawing/2014/main" id="{DC1041DE-C570-4450-8E05-373C0B3D6B9A}"/>
+              </a:ext>
+            </a:extLst>
+          </p:cNvPr>
+          <p:cNvSpPr>
+            <a:spLocks xmlns:a="http://schemas.openxmlformats.org/drawingml/2006/main" noGrp="1"/>
+          </p:cNvSpPr>
+          <p:nvPr/>
+        </p:nvSpPr>
+        <p:spPr>
+          <a:xfrm xmlns:a="http://schemas.openxmlformats.org/drawingml/2006/main">
+            <a:off x="7981950" y="4457700"/>
+            <a:ext cx="3162300" cy="476250"/>
+          </a:xfrm>
+          <a:prstGeom xmlns:a="http://schemas.openxmlformats.org/drawingml/2006/main" prst="rect">
+            <a:avLst/>
+          </a:prstGeom>
+          <a:solidFill xmlns:a="http://schemas.openxmlformats.org/drawingml/2006/main">
+            <a:srgbClr val="EAF2FF"/>
+          </a:solidFill>
+          <a:ln xmlns:a="http://schemas.openxmlformats.org/drawingml/2006/main" w="0">
+            <a:noFill/>
+            <a:prstDash val="solid"/>
+          </a:ln>
+        </p:spPr>
+      </p:sp>
+      <p:sp>
+        <p:nvSpPr>
+          <p:cNvPr id="69" name="compat-card-6">
+            <a:extLst xmlns:a="http://schemas.openxmlformats.org/drawingml/2006/main">
+              <a:ext uri="{FF2B5EF4-FFF2-40B4-BE49-F238E27FC236}">
+                <a16:creationId xmlns:a16="http://schemas.microsoft.com/office/drawing/2014/main" id="{A0845199-7DAE-4F90-B433-E53849F2B76F}"/>
+              </a:ext>
+            </a:extLst>
+          </p:cNvPr>
+          <p:cNvSpPr>
+            <a:spLocks xmlns:a="http://schemas.openxmlformats.org/drawingml/2006/main" noGrp="1"/>
+          </p:cNvSpPr>
+          <p:nvPr/>
+        </p:nvSpPr>
+        <p:spPr>
+          <a:xfrm xmlns:a="http://schemas.openxmlformats.org/drawingml/2006/main">
+            <a:off x="7924800" y="3638550"/>
+            <a:ext cx="3276600" cy="1352550"/>
+          </a:xfrm>
+          <a:prstGeom xmlns:a="http://schemas.openxmlformats.org/drawingml/2006/main" prst="roundRect">
+            <a:avLst>
+              <a:gd name="adj" fmla="val 5634"/>
+            </a:avLst>
+          </a:prstGeom>
+          <a:noFill xmlns:a="http://schemas.openxmlformats.org/drawingml/2006/main"/>
+          <a:ln xmlns:a="http://schemas.openxmlformats.org/drawingml/2006/main" w="9525">
+            <a:solidFill>
+              <a:srgbClr val="DDE7F5"/>
+            </a:solidFill>
+            <a:prstDash val="solid"/>
+          </a:ln>
+        </p:spPr>
+      </p:sp>
+      <p:sp>
+        <p:nvSpPr>
+          <p:cNvPr id="70" name="compat-accent-6">
+            <a:extLst xmlns:a="http://schemas.openxmlformats.org/drawingml/2006/main">
+              <a:ext uri="{FF2B5EF4-FFF2-40B4-BE49-F238E27FC236}">
+                <a16:creationId xmlns:a16="http://schemas.microsoft.com/office/drawing/2014/main" id="{1EAA9EC5-B647-4985-93CD-2920FC7D0E2E}"/>
+              </a:ext>
+            </a:extLst>
+          </p:cNvPr>
+          <p:cNvSpPr>
+            <a:spLocks xmlns:a="http://schemas.openxmlformats.org/drawingml/2006/main" noGrp="1"/>
+          </p:cNvSpPr>
+          <p:nvPr/>
+        </p:nvSpPr>
+        <p:spPr>
+          <a:xfrm xmlns:a="http://schemas.openxmlformats.org/drawingml/2006/main">
+            <a:off x="7924800" y="3790950"/>
+            <a:ext cx="47625" cy="1047750"/>
+          </a:xfrm>
+          <a:prstGeom xmlns:a="http://schemas.openxmlformats.org/drawingml/2006/main" prst="rect">
+            <a:avLst/>
+          </a:prstGeom>
+          <a:solidFill xmlns:a="http://schemas.openxmlformats.org/drawingml/2006/main">
+            <a:srgbClr val="176BFF"/>
+          </a:solidFill>
+          <a:ln xmlns:a="http://schemas.openxmlformats.org/drawingml/2006/main" w="0">
+            <a:noFill/>
+            <a:prstDash val="solid"/>
+          </a:ln>
+        </p:spPr>
+      </p:sp>
+      <p:sp>
+        <p:nvSpPr>
+          <p:cNvPr id="71" name="compat-title-6">
+            <a:extLst xmlns:a="http://schemas.openxmlformats.org/drawingml/2006/main">
+              <a:ext uri="{FF2B5EF4-FFF2-40B4-BE49-F238E27FC236}">
+                <a16:creationId xmlns:a16="http://schemas.microsoft.com/office/drawing/2014/main" id="{80C194AA-D60E-4C5B-BEA3-071A33ECE20D}"/>
+              </a:ext>
+            </a:extLst>
+          </p:cNvPr>
+          <p:cNvSpPr>
+            <a:spLocks xmlns:a="http://schemas.openxmlformats.org/drawingml/2006/main" noGrp="1"/>
+          </p:cNvSpPr>
+          <p:nvPr/>
+        </p:nvSpPr>
+        <p:spPr>
+          <a:xfrm xmlns:a="http://schemas.openxmlformats.org/drawingml/2006/main">
+            <a:off x="8153400" y="3810000"/>
+            <a:ext cx="2781300" cy="209550"/>
+          </a:xfrm>
+          <a:prstGeom xmlns:a="http://schemas.openxmlformats.org/drawingml/2006/main" prst="rect">
+            <a:avLst/>
+          </a:prstGeom>
+          <a:noFill xmlns:a="http://schemas.openxmlformats.org/drawingml/2006/main"/>
+          <a:ln xmlns:a="http://schemas.openxmlformats.org/drawingml/2006/main" w="0">
+            <a:noFill/>
+            <a:prstDash val="solid"/>
+          </a:ln>
+        </p:spPr>
+        <p:txBody>
+          <a:bodyPr xmlns:a="http://schemas.openxmlformats.org/drawingml/2006/main" wrap="square" lIns="0" tIns="0" rIns="0" bIns="0" anchor="ctr">
+            <a:normAutofit fontScale="100000"/>
+          </a:bodyPr>
+          <a:lstStyle xmlns:a="http://schemas.openxmlformats.org/drawingml/2006/main"/>
+          <a:p xmlns:a="http://schemas.openxmlformats.org/drawingml/2006/main">
+            <a:pPr algn="l">
+              <a:defRPr sz="1200" b="1">
+                <a:solidFill>
+                  <a:srgbClr val="176BFF"/>
+                </a:solidFill>
+                <a:latin typeface="Microsoft YaHei"/>
+                <a:ea typeface="Microsoft YaHei"/>
+                <a:cs typeface="Microsoft YaHei"/>
+              </a:defRPr>
+            </a:pPr>
+            <a:r>
+              <a:rPr sz="1200" b="1">
+                <a:solidFill>
+                  <a:srgbClr val="176BFF"/>
+                </a:solidFill>
+                <a:latin typeface="Microsoft YaHei"/>
+                <a:ea typeface="Microsoft YaHei"/>
+                <a:cs typeface="Microsoft YaHei"/>
+              </a:rPr>
+              <a:t>可组合研究工作台</a:t>
+            </a:r>
+          </a:p>
+        </p:txBody>
+      </p:sp>
+      <p:sp>
+        <p:nvSpPr>
+          <p:cNvPr id="72" name="compat-name-6">
+            <a:extLst xmlns:a="http://schemas.openxmlformats.org/drawingml/2006/main">
+              <a:ext uri="{FF2B5EF4-FFF2-40B4-BE49-F238E27FC236}">
+                <a16:creationId xmlns:a16="http://schemas.microsoft.com/office/drawing/2014/main" id="{3405F951-01AF-4756-B8E9-74CA6384748F}"/>
+              </a:ext>
+            </a:extLst>
+          </p:cNvPr>
+          <p:cNvSpPr>
+            <a:spLocks xmlns:a="http://schemas.openxmlformats.org/drawingml/2006/main" noGrp="1"/>
+          </p:cNvSpPr>
+          <p:nvPr/>
+        </p:nvSpPr>
+        <p:spPr>
+          <a:xfrm xmlns:a="http://schemas.openxmlformats.org/drawingml/2006/main">
+            <a:off x="8153400" y="4095750"/>
+            <a:ext cx="2781300" cy="323850"/>
+          </a:xfrm>
+          <a:prstGeom xmlns:a="http://schemas.openxmlformats.org/drawingml/2006/main" prst="rect">
+            <a:avLst/>
+          </a:prstGeom>
+          <a:noFill xmlns:a="http://schemas.openxmlformats.org/drawingml/2006/main"/>
+          <a:ln xmlns:a="http://schemas.openxmlformats.org/drawingml/2006/main" w="0">
+            <a:noFill/>
+            <a:prstDash val="solid"/>
+          </a:ln>
+        </p:spPr>
+        <p:txBody>
+          <a:bodyPr xmlns:a="http://schemas.openxmlformats.org/drawingml/2006/main" wrap="square" lIns="0" tIns="0" rIns="0" bIns="0" anchor="ctr">
+            <a:normAutofit fontScale="100000"/>
+          </a:bodyPr>
+          <a:lstStyle xmlns:a="http://schemas.openxmlformats.org/drawingml/2006/main"/>
+          <a:p xmlns:a="http://schemas.openxmlformats.org/drawingml/2006/main">
+            <a:pPr algn="l">
+              <a:defRPr sz="1725" b="1">
                 <a:solidFill>
                   <a:srgbClr val="111827"/>
                 </a:solidFill>
@@ -19114,7 +21515,7 @@
               </a:defRPr>
             </a:pPr>
             <a:r>
-              <a:rPr sz="1500" b="1" i="0">
+              <a:rPr sz="1725" b="1">
                 <a:solidFill>
                   <a:srgbClr val="111827"/>
                 </a:solidFill>
@@ -19122,329 +21523,65 @@
                 <a:ea typeface="Microsoft YaHei"/>
                 <a:cs typeface="Microsoft YaHei"/>
               </a:rPr>
-              <a:t>↓</a:t>
-            </a:r>
-          </a:p>
-          <a:p xmlns:a="http://schemas.openxmlformats.org/drawingml/2006/main">
-            <a:pPr algn="ctr">
-              <a:buNone/>
-              <a:defRPr sz="1500" b="1" i="0">
-                <a:solidFill>
-                  <a:srgbClr val="111827"/>
-                </a:solidFill>
-                <a:latin typeface="Microsoft YaHei"/>
-                <a:ea typeface="Microsoft YaHei"/>
-                <a:cs typeface="Microsoft YaHei"/>
-              </a:defRPr>
-            </a:pPr>
-            <a:r>
-              <a:rPr sz="1500" b="1" i="0">
-                <a:solidFill>
-                  <a:srgbClr val="111827"/>
-                </a:solidFill>
-                <a:latin typeface="Microsoft YaHei"/>
-                <a:ea typeface="Microsoft YaHei"/>
-                <a:cs typeface="Microsoft YaHei"/>
-              </a:rPr>
-              <a:t>专业十二类</a:t>
-            </a:r>
-          </a:p>
-          <a:p xmlns:a="http://schemas.openxmlformats.org/drawingml/2006/main">
-            <a:pPr algn="ctr">
-              <a:buNone/>
-              <a:defRPr sz="1500" b="1" i="0">
-                <a:solidFill>
-                  <a:srgbClr val="111827"/>
-                </a:solidFill>
-                <a:latin typeface="Microsoft YaHei"/>
-                <a:ea typeface="Microsoft YaHei"/>
-                <a:cs typeface="Microsoft YaHei"/>
-              </a:defRPr>
-            </a:pPr>
-            <a:r>
-              <a:rPr sz="1500" b="1" i="0">
-                <a:solidFill>
-                  <a:srgbClr val="111827"/>
-                </a:solidFill>
-                <a:latin typeface="Microsoft YaHei"/>
-                <a:ea typeface="Microsoft YaHei"/>
-                <a:cs typeface="Microsoft YaHei"/>
-              </a:rPr>
-              <a:t>↓</a:t>
-            </a:r>
-          </a:p>
-          <a:p xmlns:a="http://schemas.openxmlformats.org/drawingml/2006/main">
-            <a:pPr algn="ctr">
-              <a:buNone/>
-              <a:defRPr sz="1500" b="1" i="0">
-                <a:solidFill>
-                  <a:srgbClr val="111827"/>
-                </a:solidFill>
-                <a:latin typeface="Microsoft YaHei"/>
-                <a:ea typeface="Microsoft YaHei"/>
-                <a:cs typeface="Microsoft YaHei"/>
-              </a:defRPr>
-            </a:pPr>
-            <a:r>
-              <a:rPr sz="1500" b="1" i="0">
-                <a:solidFill>
-                  <a:srgbClr val="111827"/>
-                </a:solidFill>
-                <a:latin typeface="Microsoft YaHei"/>
-                <a:ea typeface="Microsoft YaHei"/>
-                <a:cs typeface="Microsoft YaHei"/>
-              </a:rPr>
-              <a:t>蓝图 / 代码</a:t>
-            </a:r>
-          </a:p>
-          <a:p xmlns:a="http://schemas.openxmlformats.org/drawingml/2006/main">
-            <a:pPr algn="ctr">
-              <a:buNone/>
-              <a:defRPr sz="1500" b="1" i="0">
-                <a:solidFill>
-                  <a:srgbClr val="111827"/>
-                </a:solidFill>
-                <a:latin typeface="Microsoft YaHei"/>
-                <a:ea typeface="Microsoft YaHei"/>
-                <a:cs typeface="Microsoft YaHei"/>
-              </a:defRPr>
-            </a:pPr>
-            <a:r>
-              <a:rPr sz="1500" b="1" i="0">
-                <a:solidFill>
-                  <a:srgbClr val="111827"/>
-                </a:solidFill>
-                <a:latin typeface="Microsoft YaHei"/>
-                <a:ea typeface="Microsoft YaHei"/>
-                <a:cs typeface="Microsoft YaHei"/>
-              </a:rPr>
-              <a:t>↓</a:t>
-            </a:r>
-          </a:p>
-          <a:p xmlns:a="http://schemas.openxmlformats.org/drawingml/2006/main">
-            <a:pPr algn="ctr">
-              <a:buNone/>
-              <a:defRPr sz="1500" b="1" i="0">
-                <a:solidFill>
-                  <a:srgbClr val="111827"/>
-                </a:solidFill>
-                <a:latin typeface="Microsoft YaHei"/>
-                <a:ea typeface="Microsoft YaHei"/>
-                <a:cs typeface="Microsoft YaHei"/>
-              </a:defRPr>
-            </a:pPr>
-            <a:r>
-              <a:rPr sz="1500" b="1" i="0">
-                <a:solidFill>
-                  <a:srgbClr val="111827"/>
-                </a:solidFill>
-                <a:latin typeface="Microsoft YaHei"/>
-                <a:ea typeface="Microsoft YaHei"/>
-                <a:cs typeface="Microsoft YaHei"/>
-              </a:rPr>
-              <a:t>运行轨迹</a:t>
-            </a:r>
-          </a:p>
-        </p:txBody>
-      </p:sp>
-      <p:sp>
-        <p:nvSpPr>
-          <p:cNvPr id="21" name="">
-            <a:extLst xmlns:a="http://schemas.openxmlformats.org/drawingml/2006/main">
-              <a:ext uri="{FF2B5EF4-FFF2-40B4-BE49-F238E27FC236}">
-                <a16:creationId xmlns:a16="http://schemas.microsoft.com/office/drawing/2014/main" id="{5ACF8F47-F459-4EE8-AFFB-431D2346A884}"/>
-              </a:ext>
-            </a:extLst>
-          </p:cNvPr>
-          <p:cNvSpPr>
-            <a:spLocks xmlns:a="http://schemas.openxmlformats.org/drawingml/2006/main" noGrp="1"/>
-          </p:cNvSpPr>
-          <p:nvPr/>
-        </p:nvSpPr>
-        <p:spPr>
-          <a:xfrm xmlns:a="http://schemas.openxmlformats.org/drawingml/2006/main">
-            <a:off x="1714500" y="5657850"/>
-            <a:ext cx="7905750" cy="228600"/>
-          </a:xfrm>
-          <a:prstGeom xmlns:a="http://schemas.openxmlformats.org/drawingml/2006/main" prst="rect">
-            <a:avLst/>
-          </a:prstGeom>
-          <a:noFill xmlns:a="http://schemas.openxmlformats.org/drawingml/2006/main"/>
-          <a:ln xmlns:a="http://schemas.openxmlformats.org/drawingml/2006/main" w="0">
-            <a:noFill/>
-            <a:prstDash val="solid"/>
-          </a:ln>
-        </p:spPr>
-        <p:txBody>
-          <a:bodyPr xmlns:a="http://schemas.openxmlformats.org/drawingml/2006/main"/>
-          <a:lstStyle xmlns:a="http://schemas.openxmlformats.org/drawingml/2006/main"/>
-          <a:p xmlns:a="http://schemas.openxmlformats.org/drawingml/2006/main">
-            <a:pPr algn="ctr">
-              <a:buNone/>
-              <a:defRPr sz="1050" b="0" i="0">
-                <a:solidFill>
-                  <a:srgbClr val="98A2B3"/>
-                </a:solidFill>
-                <a:latin typeface="Microsoft YaHei"/>
-                <a:ea typeface="Microsoft YaHei"/>
-                <a:cs typeface="Microsoft YaHei"/>
-              </a:defRPr>
-            </a:pPr>
-            <a:r>
-              <a:rPr sz="1050" b="0" i="0">
-                <a:solidFill>
-                  <a:srgbClr val="98A2B3"/>
-                </a:solidFill>
-                <a:latin typeface="Microsoft YaHei"/>
-                <a:ea typeface="Microsoft YaHei"/>
-                <a:cs typeface="Microsoft YaHei"/>
-              </a:rPr>
-              <a:t>同一项目格式与运行内核，支持从入门视图平滑进阶到专业视图。</a:t>
-            </a:r>
-          </a:p>
-        </p:txBody>
-      </p:sp>
-      <p:sp>
-        <p:nvSpPr>
-          <p:cNvPr id="22" name="">
-            <a:extLst xmlns:a="http://schemas.openxmlformats.org/drawingml/2006/main">
-              <a:ext uri="{FF2B5EF4-FFF2-40B4-BE49-F238E27FC236}">
-                <a16:creationId xmlns:a16="http://schemas.microsoft.com/office/drawing/2014/main" id="{7CA2238B-6981-4EEF-9644-CAB79A1ED2D3}"/>
-              </a:ext>
-            </a:extLst>
-          </p:cNvPr>
-          <p:cNvSpPr>
-            <a:spLocks xmlns:a="http://schemas.openxmlformats.org/drawingml/2006/main" noGrp="1"/>
-          </p:cNvSpPr>
-          <p:nvPr/>
-        </p:nvSpPr>
-        <p:spPr>
-          <a:xfrm xmlns:a="http://schemas.openxmlformats.org/drawingml/2006/main">
-            <a:off x="685800" y="6496050"/>
-            <a:ext cx="10820400" cy="9525"/>
-          </a:xfrm>
-          <a:prstGeom xmlns:a="http://schemas.openxmlformats.org/drawingml/2006/main" prst="rect">
-            <a:avLst/>
-          </a:prstGeom>
-          <a:solidFill xmlns:a="http://schemas.openxmlformats.org/drawingml/2006/main">
-            <a:srgbClr val="DCE3EC"/>
-          </a:solidFill>
-          <a:ln xmlns:a="http://schemas.openxmlformats.org/drawingml/2006/main" w="0">
-            <a:noFill/>
-            <a:prstDash val="solid"/>
-          </a:ln>
-        </p:spPr>
-      </p:sp>
-      <p:sp>
-        <p:nvSpPr>
-          <p:cNvPr id="23" name="">
-            <a:extLst xmlns:a="http://schemas.openxmlformats.org/drawingml/2006/main">
-              <a:ext uri="{FF2B5EF4-FFF2-40B4-BE49-F238E27FC236}">
-                <a16:creationId xmlns:a16="http://schemas.microsoft.com/office/drawing/2014/main" id="{4EEEB512-B61D-4234-BF5B-E7FCE68FD363}"/>
-              </a:ext>
-            </a:extLst>
-          </p:cNvPr>
-          <p:cNvSpPr>
-            <a:spLocks xmlns:a="http://schemas.openxmlformats.org/drawingml/2006/main" noGrp="1"/>
-          </p:cNvSpPr>
-          <p:nvPr/>
-        </p:nvSpPr>
-        <p:spPr>
-          <a:xfrm xmlns:a="http://schemas.openxmlformats.org/drawingml/2006/main">
-            <a:off x="685800" y="6553200"/>
-            <a:ext cx="4762500" cy="190500"/>
-          </a:xfrm>
-          <a:prstGeom xmlns:a="http://schemas.openxmlformats.org/drawingml/2006/main" prst="rect">
-            <a:avLst/>
-          </a:prstGeom>
-          <a:noFill xmlns:a="http://schemas.openxmlformats.org/drawingml/2006/main"/>
-          <a:ln xmlns:a="http://schemas.openxmlformats.org/drawingml/2006/main" w="0">
-            <a:noFill/>
-            <a:prstDash val="solid"/>
-          </a:ln>
-        </p:spPr>
-        <p:txBody>
-          <a:bodyPr xmlns:a="http://schemas.openxmlformats.org/drawingml/2006/main"/>
+              <a:t>DeepSeek Harness</a:t>
+            </a:r>
+          </a:p>
+        </p:txBody>
+      </p:sp>
+      <p:sp>
+        <p:nvSpPr>
+          <p:cNvPr id="73" name="compat-desc-6">
+            <a:extLst xmlns:a="http://schemas.openxmlformats.org/drawingml/2006/main">
+              <a:ext uri="{FF2B5EF4-FFF2-40B4-BE49-F238E27FC236}">
+                <a16:creationId xmlns:a16="http://schemas.microsoft.com/office/drawing/2014/main" id="{2ECFBFFD-E59A-4A3A-8724-DE3549232001}"/>
+              </a:ext>
+            </a:extLst>
+          </p:cNvPr>
+          <p:cNvSpPr>
+            <a:spLocks xmlns:a="http://schemas.openxmlformats.org/drawingml/2006/main" noGrp="1"/>
+          </p:cNvSpPr>
+          <p:nvPr/>
+        </p:nvSpPr>
+        <p:spPr>
+          <a:xfrm xmlns:a="http://schemas.openxmlformats.org/drawingml/2006/main">
+            <a:off x="8153400" y="4514850"/>
+            <a:ext cx="2819400" cy="323850"/>
+          </a:xfrm>
+          <a:prstGeom xmlns:a="http://schemas.openxmlformats.org/drawingml/2006/main" prst="rect">
+            <a:avLst/>
+          </a:prstGeom>
+          <a:noFill xmlns:a="http://schemas.openxmlformats.org/drawingml/2006/main"/>
+          <a:ln xmlns:a="http://schemas.openxmlformats.org/drawingml/2006/main" w="0">
+            <a:noFill/>
+            <a:prstDash val="solid"/>
+          </a:ln>
+        </p:spPr>
+        <p:txBody>
+          <a:bodyPr xmlns:a="http://schemas.openxmlformats.org/drawingml/2006/main" wrap="square" lIns="0" tIns="0" rIns="0" bIns="0" anchor="ctr">
+            <a:normAutofit fontScale="100000"/>
+          </a:bodyPr>
           <a:lstStyle xmlns:a="http://schemas.openxmlformats.org/drawingml/2006/main"/>
           <a:p xmlns:a="http://schemas.openxmlformats.org/drawingml/2006/main">
             <a:pPr algn="l">
-              <a:buNone/>
-              <a:defRPr sz="975" b="0" i="0">
-                <a:solidFill>
-                  <a:srgbClr val="98A2B3"/>
-                </a:solidFill>
-                <a:latin typeface="Microsoft YaHei"/>
-                <a:ea typeface="Microsoft YaHei"/>
-                <a:cs typeface="Microsoft YaHei"/>
-              </a:defRPr>
-            </a:pPr>
-            <a:r>
-              <a:rPr sz="975" b="0" i="0">
-                <a:solidFill>
-                  <a:srgbClr val="98A2B3"/>
-                </a:solidFill>
-                <a:latin typeface="Microsoft YaHei"/>
-                <a:ea typeface="Microsoft YaHei"/>
-                <a:cs typeface="Microsoft YaHei"/>
-              </a:rPr>
-              <a:t>Blocky Studio · 息壤杯 AI+教育</a:t>
-            </a:r>
-          </a:p>
-        </p:txBody>
-      </p:sp>
-      <p:sp>
-        <p:nvSpPr>
-          <p:cNvPr id="24" name="">
-            <a:extLst xmlns:a="http://schemas.openxmlformats.org/drawingml/2006/main">
-              <a:ext uri="{FF2B5EF4-FFF2-40B4-BE49-F238E27FC236}">
-                <a16:creationId xmlns:a16="http://schemas.microsoft.com/office/drawing/2014/main" id="{F36BBFE9-8C7C-4891-A36F-ED778245CE43}"/>
-              </a:ext>
-            </a:extLst>
-          </p:cNvPr>
-          <p:cNvSpPr>
-            <a:spLocks xmlns:a="http://schemas.openxmlformats.org/drawingml/2006/main" noGrp="1"/>
-          </p:cNvSpPr>
-          <p:nvPr/>
-        </p:nvSpPr>
-        <p:spPr>
-          <a:xfrm xmlns:a="http://schemas.openxmlformats.org/drawingml/2006/main">
-            <a:off x="10953750" y="6553200"/>
-            <a:ext cx="552450" cy="190500"/>
-          </a:xfrm>
-          <a:prstGeom xmlns:a="http://schemas.openxmlformats.org/drawingml/2006/main" prst="rect">
-            <a:avLst/>
-          </a:prstGeom>
-          <a:noFill xmlns:a="http://schemas.openxmlformats.org/drawingml/2006/main"/>
-          <a:ln xmlns:a="http://schemas.openxmlformats.org/drawingml/2006/main" w="0">
-            <a:noFill/>
-            <a:prstDash val="solid"/>
-          </a:ln>
-        </p:spPr>
-        <p:txBody>
-          <a:bodyPr xmlns:a="http://schemas.openxmlformats.org/drawingml/2006/main"/>
-          <a:lstStyle xmlns:a="http://schemas.openxmlformats.org/drawingml/2006/main"/>
-          <a:p xmlns:a="http://schemas.openxmlformats.org/drawingml/2006/main">
-            <a:pPr algn="r">
-              <a:buNone/>
-              <a:defRPr sz="975" b="0" i="0">
-                <a:solidFill>
-                  <a:srgbClr val="98A2B3"/>
-                </a:solidFill>
-                <a:latin typeface="Microsoft YaHei"/>
-                <a:ea typeface="Microsoft YaHei"/>
-                <a:cs typeface="Microsoft YaHei"/>
-              </a:defRPr>
-            </a:pPr>
-            <a:r>
-              <a:rPr sz="975" b="0" i="0">
-                <a:solidFill>
-                  <a:srgbClr val="98A2B3"/>
-                </a:solidFill>
-                <a:latin typeface="Microsoft YaHei"/>
-                <a:ea typeface="Microsoft YaHei"/>
-                <a:cs typeface="Microsoft YaHei"/>
-              </a:rPr>
-              <a:t>08</a:t>
+              <a:defRPr sz="1050">
+                <a:solidFill>
+                  <a:srgbClr val="64748B"/>
+                </a:solidFill>
+                <a:latin typeface="Microsoft YaHei"/>
+                <a:ea typeface="Microsoft YaHei"/>
+                <a:cs typeface="Microsoft YaHei"/>
+              </a:defRPr>
+            </a:pPr>
+            <a:r>
+              <a:rPr sz="1050">
+                <a:solidFill>
+                  <a:srgbClr val="64748B"/>
+                </a:solidFill>
+                <a:latin typeface="Microsoft YaHei"/>
+                <a:ea typeface="Microsoft YaHei"/>
+                <a:cs typeface="Microsoft YaHei"/>
+              </a:rPr>
+              <a:t>Profile · Bundle · Cordis 插件树 · 审批</a:t>
             </a:r>
           </a:p>
         </p:txBody>
@@ -19564,7 +21701,9 @@
           </a:ln>
         </p:spPr>
         <p:txBody>
-          <a:bodyPr xmlns:a="http://schemas.openxmlformats.org/drawingml/2006/main"/>
+          <a:bodyPr xmlns:a="http://schemas.openxmlformats.org/drawingml/2006/main" wrap="square" lIns="0" tIns="0" rIns="0" bIns="0" anchor="ctr">
+            <a:normAutofit fontScale="100000"/>
+          </a:bodyPr>
           <a:lstStyle xmlns:a="http://schemas.openxmlformats.org/drawingml/2006/main"/>
           <a:p xmlns:a="http://schemas.openxmlformats.org/drawingml/2006/main">
             <a:pPr algn="l">
@@ -19587,7 +21726,7 @@
                 <a:ea typeface="Microsoft YaHei"/>
                 <a:cs typeface="Microsoft YaHei"/>
               </a:rPr>
-              <a:t>底座已验证；正式产品 Demo 仍在下一阶段</a:t>
+              <a:t>底座已验证；六模板、CLI 与教育工作区仍按阶段推进</a:t>
             </a:r>
           </a:p>
         </p:txBody>
@@ -20032,7 +22171,7 @@
         <p:spPr>
           <a:xfrm xmlns:a="http://schemas.openxmlformats.org/drawingml/2006/main">
             <a:off x="6153150" y="2152650"/>
-            <a:ext cx="2209800" cy="323850"/>
+            <a:ext cx="3048000" cy="323850"/>
           </a:xfrm>
           <a:prstGeom xmlns:a="http://schemas.openxmlformats.org/drawingml/2006/main" prst="roundRect">
             <a:avLst>
@@ -20065,26 +22204,28 @@
         <p:spPr>
           <a:xfrm xmlns:a="http://schemas.openxmlformats.org/drawingml/2006/main">
             <a:off x="6248400" y="2219325"/>
-            <a:ext cx="2019300" cy="190500"/>
-          </a:xfrm>
-          <a:prstGeom xmlns:a="http://schemas.openxmlformats.org/drawingml/2006/main" prst="rect">
-            <a:avLst/>
-          </a:prstGeom>
-          <a:noFill xmlns:a="http://schemas.openxmlformats.org/drawingml/2006/main"/>
-          <a:ln xmlns:a="http://schemas.openxmlformats.org/drawingml/2006/main" w="0">
-            <a:noFill/>
-            <a:prstDash val="solid"/>
-          </a:ln>
-        </p:spPr>
-        <p:txBody>
-          <a:bodyPr xmlns:a="http://schemas.openxmlformats.org/drawingml/2006/main"/>
+            <a:ext cx="2857500" cy="190500"/>
+          </a:xfrm>
+          <a:prstGeom xmlns:a="http://schemas.openxmlformats.org/drawingml/2006/main" prst="rect">
+            <a:avLst/>
+          </a:prstGeom>
+          <a:noFill xmlns:a="http://schemas.openxmlformats.org/drawingml/2006/main"/>
+          <a:ln xmlns:a="http://schemas.openxmlformats.org/drawingml/2006/main" w="0">
+            <a:noFill/>
+            <a:prstDash val="solid"/>
+          </a:ln>
+        </p:spPr>
+        <p:txBody>
+          <a:bodyPr xmlns:a="http://schemas.openxmlformats.org/drawingml/2006/main" wrap="square" lIns="0" tIns="0" rIns="0" bIns="0" anchor="ctr">
+            <a:normAutofit fontScale="100000"/>
+          </a:bodyPr>
           <a:lstStyle xmlns:a="http://schemas.openxmlformats.org/drawingml/2006/main"/>
           <a:p xmlns:a="http://schemas.openxmlformats.org/drawingml/2006/main">
             <a:pPr algn="ctr">
               <a:buNone/>
               <a:defRPr sz="1050" b="1" i="0">
                 <a:solidFill>
-                  <a:srgbClr val="E5484D"/>
+                  <a:srgbClr val="EF4444"/>
                 </a:solidFill>
                 <a:latin typeface="Microsoft YaHei"/>
                 <a:ea typeface="Microsoft YaHei"/>
@@ -20094,13 +22235,13 @@
             <a:r>
               <a:rPr sz="1050" b="1" i="0">
                 <a:solidFill>
-                  <a:srgbClr val="E5484D"/>
-                </a:solidFill>
-                <a:latin typeface="Microsoft YaHei"/>
-                <a:ea typeface="Microsoft YaHei"/>
-                <a:cs typeface="Microsoft YaHei"/>
-              </a:rPr>
-              <a:t>尚未完成 · 正式产品</a:t>
+                  <a:srgbClr val="EF4444"/>
+                </a:solidFill>
+                <a:latin typeface="Microsoft YaHei"/>
+                <a:ea typeface="Microsoft YaHei"/>
+                <a:cs typeface="Microsoft YaHei"/>
+              </a:rPr>
+              <a:t>按阶段推进 · 正式产品</a:t>
             </a:r>
           </a:p>
         </p:txBody>
@@ -20121,25 +22262,27 @@
         </p:nvSpPr>
         <p:spPr>
           <a:xfrm xmlns:a="http://schemas.openxmlformats.org/drawingml/2006/main">
-            <a:off x="6172200" y="2762250"/>
-            <a:ext cx="4857750" cy="2076450"/>
-          </a:xfrm>
-          <a:prstGeom xmlns:a="http://schemas.openxmlformats.org/drawingml/2006/main" prst="rect">
-            <a:avLst/>
-          </a:prstGeom>
-          <a:noFill xmlns:a="http://schemas.openxmlformats.org/drawingml/2006/main"/>
-          <a:ln xmlns:a="http://schemas.openxmlformats.org/drawingml/2006/main" w="0">
-            <a:noFill/>
-            <a:prstDash val="solid"/>
-          </a:ln>
-        </p:spPr>
-        <p:txBody>
-          <a:bodyPr xmlns:a="http://schemas.openxmlformats.org/drawingml/2006/main"/>
+            <a:off x="6172200" y="2647950"/>
+            <a:ext cx="4857750" cy="2457450"/>
+          </a:xfrm>
+          <a:prstGeom xmlns:a="http://schemas.openxmlformats.org/drawingml/2006/main" prst="rect">
+            <a:avLst/>
+          </a:prstGeom>
+          <a:noFill xmlns:a="http://schemas.openxmlformats.org/drawingml/2006/main"/>
+          <a:ln xmlns:a="http://schemas.openxmlformats.org/drawingml/2006/main" w="0">
+            <a:noFill/>
+            <a:prstDash val="solid"/>
+          </a:ln>
+        </p:spPr>
+        <p:txBody>
+          <a:bodyPr xmlns:a="http://schemas.openxmlformats.org/drawingml/2006/main" wrap="square" lIns="0" tIns="0" rIns="0" bIns="0" anchor="ctr">
+            <a:normAutofit fontScale="100000"/>
+          </a:bodyPr>
           <a:lstStyle xmlns:a="http://schemas.openxmlformats.org/drawingml/2006/main"/>
           <a:p xmlns:a="http://schemas.openxmlformats.org/drawingml/2006/main">
             <a:pPr algn="l">
               <a:buNone/>
-              <a:defRPr sz="1500" b="0" i="0">
+              <a:defRPr sz="1200" b="0" i="0">
                 <a:solidFill>
                   <a:srgbClr val="111827"/>
                 </a:solidFill>
@@ -20149,7 +22292,7 @@
               </a:defRPr>
             </a:pPr>
             <a:r>
-              <a:rPr sz="1500" b="0" i="0">
+              <a:rPr sz="1200" b="0" i="0">
                 <a:solidFill>
                   <a:srgbClr val="111827"/>
                 </a:solidFill>
@@ -20157,13 +22300,13 @@
                 <a:ea typeface="Microsoft YaHei"/>
                 <a:cs typeface="Microsoft YaHei"/>
               </a:rPr>
-              <a:t>○ 阶段 1 正式 monorepo Demo</a:t>
+              <a:t>○ 阶段 1：正式 monorepo Demo</a:t>
             </a:r>
           </a:p>
           <a:p xmlns:a="http://schemas.openxmlformats.org/drawingml/2006/main">
             <a:pPr algn="l">
               <a:buNone/>
-              <a:defRPr sz="1500" b="0" i="0">
+              <a:defRPr sz="1200" b="0" i="0">
                 <a:solidFill>
                   <a:srgbClr val="111827"/>
                 </a:solidFill>
@@ -20173,7 +22316,7 @@
               </a:defRPr>
             </a:pPr>
             <a:r>
-              <a:rPr sz="1500" b="0" i="0">
+              <a:rPr sz="1200" b="0" i="0">
                 <a:solidFill>
                   <a:srgbClr val="111827"/>
                 </a:solidFill>
@@ -20181,13 +22324,13 @@
                 <a:ea typeface="Microsoft YaHei"/>
                 <a:cs typeface="Microsoft YaHei"/>
               </a:rPr>
-              <a:t>○ 真实 RAG / 模型 / Provider</a:t>
+              <a:t>○ 阶段 3–4：真实 RAG / 模型 / Provider</a:t>
             </a:r>
           </a:p>
           <a:p xmlns:a="http://schemas.openxmlformats.org/drawingml/2006/main">
             <a:pPr algn="l">
               <a:buNone/>
-              <a:defRPr sz="1500" b="0" i="0">
+              <a:defRPr sz="1200" b="0" i="0">
                 <a:solidFill>
                   <a:srgbClr val="111827"/>
                 </a:solidFill>
@@ -20197,7 +22340,7 @@
               </a:defRPr>
             </a:pPr>
             <a:r>
-              <a:rPr sz="1500" b="0" i="0">
+              <a:rPr sz="1200" b="0" i="0">
                 <a:solidFill>
                   <a:srgbClr val="111827"/>
                 </a:solidFill>
@@ -20205,13 +22348,13 @@
                 <a:ea typeface="Microsoft YaHei"/>
                 <a:cs typeface="Microsoft YaHei"/>
               </a:rPr>
-              <a:t>○ Blocky 构建助手</a:t>
+              <a:t>○ 阶段 5–7：构建助手、多画布、AppSurface、有人值守 RPA</a:t>
             </a:r>
           </a:p>
           <a:p xmlns:a="http://schemas.openxmlformats.org/drawingml/2006/main">
             <a:pPr algn="l">
               <a:buNone/>
-              <a:defRPr sz="1500" b="0" i="0">
+              <a:defRPr sz="1200" b="0" i="0">
                 <a:solidFill>
                   <a:srgbClr val="111827"/>
                 </a:solidFill>
@@ -20221,7 +22364,7 @@
               </a:defRPr>
             </a:pPr>
             <a:r>
-              <a:rPr sz="1500" b="0" i="0">
+              <a:rPr sz="1200" b="0" i="0">
                 <a:solidFill>
                   <a:srgbClr val="111827"/>
                 </a:solidFill>
@@ -20229,13 +22372,13 @@
                 <a:ea typeface="Microsoft YaHei"/>
                 <a:cs typeface="Microsoft YaHei"/>
               </a:rPr>
-              <a:t>○ 班级 / 作业 / 提交工作区</a:t>
+              <a:t>○ 阶段 8：六个兼容模板与独立兼容矩阵</a:t>
             </a:r>
           </a:p>
           <a:p xmlns:a="http://schemas.openxmlformats.org/drawingml/2006/main">
             <a:pPr algn="l">
               <a:buNone/>
-              <a:defRPr sz="1500" b="0" i="0">
+              <a:defRPr sz="1200" b="0" i="0">
                 <a:solidFill>
                   <a:srgbClr val="111827"/>
                 </a:solidFill>
@@ -20245,7 +22388,7 @@
               </a:defRPr>
             </a:pPr>
             <a:r>
-              <a:rPr sz="1500" b="0" i="0">
+              <a:rPr sz="1200" b="0" i="0">
                 <a:solidFill>
                   <a:srgbClr val="111827"/>
                 </a:solidFill>
@@ -20253,7 +22396,55 @@
                 <a:ea typeface="Microsoft YaHei"/>
                 <a:cs typeface="Microsoft YaHei"/>
               </a:rPr>
-              <a:t>○ 正式安装包与试点数据</a:t>
+              <a:t>○ 阶段 9：CLI / 四个官方 Skills / Codex 插件</a:t>
+            </a:r>
+          </a:p>
+          <a:p xmlns:a="http://schemas.openxmlformats.org/drawingml/2006/main">
+            <a:pPr algn="l">
+              <a:buNone/>
+              <a:defRPr sz="1200" b="0" i="0">
+                <a:solidFill>
+                  <a:srgbClr val="111827"/>
+                </a:solidFill>
+                <a:latin typeface="Microsoft YaHei"/>
+                <a:ea typeface="Microsoft YaHei"/>
+                <a:cs typeface="Microsoft YaHei"/>
+              </a:defRPr>
+            </a:pPr>
+            <a:r>
+              <a:rPr sz="1200" b="0" i="0">
+                <a:solidFill>
+                  <a:srgbClr val="111827"/>
+                </a:solidFill>
+                <a:latin typeface="Microsoft YaHei"/>
+                <a:ea typeface="Microsoft YaHei"/>
+                <a:cs typeface="Microsoft YaHei"/>
+              </a:rPr>
+              <a:t>○ 阶段 10：教师、班级、作业与提交工作区</a:t>
+            </a:r>
+          </a:p>
+          <a:p xmlns:a="http://schemas.openxmlformats.org/drawingml/2006/main">
+            <a:pPr algn="l">
+              <a:buNone/>
+              <a:defRPr sz="1200" b="0" i="0">
+                <a:solidFill>
+                  <a:srgbClr val="111827"/>
+                </a:solidFill>
+                <a:latin typeface="Microsoft YaHei"/>
+                <a:ea typeface="Microsoft YaHei"/>
+                <a:cs typeface="Microsoft YaHei"/>
+              </a:defRPr>
+            </a:pPr>
+            <a:r>
+              <a:rPr sz="1200" b="0" i="0">
+                <a:solidFill>
+                  <a:srgbClr val="111827"/>
+                </a:solidFill>
+                <a:latin typeface="Microsoft YaHei"/>
+                <a:ea typeface="Microsoft YaHei"/>
+                <a:cs typeface="Microsoft YaHei"/>
+              </a:rPr>
+              <a:t>○ 正式安装包、试点与商业验证</a:t>
             </a:r>
           </a:p>
         </p:txBody>
@@ -20267,7 +22458,7 @@
           <p:nvPr/>
         </p:nvPicPr>
         <p:blipFill>
-          <a:blip xmlns:r="http://schemas.openxmlformats.org/officeDocument/2006/relationships" xmlns:a="http://schemas.openxmlformats.org/drawingml/2006/main" r:embed="R11607b52ed294fd9"/>
+          <a:blip xmlns:r="http://schemas.openxmlformats.org/officeDocument/2006/relationships" xmlns:a="http://schemas.openxmlformats.org/drawingml/2006/main" r:embed="R15e4cf8299324b79"/>
           <a:srcRect xmlns:a="http://schemas.openxmlformats.org/drawingml/2006/main" l="0" t="11290" r="0" b="11290"/>
           <a:stretch xmlns:a="http://schemas.openxmlformats.org/drawingml/2006/main">
             <a:fillRect l="0" t="0" r="0" b="0"/>
@@ -20275,7 +22466,7 @@
         </p:blipFill>
         <p:spPr>
           <a:xfrm xmlns:a="http://schemas.openxmlformats.org/drawingml/2006/main">
-            <a:off x="8267700" y="4095750"/>
+            <a:off x="13335000" y="4095750"/>
             <a:ext cx="2952750" cy="1428750"/>
           </a:xfrm>
           <a:prstGeom xmlns:a="http://schemas.openxmlformats.org/drawingml/2006/main" prst="roundRect">
@@ -20301,8 +22492,8 @@
         </p:nvSpPr>
         <p:spPr>
           <a:xfrm xmlns:a="http://schemas.openxmlformats.org/drawingml/2006/main">
-            <a:off x="8448675" y="5219700"/>
-            <a:ext cx="2590800" cy="323850"/>
+            <a:off x="6172200" y="5219700"/>
+            <a:ext cx="4857750" cy="323850"/>
           </a:xfrm>
           <a:prstGeom xmlns:a="http://schemas.openxmlformats.org/drawingml/2006/main" prst="roundRect">
             <a:avLst>
@@ -20334,20 +22525,22 @@
         </p:nvSpPr>
         <p:spPr>
           <a:xfrm xmlns:a="http://schemas.openxmlformats.org/drawingml/2006/main">
-            <a:off x="8543925" y="5286375"/>
-            <a:ext cx="2400300" cy="190500"/>
-          </a:xfrm>
-          <a:prstGeom xmlns:a="http://schemas.openxmlformats.org/drawingml/2006/main" prst="rect">
-            <a:avLst/>
-          </a:prstGeom>
-          <a:noFill xmlns:a="http://schemas.openxmlformats.org/drawingml/2006/main"/>
-          <a:ln xmlns:a="http://schemas.openxmlformats.org/drawingml/2006/main" w="0">
-            <a:noFill/>
-            <a:prstDash val="solid"/>
-          </a:ln>
-        </p:spPr>
-        <p:txBody>
-          <a:bodyPr xmlns:a="http://schemas.openxmlformats.org/drawingml/2006/main"/>
+            <a:off x="6267450" y="5286375"/>
+            <a:ext cx="4667250" cy="190500"/>
+          </a:xfrm>
+          <a:prstGeom xmlns:a="http://schemas.openxmlformats.org/drawingml/2006/main" prst="rect">
+            <a:avLst/>
+          </a:prstGeom>
+          <a:noFill xmlns:a="http://schemas.openxmlformats.org/drawingml/2006/main"/>
+          <a:ln xmlns:a="http://schemas.openxmlformats.org/drawingml/2006/main" w="0">
+            <a:noFill/>
+            <a:prstDash val="solid"/>
+          </a:ln>
+        </p:spPr>
+        <p:txBody>
+          <a:bodyPr xmlns:a="http://schemas.openxmlformats.org/drawingml/2006/main" wrap="square" lIns="0" tIns="0" rIns="0" bIns="0" anchor="ctr">
+            <a:normAutofit fontScale="100000"/>
+          </a:bodyPr>
           <a:lstStyle xmlns:a="http://schemas.openxmlformats.org/drawingml/2006/main"/>
           <a:p xmlns:a="http://schemas.openxmlformats.org/drawingml/2006/main">
             <a:pPr algn="ctr">
@@ -20370,7 +22563,7 @@
                 <a:ea typeface="Microsoft YaHei"/>
                 <a:cs typeface="Microsoft YaHei"/>
               </a:rPr>
-              <a:t>技术尖峰 · 非正式产品界面</a:t>
+              <a:t>设计完整 ≠ 已实现；按阶段门禁逐项替换固定夹具。</a:t>
             </a:r>
           </a:p>
         </p:txBody>

</xml_diff>

<commit_message>
docs: reframe contest deck around verified outcomes
</commit_message>
<xml_diff>
--- a/PPT与商业计划书/Blocky-Studio-息壤杯-AI+教育.pptx
+++ b/PPT与商业计划书/Blocky-Studio-息壤杯-AI+教育.pptx
@@ -2,26 +2,26 @@
 <file path=ppt/presentation.xml><?xml version="1.0" encoding="utf-8"?>
 <p:presentation xmlns:p="http://schemas.openxmlformats.org/presentationml/2006/main">
   <p:sldMasterIdLst>
-    <p:sldMasterId xmlns:r="http://schemas.openxmlformats.org/officeDocument/2006/relationships" id="2147483648" r:id="Rb220d6a136f241f5"/>
+    <p:sldMasterId xmlns:r="http://schemas.openxmlformats.org/officeDocument/2006/relationships" id="2147483648" r:id="Ra7919b6b8d2141d4"/>
   </p:sldMasterIdLst>
   <p:notesMasterIdLst>
-    <p:notesMasterId xmlns:r="http://schemas.openxmlformats.org/officeDocument/2006/relationships" r:id="R6d8de98c84414067"/>
+    <p:notesMasterId xmlns:r="http://schemas.openxmlformats.org/officeDocument/2006/relationships" r:id="R6c3cf2bf73a3452a"/>
   </p:notesMasterIdLst>
   <p:sldIdLst>
-    <p:sldId xmlns:r="http://schemas.openxmlformats.org/officeDocument/2006/relationships" id="256" r:id="Re87813326975443a"/>
-    <p:sldId xmlns:r="http://schemas.openxmlformats.org/officeDocument/2006/relationships" id="257" r:id="R3d2316e7e9b14cef"/>
-    <p:sldId xmlns:r="http://schemas.openxmlformats.org/officeDocument/2006/relationships" id="258" r:id="R0284ec97fb814956"/>
-    <p:sldId xmlns:r="http://schemas.openxmlformats.org/officeDocument/2006/relationships" id="259" r:id="R9d9a4a126b104ea0"/>
-    <p:sldId xmlns:r="http://schemas.openxmlformats.org/officeDocument/2006/relationships" id="260" r:id="Ra91923d7b9c54943"/>
-    <p:sldId xmlns:r="http://schemas.openxmlformats.org/officeDocument/2006/relationships" id="261" r:id="R65486dbdb898408b"/>
-    <p:sldId xmlns:r="http://schemas.openxmlformats.org/officeDocument/2006/relationships" id="262" r:id="Rd45a86d3b1ef41c5"/>
-    <p:sldId xmlns:r="http://schemas.openxmlformats.org/officeDocument/2006/relationships" id="263" r:id="R95e92944edf14a8e"/>
-    <p:sldId xmlns:r="http://schemas.openxmlformats.org/officeDocument/2006/relationships" id="264" r:id="R2ef8df90b4214fd8"/>
-    <p:sldId xmlns:r="http://schemas.openxmlformats.org/officeDocument/2006/relationships" id="265" r:id="R533e2f8e5fb14cd3"/>
-    <p:sldId xmlns:r="http://schemas.openxmlformats.org/officeDocument/2006/relationships" id="266" r:id="R6aa1164f1ff74b68"/>
-    <p:sldId xmlns:r="http://schemas.openxmlformats.org/officeDocument/2006/relationships" id="267" r:id="Ree83d49e100c4a43"/>
-    <p:sldId xmlns:r="http://schemas.openxmlformats.org/officeDocument/2006/relationships" id="268" r:id="R9aa1057f86c94737"/>
-    <p:sldId xmlns:r="http://schemas.openxmlformats.org/officeDocument/2006/relationships" id="269" r:id="R8f9dbc920fac418d"/>
+    <p:sldId xmlns:r="http://schemas.openxmlformats.org/officeDocument/2006/relationships" id="256" r:id="R25b253aa7067421d"/>
+    <p:sldId xmlns:r="http://schemas.openxmlformats.org/officeDocument/2006/relationships" id="257" r:id="R9d215881f5a944dd"/>
+    <p:sldId xmlns:r="http://schemas.openxmlformats.org/officeDocument/2006/relationships" id="258" r:id="Rd8296b159fce4fdd"/>
+    <p:sldId xmlns:r="http://schemas.openxmlformats.org/officeDocument/2006/relationships" id="259" r:id="R13510ff4f5ed4d95"/>
+    <p:sldId xmlns:r="http://schemas.openxmlformats.org/officeDocument/2006/relationships" id="260" r:id="Rc775176e28434a0b"/>
+    <p:sldId xmlns:r="http://schemas.openxmlformats.org/officeDocument/2006/relationships" id="261" r:id="Rce8028b252c24373"/>
+    <p:sldId xmlns:r="http://schemas.openxmlformats.org/officeDocument/2006/relationships" id="262" r:id="Rcfa49a51c68b4e38"/>
+    <p:sldId xmlns:r="http://schemas.openxmlformats.org/officeDocument/2006/relationships" id="263" r:id="R9e95e016453f4674"/>
+    <p:sldId xmlns:r="http://schemas.openxmlformats.org/officeDocument/2006/relationships" id="264" r:id="R590b3316820c4e98"/>
+    <p:sldId xmlns:r="http://schemas.openxmlformats.org/officeDocument/2006/relationships" id="265" r:id="Rfc28697ed9634241"/>
+    <p:sldId xmlns:r="http://schemas.openxmlformats.org/officeDocument/2006/relationships" id="266" r:id="R16bbbfbcd2014958"/>
+    <p:sldId xmlns:r="http://schemas.openxmlformats.org/officeDocument/2006/relationships" id="267" r:id="Rbb3ac6ae028149de"/>
+    <p:sldId xmlns:r="http://schemas.openxmlformats.org/officeDocument/2006/relationships" id="268" r:id="R564050805daa434a"/>
+    <p:sldId xmlns:r="http://schemas.openxmlformats.org/officeDocument/2006/relationships" id="269" r:id="Rbc3e9cd678304f05"/>
   </p:sldIdLst>
   <p:sldSz cx="12192000" cy="6858000"/>
   <p:notesSz cx="6858000" cy="9144000"/>
@@ -550,7 +550,7 @@
           <a:lstStyle xmlns:a="http://schemas.openxmlformats.org/drawingml/2006/main"/>
           <a:p xmlns:a="http://schemas.openxmlformats.org/drawingml/2006/main">
             <a:r>
-              <a:t>应用成效以可验收行为表述。真实课堂数据要在后续教师试点后补充。</a:t>
+              <a:t>四项指标可以在演示现场直接核验：作品能运行、学生能解释、回答有来源、保存后可复现。教师试点可继续积累班级级完成率、解释率与引用质量数据。</a:t>
             </a:r>
           </a:p>
           <a:p xmlns:a="http://schemas.openxmlformats.org/drawingml/2006/main">
@@ -565,12 +565,12 @@
           </a:p>
           <a:p xmlns:a="http://schemas.openxmlformats.org/drawingml/2006/main">
             <a:r>
-              <a:t>- D:\1Folder\Blocky-AI\doc\执行计划\2026-08-23-Blocky-竞品驱动完整开发计划.md (阶段 1 验收旅程)</a:t>
-            </a:r>
-          </a:p>
-          <a:p xmlns:a="http://schemas.openxmlformats.org/drawingml/2006/main">
-            <a:r>
-              <a:t>- D:\1Folder\Blocky-AI\doc\技术设计\正式契约\07-阶段1-Demo接口交接.md (固定夹具与失败语义)</a:t>
+              <a:t>- D:\1Folder\Blocky-AI\doc\执行计划\2026-08-23-Blocky-竞品驱动完整开发计划.md (课堂闭环验收旅程)</a:t>
+            </a:r>
+          </a:p>
+          <a:p xmlns:a="http://schemas.openxmlformats.org/drawingml/2006/main">
+            <a:r>
+              <a:t>- D:\1Folder\Blocky-AI\doc\技术设计\正式契约\07-阶段1-Demo接口交接.md (固定夹具与运行事件契约)</a:t>
             </a:r>
           </a:p>
           <a:p xmlns:a="http://schemas.openxmlformats.org/drawingml/2006/main">
@@ -645,7 +645,7 @@
           <a:lstStyle xmlns:a="http://schemas.openxmlformats.org/drawingml/2006/main"/>
           <a:p xmlns:a="http://schemas.openxmlformats.org/drawingml/2006/main">
             <a:r>
-              <a:t>商业路径遵循先产品价值、后收入验证。教育扩展价格只作为内部设计基线，不当作已验证价格。</a:t>
+              <a:t>商业路径从免费教育底座进入个人能力扩展与学校/机构授权。价格用于商业设计基线，并结合教师试点、机构合作与服务成本持续校准。</a:t>
             </a:r>
           </a:p>
           <a:p xmlns:a="http://schemas.openxmlformats.org/drawingml/2006/main">
@@ -665,7 +665,7 @@
           </a:p>
           <a:p xmlns:a="http://schemas.openxmlformats.org/drawingml/2006/main">
             <a:r>
-              <a:t>- D:\1Folder\Blocky-AI\doc\执行计划\2026-08-23-Blocky-竞品驱动完整开发计划.md (教育工作区与阶段门禁)</a:t>
+              <a:t>- D:\1Folder\Blocky-AI\doc\执行计划\2026-08-23-Blocky-竞品驱动完整开发计划.md (教育工作区与机构服务路线)</a:t>
             </a:r>
           </a:p>
           <a:p xmlns:a="http://schemas.openxmlformats.org/drawingml/2006/main">
@@ -840,7 +840,7 @@
           <a:lstStyle xmlns:a="http://schemas.openxmlformats.org/drawingml/2006/main"/>
           <a:p xmlns:a="http://schemas.openxmlformats.org/drawingml/2006/main">
             <a:r>
-              <a:t>赛事节奏用于安排展示与试点，不改变 Blocky 的正式阶段门禁。复赛优先验证真实 RAG/模型和教师共创；总决赛可输出 Pi/Codex 只读兼容报告，但六个正式适配器仍在阶段 8、四个官方 Skills 与 Codex 插件仍在阶段 9。</a:t>
+              <a:t>赛事节奏从演示闭环、教师试点到产品、兼容与商业验证。六模板兼容版图与四个官方 Skills 形成长线生态规划，连接主流 Agent 生态、学校合作与规模化服务。</a:t>
             </a:r>
           </a:p>
           <a:p xmlns:a="http://schemas.openxmlformats.org/drawingml/2006/main">
@@ -860,12 +860,12 @@
           </a:p>
           <a:p xmlns:a="http://schemas.openxmlformats.org/drawingml/2006/main">
             <a:r>
-              <a:t>- D:\1Folder\Blocky-AI\doc\执行计划\2026-08-23-Blocky-竞品驱动完整开发计划.md (阶段 1、3–10 门禁)</a:t>
-            </a:r>
-          </a:p>
-          <a:p xmlns:a="http://schemas.openxmlformats.org/drawingml/2006/main">
-            <a:r>
-              <a:t>- D:\1Folder\Blocky-AI\doc\产品设计\Blocky-内置兼容模板.md (六模板独立兼容矩阵)</a:t>
+              <a:t>- D:\1Folder\Blocky-AI\doc\执行计划\2026-08-23-Blocky-竞品驱动完整开发计划.md (阶段 1、3–10 研发路线)</a:t>
+            </a:r>
+          </a:p>
+          <a:p xmlns:a="http://schemas.openxmlformats.org/drawingml/2006/main">
+            <a:r>
+              <a:t>- D:\1Folder\Blocky-AI\doc\产品设计\Blocky-内置兼容模板.md (六模板兼容矩阵)</a:t>
             </a:r>
           </a:p>
           <a:p xmlns:a="http://schemas.openxmlformats.org/drawingml/2006/main">
@@ -960,12 +960,12 @@
           </a:p>
           <a:p xmlns:a="http://schemas.openxmlformats.org/drawingml/2006/main">
             <a:r>
-              <a:t>- D:\1Folder\Blocky-AI\README.md (产品愿景、六模板与当前阶段)</a:t>
-            </a:r>
-          </a:p>
-          <a:p xmlns:a="http://schemas.openxmlformats.org/drawingml/2006/main">
-            <a:r>
-              <a:t>- D:\1Folder\Blocky-AI\doc\执行计划\2026-08-23-Blocky-竞品驱动完整开发计划.md (CLI、Skills、社区与多端阶段)</a:t>
+              <a:t>- D:\1Folder\Blocky-AI\README.md (产品愿景、六模板与产品路线)</a:t>
+            </a:r>
+          </a:p>
+          <a:p xmlns:a="http://schemas.openxmlformats.org/drawingml/2006/main">
+            <a:r>
+              <a:t>- D:\1Folder\Blocky-AI\doc\执行计划\2026-08-23-Blocky-竞品驱动完整开发计划.md (CLI、Skills、社区与多端路线)</a:t>
             </a:r>
           </a:p>
           <a:p xmlns:a="http://schemas.openxmlformats.org/drawingml/2006/main">
@@ -1040,7 +1040,7 @@
           <a:lstStyle xmlns:a="http://schemas.openxmlformats.org/drawingml/2006/main"/>
           <a:p xmlns:a="http://schemas.openxmlformats.org/drawingml/2006/main">
             <a:r>
-              <a:t>三个痛点对应三类现有入口，不点名竞品；结论是教育需要新的表达层。</a:t>
+              <a:t>三个现有入口对应三种学习断点；Blocky 用 Scratch 式嵌套积木提供新的表达层，让学生看见角色、知识、工具、权限与运行过程。</a:t>
             </a:r>
           </a:p>
           <a:p xmlns:a="http://schemas.openxmlformats.org/drawingml/2006/main">
@@ -1335,7 +1335,7 @@
           <a:lstStyle xmlns:a="http://schemas.openxmlformats.org/drawingml/2006/main"/>
           <a:p xmlns:a="http://schemas.openxmlformats.org/drawingml/2006/main">
             <a:r>
-              <a:t>这是首个课堂 POC 场景。老师掌握资料边界，学生掌握系统构造和解释。</a:t>
+              <a:t>这是首个课堂演示场景：老师掌握资料边界，学生掌握系统构造、运行观察和解释表达。</a:t>
             </a:r>
           </a:p>
           <a:p xmlns:a="http://schemas.openxmlformats.org/drawingml/2006/main">
@@ -1350,7 +1350,7 @@
           </a:p>
           <a:p xmlns:a="http://schemas.openxmlformats.org/drawingml/2006/main">
             <a:r>
-              <a:t>- D:\1Folder\Blocky-AI\doc\执行计划\2026-08-23-Blocky-竞品驱动完整开发计划.md (阶段 1 资料问答伙伴闭环)</a:t>
+              <a:t>- D:\1Folder\Blocky-AI\doc\执行计划\2026-08-23-Blocky-竞品驱动完整开发计划.md (资料问答伙伴课堂闭环)</a:t>
             </a:r>
           </a:p>
           <a:p xmlns:a="http://schemas.openxmlformats.org/drawingml/2006/main">
@@ -1430,7 +1430,7 @@
           <a:lstStyle xmlns:a="http://schemas.openxmlformats.org/drawingml/2006/main"/>
           <a:p xmlns:a="http://schemas.openxmlformats.org/drawingml/2006/main">
             <a:r>
-              <a:t>这页是演示视频脚本骨架。首轮不铺全功能，只证明完整闭环和诚实的失败行为。</a:t>
+              <a:t>演示视频围绕技术实证闭环展开：选择蓝图、编辑积木、运行回答、观察轨迹、保存重开；同步展示确定性 Provider、证据提示与行为复现能力。</a:t>
             </a:r>
           </a:p>
           <a:p xmlns:a="http://schemas.openxmlformats.org/drawingml/2006/main">
@@ -1445,12 +1445,12 @@
           </a:p>
           <a:p xmlns:a="http://schemas.openxmlformats.org/drawingml/2006/main">
             <a:r>
-              <a:t>- D:\1Folder\Blocky-AI\doc\执行计划\2026-08-23-Blocky-竞品驱动完整开发计划.md (阶段 1 Demo 旅程与固定夹具)</a:t>
-            </a:r>
-          </a:p>
-          <a:p xmlns:a="http://schemas.openxmlformats.org/drawingml/2006/main">
-            <a:r>
-              <a:t>- D:\1Folder\Blocky-AI\doc\技术设计\正式契约\07-阶段1-Demo接口交接.md (阶段 1 接口与替换边界)</a:t>
+              <a:t>- D:\1Folder\Blocky-AI\doc\执行计划\2026-08-23-Blocky-竞品驱动完整开发计划.md (资料问答伙伴演示旅程与固定夹具)</a:t>
+            </a:r>
+          </a:p>
+          <a:p xmlns:a="http://schemas.openxmlformats.org/drawingml/2006/main">
+            <a:r>
+              <a:t>- D:\1Folder\Blocky-AI\doc\技术设计\正式契约\07-阶段1-Demo接口交接.md (固定夹具与运行事件契约)</a:t>
             </a:r>
           </a:p>
           <a:p xmlns:a="http://schemas.openxmlformats.org/drawingml/2006/main">
@@ -1525,7 +1525,7 @@
           <a:lstStyle xmlns:a="http://schemas.openxmlformats.org/drawingml/2006/main"/>
           <a:p xmlns:a="http://schemas.openxmlformats.org/drawingml/2006/main">
             <a:r>
-              <a:t>技术壁垒是从可见积木到稳定 IR、受控 Runtime、可回放 Trace，再到模板与原生配置可逆映射。四个官方 Skills、CLI、桌面画布和六个兼容模板共用同一积木目录、Build Spec、权限和运行事件，不建立隐藏语言。</a:t>
+              <a:t>技术壁垒从可见积木延伸到稳定 IR、受控 Runtime、可回放 Trace，再到模板与原生配置可逆映射。四个官方 Skills、CLI、桌面画布和六个兼容模板共享积木目录、Build Spec、权限和运行事件，保持单一透明语言。</a:t>
             </a:r>
           </a:p>
           <a:p xmlns:a="http://schemas.openxmlformats.org/drawingml/2006/main">
@@ -1625,7 +1625,7 @@
           <a:lstStyle xmlns:a="http://schemas.openxmlformats.org/drawingml/2006/main"/>
           <a:p xmlns:a="http://schemas.openxmlformats.org/drawingml/2006/main">
             <a:r>
-              <a:t>六个模板都是可继续增删积木的普通 Blocky 项目起点，不是六种封闭模式。官方运行时继续作为行为事实源；Blocky 通过锁定上游版本、进程外运行时、版本化适配器和可逆投影完成结构映射、配置往返与行为对照。当前这些是阶段 8 设计，正式适配器尚未实现。</a:t>
+              <a:t>兼容版图覆盖轻量代码、专业编程、个人助理、团队协作、工程开发与组合研究六类生态方向。每个方向都采用锁定上游版本、进程外运行时、版本化适配器和可逆投影，形成可核验的结构映射、配置往返与行为对照方法。</a:t>
             </a:r>
           </a:p>
           <a:p xmlns:a="http://schemas.openxmlformats.org/drawingml/2006/main">
@@ -1640,17 +1640,12 @@
           </a:p>
           <a:p xmlns:a="http://schemas.openxmlformats.org/drawingml/2006/main">
             <a:r>
-              <a:t>- D:\1Folder\Blocky-AI\doc\产品设计\Blocky-内置兼容模板.md (六个模板、用户任务名、兼容等级与独立门禁)</a:t>
+              <a:t>- D:\1Folder\Blocky-AI\doc\产品设计\Blocky-内置兼容模板.md (六个模板方向、用户任务名与独立兼容矩阵)</a:t>
             </a:r>
           </a:p>
           <a:p xmlns:a="http://schemas.openxmlformats.org/drawingml/2006/main">
             <a:r>
               <a:t>- D:\1Folder\Blocky-AI\doc\技术设计\ADR-002-原生Agent兼容运行时.md (固定上游版本、进程外运行时、版本化适配器、可逆投影)</a:t>
-            </a:r>
-          </a:p>
-          <a:p xmlns:a="http://schemas.openxmlformats.org/drawingml/2006/main">
-            <a:r>
-              <a:t>- D:\1Folder\Blocky-AI\doc\产品设计\Blocky-状态与阶段替换账本.md (六个正式适配器尚未实现)</a:t>
             </a:r>
           </a:p>
           <a:p xmlns:a="http://schemas.openxmlformats.org/drawingml/2006/main">
@@ -1725,7 +1720,7 @@
           <a:lstStyle xmlns:a="http://schemas.openxmlformats.org/drawingml/2006/main"/>
           <a:p xmlns:a="http://schemas.openxmlformats.org/drawingml/2006/main">
             <a:r>
-              <a:t>左侧只陈述 Windows Core 技术尖峰已经验证的底座事实；右侧按正式开发计划列出尚未实现的阶段能力。长稳数据绑定原精确提交。六模板属于阶段 8，CLI、四个官方 Skills 与 Codex 插件属于阶段 9，教育工作区属于阶段 10。</a:t>
+              <a:t>左侧展示 Windows Core 已完成的可复现实测；右侧展示阶段 0 已冻结并通过验收的正式契约资产。二者共同证明产品路线的技术可行性和一致语义基础。</a:t>
             </a:r>
           </a:p>
           <a:p xmlns:a="http://schemas.openxmlformats.org/drawingml/2006/main">
@@ -1740,17 +1735,17 @@
           </a:p>
           <a:p xmlns:a="http://schemas.openxmlformats.org/drawingml/2006/main">
             <a:r>
-              <a:t>- D:\1Folder\Blocky-AI\doc\技术设计\Windows-Core技术尖峰报告.md (尖峰验证范围、360 次循环与边界)</a:t>
-            </a:r>
-          </a:p>
-          <a:p xmlns:a="http://schemas.openxmlformats.org/drawingml/2006/main">
-            <a:r>
-              <a:t>- D:\1Folder\Blocky-AI\doc\执行计划\2026-08-23-Blocky-竞品驱动完整开发计划.md (阶段 1–10 实施顺序)</a:t>
-            </a:r>
-          </a:p>
-          <a:p xmlns:a="http://schemas.openxmlformats.org/drawingml/2006/main">
-            <a:r>
-              <a:t>- D:\1Folder\Blocky-AI\doc\产品设计\Blocky-状态与阶段替换账本.md (正式能力未实现清单)</a:t>
+              <a:t>- D:\1Folder\Blocky-AI\doc\技术设计\Windows-Core技术尖峰报告.md (尖峰验证范围与 360 次循环)</a:t>
+            </a:r>
+          </a:p>
+          <a:p xmlns:a="http://schemas.openxmlformats.org/drawingml/2006/main">
+            <a:r>
+              <a:t>- D:\1Folder\Blocky-AI\doc\技术设计\正式契约\README.md (阶段 0 正式契约注册表)</a:t>
+            </a:r>
+          </a:p>
+          <a:p xmlns:a="http://schemas.openxmlformats.org/drawingml/2006/main">
+            <a:r>
+              <a:t>- D:\1Folder\Blocky-AI\doc\验收\归档\2026-08-23\验收-Blocky阶段0契约冻结.md (阶段 0 契约验收)</a:t>
             </a:r>
           </a:p>
           <a:p xmlns:a="http://schemas.openxmlformats.org/drawingml/2006/main">
@@ -1823,7 +1818,7 @@
   </p:cSld>
   <p:clrMap bg1="lt1" tx1="dk1" bg2="lt2" tx2="dk2" accent1="accent1" accent2="accent2" accent3="accent3" accent4="accent4" accent5="accent5" accent6="accent6" hlink="hlink" folHlink="folHlink"/>
   <p:sldLayoutIdLst>
-    <p:sldLayoutId xmlns:r="http://schemas.openxmlformats.org/officeDocument/2006/relationships" id="2147483649" r:id="Rc62fcc91a5e24768"/>
+    <p:sldLayoutId xmlns:r="http://schemas.openxmlformats.org/officeDocument/2006/relationships" id="2147483649" r:id="R2942cf4e2d314ddb"/>
   </p:sldLayoutIdLst>
   <p:txStyles>
     <p:titleStyle>
@@ -2471,7 +2466,7 @@
           <p:nvPr/>
         </p:nvPicPr>
         <p:blipFill>
-          <a:blip xmlns:r="http://schemas.openxmlformats.org/officeDocument/2006/relationships" xmlns:a="http://schemas.openxmlformats.org/drawingml/2006/main" r:embed="Rac6c41fa6e0547d4"/>
+          <a:blip xmlns:r="http://schemas.openxmlformats.org/officeDocument/2006/relationships" xmlns:a="http://schemas.openxmlformats.org/drawingml/2006/main" r:embed="R69965a2d9acf4b4c"/>
           <a:stretch xmlns:a="http://schemas.openxmlformats.org/drawingml/2006/main"/>
         </p:blipFill>
         <p:spPr>
@@ -2854,7 +2849,7 @@
                 <a:ea typeface="Microsoft YaHei"/>
                 <a:cs typeface="Microsoft YaHei"/>
               </a:rPr>
-              <a:t>POC 提案 · 教育优先</a:t>
+              <a:t>参赛方案 · 教育优先</a:t>
             </a:r>
           </a:p>
         </p:txBody>
@@ -3111,7 +3106,7 @@
                 <a:ea typeface="Microsoft YaHei"/>
                 <a:cs typeface="Microsoft YaHei"/>
               </a:rPr>
-              <a:t>POC 可以在 3 分钟内验证 4 个学习结果</a:t>
+              <a:t>3 分钟完成 4 项可核验学习成果</a:t>
             </a:r>
           </a:p>
         </p:txBody>
@@ -3168,7 +3163,7 @@
                 <a:ea typeface="Microsoft YaHei"/>
                 <a:cs typeface="Microsoft YaHei"/>
               </a:rPr>
-              <a:t>不先许诺留存率和收入；先让 POC 的行为结果可重复检查。</a:t>
+              <a:t>从作品、讲解、引用到复现，形成可重复检查的课堂证据。</a:t>
             </a:r>
           </a:p>
         </p:txBody>
@@ -3780,7 +3775,7 @@
                 <a:ea typeface="Microsoft YaHei"/>
                 <a:cs typeface="Microsoft YaHei"/>
               </a:rPr>
-              <a:t>回答带来源；无证据拒答</a:t>
+              <a:t>回答带来源；证据不足清晰提示</a:t>
             </a:r>
           </a:p>
         </p:txBody>
@@ -4074,7 +4069,7 @@
                 <a:ea typeface="Microsoft YaHei"/>
                 <a:cs typeface="Microsoft YaHei"/>
               </a:rPr>
-              <a:t>阶段 1 验收口径 · 不是已经发生的用户效果数据</a:t>
+              <a:t>课堂验收：作品、解释、引用、复现四项证据同屏呈现</a:t>
             </a:r>
           </a:p>
         </p:txBody>
@@ -6032,7 +6027,7 @@
                 <a:ea typeface="Microsoft YaHei"/>
                 <a:cs typeface="Microsoft YaHei"/>
               </a:rPr>
-              <a:t>学生能探索表达方式，但不能偷偷扩大课程知识与答案边界。</a:t>
+              <a:t>学生自由探索表达方式，同时保持课程知识与答案边界清晰可控。</a:t>
             </a:r>
           </a:p>
         </p:txBody>
@@ -6880,7 +6875,7 @@
                 <a:ea typeface="Microsoft YaHei"/>
                 <a:cs typeface="Microsoft YaHei"/>
               </a:rPr>
-              <a:t>从 POC 到可规模化教育产品，三道门逐步打开</a:t>
+              <a:t>从课堂验证到规模化教育产品，三道增长门逐步打开</a:t>
             </a:r>
           </a:p>
         </p:txBody>
@@ -6939,7 +6934,7 @@
                 <a:ea typeface="Microsoft YaHei"/>
                 <a:cs typeface="Microsoft YaHei"/>
               </a:rPr>
-              <a:t>赛事节点验证教育闭环；正式研发按阶段门禁推进，不把六模板与 CLI 伪装成当前 POC。</a:t>
+              <a:t>初赛交付演示闭环，复赛沉淀教师数据，总决赛验证产品与商业价值。</a:t>
             </a:r>
           </a:p>
         </p:txBody>
@@ -7150,7 +7145,7 @@
                 <a:ea typeface="Microsoft YaHei"/>
                 <a:cs typeface="Microsoft YaHei"/>
               </a:rPr>
-              <a:t>可展示 POC</a:t>
+              <a:t>可展示成果</a:t>
             </a:r>
           </a:p>
         </p:txBody>
@@ -8138,7 +8133,7 @@
                 <a:ea typeface="Microsoft YaHei"/>
                 <a:cs typeface="Microsoft YaHei"/>
               </a:rPr>
-              <a:t>六个正式适配器与四个官方 Skills 仍依阶段 8/9 推进，不作为当前 POC 已实现能力。</a:t>
+              <a:t>六模板兼容版图与四个官方 Skills 形成长线生态规划，支撑规模化拓展。</a:t>
             </a:r>
           </a:p>
         </p:txBody>
@@ -8483,7 +8478,7 @@
                 <a:ea typeface="Microsoft YaHei"/>
                 <a:cs typeface="Microsoft YaHei"/>
               </a:rPr>
-              <a:t>而不是答案的消费者。</a:t>
+              <a:t>让创造力成为核心能力。</a:t>
             </a:r>
           </a:p>
         </p:txBody>
@@ -10053,9 +10048,55 @@
                 <a:ea typeface="Microsoft YaHei"/>
                 <a:cs typeface="Microsoft YaHei"/>
               </a:rPr>
-              <a:t>通过节点与连线组织流程
-参数复杂，初学者门槛高
-本产品不采用这种交互</a:t>
+              <a:t>通过节点与连线组织流程</a:t>
+            </a:r>
+          </a:p>
+          <a:p xmlns:a="http://schemas.openxmlformats.org/drawingml/2006/main">
+            <a:pPr algn="ctr">
+              <a:buNone/>
+              <a:defRPr sz="1500" b="0" i="0">
+                <a:solidFill>
+                  <a:srgbClr val="667085"/>
+                </a:solidFill>
+                <a:latin typeface="Microsoft YaHei"/>
+                <a:ea typeface="Microsoft YaHei"/>
+                <a:cs typeface="Microsoft YaHei"/>
+              </a:defRPr>
+            </a:pPr>
+            <a:r>
+              <a:rPr sz="1500" b="0" i="0">
+                <a:solidFill>
+                  <a:srgbClr val="667085"/>
+                </a:solidFill>
+                <a:latin typeface="Microsoft YaHei"/>
+                <a:ea typeface="Microsoft YaHei"/>
+                <a:cs typeface="Microsoft YaHei"/>
+              </a:rPr>
+              <a:t>参数复杂，初学者门槛高</a:t>
+            </a:r>
+          </a:p>
+          <a:p xmlns:a="http://schemas.openxmlformats.org/drawingml/2006/main">
+            <a:pPr algn="ctr">
+              <a:buNone/>
+              <a:defRPr sz="1500" b="0" i="0">
+                <a:solidFill>
+                  <a:srgbClr val="667085"/>
+                </a:solidFill>
+                <a:latin typeface="Microsoft YaHei"/>
+                <a:ea typeface="Microsoft YaHei"/>
+                <a:cs typeface="Microsoft YaHei"/>
+              </a:defRPr>
+            </a:pPr>
+            <a:r>
+              <a:rPr sz="1500" b="0" i="0">
+                <a:solidFill>
+                  <a:srgbClr val="667085"/>
+                </a:solidFill>
+                <a:latin typeface="Microsoft YaHei"/>
+                <a:ea typeface="Microsoft YaHei"/>
+                <a:cs typeface="Microsoft YaHei"/>
+              </a:rPr>
+              <a:t>Blocky 选择嵌套积木</a:t>
             </a:r>
           </a:p>
         </p:txBody>
@@ -11980,7 +12021,7 @@
           <p:nvPr/>
         </p:nvPicPr>
         <p:blipFill>
-          <a:blip xmlns:r="http://schemas.openxmlformats.org/officeDocument/2006/relationships" xmlns:a="http://schemas.openxmlformats.org/drawingml/2006/main" r:embed="Rd418696b11a34a98"/>
+          <a:blip xmlns:r="http://schemas.openxmlformats.org/officeDocument/2006/relationships" xmlns:a="http://schemas.openxmlformats.org/drawingml/2006/main" r:embed="R5035421f489540ac"/>
           <a:srcRect xmlns:a="http://schemas.openxmlformats.org/drawingml/2006/main" l="0" t="2671" r="0" b="2671"/>
           <a:stretch xmlns:a="http://schemas.openxmlformats.org/drawingml/2006/main">
             <a:fillRect l="0" t="0" r="0" b="0"/>
@@ -12083,7 +12124,7 @@
                 <a:ea typeface="Microsoft YaHei"/>
                 <a:cs typeface="Microsoft YaHei"/>
               </a:rPr>
-              <a:t>技术尖峰画面 · 非正式产品界面</a:t>
+              <a:t>Windows Core 实证画面</a:t>
             </a:r>
           </a:p>
         </p:txBody>
@@ -14489,7 +14530,7 @@
                 <a:ea typeface="Microsoft YaHei"/>
                 <a:cs typeface="Microsoft YaHei"/>
               </a:rPr>
-              <a:t>POC · 首轮交付</a:t>
+              <a:t>DEMO · 核心闭环</a:t>
             </a:r>
           </a:p>
         </p:txBody>
@@ -14546,7 +14587,7 @@
                 <a:ea typeface="Microsoft YaHei"/>
                 <a:cs typeface="Microsoft YaHei"/>
               </a:rPr>
-              <a:t>首个 POC 只验证一个完整闭环</a:t>
+              <a:t>技术实证闭环覆盖 5 个关键步骤</a:t>
             </a:r>
           </a:p>
         </p:txBody>
@@ -14603,7 +14644,7 @@
                 <a:ea typeface="Microsoft YaHei"/>
                 <a:cs typeface="Microsoft YaHei"/>
               </a:rPr>
-              <a:t>阶段 1 计划：用确定性本地夹具完成“创建—运行—解释—保存—重开”。</a:t>
+              <a:t>确定性本地夹具稳定呈现“创建—运行—解释—保存—重开”。</a:t>
             </a:r>
           </a:p>
         </p:txBody>
@@ -15927,7 +15968,7 @@
                 <a:ea typeface="Microsoft YaHei"/>
                 <a:cs typeface="Microsoft YaHei"/>
               </a:rPr>
-              <a:t>无密钥也能演示</a:t>
+              <a:t>确定性本地演示</a:t>
             </a:r>
           </a:p>
         </p:txBody>
@@ -16164,7 +16205,7 @@
                 <a:ea typeface="Microsoft YaHei"/>
                 <a:cs typeface="Microsoft YaHei"/>
               </a:rPr>
-              <a:t>无证据就拒答</a:t>
+              <a:t>证据不足清晰提示</a:t>
             </a:r>
           </a:p>
         </p:txBody>
@@ -16221,7 +16262,7 @@
                 <a:ea typeface="Microsoft YaHei"/>
                 <a:cs typeface="Microsoft YaHei"/>
               </a:rPr>
-              <a:t>不把幻觉包装成学习结果</a:t>
+              <a:t>回答与来源保持一致</a:t>
             </a:r>
           </a:p>
         </p:txBody>
@@ -16548,7 +16589,7 @@
                 <a:ea typeface="Microsoft YaHei"/>
                 <a:cs typeface="Microsoft YaHei"/>
               </a:rPr>
-              <a:t>POC 计划，不等同于已完成产品</a:t>
+              <a:t>核心闭环：五步可复现</a:t>
             </a:r>
           </a:p>
         </p:txBody>
@@ -18453,7 +18494,7 @@
                 <a:ea typeface="Microsoft YaHei"/>
                 <a:cs typeface="Microsoft YaHei"/>
               </a:rPr>
-              <a:t>六个兼容模板，把主流 Agent 变成可改造项目起点</a:t>
+              <a:t>六模板兼容版图，定义主流 Agent 的积木化路径</a:t>
             </a:r>
           </a:p>
         </p:txBody>
@@ -18667,7 +18708,7 @@
                 <a:ea typeface="Microsoft YaHei"/>
                 <a:cs typeface="Microsoft YaHei"/>
               </a:rPr>
-              <a:t>完整项目起点，不是六种封闭模式；共享项目格式、积木语言、运行内核和安全模型。</a:t>
+              <a:t>规划覆盖六类 Agent 生态，共享项目格式、积木语言、运行内核和安全模型。</a:t>
             </a:r>
           </a:p>
         </p:txBody>
@@ -19450,7 +19491,7 @@
                 <a:ea typeface="Microsoft YaHei"/>
                 <a:cs typeface="Microsoft YaHei"/>
               </a:rPr>
-              <a:t>兼容等级：结构映射 → 配置往返 → 行为对照 → 指定版本完整兼容｜当前为阶段 8 设计，六个正式适配器尚未实现。</a:t>
+              <a:t>兼容方法：锁定版本 → 结构映射 → 配置往返 → 行为对照 → 可逆写回</a:t>
             </a:r>
           </a:p>
         </p:txBody>
@@ -19792,6 +19833,7 @@
           <a:lstStyle xmlns:a="http://schemas.openxmlformats.org/drawingml/2006/main"/>
           <a:p xmlns:a="http://schemas.openxmlformats.org/drawingml/2006/main">
             <a:pPr algn="l">
+              <a:buNone/>
               <a:defRPr sz="1200" b="1">
                 <a:solidFill>
                   <a:srgbClr val="176BFF"/>
@@ -19850,6 +19892,7 @@
           <a:lstStyle xmlns:a="http://schemas.openxmlformats.org/drawingml/2006/main"/>
           <a:p xmlns:a="http://schemas.openxmlformats.org/drawingml/2006/main">
             <a:pPr algn="l">
+              <a:buNone/>
               <a:defRPr sz="1950" b="1">
                 <a:solidFill>
                   <a:srgbClr val="111827"/>
@@ -19908,6 +19951,7 @@
           <a:lstStyle xmlns:a="http://schemas.openxmlformats.org/drawingml/2006/main"/>
           <a:p xmlns:a="http://schemas.openxmlformats.org/drawingml/2006/main">
             <a:pPr algn="l">
+              <a:buNone/>
               <a:defRPr sz="1050">
                 <a:solidFill>
                   <a:srgbClr val="64748B"/>
@@ -20123,6 +20167,7 @@
           <a:lstStyle xmlns:a="http://schemas.openxmlformats.org/drawingml/2006/main"/>
           <a:p xmlns:a="http://schemas.openxmlformats.org/drawingml/2006/main">
             <a:pPr algn="l">
+              <a:buNone/>
               <a:defRPr sz="1200" b="1">
                 <a:solidFill>
                   <a:srgbClr val="176BFF"/>
@@ -20181,6 +20226,7 @@
           <a:lstStyle xmlns:a="http://schemas.openxmlformats.org/drawingml/2006/main"/>
           <a:p xmlns:a="http://schemas.openxmlformats.org/drawingml/2006/main">
             <a:pPr algn="l">
+              <a:buNone/>
               <a:defRPr sz="1950" b="1">
                 <a:solidFill>
                   <a:srgbClr val="111827"/>
@@ -20239,6 +20285,7 @@
           <a:lstStyle xmlns:a="http://schemas.openxmlformats.org/drawingml/2006/main"/>
           <a:p xmlns:a="http://schemas.openxmlformats.org/drawingml/2006/main">
             <a:pPr algn="l">
+              <a:buNone/>
               <a:defRPr sz="1050">
                 <a:solidFill>
                   <a:srgbClr val="64748B"/>
@@ -20454,6 +20501,7 @@
           <a:lstStyle xmlns:a="http://schemas.openxmlformats.org/drawingml/2006/main"/>
           <a:p xmlns:a="http://schemas.openxmlformats.org/drawingml/2006/main">
             <a:pPr algn="l">
+              <a:buNone/>
               <a:defRPr sz="1200" b="1">
                 <a:solidFill>
                   <a:srgbClr val="176BFF"/>
@@ -20512,6 +20560,7 @@
           <a:lstStyle xmlns:a="http://schemas.openxmlformats.org/drawingml/2006/main"/>
           <a:p xmlns:a="http://schemas.openxmlformats.org/drawingml/2006/main">
             <a:pPr algn="l">
+              <a:buNone/>
               <a:defRPr sz="1950" b="1">
                 <a:solidFill>
                   <a:srgbClr val="111827"/>
@@ -20570,6 +20619,7 @@
           <a:lstStyle xmlns:a="http://schemas.openxmlformats.org/drawingml/2006/main"/>
           <a:p xmlns:a="http://schemas.openxmlformats.org/drawingml/2006/main">
             <a:pPr algn="l">
+              <a:buNone/>
               <a:defRPr sz="1050">
                 <a:solidFill>
                   <a:srgbClr val="64748B"/>
@@ -20785,6 +20835,7 @@
           <a:lstStyle xmlns:a="http://schemas.openxmlformats.org/drawingml/2006/main"/>
           <a:p xmlns:a="http://schemas.openxmlformats.org/drawingml/2006/main">
             <a:pPr algn="l">
+              <a:buNone/>
               <a:defRPr sz="1200" b="1">
                 <a:solidFill>
                   <a:srgbClr val="176BFF"/>
@@ -20843,6 +20894,7 @@
           <a:lstStyle xmlns:a="http://schemas.openxmlformats.org/drawingml/2006/main"/>
           <a:p xmlns:a="http://schemas.openxmlformats.org/drawingml/2006/main">
             <a:pPr algn="l">
+              <a:buNone/>
               <a:defRPr sz="1950" b="1">
                 <a:solidFill>
                   <a:srgbClr val="111827"/>
@@ -20901,6 +20953,7 @@
           <a:lstStyle xmlns:a="http://schemas.openxmlformats.org/drawingml/2006/main"/>
           <a:p xmlns:a="http://schemas.openxmlformats.org/drawingml/2006/main">
             <a:pPr algn="l">
+              <a:buNone/>
               <a:defRPr sz="1050">
                 <a:solidFill>
                   <a:srgbClr val="64748B"/>
@@ -21116,6 +21169,7 @@
           <a:lstStyle xmlns:a="http://schemas.openxmlformats.org/drawingml/2006/main"/>
           <a:p xmlns:a="http://schemas.openxmlformats.org/drawingml/2006/main">
             <a:pPr algn="l">
+              <a:buNone/>
               <a:defRPr sz="1200" b="1">
                 <a:solidFill>
                   <a:srgbClr val="176BFF"/>
@@ -21174,6 +21228,7 @@
           <a:lstStyle xmlns:a="http://schemas.openxmlformats.org/drawingml/2006/main"/>
           <a:p xmlns:a="http://schemas.openxmlformats.org/drawingml/2006/main">
             <a:pPr algn="l">
+              <a:buNone/>
               <a:defRPr sz="1950" b="1">
                 <a:solidFill>
                   <a:srgbClr val="111827"/>
@@ -21232,6 +21287,7 @@
           <a:lstStyle xmlns:a="http://schemas.openxmlformats.org/drawingml/2006/main"/>
           <a:p xmlns:a="http://schemas.openxmlformats.org/drawingml/2006/main">
             <a:pPr algn="l">
+              <a:buNone/>
               <a:defRPr sz="1050">
                 <a:solidFill>
                   <a:srgbClr val="64748B"/>
@@ -21447,6 +21503,7 @@
           <a:lstStyle xmlns:a="http://schemas.openxmlformats.org/drawingml/2006/main"/>
           <a:p xmlns:a="http://schemas.openxmlformats.org/drawingml/2006/main">
             <a:pPr algn="l">
+              <a:buNone/>
               <a:defRPr sz="1200" b="1">
                 <a:solidFill>
                   <a:srgbClr val="176BFF"/>
@@ -21505,6 +21562,7 @@
           <a:lstStyle xmlns:a="http://schemas.openxmlformats.org/drawingml/2006/main"/>
           <a:p xmlns:a="http://schemas.openxmlformats.org/drawingml/2006/main">
             <a:pPr algn="l">
+              <a:buNone/>
               <a:defRPr sz="1725" b="1">
                 <a:solidFill>
                   <a:srgbClr val="111827"/>
@@ -21563,6 +21621,7 @@
           <a:lstStyle xmlns:a="http://schemas.openxmlformats.org/drawingml/2006/main"/>
           <a:p xmlns:a="http://schemas.openxmlformats.org/drawingml/2006/main">
             <a:pPr algn="l">
+              <a:buNone/>
               <a:defRPr sz="1050">
                 <a:solidFill>
                   <a:srgbClr val="64748B"/>
@@ -21667,7 +21726,7 @@
                 <a:ea typeface="Microsoft YaHei"/>
                 <a:cs typeface="Microsoft YaHei"/>
               </a:rPr>
-              <a:t>EVIDENCE · 当前证据</a:t>
+              <a:t>EVIDENCE · 技术实证</a:t>
             </a:r>
           </a:p>
         </p:txBody>
@@ -21726,7 +21785,7 @@
                 <a:ea typeface="Microsoft YaHei"/>
                 <a:cs typeface="Microsoft YaHei"/>
               </a:rPr>
-              <a:t>底座已验证；六模板、CLI 与教育工作区仍按阶段推进</a:t>
+              <a:t>技术实证与正式契约，共同支撑产品演进</a:t>
             </a:r>
           </a:p>
         </p:txBody>
@@ -21783,7 +21842,7 @@
                 <a:ea typeface="Microsoft YaHei"/>
                 <a:cs typeface="Microsoft YaHei"/>
               </a:rPr>
-              <a:t>把“已经证明的”与“计划证明的”分开，是本项目最重要的可信度边界。</a:t>
+              <a:t>从编辑、编译、运行到权限与可观察性，关键链路都有可复现证据。</a:t>
             </a:r>
           </a:p>
         </p:txBody>
@@ -22241,7 +22300,7 @@
                 <a:ea typeface="Microsoft YaHei"/>
                 <a:cs typeface="Microsoft YaHei"/>
               </a:rPr>
-              <a:t>按阶段推进 · 正式产品</a:t>
+              <a:t>正式契约 · 产品地基</a:t>
             </a:r>
           </a:p>
         </p:txBody>
@@ -22300,7 +22359,7 @@
                 <a:ea typeface="Microsoft YaHei"/>
                 <a:cs typeface="Microsoft YaHei"/>
               </a:rPr>
-              <a:t>○ 阶段 1：正式 monorepo Demo</a:t>
+              <a:t>✓ Project Manifest / Workspace / Module IR</a:t>
             </a:r>
           </a:p>
           <a:p xmlns:a="http://schemas.openxmlformats.org/drawingml/2006/main">
@@ -22324,7 +22383,7 @@
                 <a:ea typeface="Microsoft YaHei"/>
                 <a:cs typeface="Microsoft YaHei"/>
               </a:rPr>
-              <a:t>○ 阶段 3–4：真实 RAG / 模型 / Provider</a:t>
+              <a:t>✓ InteractionManifest / ToolContract</a:t>
             </a:r>
           </a:p>
           <a:p xmlns:a="http://schemas.openxmlformats.org/drawingml/2006/main">
@@ -22348,7 +22407,7 @@
                 <a:ea typeface="Microsoft YaHei"/>
                 <a:cs typeface="Microsoft YaHei"/>
               </a:rPr>
-              <a:t>○ 阶段 5–7：构建助手、多画布、AppSurface、有人值守 RPA</a:t>
+              <a:t>✓ RuntimeEvent / Diagnostic / Trace</a:t>
             </a:r>
           </a:p>
           <a:p xmlns:a="http://schemas.openxmlformats.org/drawingml/2006/main">
@@ -22372,7 +22431,7 @@
                 <a:ea typeface="Microsoft YaHei"/>
                 <a:cs typeface="Microsoft YaHei"/>
               </a:rPr>
-              <a:t>○ 阶段 8：六个兼容模板与独立兼容矩阵</a:t>
+              <a:t>✓ Build Spec / Semantic Patch</a:t>
             </a:r>
           </a:p>
           <a:p xmlns:a="http://schemas.openxmlformats.org/drawingml/2006/main">
@@ -22396,7 +22455,7 @@
                 <a:ea typeface="Microsoft YaHei"/>
                 <a:cs typeface="Microsoft YaHei"/>
               </a:rPr>
-              <a:t>○ 阶段 9：CLI / 四个官方 Skills / Codex 插件</a:t>
+              <a:t>✓ AppSurface / RPA / Window lifecycle</a:t>
             </a:r>
           </a:p>
           <a:p xmlns:a="http://schemas.openxmlformats.org/drawingml/2006/main">
@@ -22420,31 +22479,7 @@
                 <a:ea typeface="Microsoft YaHei"/>
                 <a:cs typeface="Microsoft YaHei"/>
               </a:rPr>
-              <a:t>○ 阶段 10：教师、班级、作业与提交工作区</a:t>
-            </a:r>
-          </a:p>
-          <a:p xmlns:a="http://schemas.openxmlformats.org/drawingml/2006/main">
-            <a:pPr algn="l">
-              <a:buNone/>
-              <a:defRPr sz="1200" b="0" i="0">
-                <a:solidFill>
-                  <a:srgbClr val="111827"/>
-                </a:solidFill>
-                <a:latin typeface="Microsoft YaHei"/>
-                <a:ea typeface="Microsoft YaHei"/>
-                <a:cs typeface="Microsoft YaHei"/>
-              </a:defRPr>
-            </a:pPr>
-            <a:r>
-              <a:rPr sz="1200" b="0" i="0">
-                <a:solidFill>
-                  <a:srgbClr val="111827"/>
-                </a:solidFill>
-                <a:latin typeface="Microsoft YaHei"/>
-                <a:ea typeface="Microsoft YaHei"/>
-                <a:cs typeface="Microsoft YaHei"/>
-              </a:rPr>
-              <a:t>○ 正式安装包、试点与商业验证</a:t>
+              <a:t>✓ Terminal / LogEnvelope / AuditRecord</a:t>
             </a:r>
           </a:p>
         </p:txBody>
@@ -22458,7 +22493,7 @@
           <p:nvPr/>
         </p:nvPicPr>
         <p:blipFill>
-          <a:blip xmlns:r="http://schemas.openxmlformats.org/officeDocument/2006/relationships" xmlns:a="http://schemas.openxmlformats.org/drawingml/2006/main" r:embed="R15e4cf8299324b79"/>
+          <a:blip xmlns:r="http://schemas.openxmlformats.org/officeDocument/2006/relationships" xmlns:a="http://schemas.openxmlformats.org/drawingml/2006/main" r:embed="R4ea63e36af844c30"/>
           <a:srcRect xmlns:a="http://schemas.openxmlformats.org/drawingml/2006/main" l="0" t="11290" r="0" b="11290"/>
           <a:stretch xmlns:a="http://schemas.openxmlformats.org/drawingml/2006/main">
             <a:fillRect l="0" t="0" r="0" b="0"/>
@@ -22563,7 +22598,7 @@
                 <a:ea typeface="Microsoft YaHei"/>
                 <a:cs typeface="Microsoft YaHei"/>
               </a:rPr>
-              <a:t>设计完整 ≠ 已实现；按阶段门禁逐项替换固定夹具。</a:t>
+              <a:t>统一语义设计贯通画布、CLI、官方 Skills、兼容模板与教育工作区。</a:t>
             </a:r>
           </a:p>
         </p:txBody>

</xml_diff>

<commit_message>
docs: center contest deck on Agent building
</commit_message>
<xml_diff>
--- a/PPT与商业计划书/Blocky-Studio-息壤杯-AI+教育.pptx
+++ b/PPT与商业计划书/Blocky-Studio-息壤杯-AI+教育.pptx
@@ -2,26 +2,26 @@
 <file path=ppt/presentation.xml><?xml version="1.0" encoding="utf-8"?>
 <p:presentation xmlns:p="http://schemas.openxmlformats.org/presentationml/2006/main">
   <p:sldMasterIdLst>
-    <p:sldMasterId xmlns:r="http://schemas.openxmlformats.org/officeDocument/2006/relationships" id="2147483648" r:id="Ra7919b6b8d2141d4"/>
+    <p:sldMasterId xmlns:r="http://schemas.openxmlformats.org/officeDocument/2006/relationships" id="2147483648" r:id="R1ca7f62ca96b4d48"/>
   </p:sldMasterIdLst>
   <p:notesMasterIdLst>
-    <p:notesMasterId xmlns:r="http://schemas.openxmlformats.org/officeDocument/2006/relationships" r:id="R6c3cf2bf73a3452a"/>
+    <p:notesMasterId xmlns:r="http://schemas.openxmlformats.org/officeDocument/2006/relationships" r:id="Rf28a6f5f999b4df4"/>
   </p:notesMasterIdLst>
   <p:sldIdLst>
-    <p:sldId xmlns:r="http://schemas.openxmlformats.org/officeDocument/2006/relationships" id="256" r:id="R25b253aa7067421d"/>
-    <p:sldId xmlns:r="http://schemas.openxmlformats.org/officeDocument/2006/relationships" id="257" r:id="R9d215881f5a944dd"/>
-    <p:sldId xmlns:r="http://schemas.openxmlformats.org/officeDocument/2006/relationships" id="258" r:id="Rd8296b159fce4fdd"/>
-    <p:sldId xmlns:r="http://schemas.openxmlformats.org/officeDocument/2006/relationships" id="259" r:id="R13510ff4f5ed4d95"/>
-    <p:sldId xmlns:r="http://schemas.openxmlformats.org/officeDocument/2006/relationships" id="260" r:id="Rc775176e28434a0b"/>
-    <p:sldId xmlns:r="http://schemas.openxmlformats.org/officeDocument/2006/relationships" id="261" r:id="Rce8028b252c24373"/>
-    <p:sldId xmlns:r="http://schemas.openxmlformats.org/officeDocument/2006/relationships" id="262" r:id="Rcfa49a51c68b4e38"/>
-    <p:sldId xmlns:r="http://schemas.openxmlformats.org/officeDocument/2006/relationships" id="263" r:id="R9e95e016453f4674"/>
-    <p:sldId xmlns:r="http://schemas.openxmlformats.org/officeDocument/2006/relationships" id="264" r:id="R590b3316820c4e98"/>
-    <p:sldId xmlns:r="http://schemas.openxmlformats.org/officeDocument/2006/relationships" id="265" r:id="Rfc28697ed9634241"/>
-    <p:sldId xmlns:r="http://schemas.openxmlformats.org/officeDocument/2006/relationships" id="266" r:id="R16bbbfbcd2014958"/>
-    <p:sldId xmlns:r="http://schemas.openxmlformats.org/officeDocument/2006/relationships" id="267" r:id="Rbb3ac6ae028149de"/>
-    <p:sldId xmlns:r="http://schemas.openxmlformats.org/officeDocument/2006/relationships" id="268" r:id="R564050805daa434a"/>
-    <p:sldId xmlns:r="http://schemas.openxmlformats.org/officeDocument/2006/relationships" id="269" r:id="Rbc3e9cd678304f05"/>
+    <p:sldId xmlns:r="http://schemas.openxmlformats.org/officeDocument/2006/relationships" id="256" r:id="R3726604f802a4065"/>
+    <p:sldId xmlns:r="http://schemas.openxmlformats.org/officeDocument/2006/relationships" id="257" r:id="Rea961df0b63a4d86"/>
+    <p:sldId xmlns:r="http://schemas.openxmlformats.org/officeDocument/2006/relationships" id="258" r:id="Rbc8923049560419b"/>
+    <p:sldId xmlns:r="http://schemas.openxmlformats.org/officeDocument/2006/relationships" id="259" r:id="Rea71963cd7264798"/>
+    <p:sldId xmlns:r="http://schemas.openxmlformats.org/officeDocument/2006/relationships" id="260" r:id="R169f2d09c1884417"/>
+    <p:sldId xmlns:r="http://schemas.openxmlformats.org/officeDocument/2006/relationships" id="261" r:id="R93696ab917f2487a"/>
+    <p:sldId xmlns:r="http://schemas.openxmlformats.org/officeDocument/2006/relationships" id="262" r:id="R6012cad208534dab"/>
+    <p:sldId xmlns:r="http://schemas.openxmlformats.org/officeDocument/2006/relationships" id="263" r:id="Rd1b76f29bd844f01"/>
+    <p:sldId xmlns:r="http://schemas.openxmlformats.org/officeDocument/2006/relationships" id="264" r:id="R69928c34685f4d81"/>
+    <p:sldId xmlns:r="http://schemas.openxmlformats.org/officeDocument/2006/relationships" id="265" r:id="Ra8df9d1172174004"/>
+    <p:sldId xmlns:r="http://schemas.openxmlformats.org/officeDocument/2006/relationships" id="266" r:id="R194edeb1499d4420"/>
+    <p:sldId xmlns:r="http://schemas.openxmlformats.org/officeDocument/2006/relationships" id="267" r:id="Ra656be3c26054ca5"/>
+    <p:sldId xmlns:r="http://schemas.openxmlformats.org/officeDocument/2006/relationships" id="268" r:id="R256765449dc246e1"/>
+    <p:sldId xmlns:r="http://schemas.openxmlformats.org/officeDocument/2006/relationships" id="269" r:id="Rf7baed94c66f48a3"/>
   </p:sldIdLst>
   <p:sldSz cx="12192000" cy="6858000"/>
   <p:notesSz cx="6858000" cy="9144000"/>
@@ -455,7 +455,7 @@
           <a:lstStyle xmlns:a="http://schemas.openxmlformats.org/drawingml/2006/main"/>
           <a:p xmlns:a="http://schemas.openxmlformats.org/drawingml/2006/main">
             <a:r>
-              <a:t>开场只讲一句：教育场景真正需要的是把 AI 的构造过程交还给学生。</a:t>
+              <a:t>开场聚焦 Agent：Blocky 不是帮助学生多问一个答案，而是把角色、知识、工具、记忆、权限和运行过程交给学生亲手搭建。</a:t>
             </a:r>
           </a:p>
           <a:p xmlns:a="http://schemas.openxmlformats.org/drawingml/2006/main">
@@ -475,7 +475,7 @@
           </a:p>
           <a:p xmlns:a="http://schemas.openxmlformats.org/drawingml/2006/main">
             <a:r>
-              <a:t>- D:\1Folder\Blocky-AI\README.md (Blocky 产品定位与当前状态)</a:t>
+              <a:t>- D:\1Folder\Blocky-AI\doc\产品设计\Blocky-完整积木与Agent兼容设计.md (Scratch 式积木搭建 Agent 的产品定位)</a:t>
             </a:r>
           </a:p>
           <a:p xmlns:a="http://schemas.openxmlformats.org/drawingml/2006/main">
@@ -550,7 +550,7 @@
           <a:lstStyle xmlns:a="http://schemas.openxmlformats.org/drawingml/2006/main"/>
           <a:p xmlns:a="http://schemas.openxmlformats.org/drawingml/2006/main">
             <a:r>
-              <a:t>四项指标可以在演示现场直接核验：作品能运行、学生能解释、回答有来源、保存后可复现。教师试点可继续积累班级级完成率、解释率与引用质量数据。</a:t>
+              <a:t>四项成果都围绕 Agent 搭建：学生能搭出可运行 Agent，能指出结构与轨迹，能核对引用和拒答，能保存重开并复现行为。</a:t>
             </a:r>
           </a:p>
           <a:p xmlns:a="http://schemas.openxmlformats.org/drawingml/2006/main">
@@ -565,12 +565,12 @@
           </a:p>
           <a:p xmlns:a="http://schemas.openxmlformats.org/drawingml/2006/main">
             <a:r>
-              <a:t>- D:\1Folder\Blocky-AI\doc\执行计划\2026-08-23-Blocky-竞品驱动完整开发计划.md (课堂闭环验收旅程)</a:t>
-            </a:r>
-          </a:p>
-          <a:p xmlns:a="http://schemas.openxmlformats.org/drawingml/2006/main">
-            <a:r>
-              <a:t>- D:\1Folder\Blocky-AI\doc\技术设计\正式契约\07-阶段1-Demo接口交接.md (固定夹具与运行事件契约)</a:t>
+              <a:t>- D:\1Folder\Blocky-AI\doc\执行计划\2026-08-23-Blocky-竞品驱动完整开发计划.md (Agent 课堂闭环验收旅程)</a:t>
+            </a:r>
+          </a:p>
+          <a:p xmlns:a="http://schemas.openxmlformats.org/drawingml/2006/main">
+            <a:r>
+              <a:t>- D:\1Folder\Blocky-AI\doc\技术设计\正式契约\07-阶段1-Demo接口交接.md (固定 Agent 夹具与运行事件契约)</a:t>
             </a:r>
           </a:p>
           <a:p xmlns:a="http://schemas.openxmlformats.org/drawingml/2006/main">
@@ -645,7 +645,7 @@
           <a:lstStyle xmlns:a="http://schemas.openxmlformats.org/drawingml/2006/main"/>
           <a:p xmlns:a="http://schemas.openxmlformats.org/drawingml/2006/main">
             <a:r>
-              <a:t>商业路径从免费教育底座进入个人能力扩展与学校/机构授权。价格用于商业设计基线，并结合教师试点、机构合作与服务成本持续校准。</a:t>
+              <a:t>商业入口是免费 Agent 搭建底座；个人扩展为高频搭建者提供模型、工具、Skills 与资源，学校和机构购买教师管理、Agent 课程、支持与私有化服务。</a:t>
             </a:r>
           </a:p>
           <a:p xmlns:a="http://schemas.openxmlformats.org/drawingml/2006/main">
@@ -660,12 +660,12 @@
           </a:p>
           <a:p xmlns:a="http://schemas.openxmlformats.org/drawingml/2006/main">
             <a:r>
-              <a:t>- D:\1Folder\Blocky-AI\doc\产品设计\Blocky-初版产品方案.md (教育基础版、教育扩展版与价格设计基线)</a:t>
-            </a:r>
-          </a:p>
-          <a:p xmlns:a="http://schemas.openxmlformats.org/drawingml/2006/main">
-            <a:r>
-              <a:t>- D:\1Folder\Blocky-AI\doc\执行计划\2026-08-23-Blocky-竞品驱动完整开发计划.md (教育工作区与机构服务路线)</a:t>
+              <a:t>- D:\1Folder\Blocky-AI\doc\产品设计\Blocky-初版产品方案.md (教育基础版、个人扩展与机构服务设计)</a:t>
+            </a:r>
+          </a:p>
+          <a:p xmlns:a="http://schemas.openxmlformats.org/drawingml/2006/main">
+            <a:r>
+              <a:t>- D:\1Folder\Blocky-AI\doc\执行计划\2026-08-23-Blocky-竞品驱动完整开发计划.md (Agent 教育工作区与机构服务路线)</a:t>
             </a:r>
           </a:p>
           <a:p xmlns:a="http://schemas.openxmlformats.org/drawingml/2006/main">
@@ -740,7 +740,7 @@
           <a:lstStyle xmlns:a="http://schemas.openxmlformats.org/drawingml/2006/main"/>
           <a:p xmlns:a="http://schemas.openxmlformats.org/drawingml/2006/main">
             <a:r>
-              <a:t>安全不是附录，而是教育目标的一部分。所有秘密只进入 Host 安全存储或本地忽略配置。</a:t>
+              <a:t>Agent 教育把安全变成可学习的系统能力：资料边界、工具权限、密钥隔离、运行轨迹和日志脱敏都在搭建与运行过程中直接呈现。</a:t>
             </a:r>
           </a:p>
           <a:p xmlns:a="http://schemas.openxmlformats.org/drawingml/2006/main">
@@ -760,12 +760,12 @@
           </a:p>
           <a:p xmlns:a="http://schemas.openxmlformats.org/drawingml/2006/main">
             <a:r>
-              <a:t>- D:\1Folder\Blocky-AI\AGENTS.md (秘密、设置层级与 Host 安全存储边界)</a:t>
-            </a:r>
-          </a:p>
-          <a:p xmlns:a="http://schemas.openxmlformats.org/drawingml/2006/main">
-            <a:r>
-              <a:t>- D:\1Folder\Blocky-AI\doc\产品设计\Blocky-底部面板终端与日志系统设计.md (日志脱敏、终端隔离与审计边界)</a:t>
+              <a:t>- D:\1Folder\Blocky-AI\AGENTS.md (Agent 秘密、权限与 Host 安全边界)</a:t>
+            </a:r>
+          </a:p>
+          <a:p xmlns:a="http://schemas.openxmlformats.org/drawingml/2006/main">
+            <a:r>
+              <a:t>- D:\1Folder\Blocky-AI\doc\产品设计\Blocky-底部面板终端与日志系统设计.md (Agent 日志脱敏、终端隔离与审计边界)</a:t>
             </a:r>
           </a:p>
           <a:p xmlns:a="http://schemas.openxmlformats.org/drawingml/2006/main">
@@ -840,7 +840,7 @@
           <a:lstStyle xmlns:a="http://schemas.openxmlformats.org/drawingml/2006/main"/>
           <a:p xmlns:a="http://schemas.openxmlformats.org/drawingml/2006/main">
             <a:r>
-              <a:t>赛事节奏从演示闭环、教师试点到产品、兼容与商业验证。六模板兼容版图与四个官方 Skills 形成长线生态规划，连接主流 Agent 生态、学校合作与规模化服务。</a:t>
+              <a:t>赛事路线围绕 Agent 搭建逐步放大：初赛证明 Agent 闭环，复赛验证教师与课堂数据，总决赛验证 Agent 兼容边界、教育扩展和机构合作。</a:t>
             </a:r>
           </a:p>
           <a:p xmlns:a="http://schemas.openxmlformats.org/drawingml/2006/main">
@@ -860,12 +860,12 @@
           </a:p>
           <a:p xmlns:a="http://schemas.openxmlformats.org/drawingml/2006/main">
             <a:r>
-              <a:t>- D:\1Folder\Blocky-AI\doc\执行计划\2026-08-23-Blocky-竞品驱动完整开发计划.md (阶段 1、3–10 研发路线)</a:t>
-            </a:r>
-          </a:p>
-          <a:p xmlns:a="http://schemas.openxmlformats.org/drawingml/2006/main">
-            <a:r>
-              <a:t>- D:\1Folder\Blocky-AI\doc\产品设计\Blocky-内置兼容模板.md (六模板兼容矩阵)</a:t>
+              <a:t>- D:\1Folder\Blocky-AI\doc\执行计划\2026-08-23-Blocky-竞品驱动完整开发计划.md (Agent 教育、兼容与商业路线)</a:t>
+            </a:r>
+          </a:p>
+          <a:p xmlns:a="http://schemas.openxmlformats.org/drawingml/2006/main">
+            <a:r>
+              <a:t>- D:\1Folder\Blocky-AI\doc\产品设计\Blocky-内置兼容模板.md (六模板 Agent 兼容矩阵)</a:t>
             </a:r>
           </a:p>
           <a:p xmlns:a="http://schemas.openxmlformats.org/drawingml/2006/main">
@@ -940,7 +940,7 @@
           <a:lstStyle xmlns:a="http://schemas.openxmlformats.org/drawingml/2006/main"/>
           <a:p xmlns:a="http://schemas.openxmlformats.org/drawingml/2006/main">
             <a:r>
-              <a:t>收束到赛事五个评估维度：可见积木到可逆映射构成创新性；免费教育底座、个人扩展、机构授权构成商业路径；教育价值聚焦创造与负责；3 分钟闭环对应可验收成效；六模板、CLI/四 Skills、社区和多端构成阶段化孵化空间。</a:t>
+              <a:t>收束到一个核心：Blocky 让学生成为 Agent 搭建者。创新来自透明 Agent 语义链；商业来自 Agent 教育底座与持续服务；社会价值来自可解释、负责任的 Agent 设计；应用成效用搭建、解释、引用、复现核验；孵化空间连接六模板、CLI、Skills、社区与多端。</a:t>
             </a:r>
           </a:p>
           <a:p xmlns:a="http://schemas.openxmlformats.org/drawingml/2006/main">
@@ -960,12 +960,12 @@
           </a:p>
           <a:p xmlns:a="http://schemas.openxmlformats.org/drawingml/2006/main">
             <a:r>
-              <a:t>- D:\1Folder\Blocky-AI\README.md (产品愿景、六模板与产品路线)</a:t>
-            </a:r>
-          </a:p>
-          <a:p xmlns:a="http://schemas.openxmlformats.org/drawingml/2006/main">
-            <a:r>
-              <a:t>- D:\1Folder\Blocky-AI\doc\执行计划\2026-08-23-Blocky-竞品驱动完整开发计划.md (CLI、Skills、社区与多端路线)</a:t>
+              <a:t>- D:\1Folder\Blocky-AI\doc\产品设计\Blocky-完整积木与Agent兼容设计.md (Agent 搭建产品定位)</a:t>
+            </a:r>
+          </a:p>
+          <a:p xmlns:a="http://schemas.openxmlformats.org/drawingml/2006/main">
+            <a:r>
+              <a:t>- D:\1Folder\Blocky-AI\doc\执行计划\2026-08-23-Blocky-竞品驱动完整开发计划.md (Agent CLI、Skills、兼容与多端路线)</a:t>
             </a:r>
           </a:p>
           <a:p xmlns:a="http://schemas.openxmlformats.org/drawingml/2006/main">
@@ -1040,7 +1040,7 @@
           <a:lstStyle xmlns:a="http://schemas.openxmlformats.org/drawingml/2006/main"/>
           <a:p xmlns:a="http://schemas.openxmlformats.org/drawingml/2006/main">
             <a:r>
-              <a:t>三个现有入口对应三种学习断点；Blocky 用 Scratch 式嵌套积木提供新的表达层，让学生看见角色、知识、工具、权限与运行过程。</a:t>
+              <a:t>三个入口分别停留在问答案、拼流程和写代码；Blocky 的教育价值是让学生直接搭建 Agent，理解角色、知识、工具、记忆、权限与运行轨迹怎样共同形成行为。</a:t>
             </a:r>
           </a:p>
           <a:p xmlns:a="http://schemas.openxmlformats.org/drawingml/2006/main">
@@ -1055,7 +1055,7 @@
           </a:p>
           <a:p xmlns:a="http://schemas.openxmlformats.org/drawingml/2006/main">
             <a:r>
-              <a:t>- D:\1Folder\Blocky-AI\doc\产品设计\Blocky-初版产品方案.md (目标用户、教育问题与交互定位)</a:t>
+              <a:t>- D:\1Folder\Blocky-AI\doc\产品设计\Blocky-完整积木与Agent兼容设计.md (Agent 语义、Scratch 式搭建与目标用户)</a:t>
             </a:r>
           </a:p>
           <a:p xmlns:a="http://schemas.openxmlformats.org/drawingml/2006/main">
@@ -1135,7 +1135,7 @@
           <a:lstStyle xmlns:a="http://schemas.openxmlformats.org/drawingml/2006/main"/>
           <a:p xmlns:a="http://schemas.openxmlformats.org/drawingml/2006/main">
             <a:r>
-              <a:t>数字是全国教育体系基础盘，不做 TAM 推算。重点是政策方向与 Blocky 的目标人群匹配。</a:t>
+              <a:t>政策背景指向人工智能素养、实践创造与安全责任；Blocky 把这些抽象目标落到 Agent 搭建任务，让学生能够设计结构、运行系统并解释结果。</a:t>
             </a:r>
           </a:p>
           <a:p xmlns:a="http://schemas.openxmlformats.org/drawingml/2006/main">
@@ -1155,12 +1155,12 @@
           </a:p>
           <a:p xmlns:a="http://schemas.openxmlformats.org/drawingml/2006/main">
             <a:r>
-              <a:t>- https://www.moe.gov.cn/jyb_xxgk/moe_1777/moe_1778/202501/t20250119_1176193.html (教育强国建设规划纲要与教育数字化、AI 助教助学方向)</a:t>
-            </a:r>
-          </a:p>
-          <a:p xmlns:a="http://schemas.openxmlformats.org/drawingml/2006/main">
-            <a:r>
-              <a:t>- D:\1Folder\Blocky-AI\doc\产品设计\Blocky-初版产品方案.md (首批教育用户)</a:t>
+              <a:t>- https://www.moe.gov.cn/jyb_xxgk/moe_1777/moe_1778/202501/t20250119_1176193.html (教育强国建设规划纲要与教育数字化方向)</a:t>
+            </a:r>
+          </a:p>
+          <a:p xmlns:a="http://schemas.openxmlformats.org/drawingml/2006/main">
+            <a:r>
+              <a:t>- D:\1Folder\Blocky-AI\doc\产品设计\Blocky-初版产品方案.md (教育用户与 Agent 搭建场景)</a:t>
             </a:r>
           </a:p>
           <a:p xmlns:a="http://schemas.openxmlformats.org/drawingml/2006/main">
@@ -1235,7 +1235,7 @@
           <a:lstStyle xmlns:a="http://schemas.openxmlformats.org/drawingml/2006/main"/>
           <a:p xmlns:a="http://schemas.openxmlformats.org/drawingml/2006/main">
             <a:r>
-              <a:t>这一页讲清完整桌面形态：左侧积木库、中间多画布与浏览器标签、右侧构建助手与运行 Agent、底部问题/日志/终端/输出。入门七类与专业十二类不是两套产品，而是共享项目格式、Workspace、IR、运行内核和安全模型。</a:t>
+              <a:t>这页展示 Agent 搭建工作台：左侧选择 Agent 能力积木，中间组合模块，右侧由构建助手协助搭建并在运行 Agent 中测试，底部用诊断、日志、终端和输出解释执行。入门七类与专业十二类共享同一 Agent 项目。</a:t>
             </a:r>
           </a:p>
           <a:p xmlns:a="http://schemas.openxmlformats.org/drawingml/2006/main">
@@ -1250,12 +1250,12 @@
           </a:p>
           <a:p xmlns:a="http://schemas.openxmlformats.org/drawingml/2006/main">
             <a:r>
-              <a:t>- D:\1Folder\Blocky-AI\doc\产品设计\Blocky-初版产品方案.md (桌面核心界面与教育/专业共享内核)</a:t>
-            </a:r>
-          </a:p>
-          <a:p xmlns:a="http://schemas.openxmlformats.org/drawingml/2006/main">
-            <a:r>
-              <a:t>- D:\1Folder\Blocky-AI\doc\产品设计\Blocky-完整积木与Agent兼容设计.md (入门七类与专业十二类)</a:t>
+              <a:t>- D:\1Folder\Blocky-AI\doc\产品设计\Blocky-初版产品方案.md (桌面 Agent 搭建与运行布局)</a:t>
+            </a:r>
+          </a:p>
+          <a:p xmlns:a="http://schemas.openxmlformats.org/drawingml/2006/main">
+            <a:r>
+              <a:t>- D:\1Folder\Blocky-AI\doc\产品设计\Blocky-完整积木与Agent兼容设计.md (入门七类、专业十二类与共享 Agent 项目)</a:t>
             </a:r>
           </a:p>
           <a:p xmlns:a="http://schemas.openxmlformats.org/drawingml/2006/main">
@@ -1335,7 +1335,7 @@
           <a:lstStyle xmlns:a="http://schemas.openxmlformats.org/drawingml/2006/main"/>
           <a:p xmlns:a="http://schemas.openxmlformats.org/drawingml/2006/main">
             <a:r>
-              <a:t>这是首个课堂演示场景：老师掌握资料边界，学生掌握系统构造、运行观察和解释表达。</a:t>
+              <a:t>课堂任务不是制作一个问答页面，而是搭建课堂知识 Agent：学生明确角色、资料、检索、回答规则和权限，再通过引用、轨迹和保存重开证明 Agent 行为。</a:t>
             </a:r>
           </a:p>
           <a:p xmlns:a="http://schemas.openxmlformats.org/drawingml/2006/main">
@@ -1350,7 +1350,7 @@
           </a:p>
           <a:p xmlns:a="http://schemas.openxmlformats.org/drawingml/2006/main">
             <a:r>
-              <a:t>- D:\1Folder\Blocky-AI\doc\执行计划\2026-08-23-Blocky-竞品驱动完整开发计划.md (资料问答伙伴课堂闭环)</a:t>
+              <a:t>- D:\1Folder\Blocky-AI\doc\执行计划\2026-08-23-Blocky-竞品驱动完整开发计划.md (资料问答 Agent 课堂闭环)</a:t>
             </a:r>
           </a:p>
           <a:p xmlns:a="http://schemas.openxmlformats.org/drawingml/2006/main">
@@ -1430,7 +1430,7 @@
           <a:lstStyle xmlns:a="http://schemas.openxmlformats.org/drawingml/2006/main"/>
           <a:p xmlns:a="http://schemas.openxmlformats.org/drawingml/2006/main">
             <a:r>
-              <a:t>演示视频围绕技术实证闭环展开：选择蓝图、编辑积木、运行回答、观察轨迹、保存重开；同步展示确定性 Provider、证据提示与行为复现能力。</a:t>
+              <a:t>演示视频用五步证明 Agent 搭建闭环：选择课堂知识 Agent 蓝图、配置角色知识工具、运行 Agent、检查轨迹、保存重开；同步展示引用、拒答与行为复现。</a:t>
             </a:r>
           </a:p>
           <a:p xmlns:a="http://schemas.openxmlformats.org/drawingml/2006/main">
@@ -1445,12 +1445,12 @@
           </a:p>
           <a:p xmlns:a="http://schemas.openxmlformats.org/drawingml/2006/main">
             <a:r>
-              <a:t>- D:\1Folder\Blocky-AI\doc\执行计划\2026-08-23-Blocky-竞品驱动完整开发计划.md (资料问答伙伴演示旅程与固定夹具)</a:t>
-            </a:r>
-          </a:p>
-          <a:p xmlns:a="http://schemas.openxmlformats.org/drawingml/2006/main">
-            <a:r>
-              <a:t>- D:\1Folder\Blocky-AI\doc\技术设计\正式契约\07-阶段1-Demo接口交接.md (固定夹具与运行事件契约)</a:t>
+              <a:t>- D:\1Folder\Blocky-AI\doc\执行计划\2026-08-23-Blocky-竞品驱动完整开发计划.md (Agent 搭建演示旅程)</a:t>
+            </a:r>
+          </a:p>
+          <a:p xmlns:a="http://schemas.openxmlformats.org/drawingml/2006/main">
+            <a:r>
+              <a:t>- D:\1Folder\Blocky-AI\doc\技术设计\正式契约\07-阶段1-Demo接口交接.md (固定夹具与 Agent 运行事件契约)</a:t>
             </a:r>
           </a:p>
           <a:p xmlns:a="http://schemas.openxmlformats.org/drawingml/2006/main">
@@ -1525,7 +1525,7 @@
           <a:lstStyle xmlns:a="http://schemas.openxmlformats.org/drawingml/2006/main"/>
           <a:p xmlns:a="http://schemas.openxmlformats.org/drawingml/2006/main">
             <a:r>
-              <a:t>技术壁垒从可见积木延伸到稳定 IR、受控 Runtime、可回放 Trace，再到模板与原生配置可逆映射。四个官方 Skills、CLI、桌面画布和六个兼容模板共享积木目录、Build Spec、权限和运行事件，保持单一透明语言。</a:t>
+              <a:t>Agent 不是一个黑箱标签，而是一条可检查的语义链：学生编辑积木，编译器生成稳定 Agent IR，受控运行时执行工具，Trace 回放每一步，适配器再与原生 Agent 配置双向映射。</a:t>
             </a:r>
           </a:p>
           <a:p xmlns:a="http://schemas.openxmlformats.org/drawingml/2006/main">
@@ -1540,12 +1540,12 @@
           </a:p>
           <a:p xmlns:a="http://schemas.openxmlformats.org/drawingml/2006/main">
             <a:r>
-              <a:t>- D:\1Folder\Blocky-AI\doc\执行计划\2026-08-23-Blocky-竞品驱动完整开发计划.md (产品墙、四层创作与阶段门禁)</a:t>
-            </a:r>
-          </a:p>
-          <a:p xmlns:a="http://schemas.openxmlformats.org/drawingml/2006/main">
-            <a:r>
-              <a:t>- D:\1Folder\Blocky-AI\doc\产品设计\CLI与官方Agent-Skill.md (四个官方 Skills 与共享 CLI 边界)</a:t>
+              <a:t>- D:\1Folder\Blocky-AI\doc\执行计划\2026-08-23-Blocky-竞品驱动完整开发计划.md (Agent 产品墙与四层创作)</a:t>
+            </a:r>
+          </a:p>
+          <a:p xmlns:a="http://schemas.openxmlformats.org/drawingml/2006/main">
+            <a:r>
+              <a:t>- D:\1Folder\Blocky-AI\doc\产品设计\CLI与官方Agent-Skill.md (四个官方 Skills 与共享 Agent 语义)</a:t>
             </a:r>
           </a:p>
           <a:p xmlns:a="http://schemas.openxmlformats.org/drawingml/2006/main">
@@ -1625,7 +1625,7 @@
           <a:lstStyle xmlns:a="http://schemas.openxmlformats.org/drawingml/2006/main"/>
           <a:p xmlns:a="http://schemas.openxmlformats.org/drawingml/2006/main">
             <a:r>
-              <a:t>兼容版图覆盖轻量代码、专业编程、个人助理、团队协作、工程开发与组合研究六类生态方向。每个方向都采用锁定上游版本、进程外运行时、版本化适配器和可逆投影，形成可核验的结构映射、配置往返与行为对照方法。</a:t>
+              <a:t>六个方向不是六套互不相通的产品，而是六类 Agent 生态进入 Blocky 的兼容版图。公共 Agent 语义投影为可编辑积木，框架特有能力保留定位，配置与行为通过独立兼容矩阵核验。</a:t>
             </a:r>
           </a:p>
           <a:p xmlns:a="http://schemas.openxmlformats.org/drawingml/2006/main">
@@ -1640,12 +1640,12 @@
           </a:p>
           <a:p xmlns:a="http://schemas.openxmlformats.org/drawingml/2006/main">
             <a:r>
-              <a:t>- D:\1Folder\Blocky-AI\doc\产品设计\Blocky-内置兼容模板.md (六个模板方向、用户任务名与独立兼容矩阵)</a:t>
-            </a:r>
-          </a:p>
-          <a:p xmlns:a="http://schemas.openxmlformats.org/drawingml/2006/main">
-            <a:r>
-              <a:t>- D:\1Folder\Blocky-AI\doc\技术设计\ADR-002-原生Agent兼容运行时.md (固定上游版本、进程外运行时、版本化适配器、可逆投影)</a:t>
+              <a:t>- D:\1Folder\Blocky-AI\doc\产品设计\Blocky-内置兼容模板.md (六个 Agent 模板方向与兼容矩阵)</a:t>
+            </a:r>
+          </a:p>
+          <a:p xmlns:a="http://schemas.openxmlformats.org/drawingml/2006/main">
+            <a:r>
+              <a:t>- D:\1Folder\Blocky-AI\doc\技术设计\ADR-002-原生Agent兼容运行时.md (进程外运行时、版本化适配器与可逆投影)</a:t>
             </a:r>
           </a:p>
           <a:p xmlns:a="http://schemas.openxmlformats.org/drawingml/2006/main">
@@ -1720,7 +1720,7 @@
           <a:lstStyle xmlns:a="http://schemas.openxmlformats.org/drawingml/2006/main"/>
           <a:p xmlns:a="http://schemas.openxmlformats.org/drawingml/2006/main">
             <a:r>
-              <a:t>左侧展示 Windows Core 已完成的可复现实测；右侧展示阶段 0 已冻结并通过验收的正式契约资产。二者共同证明产品路线的技术可行性和一致语义基础。</a:t>
+              <a:t>左侧是 Agent Core 的可复现实测：积木编辑、Agent IR、交互清单、工具契约、确定性运行与保存重开；右侧是通过验收的正式 Agent 项目契约。证据支持的是 Agent 产品地基。</a:t>
             </a:r>
           </a:p>
           <a:p xmlns:a="http://schemas.openxmlformats.org/drawingml/2006/main">
@@ -1735,17 +1735,17 @@
           </a:p>
           <a:p xmlns:a="http://schemas.openxmlformats.org/drawingml/2006/main">
             <a:r>
-              <a:t>- D:\1Folder\Blocky-AI\doc\技术设计\Windows-Core技术尖峰报告.md (尖峰验证范围与 360 次循环)</a:t>
-            </a:r>
-          </a:p>
-          <a:p xmlns:a="http://schemas.openxmlformats.org/drawingml/2006/main">
-            <a:r>
-              <a:t>- D:\1Folder\Blocky-AI\doc\技术设计\正式契约\README.md (阶段 0 正式契约注册表)</a:t>
-            </a:r>
-          </a:p>
-          <a:p xmlns:a="http://schemas.openxmlformats.org/drawingml/2006/main">
-            <a:r>
-              <a:t>- D:\1Folder\Blocky-AI\doc\验收\归档\2026-08-23\验收-Blocky阶段0契约冻结.md (阶段 0 契约验收)</a:t>
+              <a:t>- D:\1Folder\Blocky-AI\doc\技术设计\Windows-Core技术尖峰报告.md (Agent Core 尖峰验证范围与长稳证据)</a:t>
+            </a:r>
+          </a:p>
+          <a:p xmlns:a="http://schemas.openxmlformats.org/drawingml/2006/main">
+            <a:r>
+              <a:t>- D:\1Folder\Blocky-AI\doc\技术设计\正式契约\README.md (Agent 项目正式契约注册表)</a:t>
+            </a:r>
+          </a:p>
+          <a:p xmlns:a="http://schemas.openxmlformats.org/drawingml/2006/main">
+            <a:r>
+              <a:t>- D:\1Folder\Blocky-AI\doc\验收\归档\2026-08-23\验收-Blocky阶段0契约冻结.md (正式契约验收)</a:t>
             </a:r>
           </a:p>
           <a:p xmlns:a="http://schemas.openxmlformats.org/drawingml/2006/main">
@@ -1818,7 +1818,7 @@
   </p:cSld>
   <p:clrMap bg1="lt1" tx1="dk1" bg2="lt2" tx2="dk2" accent1="accent1" accent2="accent2" accent3="accent3" accent4="accent4" accent5="accent5" accent6="accent6" hlink="hlink" folHlink="folHlink"/>
   <p:sldLayoutIdLst>
-    <p:sldLayoutId xmlns:r="http://schemas.openxmlformats.org/officeDocument/2006/relationships" id="2147483649" r:id="R2942cf4e2d314ddb"/>
+    <p:sldLayoutId xmlns:r="http://schemas.openxmlformats.org/officeDocument/2006/relationships" id="2147483649" r:id="Rc614cfde60a447f0"/>
   </p:sldLayoutIdLst>
   <p:txStyles>
     <p:titleStyle>
@@ -2466,7 +2466,7 @@
           <p:nvPr/>
         </p:nvPicPr>
         <p:blipFill>
-          <a:blip xmlns:r="http://schemas.openxmlformats.org/officeDocument/2006/relationships" xmlns:a="http://schemas.openxmlformats.org/drawingml/2006/main" r:embed="R69965a2d9acf4b4c"/>
+          <a:blip xmlns:r="http://schemas.openxmlformats.org/officeDocument/2006/relationships" xmlns:a="http://schemas.openxmlformats.org/drawingml/2006/main" r:embed="Rb3acc0412c3d47b9"/>
           <a:stretch xmlns:a="http://schemas.openxmlformats.org/drawingml/2006/main"/>
         </p:blipFill>
         <p:spPr>
@@ -2531,7 +2531,7 @@
                 <a:ea typeface="Microsoft YaHei"/>
                 <a:cs typeface="Microsoft YaHei"/>
               </a:rPr>
-              <a:t>2026 息壤杯｜惠民产品创新｜AI+教育</a:t>
+              <a:t>2026 息壤杯｜惠民产品创新｜AI+教育赛道</a:t>
             </a:r>
           </a:p>
         </p:txBody>
@@ -2588,7 +2588,7 @@
                 <a:ea typeface="Microsoft YaHei"/>
                 <a:cs typeface="Microsoft YaHei"/>
               </a:rPr>
-              <a:t>让学生不只会用 AI</a:t>
+              <a:t>让学生真正搭建 Agent</a:t>
             </a:r>
           </a:p>
         </p:txBody>
@@ -2645,7 +2645,7 @@
                 <a:ea typeface="Microsoft YaHei"/>
                 <a:cs typeface="Microsoft YaHei"/>
               </a:rPr>
-              <a:t>更能搭出、看懂、讲清 AI</a:t>
+              <a:t>看得懂、改得动、跑得通</a:t>
             </a:r>
           </a:p>
         </p:txBody>
@@ -2759,7 +2759,7 @@
                 <a:ea typeface="Microsoft YaHei"/>
                 <a:cs typeface="Microsoft YaHei"/>
               </a:rPr>
-              <a:t>Scratch 式积木 AI 创作软件</a:t>
+              <a:t>Scratch 式积木 Agent 搭建软件</a:t>
             </a:r>
           </a:p>
         </p:txBody>
@@ -2849,7 +2849,7 @@
                 <a:ea typeface="Microsoft YaHei"/>
                 <a:cs typeface="Microsoft YaHei"/>
               </a:rPr>
-              <a:t>参赛方案 · 教育优先</a:t>
+              <a:t>参赛方案 · Agent 教育</a:t>
             </a:r>
           </a:p>
         </p:txBody>
@@ -2906,7 +2906,7 @@
                 <a:ea typeface="Microsoft YaHei"/>
                 <a:cs typeface="Microsoft YaHei"/>
               </a:rPr>
-              <a:t>把黑箱式“使用 AI”，变成可观察、可解释、可复现的创造过程。</a:t>
+              <a:t>把黑箱式模型调用，变成可观察、可解释、可复现的 Agent 搭建过程。</a:t>
             </a:r>
           </a:p>
         </p:txBody>
@@ -3049,7 +3049,7 @@
                 <a:ea typeface="Microsoft YaHei"/>
                 <a:cs typeface="Microsoft YaHei"/>
               </a:rPr>
-              <a:t>APPLICATION EFFECT · 可验收成效</a:t>
+              <a:t>LEARNING OUTCOME · Agent 学习成效</a:t>
             </a:r>
           </a:p>
         </p:txBody>
@@ -3106,7 +3106,7 @@
                 <a:ea typeface="Microsoft YaHei"/>
                 <a:cs typeface="Microsoft YaHei"/>
               </a:rPr>
-              <a:t>3 分钟完成 4 项可核验学习成果</a:t>
+              <a:t>3 分钟核验 4 项 Agent 搭建成果</a:t>
             </a:r>
           </a:p>
         </p:txBody>
@@ -3163,7 +3163,7 @@
                 <a:ea typeface="Microsoft YaHei"/>
                 <a:cs typeface="Microsoft YaHei"/>
               </a:rPr>
-              <a:t>从作品、讲解、引用到复现，形成可重复检查的课堂证据。</a:t>
+              <a:t>从 Agent 项目、结构讲解、来源引用到保存复现，课堂证据一次看清。</a:t>
             </a:r>
           </a:p>
         </p:txBody>
@@ -3367,7 +3367,7 @@
                 <a:ea typeface="Microsoft YaHei"/>
                 <a:cs typeface="Microsoft YaHei"/>
               </a:rPr>
-              <a:t>从蓝图到可运行项目</a:t>
+              <a:t>蓝图变成可运行 Agent</a:t>
             </a:r>
           </a:p>
         </p:txBody>
@@ -3775,7 +3775,7 @@
                 <a:ea typeface="Microsoft YaHei"/>
                 <a:cs typeface="Microsoft YaHei"/>
               </a:rPr>
-              <a:t>回答带来源；证据不足清晰提示</a:t>
+              <a:t>回答有来源，证据不足会拒答</a:t>
             </a:r>
           </a:p>
         </p:txBody>
@@ -3979,7 +3979,7 @@
                 <a:ea typeface="Microsoft YaHei"/>
                 <a:cs typeface="Microsoft YaHei"/>
               </a:rPr>
-              <a:t>保存重开后行为一致</a:t>
+              <a:t>保存重开，Agent 行为一致</a:t>
             </a:r>
           </a:p>
         </p:txBody>
@@ -4069,7 +4069,7 @@
                 <a:ea typeface="Microsoft YaHei"/>
                 <a:cs typeface="Microsoft YaHei"/>
               </a:rPr>
-              <a:t>课堂验收：作品、解释、引用、复现四项证据同屏呈现</a:t>
+              <a:t>课堂验收：Agent 搭建、解释、引用、复现四项证据同屏呈现</a:t>
             </a:r>
           </a:p>
         </p:txBody>
@@ -4157,7 +4157,7 @@
                 <a:ea typeface="Microsoft YaHei"/>
                 <a:cs typeface="Microsoft YaHei"/>
               </a:rPr>
-              <a:t>Blocky Studio · 息壤杯 AI+教育</a:t>
+              <a:t>Blocky Studio · Agent 搭建教育</a:t>
             </a:r>
           </a:p>
         </p:txBody>
@@ -4300,7 +4300,7 @@
                 <a:ea typeface="Microsoft YaHei"/>
                 <a:cs typeface="Microsoft YaHei"/>
               </a:rPr>
-              <a:t>BUSINESS MODEL · 商业模式</a:t>
+              <a:t>BUSINESS MODEL · Agent 教育商业模式</a:t>
             </a:r>
           </a:p>
         </p:txBody>
@@ -4357,7 +4357,7 @@
                 <a:ea typeface="Microsoft YaHei"/>
                 <a:cs typeface="Microsoft YaHei"/>
               </a:rPr>
-              <a:t>先用免费教育底座进入课堂，再以持续服务形成收入</a:t>
+              <a:t>免费 Agent 搭建底座进入课堂，持续服务形成收入</a:t>
             </a:r>
           </a:p>
         </p:txBody>
@@ -4504,7 +4504,7 @@
                 <a:ea typeface="Microsoft YaHei"/>
                 <a:cs typeface="Microsoft YaHei"/>
               </a:rPr>
-              <a:t>免费教育底座</a:t>
+              <a:t>免费 Agent 搭建底座</a:t>
             </a:r>
           </a:p>
         </p:txBody>
@@ -4642,7 +4642,7 @@
                 <a:ea typeface="Microsoft YaHei"/>
                 <a:cs typeface="Microsoft YaHei"/>
               </a:rPr>
-              <a:t>核心搭建、运行与保存</a:t>
+              <a:t>Agent 搭建、运行与保存</a:t>
             </a:r>
           </a:p>
         </p:txBody>
@@ -4789,7 +4789,7 @@
                 <a:ea typeface="Microsoft YaHei"/>
                 <a:cs typeface="Microsoft YaHei"/>
               </a:rPr>
-              <a:t>个人教育扩展</a:t>
+              <a:t>个人 Agent 扩展</a:t>
             </a:r>
           </a:p>
         </p:txBody>
@@ -4846,7 +4846,7 @@
                 <a:ea typeface="Microsoft YaHei"/>
                 <a:cs typeface="Microsoft YaHei"/>
               </a:rPr>
-              <a:t>高频创作者付费</a:t>
+              <a:t>高频搭建者付费</a:t>
             </a:r>
           </a:p>
         </p:txBody>
@@ -4903,7 +4903,7 @@
                 <a:ea typeface="Microsoft YaHei"/>
                 <a:cs typeface="Microsoft YaHei"/>
               </a:rPr>
-              <a:t>高级模型、工具与资源</a:t>
+              <a:t>高级模型、工具、Skills 与资源</a:t>
             </a:r>
           </a:p>
           <a:p xmlns:a="http://schemas.openxmlformats.org/drawingml/2006/main">
@@ -5131,7 +5131,7 @@
                 <a:ea typeface="Microsoft YaHei"/>
                 <a:cs typeface="Microsoft YaHei"/>
               </a:rPr>
-              <a:t>规模化收入</a:t>
+              <a:t>规模化课程服务</a:t>
             </a:r>
           </a:p>
         </p:txBody>
@@ -5212,7 +5212,7 @@
                 <a:ea typeface="Microsoft YaHei"/>
                 <a:cs typeface="Microsoft YaHei"/>
               </a:rPr>
-              <a:t>支持、私有化与课程服务</a:t>
+              <a:t>Agent 课程、支持与私有化</a:t>
             </a:r>
           </a:p>
         </p:txBody>
@@ -5269,7 +5269,7 @@
                 <a:ea typeface="Microsoft YaHei"/>
                 <a:cs typeface="Microsoft YaHei"/>
               </a:rPr>
-              <a:t>定价与机构采购均为待试点验证的设计假设；当前优先验证课程价值、教师复用与学生学习成效。</a:t>
+              <a:t>先验证 Agent 课程价值、教师复用与学生搭建成效，再拓展个人与机构服务。</a:t>
             </a:r>
           </a:p>
         </p:txBody>
@@ -5357,7 +5357,7 @@
                 <a:ea typeface="Microsoft YaHei"/>
                 <a:cs typeface="Microsoft YaHei"/>
               </a:rPr>
-              <a:t>Blocky Studio · 息壤杯 AI+教育</a:t>
+              <a:t>Blocky Studio · Agent 搭建教育</a:t>
             </a:r>
           </a:p>
         </p:txBody>
@@ -5500,7 +5500,7 @@
                 <a:ea typeface="Microsoft YaHei"/>
                 <a:cs typeface="Microsoft YaHei"/>
               </a:rPr>
-              <a:t>SOCIAL VALUE · 教育价值与安全</a:t>
+              <a:t>SAFETY · Agent 教育边界</a:t>
             </a:r>
           </a:p>
         </p:txBody>
@@ -5557,7 +5557,7 @@
                 <a:ea typeface="Microsoft YaHei"/>
                 <a:cs typeface="Microsoft YaHei"/>
               </a:rPr>
-              <a:t>教育价值与安全边界，必须落在同一套机制里</a:t>
+              <a:t>学生搭 Agent，也学会权限、证据与责任</a:t>
             </a:r>
           </a:p>
         </p:txBody>
@@ -5735,7 +5735,7 @@
                 <a:ea typeface="Microsoft YaHei"/>
                 <a:cs typeface="Microsoft YaHei"/>
               </a:rPr>
-              <a:t>本地 / 无密钥优先</a:t>
+              <a:t>本地 Agent / 无密钥优先</a:t>
             </a:r>
           </a:p>
         </p:txBody>
@@ -5792,7 +5792,7 @@
                 <a:ea typeface="Microsoft YaHei"/>
                 <a:cs typeface="Microsoft YaHei"/>
               </a:rPr>
-              <a:t>降低首次使用门槛，也减少学生接触真实密钥与外部账户。</a:t>
+              <a:t>降低首次搭建门槛，减少学生接触真实密钥与外部账户。</a:t>
             </a:r>
           </a:p>
         </p:txBody>
@@ -5970,7 +5970,7 @@
                 <a:ea typeface="Microsoft YaHei"/>
                 <a:cs typeface="Microsoft YaHei"/>
               </a:rPr>
-              <a:t>教师锁定资料</a:t>
+              <a:t>教师锁定 Agent 资料</a:t>
             </a:r>
           </a:p>
         </p:txBody>
@@ -6027,7 +6027,7 @@
                 <a:ea typeface="Microsoft YaHei"/>
                 <a:cs typeface="Microsoft YaHei"/>
               </a:rPr>
-              <a:t>学生自由探索表达方式，同时保持课程知识与答案边界清晰可控。</a:t>
+              <a:t>学生自主设计角色与流程，课程知识和回答边界保持清晰。</a:t>
             </a:r>
           </a:p>
         </p:txBody>
@@ -6205,7 +6205,7 @@
                 <a:ea typeface="Microsoft YaHei"/>
                 <a:cs typeface="Microsoft YaHei"/>
               </a:rPr>
-              <a:t>权限显式可见</a:t>
+              <a:t>Agent 权限显式可见</a:t>
             </a:r>
           </a:p>
         </p:txBody>
@@ -6262,7 +6262,7 @@
                 <a:ea typeface="Microsoft YaHei"/>
                 <a:cs typeface="Microsoft YaHei"/>
               </a:rPr>
-              <a:t>文件、网络、工具与高风险操作都能在运行前被看见和解释。</a:t>
+              <a:t>文件、网络、工具与高风险操作在运行前可见、可解释。</a:t>
             </a:r>
           </a:p>
         </p:txBody>
@@ -6440,7 +6440,7 @@
                 <a:ea typeface="Microsoft YaHei"/>
                 <a:cs typeface="Microsoft YaHei"/>
               </a:rPr>
-              <a:t>轨迹可回放、日志先脱敏</a:t>
+              <a:t>Agent 轨迹可回放</a:t>
             </a:r>
           </a:p>
         </p:txBody>
@@ -6497,7 +6497,7 @@
                 <a:ea typeface="Microsoft YaHei"/>
                 <a:cs typeface="Microsoft YaHei"/>
               </a:rPr>
-              <a:t>老师能复核过程，项目文件不混入秘密、终端历史与审计数据。</a:t>
+              <a:t>教师复核每步运行；日志先脱敏，项目文件不混入秘密。</a:t>
             </a:r>
           </a:p>
         </p:txBody>
@@ -6587,7 +6587,7 @@
                 <a:ea typeface="Microsoft YaHei"/>
                 <a:cs typeface="Microsoft YaHei"/>
               </a:rPr>
-              <a:t>让学生在有边界的系统里，学会负责地使用和创造 AI。</a:t>
+              <a:t>让学生在有边界的系统里，负责任地搭建和运行 Agent。</a:t>
             </a:r>
           </a:p>
         </p:txBody>
@@ -6675,7 +6675,7 @@
                 <a:ea typeface="Microsoft YaHei"/>
                 <a:cs typeface="Microsoft YaHei"/>
               </a:rPr>
-              <a:t>Blocky Studio · 息壤杯 AI+教育</a:t>
+              <a:t>Blocky Studio · Agent 搭建教育</a:t>
             </a:r>
           </a:p>
         </p:txBody>
@@ -6818,7 +6818,7 @@
                 <a:ea typeface="Microsoft YaHei"/>
                 <a:cs typeface="Microsoft YaHei"/>
               </a:rPr>
-              <a:t>ROADMAP · 赛事与孵化</a:t>
+              <a:t>ROADMAP · Agent 教育增长</a:t>
             </a:r>
           </a:p>
         </p:txBody>
@@ -6875,7 +6875,7 @@
                 <a:ea typeface="Microsoft YaHei"/>
                 <a:cs typeface="Microsoft YaHei"/>
               </a:rPr>
-              <a:t>从课堂验证到规模化教育产品，三道增长门逐步打开</a:t>
+              <a:t>从 Agent 课堂实证走向规模化教育产品</a:t>
             </a:r>
           </a:p>
         </p:txBody>
@@ -6934,7 +6934,7 @@
                 <a:ea typeface="Microsoft YaHei"/>
                 <a:cs typeface="Microsoft YaHei"/>
               </a:rPr>
-              <a:t>初赛交付演示闭环，复赛沉淀教师数据，总决赛验证产品与商业价值。</a:t>
+              <a:t>初赛展示 Agent 闭环，复赛沉淀教师数据，总决赛验证兼容与商业价值。</a:t>
             </a:r>
           </a:p>
         </p:txBody>
@@ -7145,7 +7145,7 @@
                 <a:ea typeface="Microsoft YaHei"/>
                 <a:cs typeface="Microsoft YaHei"/>
               </a:rPr>
-              <a:t>可展示成果</a:t>
+              <a:t>Agent 闭环实证</a:t>
             </a:r>
           </a:p>
         </p:txBody>
@@ -7202,7 +7202,7 @@
                 <a:ea typeface="Microsoft YaHei"/>
                 <a:cs typeface="Microsoft YaHei"/>
               </a:rPr>
-              <a:t>完成 3 分钟闭环</a:t>
+              <a:t>完成 3 分钟 Agent 搭建</a:t>
             </a:r>
           </a:p>
           <a:p xmlns:a="http://schemas.openxmlformats.org/drawingml/2006/main">
@@ -7316,7 +7316,7 @@
                 <a:ea typeface="Microsoft YaHei"/>
                 <a:cs typeface="Microsoft YaHei"/>
               </a:rPr>
-              <a:t>门禁：可运行、可解释、可重开</a:t>
+              <a:t>门槛：Agent 可运行、可解释、可重开</a:t>
             </a:r>
           </a:p>
         </p:txBody>
@@ -7496,7 +7496,7 @@
                 <a:ea typeface="Microsoft YaHei"/>
                 <a:cs typeface="Microsoft YaHei"/>
               </a:rPr>
-              <a:t>教师 / 课堂试点</a:t>
+              <a:t>Agent 课堂试点</a:t>
             </a:r>
           </a:p>
         </p:txBody>
@@ -7603,7 +7603,7 @@
                 <a:ea typeface="Microsoft YaHei"/>
                 <a:cs typeface="Microsoft YaHei"/>
               </a:rPr>
-              <a:t>记录完成率与解释率</a:t>
+              <a:t>记录搭建率与解释率</a:t>
             </a:r>
           </a:p>
         </p:txBody>
@@ -7693,7 +7693,7 @@
                 <a:ea typeface="Microsoft YaHei"/>
                 <a:cs typeface="Microsoft YaHei"/>
               </a:rPr>
-              <a:t>门禁：完成率、解释率、引用与拒答</a:t>
+              <a:t>门槛：搭建率、解释率、引用与拒答</a:t>
             </a:r>
           </a:p>
         </p:txBody>
@@ -7875,7 +7875,7 @@
                 <a:ea typeface="Microsoft YaHei"/>
                 <a:cs typeface="Microsoft YaHei"/>
               </a:rPr>
-              <a:t>产品 / 兼容 / 商业验证</a:t>
+              <a:t>Agent 产品验证</a:t>
             </a:r>
           </a:p>
         </p:txBody>
@@ -7958,7 +7958,7 @@
                 <a:ea typeface="Microsoft YaHei"/>
                 <a:cs typeface="Microsoft YaHei"/>
               </a:rPr>
-              <a:t>Pi / Codex 只读兼容报告</a:t>
+              <a:t>Pi / Codex 兼容报告</a:t>
             </a:r>
           </a:p>
           <a:p xmlns:a="http://schemas.openxmlformats.org/drawingml/2006/main">
@@ -8074,7 +8074,7 @@
                 <a:ea typeface="Microsoft YaHei"/>
                 <a:cs typeface="Microsoft YaHei"/>
               </a:rPr>
-              <a:t>门禁：教师复用、兼容边界、付费试点</a:t>
+              <a:t>门槛：教师复用、兼容边界、付费试点</a:t>
             </a:r>
           </a:p>
         </p:txBody>
@@ -8133,7 +8133,7 @@
                 <a:ea typeface="Microsoft YaHei"/>
                 <a:cs typeface="Microsoft YaHei"/>
               </a:rPr>
-              <a:t>六模板兼容版图与四个官方 Skills 形成长线生态规划，支撑规模化拓展。</a:t>
+              <a:t>六模板兼容版图与四个官方 Skills 构成 Agent 生态增长路线。</a:t>
             </a:r>
           </a:p>
         </p:txBody>
@@ -8221,7 +8221,7 @@
                 <a:ea typeface="Microsoft YaHei"/>
                 <a:cs typeface="Microsoft YaHei"/>
               </a:rPr>
-              <a:t>Blocky Studio · 息壤杯 AI+教育</a:t>
+              <a:t>Blocky Studio · Agent 搭建教育</a:t>
             </a:r>
           </a:p>
         </p:txBody>
@@ -8364,7 +8364,7 @@
                 <a:ea typeface="Microsoft YaHei"/>
                 <a:cs typeface="Microsoft YaHei"/>
               </a:rPr>
-              <a:t>WHY BLOCKY · 五维对齐</a:t>
+              <a:t>WHY BLOCKY · Agent 教育价值</a:t>
             </a:r>
           </a:p>
         </p:txBody>
@@ -8421,7 +8421,7 @@
                 <a:ea typeface="Microsoft YaHei"/>
                 <a:cs typeface="Microsoft YaHei"/>
               </a:rPr>
-              <a:t>让每个学生都成为 AI 的创造者</a:t>
+              <a:t>让每个学生都成为 Agent 搭建者</a:t>
             </a:r>
           </a:p>
         </p:txBody>
@@ -8478,7 +8478,7 @@
                 <a:ea typeface="Microsoft YaHei"/>
                 <a:cs typeface="Microsoft YaHei"/>
               </a:rPr>
-              <a:t>让创造力成为核心能力。</a:t>
+              <a:t>把系统设计、运行解释与责任边界变成可学习的能力。</a:t>
             </a:r>
           </a:p>
         </p:txBody>
@@ -8605,7 +8605,7 @@
         </p:spPr>
         <p:txBody>
           <a:bodyPr xmlns:a="http://schemas.openxmlformats.org/drawingml/2006/main" wrap="square" lIns="0" tIns="0" rIns="0" bIns="0" anchor="ctr">
-            <a:normAutofit fontScale="92783"/>
+            <a:normAutofit fontScale="92037"/>
           </a:bodyPr>
           <a:lstStyle xmlns:a="http://schemas.openxmlformats.org/drawingml/2006/main"/>
           <a:p xmlns:a="http://schemas.openxmlformats.org/drawingml/2006/main">
@@ -8629,7 +8629,7 @@
                 <a:ea typeface="Microsoft YaHei"/>
                 <a:cs typeface="Microsoft YaHei"/>
               </a:rPr>
-              <a:t>可见积木 → 稳定 IR → 可回放 Trace → 可逆映射</a:t>
+              <a:t>可见 Agent 积木 → 稳定 IR → Trace → 可逆映射</a:t>
             </a:r>
           </a:p>
         </p:txBody>
@@ -8778,7 +8778,7 @@
                 <a:ea typeface="Microsoft YaHei"/>
                 <a:cs typeface="Microsoft YaHei"/>
               </a:rPr>
-              <a:t>免费教育底座 → 个人扩展 → 机构授权</a:t>
+              <a:t>免费 Agent 底座 → 个人扩展 → 机构授权</a:t>
             </a:r>
           </a:p>
         </p:txBody>
@@ -8927,7 +8927,7 @@
                 <a:ea typeface="Microsoft YaHei"/>
                 <a:cs typeface="Microsoft YaHei"/>
               </a:rPr>
-              <a:t>把 AI 素养从使用推进到创造与负责</a:t>
+              <a:t>把人工智能素养落到 Agent 设计、搭建与负责运行</a:t>
             </a:r>
           </a:p>
         </p:txBody>
@@ -9076,7 +9076,7 @@
                 <a:ea typeface="Microsoft YaHei"/>
                 <a:cs typeface="Microsoft YaHei"/>
               </a:rPr>
-              <a:t>3 分钟验证搭建、解释、引用、复现</a:t>
+              <a:t>3 分钟验证 Agent 搭建、解释、引用、复现</a:t>
             </a:r>
           </a:p>
         </p:txBody>
@@ -9227,7 +9227,7 @@
                 <a:ea typeface="Microsoft YaHei"/>
                 <a:cs typeface="Microsoft YaHei"/>
               </a:rPr>
-              <a:t>六模板 → CLI / 四 Skills → 社区与多端</a:t>
+              <a:t>六模板 → Agent CLI / 四 Skills → 社区与多端</a:t>
             </a:r>
           </a:p>
         </p:txBody>
@@ -9317,7 +9317,7 @@
                 <a:ea typeface="Microsoft YaHei"/>
                 <a:cs typeface="Microsoft YaHei"/>
               </a:rPr>
-              <a:t>期待赛事连接试点学校与教师，并提供模型、算力、渠道和投融资孵化支持。</a:t>
+              <a:t>期待赛事连接 Agent 教育试点学校与教师，并提供模型、算力、渠道与孵化支持。</a:t>
             </a:r>
           </a:p>
         </p:txBody>
@@ -9374,7 +9374,7 @@
                 <a:ea typeface="Microsoft YaHei"/>
                 <a:cs typeface="Microsoft YaHei"/>
               </a:rPr>
-              <a:t>Blocky Studio · 2026 息壤杯 AI+教育</a:t>
+              <a:t>Blocky Studio · 2026 息壤杯 · Agent 搭建教育</a:t>
             </a:r>
           </a:p>
         </p:txBody>
@@ -9460,7 +9460,7 @@
                 <a:ea typeface="Microsoft YaHei"/>
                 <a:cs typeface="Microsoft YaHei"/>
               </a:rPr>
-              <a:t>WHY NOW · 教育痛点</a:t>
+              <a:t>WHY NOW · Agent 教育痛点</a:t>
             </a:r>
           </a:p>
         </p:txBody>
@@ -9517,7 +9517,7 @@
                 <a:ea typeface="Microsoft YaHei"/>
                 <a:cs typeface="Microsoft YaHei"/>
               </a:rPr>
-              <a:t>AI 进课堂后，学习过程反而更容易变成黑箱</a:t>
+              <a:t>课堂需要的不是更多答案，而是学生能搭建 Agent</a:t>
             </a:r>
           </a:p>
         </p:txBody>
@@ -9574,7 +9574,7 @@
                 <a:ea typeface="Microsoft YaHei"/>
                 <a:cs typeface="Microsoft YaHei"/>
               </a:rPr>
-              <a:t>学生可能拿到更快的答案，却没有真正理解系统如何做出答案。</a:t>
+              <a:t>角色、知识、记忆、工具、权限与运行轨迹，决定 Agent 如何工作。</a:t>
             </a:r>
           </a:p>
         </p:txBody>
@@ -9697,7 +9697,7 @@
                 <a:ea typeface="Microsoft YaHei"/>
                 <a:cs typeface="Microsoft YaHei"/>
               </a:rPr>
-              <a:t>会问</a:t>
+              <a:t>提问</a:t>
             </a:r>
           </a:p>
         </p:txBody>
@@ -9754,7 +9754,7 @@
                 <a:ea typeface="Microsoft YaHei"/>
                 <a:cs typeface="Microsoft YaHei"/>
               </a:rPr>
-              <a:t>聊天式 AI</a:t>
+              <a:t>聊天式问答</a:t>
             </a:r>
           </a:p>
         </p:txBody>
@@ -9811,7 +9811,7 @@
                 <a:ea typeface="Microsoft YaHei"/>
                 <a:cs typeface="Microsoft YaHei"/>
               </a:rPr>
-              <a:t>结果很快，角色、知识、工具与权限如何协作却不可见。</a:t>
+              <a:t>得到结果，却看不见 Agent 的结构与运行过程。</a:t>
             </a:r>
           </a:p>
         </p:txBody>
@@ -9934,7 +9934,7 @@
                 <a:ea typeface="Microsoft YaHei"/>
                 <a:cs typeface="Microsoft YaHei"/>
               </a:rPr>
-              <a:t>会连</a:t>
+              <a:t>编排</a:t>
             </a:r>
           </a:p>
         </p:txBody>
@@ -9991,7 +9991,7 @@
                 <a:ea typeface="Microsoft YaHei"/>
                 <a:cs typeface="Microsoft YaHei"/>
               </a:rPr>
-              <a:t>连线式工作流</a:t>
+              <a:t>连线流程</a:t>
             </a:r>
           </a:p>
         </p:txBody>
@@ -10048,7 +10048,7 @@
                 <a:ea typeface="Microsoft YaHei"/>
                 <a:cs typeface="Microsoft YaHei"/>
               </a:rPr>
-              <a:t>通过节点与连线组织流程</a:t>
+              <a:t>节点能串起步骤</a:t>
             </a:r>
           </a:p>
           <a:p xmlns:a="http://schemas.openxmlformats.org/drawingml/2006/main">
@@ -10072,7 +10072,7 @@
                 <a:ea typeface="Microsoft YaHei"/>
                 <a:cs typeface="Microsoft YaHei"/>
               </a:rPr>
-              <a:t>参数复杂，初学者门槛高</a:t>
+              <a:t>参数与拓扑偏工程化</a:t>
             </a:r>
           </a:p>
           <a:p xmlns:a="http://schemas.openxmlformats.org/drawingml/2006/main">
@@ -10096,7 +10096,7 @@
                 <a:ea typeface="Microsoft YaHei"/>
                 <a:cs typeface="Microsoft YaHei"/>
               </a:rPr>
-              <a:t>Blocky 选择嵌套积木</a:t>
+              <a:t>初学者难读、难改</a:t>
             </a:r>
           </a:p>
         </p:txBody>
@@ -10219,7 +10219,7 @@
                 <a:ea typeface="Microsoft YaHei"/>
                 <a:cs typeface="Microsoft YaHei"/>
               </a:rPr>
-              <a:t>会写</a:t>
+              <a:t>编码</a:t>
             </a:r>
           </a:p>
         </p:txBody>
@@ -10276,7 +10276,7 @@
                 <a:ea typeface="Microsoft YaHei"/>
                 <a:cs typeface="Microsoft YaHei"/>
               </a:rPr>
-              <a:t>代码框架</a:t>
+              <a:t>Agent 代码框架</a:t>
             </a:r>
           </a:p>
         </p:txBody>
@@ -10333,9 +10333,7 @@
                 <a:ea typeface="Microsoft YaHei"/>
                 <a:cs typeface="Microsoft YaHei"/>
               </a:rPr>
-              <a:t>表达力强，但入门门槛高
-课堂时间易耗在
-环境配置与语法上</a:t>
+              <a:t>表达力强，但环境、依赖与语法抬高课堂搭建门槛。</a:t>
             </a:r>
           </a:p>
         </p:txBody>
@@ -10425,7 +10423,7 @@
                 <a:ea typeface="Microsoft YaHei"/>
                 <a:cs typeface="Microsoft YaHei"/>
               </a:rPr>
-              <a:t>教育真正缺的，不是另一个回答器；而是一种能让学生看见过程、解释过程、重做过程的 AI 创作工具。</a:t>
+              <a:t>Blocky 把 Agent 的结构、运行和解释，变成学生可以亲手编辑的积木。</a:t>
             </a:r>
           </a:p>
         </p:txBody>
@@ -10513,7 +10511,7 @@
                 <a:ea typeface="Microsoft YaHei"/>
                 <a:cs typeface="Microsoft YaHei"/>
               </a:rPr>
-              <a:t>Blocky Studio · 息壤杯 AI+教育</a:t>
+              <a:t>Blocky Studio · Agent 搭建教育</a:t>
             </a:r>
           </a:p>
         </p:txBody>
@@ -10656,7 +10654,7 @@
                 <a:ea typeface="Microsoft YaHei"/>
                 <a:cs typeface="Microsoft YaHei"/>
               </a:rPr>
-              <a:t>OPPORTUNITY · 政策与规模</a:t>
+              <a:t>OPPORTUNITY · Agent 教育机会</a:t>
             </a:r>
           </a:p>
         </p:txBody>
@@ -10713,7 +10711,7 @@
                 <a:ea typeface="Microsoft YaHei"/>
                 <a:cs typeface="Microsoft YaHei"/>
               </a:rPr>
-              <a:t>AI 素养正在从“会使用”升级到“会理解、会创造、会负责”</a:t>
+              <a:t>Agent 搭建正在成为人工智能教育的下一步实践</a:t>
             </a:r>
           </a:p>
         </p:txBody>
@@ -11211,7 +11209,7 @@
                 <a:ea typeface="Microsoft YaHei"/>
                 <a:cs typeface="Microsoft YaHei"/>
               </a:rPr>
-              <a:t>全国教育体系规模口径，仅用于说明基础覆盖面，不等同于 Blocky 的可服务市场或收入预测。</a:t>
+              <a:t>全国教育体系规模，为 Agent 搭建课程提供广泛的课堂入口。</a:t>
             </a:r>
           </a:p>
         </p:txBody>
@@ -11301,7 +11299,7 @@
                 <a:ea typeface="Microsoft YaHei"/>
                 <a:cs typeface="Microsoft YaHei"/>
               </a:rPr>
-              <a:t>政策信号</a:t>
+              <a:t>政策方向</a:t>
             </a:r>
           </a:p>
         </p:txBody>
@@ -11358,7 +11356,7 @@
                 <a:ea typeface="Microsoft YaHei"/>
                 <a:cs typeface="Microsoft YaHei"/>
               </a:rPr>
-              <a:t>• 国家教育数字化持续推进</a:t>
+              <a:t>• 教育数字化持续推进</a:t>
             </a:r>
           </a:p>
           <a:p xmlns:a="http://schemas.openxmlformats.org/drawingml/2006/main">
@@ -11382,7 +11380,7 @@
                 <a:ea typeface="Microsoft YaHei"/>
                 <a:cs typeface="Microsoft YaHei"/>
               </a:rPr>
-              <a:t>• 人工智能助力教育变革</a:t>
+              <a:t>• 人工智能助力教学变革</a:t>
             </a:r>
           </a:p>
           <a:p xmlns:a="http://schemas.openxmlformats.org/drawingml/2006/main">
@@ -11406,7 +11404,7 @@
                 <a:ea typeface="Microsoft YaHei"/>
                 <a:cs typeface="Microsoft YaHei"/>
               </a:rPr>
-              <a:t>• 强化师生数字素养与技能</a:t>
+              <a:t>• 强调实践、创造与问题解决</a:t>
             </a:r>
           </a:p>
           <a:p xmlns:a="http://schemas.openxmlformats.org/drawingml/2006/main">
@@ -11430,7 +11428,7 @@
                 <a:ea typeface="Microsoft YaHei"/>
                 <a:cs typeface="Microsoft YaHei"/>
               </a:rPr>
-              <a:t>• 同步强调安全、伦理与规范</a:t>
+              <a:t>• 同步重视安全、伦理与规范</a:t>
             </a:r>
           </a:p>
         </p:txBody>
@@ -11520,7 +11518,7 @@
                 <a:ea typeface="Microsoft YaHei"/>
                 <a:cs typeface="Microsoft YaHei"/>
               </a:rPr>
-              <a:t>Blocky 的首批人群</a:t>
+              <a:t>Agent 教育入口</a:t>
             </a:r>
           </a:p>
         </p:txBody>
@@ -11601,7 +11599,7 @@
                 <a:ea typeface="Microsoft YaHei"/>
                 <a:cs typeface="Microsoft YaHei"/>
               </a:rPr>
-              <a:t>职业教育与高校 AI 入门课程</a:t>
+              <a:t>职教与高校 Agent 入门课程</a:t>
             </a:r>
           </a:p>
           <a:p xmlns:a="http://schemas.openxmlformats.org/drawingml/2006/main">
@@ -11625,7 +11623,7 @@
                 <a:ea typeface="Microsoft YaHei"/>
                 <a:cs typeface="Microsoft YaHei"/>
               </a:rPr>
-              <a:t>需要设计 AI 项目的教师创作者</a:t>
+              <a:t>设计 Agent 项目的教师创作者</a:t>
             </a:r>
           </a:p>
         </p:txBody>
@@ -11713,7 +11711,7 @@
                 <a:ea typeface="Microsoft YaHei"/>
                 <a:cs typeface="Microsoft YaHei"/>
               </a:rPr>
-              <a:t>Blocky Studio · 息壤杯 AI+教育</a:t>
+              <a:t>Blocky Studio · Agent 搭建教育</a:t>
             </a:r>
           </a:p>
         </p:txBody>
@@ -11856,7 +11854,7 @@
                 <a:ea typeface="Microsoft YaHei"/>
                 <a:cs typeface="Microsoft YaHei"/>
               </a:rPr>
-              <a:t>PRODUCT · 产品形态</a:t>
+              <a:t>PRODUCT · Agent 搭建形态</a:t>
             </a:r>
           </a:p>
         </p:txBody>
@@ -11915,7 +11913,7 @@
                 <a:ea typeface="Microsoft YaHei"/>
                 <a:cs typeface="Microsoft YaHei"/>
               </a:rPr>
-              <a:t>一套 Scratch 式语言，贯通入门视图与专业创作</a:t>
+              <a:t>一套 Scratch 式 Agent 语言，贯通入门搭建与专业工程</a:t>
             </a:r>
           </a:p>
         </p:txBody>
@@ -11974,7 +11972,7 @@
                 <a:ea typeface="Microsoft YaHei"/>
                 <a:cs typeface="Microsoft YaHei"/>
               </a:rPr>
-              <a:t>左：积木库｜中：多画布 / 浏览器｜右：构建助手 / 运行 Agent｜下：问题 / 日志 / 终端 / 输出</a:t>
+              <a:t>左：Agent 积木库｜中：模块画布 / 浏览器｜右：构建助手 / 运行 Agent｜下：诊断 / 日志 / 终端 / 输出</a:t>
             </a:r>
           </a:p>
         </p:txBody>
@@ -12021,7 +12019,7 @@
           <p:nvPr/>
         </p:nvPicPr>
         <p:blipFill>
-          <a:blip xmlns:r="http://schemas.openxmlformats.org/officeDocument/2006/relationships" xmlns:a="http://schemas.openxmlformats.org/drawingml/2006/main" r:embed="R5035421f489540ac"/>
+          <a:blip xmlns:r="http://schemas.openxmlformats.org/officeDocument/2006/relationships" xmlns:a="http://schemas.openxmlformats.org/drawingml/2006/main" r:embed="Rc7793aa13c044f8b"/>
           <a:srcRect xmlns:a="http://schemas.openxmlformats.org/drawingml/2006/main" l="0" t="2671" r="0" b="2671"/>
           <a:stretch xmlns:a="http://schemas.openxmlformats.org/drawingml/2006/main">
             <a:fillRect l="0" t="0" r="0" b="0"/>
@@ -12124,7 +12122,7 @@
                 <a:ea typeface="Microsoft YaHei"/>
                 <a:cs typeface="Microsoft YaHei"/>
               </a:rPr>
-              <a:t>Windows Core 实证画面</a:t>
+              <a:t>Windows Core · Agent 搭建实证</a:t>
             </a:r>
           </a:p>
         </p:txBody>
@@ -12905,7 +12903,7 @@
                 <a:ea typeface="Microsoft YaHei"/>
                 <a:cs typeface="Microsoft YaHei"/>
               </a:rPr>
-              <a:t>同一 Project Manifest / Workspace / IR</a:t>
+              <a:t>统一 Agent 项目格式</a:t>
             </a:r>
           </a:p>
           <a:p xmlns:a="http://schemas.openxmlformats.org/drawingml/2006/main">
@@ -12929,7 +12927,7 @@
                 <a:ea typeface="Microsoft YaHei"/>
                 <a:cs typeface="Microsoft YaHei"/>
               </a:rPr>
-              <a:t>共享运行内核、权限模型与项目格式</a:t>
+              <a:t>共享 IR、运行内核与权限模型</a:t>
             </a:r>
           </a:p>
         </p:txBody>
@@ -13017,7 +13015,7 @@
                 <a:ea typeface="Microsoft YaHei"/>
                 <a:cs typeface="Microsoft YaHei"/>
               </a:rPr>
-              <a:t>Blocky Studio · 息壤杯 AI+教育</a:t>
+              <a:t>Blocky Studio · Agent 搭建教育</a:t>
             </a:r>
           </a:p>
         </p:txBody>
@@ -13160,7 +13158,7 @@
                 <a:ea typeface="Microsoft YaHei"/>
                 <a:cs typeface="Microsoft YaHei"/>
               </a:rPr>
-              <a:t>USE CASE · 教育场景</a:t>
+              <a:t>USE CASE · Agent 课堂</a:t>
             </a:r>
           </a:p>
         </p:txBody>
@@ -13217,7 +13215,7 @@
                 <a:ea typeface="Microsoft YaHei"/>
                 <a:cs typeface="Microsoft YaHei"/>
               </a:rPr>
-              <a:t>一节 45 分钟课，完成“课堂知识小老师”</a:t>
+              <a:t>一节 45 分钟课，搭出“课堂知识 Agent”</a:t>
             </a:r>
           </a:p>
         </p:txBody>
@@ -13274,7 +13272,7 @@
                 <a:ea typeface="Microsoft YaHei"/>
                 <a:cs typeface="Microsoft YaHei"/>
               </a:rPr>
-              <a:t>把课程资料变成可追溯问答伙伴，让学生同时练习构造、验证与表达。</a:t>
+              <a:t>学生组合角色、资料检索、回答规则与权限，再用运行证据讲清系统。</a:t>
             </a:r>
           </a:p>
         </p:txBody>
@@ -13450,7 +13448,7 @@
                 <a:ea typeface="Microsoft YaHei"/>
                 <a:cs typeface="Microsoft YaHei"/>
               </a:rPr>
-              <a:t>老师准备</a:t>
+              <a:t>老师设定任务</a:t>
             </a:r>
           </a:p>
         </p:txBody>
@@ -13531,7 +13529,7 @@
                 <a:ea typeface="Microsoft YaHei"/>
                 <a:cs typeface="Microsoft YaHei"/>
               </a:rPr>
-              <a:t>定义回答边界</a:t>
+              <a:t>定义 Agent 边界</a:t>
             </a:r>
           </a:p>
         </p:txBody>
@@ -13676,7 +13674,7 @@
                 <a:ea typeface="Microsoft YaHei"/>
                 <a:cs typeface="Microsoft YaHei"/>
               </a:rPr>
-              <a:t>学生搭建</a:t>
+              <a:t>学生搭 Agent</a:t>
             </a:r>
           </a:p>
         </p:txBody>
@@ -13902,7 +13900,7 @@
                 <a:ea typeface="Microsoft YaHei"/>
                 <a:cs typeface="Microsoft YaHei"/>
               </a:rPr>
-              <a:t>运行观察</a:t>
+              <a:t>运行 Agent</a:t>
             </a:r>
           </a:p>
         </p:txBody>
@@ -13959,7 +13957,7 @@
                 <a:ea typeface="Microsoft YaHei"/>
                 <a:cs typeface="Microsoft YaHei"/>
               </a:rPr>
-              <a:t>答案带引用</a:t>
+              <a:t>回答带引用</a:t>
             </a:r>
           </a:p>
           <a:p xmlns:a="http://schemas.openxmlformats.org/drawingml/2006/main">
@@ -14128,7 +14126,7 @@
                 <a:ea typeface="Microsoft YaHei"/>
                 <a:cs typeface="Microsoft YaHei"/>
               </a:rPr>
-              <a:t>讲解反思</a:t>
+              <a:t>解释系统</a:t>
             </a:r>
           </a:p>
         </p:txBody>
@@ -14209,7 +14207,7 @@
                 <a:ea typeface="Microsoft YaHei"/>
                 <a:cs typeface="Microsoft YaHei"/>
               </a:rPr>
-              <a:t>解释回答或拒答</a:t>
+              <a:t>解释回答与拒答</a:t>
             </a:r>
           </a:p>
         </p:txBody>
@@ -14299,7 +14297,7 @@
                 <a:ea typeface="Microsoft YaHei"/>
                 <a:cs typeface="Microsoft YaHei"/>
               </a:rPr>
-              <a:t>可验证学习结果：搭得出  ·  说得清  ·  引得准  ·  复现得了</a:t>
+              <a:t>学习成果：Agent 搭得出 · 结构说得清 · 引用找得到 · 重开仍一致</a:t>
             </a:r>
           </a:p>
         </p:txBody>
@@ -14387,7 +14385,7 @@
                 <a:ea typeface="Microsoft YaHei"/>
                 <a:cs typeface="Microsoft YaHei"/>
               </a:rPr>
-              <a:t>Blocky Studio · 息壤杯 AI+教育</a:t>
+              <a:t>Blocky Studio · Agent 搭建教育</a:t>
             </a:r>
           </a:p>
         </p:txBody>
@@ -14530,7 +14528,7 @@
                 <a:ea typeface="Microsoft YaHei"/>
                 <a:cs typeface="Microsoft YaHei"/>
               </a:rPr>
-              <a:t>DEMO · 核心闭环</a:t>
+              <a:t>DEMO · Agent 闭环</a:t>
             </a:r>
           </a:p>
         </p:txBody>
@@ -14587,7 +14585,7 @@
                 <a:ea typeface="Microsoft YaHei"/>
                 <a:cs typeface="Microsoft YaHei"/>
               </a:rPr>
-              <a:t>技术实证闭环覆盖 5 个关键步骤</a:t>
+              <a:t>3 分钟完成 Agent 搭建与运行闭环</a:t>
             </a:r>
           </a:p>
         </p:txBody>
@@ -14644,7 +14642,7 @@
                 <a:ea typeface="Microsoft YaHei"/>
                 <a:cs typeface="Microsoft YaHei"/>
               </a:rPr>
-              <a:t>确定性本地夹具稳定呈现“创建—运行—解释—保存—重开”。</a:t>
+              <a:t>确定性本地实证呈现“选蓝图—改积木—跑 Agent—看轨迹—存项目”。</a:t>
             </a:r>
           </a:p>
         </p:txBody>
@@ -14972,7 +14970,7 @@
                 <a:ea typeface="Microsoft YaHei"/>
                 <a:cs typeface="Microsoft YaHei"/>
               </a:rPr>
-              <a:t>资料问答伙伴</a:t>
+              <a:t>课堂知识 Agent</a:t>
             </a:r>
           </a:p>
         </p:txBody>
@@ -15119,7 +15117,7 @@
                 <a:ea typeface="Microsoft YaHei"/>
                 <a:cs typeface="Microsoft YaHei"/>
               </a:rPr>
-              <a:t>编辑积木</a:t>
+              <a:t>配置积木</a:t>
             </a:r>
           </a:p>
         </p:txBody>
@@ -15176,7 +15174,7 @@
                 <a:ea typeface="Microsoft YaHei"/>
                 <a:cs typeface="Microsoft YaHei"/>
               </a:rPr>
-              <a:t>角色 / 知识 / 风格</a:t>
+              <a:t>角色 / 知识 / 工具</a:t>
             </a:r>
           </a:p>
         </p:txBody>
@@ -15323,7 +15321,7 @@
                 <a:ea typeface="Microsoft YaHei"/>
                 <a:cs typeface="Microsoft YaHei"/>
               </a:rPr>
-              <a:t>运行回答</a:t>
+              <a:t>运行 Agent</a:t>
             </a:r>
           </a:p>
         </p:txBody>
@@ -15527,7 +15525,7 @@
                 <a:ea typeface="Microsoft YaHei"/>
                 <a:cs typeface="Microsoft YaHei"/>
               </a:rPr>
-              <a:t>观察轨迹</a:t>
+              <a:t>检查轨迹</a:t>
             </a:r>
           </a:p>
         </p:txBody>
@@ -15584,7 +15582,7 @@
                 <a:ea typeface="Microsoft YaHei"/>
                 <a:cs typeface="Microsoft YaHei"/>
               </a:rPr>
-              <a:t>绿 / 黄 / 红状态</a:t>
+              <a:t>步骤 / 状态 / 输出</a:t>
             </a:r>
           </a:p>
         </p:txBody>
@@ -15788,7 +15786,7 @@
                 <a:ea typeface="Microsoft YaHei"/>
                 <a:cs typeface="Microsoft YaHei"/>
               </a:rPr>
-              <a:t>行为保持一致</a:t>
+              <a:t>Agent 行为一致</a:t>
             </a:r>
           </a:p>
         </p:txBody>
@@ -15968,7 +15966,7 @@
                 <a:ea typeface="Microsoft YaHei"/>
                 <a:cs typeface="Microsoft YaHei"/>
               </a:rPr>
-              <a:t>确定性本地演示</a:t>
+              <a:t>本地 Agent 实证</a:t>
             </a:r>
           </a:p>
         </p:txBody>
@@ -16205,7 +16203,7 @@
                 <a:ea typeface="Microsoft YaHei"/>
                 <a:cs typeface="Microsoft YaHei"/>
               </a:rPr>
-              <a:t>证据不足清晰提示</a:t>
+              <a:t>拒答与引用可见</a:t>
             </a:r>
           </a:p>
         </p:txBody>
@@ -16442,7 +16440,7 @@
                 <a:ea typeface="Microsoft YaHei"/>
                 <a:cs typeface="Microsoft YaHei"/>
               </a:rPr>
-              <a:t>重开仍可复现</a:t>
+              <a:t>Agent 项目可复现</a:t>
             </a:r>
           </a:p>
         </p:txBody>
@@ -16499,7 +16497,7 @@
                 <a:ea typeface="Microsoft YaHei"/>
                 <a:cs typeface="Microsoft YaHei"/>
               </a:rPr>
-              <a:t>项目语义与会话状态分离</a:t>
+              <a:t>语义与会话状态分离</a:t>
             </a:r>
           </a:p>
         </p:txBody>
@@ -16589,7 +16587,7 @@
                 <a:ea typeface="Microsoft YaHei"/>
                 <a:cs typeface="Microsoft YaHei"/>
               </a:rPr>
-              <a:t>核心闭环：五步可复现</a:t>
+              <a:t>Agent 闭环：五步可复现</a:t>
             </a:r>
           </a:p>
         </p:txBody>
@@ -16677,7 +16675,7 @@
                 <a:ea typeface="Microsoft YaHei"/>
                 <a:cs typeface="Microsoft YaHei"/>
               </a:rPr>
-              <a:t>Blocky Studio · 息壤杯 AI+教育</a:t>
+              <a:t>Blocky Studio · Agent 搭建教育</a:t>
             </a:r>
           </a:p>
         </p:txBody>
@@ -16820,7 +16818,7 @@
                 <a:ea typeface="Microsoft YaHei"/>
                 <a:cs typeface="Microsoft YaHei"/>
               </a:rPr>
-              <a:t>INNOVATION · 技术与教育创新</a:t>
+              <a:t>INNOVATION · Agent 语义</a:t>
             </a:r>
           </a:p>
         </p:txBody>
@@ -16879,7 +16877,7 @@
                 <a:ea typeface="Microsoft YaHei"/>
                 <a:cs typeface="Microsoft YaHei"/>
               </a:rPr>
-              <a:t>壁垒不是积木数量，而是可验证、可回放、可逆的语义链</a:t>
+              <a:t>壁垒是一条可验证、可回放、可逆的 Agent 语义链</a:t>
             </a:r>
           </a:p>
         </p:txBody>
@@ -16938,7 +16936,7 @@
                 <a:ea typeface="Microsoft YaHei"/>
                 <a:cs typeface="Microsoft YaHei"/>
               </a:rPr>
-              <a:t>一条语义链同时服务学生理解、系统执行、教师复核与主流 Agent 兼容。</a:t>
+              <a:t>同一套 Agent 结构同时服务学生搭建、运行执行、教师复核与原生兼容。</a:t>
             </a:r>
           </a:p>
         </p:txBody>
@@ -17380,7 +17378,31 @@
                 <a:ea typeface="Microsoft YaHei"/>
                 <a:cs typeface="Microsoft YaHei"/>
               </a:rPr>
-              <a:t>可见积木 AST</a:t>
+              <a:t>可见 Agent</a:t>
+            </a:r>
+          </a:p>
+          <a:p xmlns:a="http://schemas.openxmlformats.org/drawingml/2006/main">
+            <a:pPr algn="ctr">
+              <a:buNone/>
+              <a:defRPr sz="1725" b="1" i="0">
+                <a:solidFill>
+                  <a:srgbClr val="FFFFFF"/>
+                </a:solidFill>
+                <a:latin typeface="Microsoft YaHei"/>
+                <a:ea typeface="Microsoft YaHei"/>
+                <a:cs typeface="Microsoft YaHei"/>
+              </a:defRPr>
+            </a:pPr>
+            <a:r>
+              <a:rPr sz="1725" b="1" i="0">
+                <a:solidFill>
+                  <a:srgbClr val="FFFFFF"/>
+                </a:solidFill>
+                <a:latin typeface="Microsoft YaHei"/>
+                <a:ea typeface="Microsoft YaHei"/>
+                <a:cs typeface="Microsoft YaHei"/>
+              </a:rPr>
+              <a:t>积木</a:t>
             </a:r>
           </a:p>
         </p:txBody>
@@ -17527,7 +17549,7 @@
                 <a:ea typeface="Microsoft YaHei"/>
                 <a:cs typeface="Microsoft YaHei"/>
               </a:rPr>
-              <a:t>稳定 IR</a:t>
+              <a:t>稳定 Agent IR</a:t>
             </a:r>
           </a:p>
         </p:txBody>
@@ -17584,7 +17606,7 @@
                 <a:ea typeface="Microsoft YaHei"/>
                 <a:cs typeface="Microsoft YaHei"/>
               </a:rPr>
-              <a:t>系统能校验</a:t>
+              <a:t>系统能校验 Agent</a:t>
             </a:r>
           </a:p>
         </p:txBody>
@@ -17821,7 +17843,7 @@
                 <a:ea typeface="Microsoft YaHei"/>
                 <a:cs typeface="Microsoft YaHei"/>
               </a:rPr>
-              <a:t>可回放 Trace</a:t>
+              <a:t>Agent Trace</a:t>
             </a:r>
           </a:p>
         </p:txBody>
@@ -17878,7 +17900,7 @@
                 <a:ea typeface="Microsoft YaHei"/>
                 <a:cs typeface="Microsoft YaHei"/>
               </a:rPr>
-              <a:t>过程能解释</a:t>
+              <a:t>每步可回放解释</a:t>
             </a:r>
           </a:p>
         </p:txBody>
@@ -18121,7 +18143,7 @@
                 <a:ea typeface="Microsoft YaHei"/>
                 <a:cs typeface="Microsoft YaHei"/>
               </a:rPr>
-              <a:t>同一语义链服务桌面、CLI、四个官方 Skills 与六个兼容模板</a:t>
+              <a:t>同一 Agent 语义链贯通桌面、CLI、四个官方 Skills 与六模板兼容版图</a:t>
             </a:r>
           </a:p>
         </p:txBody>
@@ -18292,7 +18314,7 @@
                 <a:ea typeface="Microsoft YaHei"/>
                 <a:cs typeface="Microsoft YaHei"/>
               </a:rPr>
-              <a:t>Blocky Studio · 息壤杯 AI+教育</a:t>
+              <a:t>Blocky Studio · Agent 搭建教育</a:t>
             </a:r>
           </a:p>
         </p:txBody>
@@ -18435,7 +18457,7 @@
                 <a:ea typeface="Microsoft YaHei"/>
                 <a:cs typeface="Microsoft YaHei"/>
               </a:rPr>
-              <a:t>DIFFERENTIATION · 差异化</a:t>
+              <a:t>ECOSYSTEM · Agent 兼容版图</a:t>
             </a:r>
           </a:p>
         </p:txBody>
@@ -18494,7 +18516,7 @@
                 <a:ea typeface="Microsoft YaHei"/>
                 <a:cs typeface="Microsoft YaHei"/>
               </a:rPr>
-              <a:t>六模板兼容版图，定义主流 Agent 的积木化路径</a:t>
+              <a:t>六类 Agent 生态，共用一套可改造的积木语言</a:t>
             </a:r>
           </a:p>
         </p:txBody>
@@ -18708,7 +18730,7 @@
                 <a:ea typeface="Microsoft YaHei"/>
                 <a:cs typeface="Microsoft YaHei"/>
               </a:rPr>
-              <a:t>规划覆盖六类 Agent 生态，共享项目格式、积木语言、运行内核和安全模型。</a:t>
+              <a:t>Pi、Codex、OpenClaw、Hermes、OpenCode、DeepSeek Harness 映射到统一 Agent 项目。</a:t>
             </a:r>
           </a:p>
         </p:txBody>
@@ -18767,7 +18789,7 @@
                 <a:ea typeface="Microsoft YaHei"/>
                 <a:cs typeface="Microsoft YaHei"/>
               </a:rPr>
-              <a:t>固定上游版本 + 进程外原生运行时 + 版本化适配器 + 可逆积木投影</a:t>
+              <a:t>统一 Agent 语义 + 进程外原生运行时 + 版本化适配器 + 可逆积木投影</a:t>
             </a:r>
           </a:p>
         </p:txBody>
@@ -18855,7 +18877,7 @@
                 <a:ea typeface="Microsoft YaHei"/>
                 <a:cs typeface="Microsoft YaHei"/>
               </a:rPr>
-              <a:t>聊天式回答器</a:t>
+              <a:t>问答型 Agent</a:t>
             </a:r>
           </a:p>
         </p:txBody>
@@ -18943,7 +18965,7 @@
                 <a:ea typeface="Microsoft YaHei"/>
                 <a:cs typeface="Microsoft YaHei"/>
               </a:rPr>
-              <a:t>连线式工作流</a:t>
+              <a:t>流程编排工具</a:t>
             </a:r>
           </a:p>
         </p:txBody>
@@ -19031,7 +19053,7 @@
                 <a:ea typeface="Microsoft YaHei"/>
                 <a:cs typeface="Microsoft YaHei"/>
               </a:rPr>
-              <a:t>代码框架</a:t>
+              <a:t>代码型 Agent</a:t>
             </a:r>
           </a:p>
         </p:txBody>
@@ -19207,31 +19229,7 @@
                 <a:ea typeface="Microsoft YaHei"/>
                 <a:cs typeface="Microsoft YaHei"/>
               </a:rPr>
-              <a:t>易上手</a:t>
-            </a:r>
-          </a:p>
-          <a:p xmlns:a="http://schemas.openxmlformats.org/drawingml/2006/main">
-            <a:pPr algn="ctr">
-              <a:buNone/>
-              <a:defRPr sz="1800" b="1" i="0">
-                <a:solidFill>
-                  <a:srgbClr val="176BFF"/>
-                </a:solidFill>
-                <a:latin typeface="Microsoft YaHei"/>
-                <a:ea typeface="Microsoft YaHei"/>
-                <a:cs typeface="Microsoft YaHei"/>
-              </a:defRPr>
-            </a:pPr>
-            <a:r>
-              <a:rPr sz="1800" b="1" i="0">
-                <a:solidFill>
-                  <a:srgbClr val="176BFF"/>
-                </a:solidFill>
-                <a:latin typeface="Microsoft YaHei"/>
-                <a:ea typeface="Microsoft YaHei"/>
-                <a:cs typeface="Microsoft YaHei"/>
-              </a:rPr>
-              <a:t>可成长</a:t>
+              <a:t>积木搭建 / 深度扩展</a:t>
             </a:r>
           </a:p>
         </p:txBody>
@@ -19288,7 +19286,7 @@
                 <a:ea typeface="Microsoft YaHei"/>
                 <a:cs typeface="Microsoft YaHei"/>
               </a:rPr>
-              <a:t>入门七类</a:t>
+              <a:t>入门 Agent</a:t>
             </a:r>
           </a:p>
           <a:p xmlns:a="http://schemas.openxmlformats.org/drawingml/2006/main">
@@ -19336,7 +19334,7 @@
                 <a:ea typeface="Microsoft YaHei"/>
                 <a:cs typeface="Microsoft YaHei"/>
               </a:rPr>
-              <a:t>专业十二类</a:t>
+              <a:t>专业 Agent</a:t>
             </a:r>
           </a:p>
           <a:p xmlns:a="http://schemas.openxmlformats.org/drawingml/2006/main">
@@ -19491,7 +19489,7 @@
                 <a:ea typeface="Microsoft YaHei"/>
                 <a:cs typeface="Microsoft YaHei"/>
               </a:rPr>
-              <a:t>兼容方法：锁定版本 → 结构映射 → 配置往返 → 行为对照 → 可逆写回</a:t>
+              <a:t>兼容结果：公共语义可编辑，原生能力可定位，项目配置可逆写回</a:t>
             </a:r>
           </a:p>
         </p:txBody>
@@ -19579,7 +19577,7 @@
                 <a:ea typeface="Microsoft YaHei"/>
                 <a:cs typeface="Microsoft YaHei"/>
               </a:rPr>
-              <a:t>Blocky Studio · 息壤杯 AI+教育</a:t>
+              <a:t>Blocky Studio · Agent 搭建教育</a:t>
             </a:r>
           </a:p>
         </p:txBody>
@@ -19852,7 +19850,7 @@
                 <a:ea typeface="Microsoft YaHei"/>
                 <a:cs typeface="Microsoft YaHei"/>
               </a:rPr>
-              <a:t>轻量代码助手</a:t>
+              <a:t>轻量编码 Agent</a:t>
             </a:r>
           </a:p>
         </p:txBody>
@@ -19970,7 +19968,7 @@
                 <a:ea typeface="Microsoft YaHei"/>
                 <a:cs typeface="Microsoft YaHei"/>
               </a:rPr>
-              <a:t>极简 Agent · read / write / edit / bash</a:t>
+              <a:t>工具调用 · 文件读写 · Shell</a:t>
             </a:r>
           </a:p>
         </p:txBody>
@@ -20186,7 +20184,7 @@
                 <a:ea typeface="Microsoft YaHei"/>
                 <a:cs typeface="Microsoft YaHei"/>
               </a:rPr>
-              <a:t>专业编程助手</a:t>
+              <a:t>专业编程 Agent</a:t>
             </a:r>
           </a:p>
         </p:txBody>
@@ -20304,7 +20302,7 @@
                 <a:ea typeface="Microsoft YaHei"/>
                 <a:cs typeface="Microsoft YaHei"/>
               </a:rPr>
-              <a:t>AGENTS.md · Skills · MCP · 沙箱 / 审批</a:t>
+              <a:t>AGENTS.md · Skills · MCP · 沙箱</a:t>
             </a:r>
           </a:p>
         </p:txBody>
@@ -20520,7 +20518,7 @@
                 <a:ea typeface="Microsoft YaHei"/>
                 <a:cs typeface="Microsoft YaHei"/>
               </a:rPr>
-              <a:t>个人全能助理</a:t>
+              <a:t>个人助理 Agent</a:t>
             </a:r>
           </a:p>
         </p:txBody>
@@ -20638,7 +20636,7 @@
                 <a:ea typeface="Microsoft YaHei"/>
                 <a:cs typeface="Microsoft YaHei"/>
               </a:rPr>
-              <a:t>Gateway · 会话 · 记忆 · Channels</a:t>
+              <a:t>Gateway · 会话 · 记忆 · 渠道</a:t>
             </a:r>
           </a:p>
         </p:txBody>
@@ -20854,7 +20852,7 @@
                 <a:ea typeface="Microsoft YaHei"/>
                 <a:cs typeface="Microsoft YaHei"/>
               </a:rPr>
-              <a:t>团队协作中枢</a:t>
+              <a:t>团队协作 Agent</a:t>
             </a:r>
           </a:p>
         </p:txBody>
@@ -20972,7 +20970,7 @@
                 <a:ea typeface="Microsoft YaHei"/>
                 <a:cs typeface="Microsoft YaHei"/>
               </a:rPr>
-              <a:t>团队协作 · 消息 · 任务 · 扩展</a:t>
+              <a:t>协作 · 消息 · 任务 · 扩展</a:t>
             </a:r>
           </a:p>
         </p:txBody>
@@ -21188,7 +21186,7 @@
                 <a:ea typeface="Microsoft YaHei"/>
                 <a:cs typeface="Microsoft YaHei"/>
               </a:rPr>
-              <a:t>工程开发工作台</a:t>
+              <a:t>工程开发 Agent</a:t>
             </a:r>
           </a:p>
         </p:txBody>
@@ -21306,7 +21304,7 @@
                 <a:ea typeface="Microsoft YaHei"/>
                 <a:cs typeface="Microsoft YaHei"/>
               </a:rPr>
-              <a:t>主 / 子 Agent · 工具权限 · MCP · 插件</a:t>
+              <a:t>主 / 子 Agent · 工具权限 · 插件</a:t>
             </a:r>
           </a:p>
         </p:txBody>
@@ -21522,7 +21520,7 @@
                 <a:ea typeface="Microsoft YaHei"/>
                 <a:cs typeface="Microsoft YaHei"/>
               </a:rPr>
-              <a:t>可组合研究工作台</a:t>
+              <a:t>组合研究 Agent</a:t>
             </a:r>
           </a:p>
         </p:txBody>
@@ -21640,7 +21638,7 @@
                 <a:ea typeface="Microsoft YaHei"/>
                 <a:cs typeface="Microsoft YaHei"/>
               </a:rPr>
-              <a:t>Profile · Bundle · Cordis 插件树 · 审批</a:t>
+              <a:t>Profile · Bundle · Cordis · 审批</a:t>
             </a:r>
           </a:p>
         </p:txBody>
@@ -21726,7 +21724,7 @@
                 <a:ea typeface="Microsoft YaHei"/>
                 <a:cs typeface="Microsoft YaHei"/>
               </a:rPr>
-              <a:t>EVIDENCE · 技术实证</a:t>
+              <a:t>EVIDENCE · Agent 内核实证</a:t>
             </a:r>
           </a:p>
         </p:txBody>
@@ -21785,7 +21783,7 @@
                 <a:ea typeface="Microsoft YaHei"/>
                 <a:cs typeface="Microsoft YaHei"/>
               </a:rPr>
-              <a:t>技术实证与正式契约，共同支撑产品演进</a:t>
+              <a:t>Agent 搭建与运行链路，已有可复现技术证据</a:t>
             </a:r>
           </a:p>
         </p:txBody>
@@ -21842,7 +21840,7 @@
                 <a:ea typeface="Microsoft YaHei"/>
                 <a:cs typeface="Microsoft YaHei"/>
               </a:rPr>
-              <a:t>从编辑、编译、运行到权限与可观察性，关键链路都有可复现证据。</a:t>
+              <a:t>Windows Core 实证与正式契约共同支撑 Agent 产品地基。</a:t>
             </a:r>
           </a:p>
         </p:txBody>
@@ -21965,7 +21963,7 @@
                 <a:ea typeface="Microsoft YaHei"/>
                 <a:cs typeface="Microsoft YaHei"/>
               </a:rPr>
-              <a:t>已验证 · Windows Core 技术尖峰</a:t>
+              <a:t>已验证 · Agent Core 技术尖峰</a:t>
             </a:r>
           </a:p>
         </p:txBody>
@@ -22022,7 +22020,7 @@
                 <a:ea typeface="Microsoft YaHei"/>
                 <a:cs typeface="Microsoft YaHei"/>
               </a:rPr>
-              <a:t>✓ 本地 Blockly 与稳定 IR</a:t>
+              <a:t>✓ 本地 Blockly 与稳定 Agent IR</a:t>
             </a:r>
           </a:p>
           <a:p xmlns:a="http://schemas.openxmlformats.org/drawingml/2006/main">
@@ -22070,7 +22068,7 @@
                 <a:ea typeface="Microsoft YaHei"/>
                 <a:cs typeface="Microsoft YaHei"/>
               </a:rPr>
-              <a:t>✓ 确定性运行时与窄 Tauri Host</a:t>
+              <a:t>✓ 确定性 Agent Runtime 与窄 Tauri Host</a:t>
             </a:r>
           </a:p>
           <a:p xmlns:a="http://schemas.openxmlformats.org/drawingml/2006/main">
@@ -22094,7 +22092,7 @@
                 <a:ea typeface="Microsoft YaHei"/>
                 <a:cs typeface="Microsoft YaHei"/>
               </a:rPr>
-              <a:t>✓ 100 积木保存—重开</a:t>
+              <a:t>✓ 100 积木 Agent 项目保存—重开</a:t>
             </a:r>
           </a:p>
           <a:p xmlns:a="http://schemas.openxmlformats.org/drawingml/2006/main">
@@ -22175,7 +22173,7 @@
                 <a:ea typeface="Microsoft YaHei"/>
                 <a:cs typeface="Microsoft YaHei"/>
               </a:rPr>
-              <a:t>结论：正式架构的关键风险已有可复现证据。</a:t>
+              <a:t>结论：Agent 项目核心风险已有可复现实证。</a:t>
             </a:r>
           </a:p>
         </p:txBody>
@@ -22300,7 +22298,7 @@
                 <a:ea typeface="Microsoft YaHei"/>
                 <a:cs typeface="Microsoft YaHei"/>
               </a:rPr>
-              <a:t>正式契约 · 产品地基</a:t>
+              <a:t>正式契约 · Agent 产品地基</a:t>
             </a:r>
           </a:p>
         </p:txBody>
@@ -22359,7 +22357,7 @@
                 <a:ea typeface="Microsoft YaHei"/>
                 <a:cs typeface="Microsoft YaHei"/>
               </a:rPr>
-              <a:t>✓ Project Manifest / Workspace / Module IR</a:t>
+              <a:t>✓ Agent Project Manifest / Module Workspace / IR</a:t>
             </a:r>
           </a:p>
           <a:p xmlns:a="http://schemas.openxmlformats.org/drawingml/2006/main">
@@ -22407,7 +22405,7 @@
                 <a:ea typeface="Microsoft YaHei"/>
                 <a:cs typeface="Microsoft YaHei"/>
               </a:rPr>
-              <a:t>✓ RuntimeEvent / Diagnostic / Trace</a:t>
+              <a:t>✓ RuntimeEvent / Diagnostic / Agent Trace</a:t>
             </a:r>
           </a:p>
           <a:p xmlns:a="http://schemas.openxmlformats.org/drawingml/2006/main">
@@ -22493,7 +22491,7 @@
           <p:nvPr/>
         </p:nvPicPr>
         <p:blipFill>
-          <a:blip xmlns:r="http://schemas.openxmlformats.org/officeDocument/2006/relationships" xmlns:a="http://schemas.openxmlformats.org/drawingml/2006/main" r:embed="R4ea63e36af844c30"/>
+          <a:blip xmlns:r="http://schemas.openxmlformats.org/officeDocument/2006/relationships" xmlns:a="http://schemas.openxmlformats.org/drawingml/2006/main" r:embed="Rbf5a4885428546ec"/>
           <a:srcRect xmlns:a="http://schemas.openxmlformats.org/drawingml/2006/main" l="0" t="11290" r="0" b="11290"/>
           <a:stretch xmlns:a="http://schemas.openxmlformats.org/drawingml/2006/main">
             <a:fillRect l="0" t="0" r="0" b="0"/>
@@ -22598,7 +22596,7 @@
                 <a:ea typeface="Microsoft YaHei"/>
                 <a:cs typeface="Microsoft YaHei"/>
               </a:rPr>
-              <a:t>统一语义设计贯通画布、CLI、官方 Skills、兼容模板与教育工作区。</a:t>
+              <a:t>同一 Agent 语义贯通画布、CLI、官方 Skills、兼容模板与教育工作区。</a:t>
             </a:r>
           </a:p>
         </p:txBody>
@@ -22686,7 +22684,7 @@
                 <a:ea typeface="Microsoft YaHei"/>
                 <a:cs typeface="Microsoft YaHei"/>
               </a:rPr>
-              <a:t>Blocky Studio · 息壤杯 AI+教育</a:t>
+              <a:t>Blocky Studio · Agent 搭建教育</a:t>
             </a:r>
           </a:p>
         </p:txBody>

</xml_diff>

<commit_message>
docs: remove POC label from contest deck
</commit_message>
<xml_diff>
--- a/PPT与商业计划书/Blocky-Studio-息壤杯-AI+教育.pptx
+++ b/PPT与商业计划书/Blocky-Studio-息壤杯-AI+教育.pptx
@@ -2,26 +2,26 @@
 <file path=ppt/presentation.xml><?xml version="1.0" encoding="utf-8"?>
 <p:presentation xmlns:p="http://schemas.openxmlformats.org/presentationml/2006/main">
   <p:sldMasterIdLst>
-    <p:sldMasterId xmlns:r="http://schemas.openxmlformats.org/officeDocument/2006/relationships" id="2147483648" r:id="R1ca7f62ca96b4d48"/>
+    <p:sldMasterId xmlns:r="http://schemas.openxmlformats.org/officeDocument/2006/relationships" id="2147483648" r:id="R843e403a480d41a1"/>
   </p:sldMasterIdLst>
   <p:notesMasterIdLst>
-    <p:notesMasterId xmlns:r="http://schemas.openxmlformats.org/officeDocument/2006/relationships" r:id="Rf28a6f5f999b4df4"/>
+    <p:notesMasterId xmlns:r="http://schemas.openxmlformats.org/officeDocument/2006/relationships" r:id="R80fec2e0116d4b45"/>
   </p:notesMasterIdLst>
   <p:sldIdLst>
-    <p:sldId xmlns:r="http://schemas.openxmlformats.org/officeDocument/2006/relationships" id="256" r:id="R3726604f802a4065"/>
-    <p:sldId xmlns:r="http://schemas.openxmlformats.org/officeDocument/2006/relationships" id="257" r:id="Rea961df0b63a4d86"/>
-    <p:sldId xmlns:r="http://schemas.openxmlformats.org/officeDocument/2006/relationships" id="258" r:id="Rbc8923049560419b"/>
-    <p:sldId xmlns:r="http://schemas.openxmlformats.org/officeDocument/2006/relationships" id="259" r:id="Rea71963cd7264798"/>
-    <p:sldId xmlns:r="http://schemas.openxmlformats.org/officeDocument/2006/relationships" id="260" r:id="R169f2d09c1884417"/>
-    <p:sldId xmlns:r="http://schemas.openxmlformats.org/officeDocument/2006/relationships" id="261" r:id="R93696ab917f2487a"/>
-    <p:sldId xmlns:r="http://schemas.openxmlformats.org/officeDocument/2006/relationships" id="262" r:id="R6012cad208534dab"/>
-    <p:sldId xmlns:r="http://schemas.openxmlformats.org/officeDocument/2006/relationships" id="263" r:id="Rd1b76f29bd844f01"/>
-    <p:sldId xmlns:r="http://schemas.openxmlformats.org/officeDocument/2006/relationships" id="264" r:id="R69928c34685f4d81"/>
-    <p:sldId xmlns:r="http://schemas.openxmlformats.org/officeDocument/2006/relationships" id="265" r:id="Ra8df9d1172174004"/>
-    <p:sldId xmlns:r="http://schemas.openxmlformats.org/officeDocument/2006/relationships" id="266" r:id="R194edeb1499d4420"/>
-    <p:sldId xmlns:r="http://schemas.openxmlformats.org/officeDocument/2006/relationships" id="267" r:id="Ra656be3c26054ca5"/>
-    <p:sldId xmlns:r="http://schemas.openxmlformats.org/officeDocument/2006/relationships" id="268" r:id="R256765449dc246e1"/>
-    <p:sldId xmlns:r="http://schemas.openxmlformats.org/officeDocument/2006/relationships" id="269" r:id="Rf7baed94c66f48a3"/>
+    <p:sldId xmlns:r="http://schemas.openxmlformats.org/officeDocument/2006/relationships" id="256" r:id="Reaa84c50050c4cf9"/>
+    <p:sldId xmlns:r="http://schemas.openxmlformats.org/officeDocument/2006/relationships" id="257" r:id="R0fe4fa1a0cf34e2c"/>
+    <p:sldId xmlns:r="http://schemas.openxmlformats.org/officeDocument/2006/relationships" id="258" r:id="Rbb1edf8cb7d5458a"/>
+    <p:sldId xmlns:r="http://schemas.openxmlformats.org/officeDocument/2006/relationships" id="259" r:id="Re9761dd4150c43e5"/>
+    <p:sldId xmlns:r="http://schemas.openxmlformats.org/officeDocument/2006/relationships" id="260" r:id="Rea3568810d3041df"/>
+    <p:sldId xmlns:r="http://schemas.openxmlformats.org/officeDocument/2006/relationships" id="261" r:id="Rd45536cee3ce4192"/>
+    <p:sldId xmlns:r="http://schemas.openxmlformats.org/officeDocument/2006/relationships" id="262" r:id="R8738bd8157d64c36"/>
+    <p:sldId xmlns:r="http://schemas.openxmlformats.org/officeDocument/2006/relationships" id="263" r:id="Rcd6950159ec54787"/>
+    <p:sldId xmlns:r="http://schemas.openxmlformats.org/officeDocument/2006/relationships" id="264" r:id="R03f8b9b8a71c4312"/>
+    <p:sldId xmlns:r="http://schemas.openxmlformats.org/officeDocument/2006/relationships" id="265" r:id="R494b8a0321ca425c"/>
+    <p:sldId xmlns:r="http://schemas.openxmlformats.org/officeDocument/2006/relationships" id="266" r:id="Rcc0226039ab14081"/>
+    <p:sldId xmlns:r="http://schemas.openxmlformats.org/officeDocument/2006/relationships" id="267" r:id="R45b5f2beaf454ef6"/>
+    <p:sldId xmlns:r="http://schemas.openxmlformats.org/officeDocument/2006/relationships" id="268" r:id="R482b13f9a8ee4af2"/>
+    <p:sldId xmlns:r="http://schemas.openxmlformats.org/officeDocument/2006/relationships" id="269" r:id="R6937cbe7eef841ce"/>
   </p:sldIdLst>
   <p:sldSz cx="12192000" cy="6858000"/>
   <p:notesSz cx="6858000" cy="9144000"/>
@@ -1818,7 +1818,7 @@
   </p:cSld>
   <p:clrMap bg1="lt1" tx1="dk1" bg2="lt2" tx2="dk2" accent1="accent1" accent2="accent2" accent3="accent3" accent4="accent4" accent5="accent5" accent6="accent6" hlink="hlink" folHlink="folHlink"/>
   <p:sldLayoutIdLst>
-    <p:sldLayoutId xmlns:r="http://schemas.openxmlformats.org/officeDocument/2006/relationships" id="2147483649" r:id="Rc614cfde60a447f0"/>
+    <p:sldLayoutId xmlns:r="http://schemas.openxmlformats.org/officeDocument/2006/relationships" id="2147483649" r:id="Rb81f76ba6d0c45dc"/>
   </p:sldLayoutIdLst>
   <p:txStyles>
     <p:titleStyle>
@@ -2466,7 +2466,7 @@
           <p:nvPr/>
         </p:nvPicPr>
         <p:blipFill>
-          <a:blip xmlns:r="http://schemas.openxmlformats.org/officeDocument/2006/relationships" xmlns:a="http://schemas.openxmlformats.org/drawingml/2006/main" r:embed="Rb3acc0412c3d47b9"/>
+          <a:blip xmlns:r="http://schemas.openxmlformats.org/officeDocument/2006/relationships" xmlns:a="http://schemas.openxmlformats.org/drawingml/2006/main" r:embed="Rf9bce5dc0e5248a7"/>
           <a:stretch xmlns:a="http://schemas.openxmlformats.org/drawingml/2006/main"/>
         </p:blipFill>
         <p:spPr>
@@ -2849,7 +2849,7 @@
                 <a:ea typeface="Microsoft YaHei"/>
                 <a:cs typeface="Microsoft YaHei"/>
               </a:rPr>
-              <a:t>参赛方案 · Agent 教育</a:t>
+              <a:t>Agent 搭建 · 教育场景</a:t>
             </a:r>
           </a:p>
         </p:txBody>
@@ -12019,7 +12019,7 @@
           <p:nvPr/>
         </p:nvPicPr>
         <p:blipFill>
-          <a:blip xmlns:r="http://schemas.openxmlformats.org/officeDocument/2006/relationships" xmlns:a="http://schemas.openxmlformats.org/drawingml/2006/main" r:embed="Rc7793aa13c044f8b"/>
+          <a:blip xmlns:r="http://schemas.openxmlformats.org/officeDocument/2006/relationships" xmlns:a="http://schemas.openxmlformats.org/drawingml/2006/main" r:embed="Re03cd830b97f4b44"/>
           <a:srcRect xmlns:a="http://schemas.openxmlformats.org/drawingml/2006/main" l="0" t="2671" r="0" b="2671"/>
           <a:stretch xmlns:a="http://schemas.openxmlformats.org/drawingml/2006/main">
             <a:fillRect l="0" t="0" r="0" b="0"/>
@@ -22491,7 +22491,7 @@
           <p:nvPr/>
         </p:nvPicPr>
         <p:blipFill>
-          <a:blip xmlns:r="http://schemas.openxmlformats.org/officeDocument/2006/relationships" xmlns:a="http://schemas.openxmlformats.org/drawingml/2006/main" r:embed="Rbf5a4885428546ec"/>
+          <a:blip xmlns:r="http://schemas.openxmlformats.org/officeDocument/2006/relationships" xmlns:a="http://schemas.openxmlformats.org/drawingml/2006/main" r:embed="Ra2ff84686f5e4cfb"/>
           <a:srcRect xmlns:a="http://schemas.openxmlformats.org/drawingml/2006/main" l="0" t="11290" r="0" b="11290"/>
           <a:stretch xmlns:a="http://schemas.openxmlformats.org/drawingml/2006/main">
             <a:fillRect l="0" t="0" r="0" b="0"/>

</xml_diff>

<commit_message>
docs: align evidence slide copy
</commit_message>
<xml_diff>
--- a/PPT与商业计划书/Blocky-Studio-息壤杯-AI+教育.pptx
+++ b/PPT与商业计划书/Blocky-Studio-息壤杯-AI+教育.pptx
@@ -2,26 +2,26 @@
 <file path=ppt/presentation.xml><?xml version="1.0" encoding="utf-8"?>
 <p:presentation xmlns:p="http://schemas.openxmlformats.org/presentationml/2006/main">
   <p:sldMasterIdLst>
-    <p:sldMasterId xmlns:r="http://schemas.openxmlformats.org/officeDocument/2006/relationships" id="2147483648" r:id="R843e403a480d41a1"/>
+    <p:sldMasterId xmlns:r="http://schemas.openxmlformats.org/officeDocument/2006/relationships" id="2147483648" r:id="Rf5c2943efab44614"/>
   </p:sldMasterIdLst>
   <p:notesMasterIdLst>
-    <p:notesMasterId xmlns:r="http://schemas.openxmlformats.org/officeDocument/2006/relationships" r:id="R80fec2e0116d4b45"/>
+    <p:notesMasterId xmlns:r="http://schemas.openxmlformats.org/officeDocument/2006/relationships" r:id="R39f2ddee2ec947a0"/>
   </p:notesMasterIdLst>
   <p:sldIdLst>
-    <p:sldId xmlns:r="http://schemas.openxmlformats.org/officeDocument/2006/relationships" id="256" r:id="Reaa84c50050c4cf9"/>
-    <p:sldId xmlns:r="http://schemas.openxmlformats.org/officeDocument/2006/relationships" id="257" r:id="R0fe4fa1a0cf34e2c"/>
-    <p:sldId xmlns:r="http://schemas.openxmlformats.org/officeDocument/2006/relationships" id="258" r:id="Rbb1edf8cb7d5458a"/>
-    <p:sldId xmlns:r="http://schemas.openxmlformats.org/officeDocument/2006/relationships" id="259" r:id="Re9761dd4150c43e5"/>
-    <p:sldId xmlns:r="http://schemas.openxmlformats.org/officeDocument/2006/relationships" id="260" r:id="Rea3568810d3041df"/>
-    <p:sldId xmlns:r="http://schemas.openxmlformats.org/officeDocument/2006/relationships" id="261" r:id="Rd45536cee3ce4192"/>
-    <p:sldId xmlns:r="http://schemas.openxmlformats.org/officeDocument/2006/relationships" id="262" r:id="R8738bd8157d64c36"/>
-    <p:sldId xmlns:r="http://schemas.openxmlformats.org/officeDocument/2006/relationships" id="263" r:id="Rcd6950159ec54787"/>
-    <p:sldId xmlns:r="http://schemas.openxmlformats.org/officeDocument/2006/relationships" id="264" r:id="R03f8b9b8a71c4312"/>
-    <p:sldId xmlns:r="http://schemas.openxmlformats.org/officeDocument/2006/relationships" id="265" r:id="R494b8a0321ca425c"/>
-    <p:sldId xmlns:r="http://schemas.openxmlformats.org/officeDocument/2006/relationships" id="266" r:id="Rcc0226039ab14081"/>
-    <p:sldId xmlns:r="http://schemas.openxmlformats.org/officeDocument/2006/relationships" id="267" r:id="R45b5f2beaf454ef6"/>
-    <p:sldId xmlns:r="http://schemas.openxmlformats.org/officeDocument/2006/relationships" id="268" r:id="R482b13f9a8ee4af2"/>
-    <p:sldId xmlns:r="http://schemas.openxmlformats.org/officeDocument/2006/relationships" id="269" r:id="R6937cbe7eef841ce"/>
+    <p:sldId xmlns:r="http://schemas.openxmlformats.org/officeDocument/2006/relationships" id="256" r:id="Rdef87392c14942ab"/>
+    <p:sldId xmlns:r="http://schemas.openxmlformats.org/officeDocument/2006/relationships" id="257" r:id="R78daefe9dae7459d"/>
+    <p:sldId xmlns:r="http://schemas.openxmlformats.org/officeDocument/2006/relationships" id="258" r:id="Rc563b0a2706e41ac"/>
+    <p:sldId xmlns:r="http://schemas.openxmlformats.org/officeDocument/2006/relationships" id="259" r:id="Redcf181eb25f4b90"/>
+    <p:sldId xmlns:r="http://schemas.openxmlformats.org/officeDocument/2006/relationships" id="260" r:id="Rc184d3cc02d84bdb"/>
+    <p:sldId xmlns:r="http://schemas.openxmlformats.org/officeDocument/2006/relationships" id="261" r:id="Rd86ecc94cd574c34"/>
+    <p:sldId xmlns:r="http://schemas.openxmlformats.org/officeDocument/2006/relationships" id="262" r:id="R1608ab2412104a08"/>
+    <p:sldId xmlns:r="http://schemas.openxmlformats.org/officeDocument/2006/relationships" id="263" r:id="Re7b9ac2f050c4b1f"/>
+    <p:sldId xmlns:r="http://schemas.openxmlformats.org/officeDocument/2006/relationships" id="264" r:id="R366933d9c03144ef"/>
+    <p:sldId xmlns:r="http://schemas.openxmlformats.org/officeDocument/2006/relationships" id="265" r:id="R5be6cab9c0e342f3"/>
+    <p:sldId xmlns:r="http://schemas.openxmlformats.org/officeDocument/2006/relationships" id="266" r:id="R280f0bde912f442d"/>
+    <p:sldId xmlns:r="http://schemas.openxmlformats.org/officeDocument/2006/relationships" id="267" r:id="Rfad0094888804e16"/>
+    <p:sldId xmlns:r="http://schemas.openxmlformats.org/officeDocument/2006/relationships" id="268" r:id="R799a41f0d7d04ef6"/>
+    <p:sldId xmlns:r="http://schemas.openxmlformats.org/officeDocument/2006/relationships" id="269" r:id="R53d5b187eef64ed5"/>
   </p:sldIdLst>
   <p:sldSz cx="12192000" cy="6858000"/>
   <p:notesSz cx="6858000" cy="9144000"/>
@@ -1818,7 +1818,7 @@
   </p:cSld>
   <p:clrMap bg1="lt1" tx1="dk1" bg2="lt2" tx2="dk2" accent1="accent1" accent2="accent2" accent3="accent3" accent4="accent4" accent5="accent5" accent6="accent6" hlink="hlink" folHlink="folHlink"/>
   <p:sldLayoutIdLst>
-    <p:sldLayoutId xmlns:r="http://schemas.openxmlformats.org/officeDocument/2006/relationships" id="2147483649" r:id="Rb81f76ba6d0c45dc"/>
+    <p:sldLayoutId xmlns:r="http://schemas.openxmlformats.org/officeDocument/2006/relationships" id="2147483649" r:id="R0454e1f6007a48e2"/>
   </p:sldLayoutIdLst>
   <p:txStyles>
     <p:titleStyle>
@@ -2466,7 +2466,7 @@
           <p:nvPr/>
         </p:nvPicPr>
         <p:blipFill>
-          <a:blip xmlns:r="http://schemas.openxmlformats.org/officeDocument/2006/relationships" xmlns:a="http://schemas.openxmlformats.org/drawingml/2006/main" r:embed="Rf9bce5dc0e5248a7"/>
+          <a:blip xmlns:r="http://schemas.openxmlformats.org/officeDocument/2006/relationships" xmlns:a="http://schemas.openxmlformats.org/drawingml/2006/main" r:embed="Rc3266413c03d4700"/>
           <a:stretch xmlns:a="http://schemas.openxmlformats.org/drawingml/2006/main"/>
         </p:blipFill>
         <p:spPr>
@@ -12019,7 +12019,7 @@
           <p:nvPr/>
         </p:nvPicPr>
         <p:blipFill>
-          <a:blip xmlns:r="http://schemas.openxmlformats.org/officeDocument/2006/relationships" xmlns:a="http://schemas.openxmlformats.org/drawingml/2006/main" r:embed="Re03cd830b97f4b44"/>
+          <a:blip xmlns:r="http://schemas.openxmlformats.org/officeDocument/2006/relationships" xmlns:a="http://schemas.openxmlformats.org/drawingml/2006/main" r:embed="Rceb58eff8a024b6f"/>
           <a:srcRect xmlns:a="http://schemas.openxmlformats.org/drawingml/2006/main" l="0" t="2671" r="0" b="2671"/>
           <a:stretch xmlns:a="http://schemas.openxmlformats.org/drawingml/2006/main">
             <a:fillRect l="0" t="0" r="0" b="0"/>
@@ -21783,7 +21783,7 @@
                 <a:ea typeface="Microsoft YaHei"/>
                 <a:cs typeface="Microsoft YaHei"/>
               </a:rPr>
-              <a:t>Agent 搭建与运行链路，已有可复现技术证据</a:t>
+              <a:t>技术尖峰已验证 Agent 核心链路，正式契约已通过验收</a:t>
             </a:r>
           </a:p>
         </p:txBody>
@@ -21840,7 +21840,7 @@
                 <a:ea typeface="Microsoft YaHei"/>
                 <a:cs typeface="Microsoft YaHei"/>
               </a:rPr>
-              <a:t>Windows Core 实证与正式契约共同支撑 Agent 产品地基。</a:t>
+              <a:t>积木编辑、稳定 IR、确定性运行、保存重开与项目协议均有可复查证据。</a:t>
             </a:r>
           </a:p>
         </p:txBody>
@@ -22491,7 +22491,7 @@
           <p:nvPr/>
         </p:nvPicPr>
         <p:blipFill>
-          <a:blip xmlns:r="http://schemas.openxmlformats.org/officeDocument/2006/relationships" xmlns:a="http://schemas.openxmlformats.org/drawingml/2006/main" r:embed="Ra2ff84686f5e4cfb"/>
+          <a:blip xmlns:r="http://schemas.openxmlformats.org/officeDocument/2006/relationships" xmlns:a="http://schemas.openxmlformats.org/drawingml/2006/main" r:embed="R38c2652f04874a18"/>
           <a:srcRect xmlns:a="http://schemas.openxmlformats.org/drawingml/2006/main" l="0" t="11290" r="0" b="11290"/>
           <a:stretch xmlns:a="http://schemas.openxmlformats.org/drawingml/2006/main">
             <a:fillRect l="0" t="0" r="0" b="0"/>

</xml_diff>

<commit_message>
docs: unify competition deck color semantics
</commit_message>
<xml_diff>
--- a/PPT与商业计划书/Blocky-Studio-息壤杯-AI+教育.pptx
+++ b/PPT与商业计划书/Blocky-Studio-息壤杯-AI+教育.pptx
@@ -2,26 +2,26 @@
 <file path=ppt/presentation.xml><?xml version="1.0" encoding="utf-8"?>
 <p:presentation xmlns:p="http://schemas.openxmlformats.org/presentationml/2006/main">
   <p:sldMasterIdLst>
-    <p:sldMasterId xmlns:r="http://schemas.openxmlformats.org/officeDocument/2006/relationships" id="2147483648" r:id="Rf5c2943efab44614"/>
+    <p:sldMasterId xmlns:r="http://schemas.openxmlformats.org/officeDocument/2006/relationships" id="2147483648" r:id="Rfb83be5a61954abe"/>
   </p:sldMasterIdLst>
   <p:notesMasterIdLst>
-    <p:notesMasterId xmlns:r="http://schemas.openxmlformats.org/officeDocument/2006/relationships" r:id="R39f2ddee2ec947a0"/>
+    <p:notesMasterId xmlns:r="http://schemas.openxmlformats.org/officeDocument/2006/relationships" r:id="R07aeb0b5096347b9"/>
   </p:notesMasterIdLst>
   <p:sldIdLst>
-    <p:sldId xmlns:r="http://schemas.openxmlformats.org/officeDocument/2006/relationships" id="256" r:id="Rdef87392c14942ab"/>
-    <p:sldId xmlns:r="http://schemas.openxmlformats.org/officeDocument/2006/relationships" id="257" r:id="R78daefe9dae7459d"/>
-    <p:sldId xmlns:r="http://schemas.openxmlformats.org/officeDocument/2006/relationships" id="258" r:id="Rc563b0a2706e41ac"/>
-    <p:sldId xmlns:r="http://schemas.openxmlformats.org/officeDocument/2006/relationships" id="259" r:id="Redcf181eb25f4b90"/>
-    <p:sldId xmlns:r="http://schemas.openxmlformats.org/officeDocument/2006/relationships" id="260" r:id="Rc184d3cc02d84bdb"/>
-    <p:sldId xmlns:r="http://schemas.openxmlformats.org/officeDocument/2006/relationships" id="261" r:id="Rd86ecc94cd574c34"/>
-    <p:sldId xmlns:r="http://schemas.openxmlformats.org/officeDocument/2006/relationships" id="262" r:id="R1608ab2412104a08"/>
-    <p:sldId xmlns:r="http://schemas.openxmlformats.org/officeDocument/2006/relationships" id="263" r:id="Re7b9ac2f050c4b1f"/>
-    <p:sldId xmlns:r="http://schemas.openxmlformats.org/officeDocument/2006/relationships" id="264" r:id="R366933d9c03144ef"/>
-    <p:sldId xmlns:r="http://schemas.openxmlformats.org/officeDocument/2006/relationships" id="265" r:id="R5be6cab9c0e342f3"/>
-    <p:sldId xmlns:r="http://schemas.openxmlformats.org/officeDocument/2006/relationships" id="266" r:id="R280f0bde912f442d"/>
-    <p:sldId xmlns:r="http://schemas.openxmlformats.org/officeDocument/2006/relationships" id="267" r:id="Rfad0094888804e16"/>
-    <p:sldId xmlns:r="http://schemas.openxmlformats.org/officeDocument/2006/relationships" id="268" r:id="R799a41f0d7d04ef6"/>
-    <p:sldId xmlns:r="http://schemas.openxmlformats.org/officeDocument/2006/relationships" id="269" r:id="R53d5b187eef64ed5"/>
+    <p:sldId xmlns:r="http://schemas.openxmlformats.org/officeDocument/2006/relationships" id="256" r:id="R6422210a39e74d02"/>
+    <p:sldId xmlns:r="http://schemas.openxmlformats.org/officeDocument/2006/relationships" id="257" r:id="R985e7e42ec9c487b"/>
+    <p:sldId xmlns:r="http://schemas.openxmlformats.org/officeDocument/2006/relationships" id="258" r:id="Rcce0dcc341704503"/>
+    <p:sldId xmlns:r="http://schemas.openxmlformats.org/officeDocument/2006/relationships" id="259" r:id="Red1ee4d8d37a42ee"/>
+    <p:sldId xmlns:r="http://schemas.openxmlformats.org/officeDocument/2006/relationships" id="260" r:id="R9b8251afa7ca4534"/>
+    <p:sldId xmlns:r="http://schemas.openxmlformats.org/officeDocument/2006/relationships" id="261" r:id="Re4043f610d394878"/>
+    <p:sldId xmlns:r="http://schemas.openxmlformats.org/officeDocument/2006/relationships" id="262" r:id="Rea19eb797a4d4b33"/>
+    <p:sldId xmlns:r="http://schemas.openxmlformats.org/officeDocument/2006/relationships" id="263" r:id="R11d003d4d28f495e"/>
+    <p:sldId xmlns:r="http://schemas.openxmlformats.org/officeDocument/2006/relationships" id="264" r:id="R00d64e32e8f44f7e"/>
+    <p:sldId xmlns:r="http://schemas.openxmlformats.org/officeDocument/2006/relationships" id="265" r:id="R4aa6cbe418614c87"/>
+    <p:sldId xmlns:r="http://schemas.openxmlformats.org/officeDocument/2006/relationships" id="266" r:id="Rfe83a8eb84b64235"/>
+    <p:sldId xmlns:r="http://schemas.openxmlformats.org/officeDocument/2006/relationships" id="267" r:id="R5b9084d612024889"/>
+    <p:sldId xmlns:r="http://schemas.openxmlformats.org/officeDocument/2006/relationships" id="268" r:id="R82c92a0cc8f946f0"/>
+    <p:sldId xmlns:r="http://schemas.openxmlformats.org/officeDocument/2006/relationships" id="269" r:id="R2eb39bdeb8894caa"/>
   </p:sldIdLst>
   <p:sldSz cx="12192000" cy="6858000"/>
   <p:notesSz cx="6858000" cy="9144000"/>
@@ -1818,7 +1818,7 @@
   </p:cSld>
   <p:clrMap bg1="lt1" tx1="dk1" bg2="lt2" tx2="dk2" accent1="accent1" accent2="accent2" accent3="accent3" accent4="accent4" accent5="accent5" accent6="accent6" hlink="hlink" folHlink="folHlink"/>
   <p:sldLayoutIdLst>
-    <p:sldLayoutId xmlns:r="http://schemas.openxmlformats.org/officeDocument/2006/relationships" id="2147483649" r:id="R0454e1f6007a48e2"/>
+    <p:sldLayoutId xmlns:r="http://schemas.openxmlformats.org/officeDocument/2006/relationships" id="2147483649" r:id="R3d9b2de8e1004473"/>
   </p:sldLayoutIdLst>
   <p:txStyles>
     <p:titleStyle>
@@ -2466,7 +2466,7 @@
           <p:nvPr/>
         </p:nvPicPr>
         <p:blipFill>
-          <a:blip xmlns:r="http://schemas.openxmlformats.org/officeDocument/2006/relationships" xmlns:a="http://schemas.openxmlformats.org/drawingml/2006/main" r:embed="Rc3266413c03d4700"/>
+          <a:blip xmlns:r="http://schemas.openxmlformats.org/officeDocument/2006/relationships" xmlns:a="http://schemas.openxmlformats.org/drawingml/2006/main" r:embed="R8641608e494f4c7b"/>
           <a:stretch xmlns:a="http://schemas.openxmlformats.org/drawingml/2006/main"/>
         </p:blipFill>
         <p:spPr>
@@ -3193,7 +3193,7 @@
             </a:avLst>
           </a:prstGeom>
           <a:solidFill xmlns:a="http://schemas.openxmlformats.org/drawingml/2006/main">
-            <a:srgbClr val="176BFF"/>
+            <a:srgbClr val="F4F7FB"/>
           </a:solidFill>
           <a:ln xmlns:a="http://schemas.openxmlformats.org/drawingml/2006/main" w="0">
             <a:noFill/>
@@ -3247,7 +3247,7 @@
             <a:r>
               <a:rPr sz="1200" b="1" i="0">
                 <a:solidFill>
-                  <a:srgbClr val="FFFFFF"/>
+                  <a:srgbClr val="176BFF"/>
                 </a:solidFill>
                 <a:latin typeface="Microsoft YaHei"/>
                 <a:ea typeface="Microsoft YaHei"/>
@@ -3304,7 +3304,7 @@
             <a:r>
               <a:rPr sz="2550" b="1" i="0">
                 <a:solidFill>
-                  <a:srgbClr val="FFFFFF"/>
+                  <a:srgbClr val="111827"/>
                 </a:solidFill>
                 <a:latin typeface="Microsoft YaHei"/>
                 <a:ea typeface="Microsoft YaHei"/>
@@ -3361,7 +3361,7 @@
             <a:r>
               <a:rPr sz="1500" b="0" i="0">
                 <a:solidFill>
-                  <a:srgbClr val="FFFFFF"/>
+                  <a:srgbClr val="667085"/>
                 </a:solidFill>
                 <a:latin typeface="Microsoft YaHei"/>
                 <a:ea typeface="Microsoft YaHei"/>
@@ -4009,7 +4009,7 @@
             </a:avLst>
           </a:prstGeom>
           <a:solidFill xmlns:a="http://schemas.openxmlformats.org/drawingml/2006/main">
-            <a:srgbClr val="FFF6D6"/>
+            <a:srgbClr val="EAF2FF"/>
           </a:solidFill>
           <a:ln xmlns:a="http://schemas.openxmlformats.org/drawingml/2006/main" w="0">
             <a:noFill/>
@@ -4063,7 +4063,7 @@
             <a:r>
               <a:rPr sz="1575" b="1" i="0">
                 <a:solidFill>
-                  <a:srgbClr val="F79009"/>
+                  <a:srgbClr val="176BFF"/>
                 </a:solidFill>
                 <a:latin typeface="Microsoft YaHei"/>
                 <a:ea typeface="Microsoft YaHei"/>
@@ -4387,7 +4387,7 @@
             </a:avLst>
           </a:prstGeom>
           <a:solidFill xmlns:a="http://schemas.openxmlformats.org/drawingml/2006/main">
-            <a:srgbClr val="EAF2FF"/>
+            <a:srgbClr val="F4F7FB"/>
           </a:solidFill>
           <a:ln xmlns:a="http://schemas.openxmlformats.org/drawingml/2006/main" w="0">
             <a:noFill/>
@@ -4672,7 +4672,7 @@
             </a:avLst>
           </a:prstGeom>
           <a:solidFill xmlns:a="http://schemas.openxmlformats.org/drawingml/2006/main">
-            <a:srgbClr val="FFF6D6"/>
+            <a:srgbClr val="F4F7FB"/>
           </a:solidFill>
           <a:ln xmlns:a="http://schemas.openxmlformats.org/drawingml/2006/main" w="0">
             <a:noFill/>
@@ -4726,7 +4726,7 @@
             <a:r>
               <a:rPr sz="1200" b="1" i="0">
                 <a:solidFill>
-                  <a:srgbClr val="F79009"/>
+                  <a:srgbClr val="176BFF"/>
                 </a:solidFill>
                 <a:latin typeface="Microsoft YaHei"/>
                 <a:ea typeface="Microsoft YaHei"/>
@@ -4840,7 +4840,7 @@
             <a:r>
               <a:rPr sz="1425" b="1" i="0">
                 <a:solidFill>
-                  <a:srgbClr val="F79009"/>
+                  <a:srgbClr val="176BFF"/>
                 </a:solidFill>
                 <a:latin typeface="Microsoft YaHei"/>
                 <a:ea typeface="Microsoft YaHei"/>
@@ -4957,7 +4957,7 @@
             </a:avLst>
           </a:prstGeom>
           <a:solidFill xmlns:a="http://schemas.openxmlformats.org/drawingml/2006/main">
-            <a:srgbClr val="E9F8F2"/>
+            <a:srgbClr val="F4F7FB"/>
           </a:solidFill>
           <a:ln xmlns:a="http://schemas.openxmlformats.org/drawingml/2006/main" w="0">
             <a:noFill/>
@@ -5011,7 +5011,7 @@
             <a:r>
               <a:rPr sz="1200" b="1" i="0">
                 <a:solidFill>
-                  <a:srgbClr val="17A673"/>
+                  <a:srgbClr val="176BFF"/>
                 </a:solidFill>
                 <a:latin typeface="Microsoft YaHei"/>
                 <a:ea typeface="Microsoft YaHei"/>
@@ -5125,7 +5125,7 @@
             <a:r>
               <a:rPr sz="1425" b="1" i="0">
                 <a:solidFill>
-                  <a:srgbClr val="17A673"/>
+                  <a:srgbClr val="176BFF"/>
                 </a:solidFill>
                 <a:latin typeface="Microsoft YaHei"/>
                 <a:ea typeface="Microsoft YaHei"/>
@@ -5853,7 +5853,7 @@
             <a:avLst/>
           </a:prstGeom>
           <a:solidFill xmlns:a="http://schemas.openxmlformats.org/drawingml/2006/main">
-            <a:srgbClr val="F79009"/>
+            <a:srgbClr val="176BFF"/>
           </a:solidFill>
           <a:ln xmlns:a="http://schemas.openxmlformats.org/drawingml/2006/main" w="0">
             <a:noFill/>
@@ -6088,7 +6088,7 @@
             <a:avLst/>
           </a:prstGeom>
           <a:solidFill xmlns:a="http://schemas.openxmlformats.org/drawingml/2006/main">
-            <a:srgbClr val="E5484D"/>
+            <a:srgbClr val="176BFF"/>
           </a:solidFill>
           <a:ln xmlns:a="http://schemas.openxmlformats.org/drawingml/2006/main" w="0">
             <a:noFill/>
@@ -6323,7 +6323,7 @@
             <a:avLst/>
           </a:prstGeom>
           <a:solidFill xmlns:a="http://schemas.openxmlformats.org/drawingml/2006/main">
-            <a:srgbClr val="17A673"/>
+            <a:srgbClr val="176BFF"/>
           </a:solidFill>
           <a:ln xmlns:a="http://schemas.openxmlformats.org/drawingml/2006/main" w="0">
             <a:noFill/>
@@ -6995,7 +6995,7 @@
             </a:avLst>
           </a:prstGeom>
           <a:solidFill xmlns:a="http://schemas.openxmlformats.org/drawingml/2006/main">
-            <a:srgbClr val="176BFF"/>
+            <a:srgbClr val="F4F7FB"/>
           </a:solidFill>
           <a:ln xmlns:a="http://schemas.openxmlformats.org/drawingml/2006/main" w="0">
             <a:noFill/>
@@ -7028,7 +7028,7 @@
             </a:avLst>
           </a:prstGeom>
           <a:solidFill xmlns:a="http://schemas.openxmlformats.org/drawingml/2006/main">
-            <a:srgbClr val="FFFFFF"/>
+            <a:srgbClr val="EAF2FF"/>
           </a:solidFill>
           <a:ln xmlns:a="http://schemas.openxmlformats.org/drawingml/2006/main" w="0">
             <a:noFill/>
@@ -7139,7 +7139,7 @@
             <a:r>
               <a:rPr sz="2100" b="1" i="0">
                 <a:solidFill>
-                  <a:srgbClr val="FFFFFF"/>
+                  <a:srgbClr val="111827"/>
                 </a:solidFill>
                 <a:latin typeface="Microsoft YaHei"/>
                 <a:ea typeface="Microsoft YaHei"/>
@@ -7196,31 +7196,31 @@
             <a:r>
               <a:rPr sz="1500" b="0" i="0">
                 <a:solidFill>
+                  <a:srgbClr val="667085"/>
+                </a:solidFill>
+                <a:latin typeface="Microsoft YaHei"/>
+                <a:ea typeface="Microsoft YaHei"/>
+                <a:cs typeface="Microsoft YaHei"/>
+              </a:rPr>
+              <a:t>完成 3 分钟 Agent 搭建</a:t>
+            </a:r>
+          </a:p>
+          <a:p xmlns:a="http://schemas.openxmlformats.org/drawingml/2006/main">
+            <a:pPr algn="l">
+              <a:buNone/>
+              <a:defRPr sz="1500" b="0" i="0">
+                <a:solidFill>
                   <a:srgbClr val="FFFFFF"/>
                 </a:solidFill>
                 <a:latin typeface="Microsoft YaHei"/>
                 <a:ea typeface="Microsoft YaHei"/>
                 <a:cs typeface="Microsoft YaHei"/>
-              </a:rPr>
-              <a:t>完成 3 分钟 Agent 搭建</a:t>
-            </a:r>
-          </a:p>
-          <a:p xmlns:a="http://schemas.openxmlformats.org/drawingml/2006/main">
-            <a:pPr algn="l">
-              <a:buNone/>
-              <a:defRPr sz="1500" b="0" i="0">
-                <a:solidFill>
-                  <a:srgbClr val="FFFFFF"/>
-                </a:solidFill>
-                <a:latin typeface="Microsoft YaHei"/>
-                <a:ea typeface="Microsoft YaHei"/>
-                <a:cs typeface="Microsoft YaHei"/>
               </a:defRPr>
             </a:pPr>
             <a:r>
               <a:rPr sz="1500" b="0" i="0">
                 <a:solidFill>
-                  <a:srgbClr val="FFFFFF"/>
+                  <a:srgbClr val="667085"/>
                 </a:solidFill>
                 <a:latin typeface="Microsoft YaHei"/>
                 <a:ea typeface="Microsoft YaHei"/>
@@ -7256,7 +7256,7 @@
             </a:avLst>
           </a:prstGeom>
           <a:solidFill xmlns:a="http://schemas.openxmlformats.org/drawingml/2006/main">
-            <a:srgbClr val="0D47B5"/>
+            <a:srgbClr val="FFFFFF"/>
           </a:solidFill>
           <a:ln xmlns:a="http://schemas.openxmlformats.org/drawingml/2006/main" w="0">
             <a:noFill/>
@@ -7310,7 +7310,7 @@
             <a:r>
               <a:rPr sz="1125" b="1" i="0">
                 <a:solidFill>
-                  <a:srgbClr val="FFFFFF"/>
+                  <a:srgbClr val="111827"/>
                 </a:solidFill>
                 <a:latin typeface="Microsoft YaHei"/>
                 <a:ea typeface="Microsoft YaHei"/>
@@ -8299,7 +8299,7 @@
     <p:bg>
       <p:bgPr>
         <a:solidFill xmlns:a="http://schemas.openxmlformats.org/drawingml/2006/main">
-          <a:srgbClr val="0B1220"/>
+          <a:srgbClr val="FFFFFF"/>
         </a:solidFill>
       </p:bgPr>
     </p:bg>
@@ -8358,7 +8358,7 @@
             <a:r>
               <a:rPr sz="1200" b="1" i="0">
                 <a:solidFill>
-                  <a:srgbClr val="FFD447"/>
+                  <a:srgbClr val="176BFF"/>
                 </a:solidFill>
                 <a:latin typeface="Microsoft YaHei"/>
                 <a:ea typeface="Microsoft YaHei"/>
@@ -8415,7 +8415,7 @@
             <a:r>
               <a:rPr sz="3600" b="1" i="0">
                 <a:solidFill>
-                  <a:srgbClr val="FFFFFF"/>
+                  <a:srgbClr val="111827"/>
                 </a:solidFill>
                 <a:latin typeface="Microsoft YaHei"/>
                 <a:ea typeface="Microsoft YaHei"/>
@@ -8472,7 +8472,7 @@
             <a:r>
               <a:rPr sz="3600" b="1" i="0">
                 <a:solidFill>
-                  <a:srgbClr val="FFD447"/>
+                  <a:srgbClr val="176BFF"/>
                 </a:solidFill>
                 <a:latin typeface="Microsoft YaHei"/>
                 <a:ea typeface="Microsoft YaHei"/>
@@ -8508,11 +8508,11 @@
             </a:avLst>
           </a:prstGeom>
           <a:solidFill xmlns:a="http://schemas.openxmlformats.org/drawingml/2006/main">
-            <a:srgbClr val="151F33"/>
+            <a:srgbClr val="F4F7FB"/>
           </a:solidFill>
           <a:ln xmlns:a="http://schemas.openxmlformats.org/drawingml/2006/main" w="9525">
             <a:solidFill>
-              <a:srgbClr val="263550"/>
+              <a:srgbClr val="DDE7F5"/>
             </a:solidFill>
             <a:prstDash val="solid"/>
           </a:ln>
@@ -8564,7 +8564,7 @@
             <a:r>
               <a:rPr sz="1425" b="1" i="0">
                 <a:solidFill>
-                  <a:srgbClr val="FFD447"/>
+                  <a:srgbClr val="176BFF"/>
                 </a:solidFill>
                 <a:latin typeface="Microsoft YaHei"/>
                 <a:ea typeface="Microsoft YaHei"/>
@@ -8623,7 +8623,7 @@
             <a:r>
               <a:rPr sz="1125" b="0" i="0">
                 <a:solidFill>
-                  <a:srgbClr val="FFFFFF"/>
+                  <a:srgbClr val="111827"/>
                 </a:solidFill>
                 <a:latin typeface="Microsoft YaHei"/>
                 <a:ea typeface="Microsoft YaHei"/>
@@ -8659,11 +8659,11 @@
             </a:avLst>
           </a:prstGeom>
           <a:solidFill xmlns:a="http://schemas.openxmlformats.org/drawingml/2006/main">
-            <a:srgbClr val="151F33"/>
+            <a:srgbClr val="F4F7FB"/>
           </a:solidFill>
           <a:ln xmlns:a="http://schemas.openxmlformats.org/drawingml/2006/main" w="9525">
             <a:solidFill>
-              <a:srgbClr val="263550"/>
+              <a:srgbClr val="DDE7F5"/>
             </a:solidFill>
             <a:prstDash val="solid"/>
           </a:ln>
@@ -8715,7 +8715,7 @@
             <a:r>
               <a:rPr sz="1425" b="1" i="0">
                 <a:solidFill>
-                  <a:srgbClr val="FFD447"/>
+                  <a:srgbClr val="176BFF"/>
                 </a:solidFill>
                 <a:latin typeface="Microsoft YaHei"/>
                 <a:ea typeface="Microsoft YaHei"/>
@@ -8772,7 +8772,7 @@
             <a:r>
               <a:rPr sz="1275" b="0" i="0">
                 <a:solidFill>
-                  <a:srgbClr val="FFFFFF"/>
+                  <a:srgbClr val="111827"/>
                 </a:solidFill>
                 <a:latin typeface="Microsoft YaHei"/>
                 <a:ea typeface="Microsoft YaHei"/>
@@ -8808,11 +8808,11 @@
             </a:avLst>
           </a:prstGeom>
           <a:solidFill xmlns:a="http://schemas.openxmlformats.org/drawingml/2006/main">
-            <a:srgbClr val="151F33"/>
+            <a:srgbClr val="F4F7FB"/>
           </a:solidFill>
           <a:ln xmlns:a="http://schemas.openxmlformats.org/drawingml/2006/main" w="9525">
             <a:solidFill>
-              <a:srgbClr val="263550"/>
+              <a:srgbClr val="DDE7F5"/>
             </a:solidFill>
             <a:prstDash val="solid"/>
           </a:ln>
@@ -8864,7 +8864,7 @@
             <a:r>
               <a:rPr sz="1425" b="1" i="0">
                 <a:solidFill>
-                  <a:srgbClr val="FFD447"/>
+                  <a:srgbClr val="176BFF"/>
                 </a:solidFill>
                 <a:latin typeface="Microsoft YaHei"/>
                 <a:ea typeface="Microsoft YaHei"/>
@@ -8921,7 +8921,7 @@
             <a:r>
               <a:rPr sz="1275" b="0" i="0">
                 <a:solidFill>
-                  <a:srgbClr val="FFFFFF"/>
+                  <a:srgbClr val="111827"/>
                 </a:solidFill>
                 <a:latin typeface="Microsoft YaHei"/>
                 <a:ea typeface="Microsoft YaHei"/>
@@ -8957,11 +8957,11 @@
             </a:avLst>
           </a:prstGeom>
           <a:solidFill xmlns:a="http://schemas.openxmlformats.org/drawingml/2006/main">
-            <a:srgbClr val="151F33"/>
+            <a:srgbClr val="F4F7FB"/>
           </a:solidFill>
           <a:ln xmlns:a="http://schemas.openxmlformats.org/drawingml/2006/main" w="9525">
             <a:solidFill>
-              <a:srgbClr val="263550"/>
+              <a:srgbClr val="DDE7F5"/>
             </a:solidFill>
             <a:prstDash val="solid"/>
           </a:ln>
@@ -9013,7 +9013,7 @@
             <a:r>
               <a:rPr sz="1425" b="1" i="0">
                 <a:solidFill>
-                  <a:srgbClr val="FFD447"/>
+                  <a:srgbClr val="176BFF"/>
                 </a:solidFill>
                 <a:latin typeface="Microsoft YaHei"/>
                 <a:ea typeface="Microsoft YaHei"/>
@@ -9070,7 +9070,7 @@
             <a:r>
               <a:rPr sz="1275" b="0" i="0">
                 <a:solidFill>
-                  <a:srgbClr val="FFFFFF"/>
+                  <a:srgbClr val="111827"/>
                 </a:solidFill>
                 <a:latin typeface="Microsoft YaHei"/>
                 <a:ea typeface="Microsoft YaHei"/>
@@ -9106,11 +9106,11 @@
             </a:avLst>
           </a:prstGeom>
           <a:solidFill xmlns:a="http://schemas.openxmlformats.org/drawingml/2006/main">
-            <a:srgbClr val="151F33"/>
+            <a:srgbClr val="F4F7FB"/>
           </a:solidFill>
           <a:ln xmlns:a="http://schemas.openxmlformats.org/drawingml/2006/main" w="9525">
             <a:solidFill>
-              <a:srgbClr val="263550"/>
+              <a:srgbClr val="DDE7F5"/>
             </a:solidFill>
             <a:prstDash val="solid"/>
           </a:ln>
@@ -9162,7 +9162,7 @@
             <a:r>
               <a:rPr sz="1425" b="1" i="0">
                 <a:solidFill>
-                  <a:srgbClr val="FFD447"/>
+                  <a:srgbClr val="176BFF"/>
                 </a:solidFill>
                 <a:latin typeface="Microsoft YaHei"/>
                 <a:ea typeface="Microsoft YaHei"/>
@@ -9221,7 +9221,7 @@
             <a:r>
               <a:rPr sz="1275" b="0" i="0">
                 <a:solidFill>
-                  <a:srgbClr val="FFFFFF"/>
+                  <a:srgbClr val="111827"/>
                 </a:solidFill>
                 <a:latin typeface="Microsoft YaHei"/>
                 <a:ea typeface="Microsoft YaHei"/>
@@ -9604,7 +9604,7 @@
             </a:avLst>
           </a:prstGeom>
           <a:solidFill xmlns:a="http://schemas.openxmlformats.org/drawingml/2006/main">
-            <a:srgbClr val="EAF2FF"/>
+            <a:srgbClr val="F4F7FB"/>
           </a:solidFill>
           <a:ln xmlns:a="http://schemas.openxmlformats.org/drawingml/2006/main" w="0">
             <a:noFill/>
@@ -9841,7 +9841,7 @@
             </a:avLst>
           </a:prstGeom>
           <a:solidFill xmlns:a="http://schemas.openxmlformats.org/drawingml/2006/main">
-            <a:srgbClr val="FFF6D6"/>
+            <a:srgbClr val="F4F7FB"/>
           </a:solidFill>
           <a:ln xmlns:a="http://schemas.openxmlformats.org/drawingml/2006/main" w="0">
             <a:noFill/>
@@ -9928,7 +9928,7 @@
             <a:r>
               <a:rPr sz="1050" b="1" i="0">
                 <a:solidFill>
-                  <a:srgbClr val="F79009"/>
+                  <a:srgbClr val="176BFF"/>
                 </a:solidFill>
                 <a:latin typeface="Microsoft YaHei"/>
                 <a:ea typeface="Microsoft YaHei"/>
@@ -10126,7 +10126,7 @@
             </a:avLst>
           </a:prstGeom>
           <a:solidFill xmlns:a="http://schemas.openxmlformats.org/drawingml/2006/main">
-            <a:srgbClr val="E9F8F2"/>
+            <a:srgbClr val="F4F7FB"/>
           </a:solidFill>
           <a:ln xmlns:a="http://schemas.openxmlformats.org/drawingml/2006/main" w="0">
             <a:noFill/>
@@ -10213,7 +10213,7 @@
             <a:r>
               <a:rPr sz="1050" b="1" i="0">
                 <a:solidFill>
-                  <a:srgbClr val="17A673"/>
+                  <a:srgbClr val="176BFF"/>
                 </a:solidFill>
                 <a:latin typeface="Microsoft YaHei"/>
                 <a:ea typeface="Microsoft YaHei"/>
@@ -10888,7 +10888,7 @@
             </a:avLst>
           </a:prstGeom>
           <a:solidFill xmlns:a="http://schemas.openxmlformats.org/drawingml/2006/main">
-            <a:srgbClr val="176BFF"/>
+            <a:srgbClr val="F4F7FB"/>
           </a:solidFill>
           <a:ln xmlns:a="http://schemas.openxmlformats.org/drawingml/2006/main" w="0">
             <a:noFill/>
@@ -10942,7 +10942,7 @@
             <a:r>
               <a:rPr sz="2700" b="1" i="0">
                 <a:solidFill>
-                  <a:srgbClr val="FFFFFF"/>
+                  <a:srgbClr val="111827"/>
                 </a:solidFill>
                 <a:latin typeface="Microsoft YaHei"/>
                 <a:ea typeface="Microsoft YaHei"/>
@@ -10999,7 +10999,7 @@
             <a:r>
               <a:rPr sz="1275" b="0" i="0">
                 <a:solidFill>
-                  <a:srgbClr val="FFFFFF"/>
+                  <a:srgbClr val="667085"/>
                 </a:solidFill>
                 <a:latin typeface="Microsoft YaHei"/>
                 <a:ea typeface="Microsoft YaHei"/>
@@ -11239,7 +11239,7 @@
             </a:avLst>
           </a:prstGeom>
           <a:solidFill xmlns:a="http://schemas.openxmlformats.org/drawingml/2006/main">
-            <a:srgbClr val="EAF2FF"/>
+            <a:srgbClr val="F4F7FB"/>
           </a:solidFill>
           <a:ln xmlns:a="http://schemas.openxmlformats.org/drawingml/2006/main" w="0">
             <a:noFill/>
@@ -11458,7 +11458,7 @@
             </a:avLst>
           </a:prstGeom>
           <a:solidFill xmlns:a="http://schemas.openxmlformats.org/drawingml/2006/main">
-            <a:srgbClr val="FFF6D6"/>
+            <a:srgbClr val="F4F7FB"/>
           </a:solidFill>
           <a:ln xmlns:a="http://schemas.openxmlformats.org/drawingml/2006/main" w="0">
             <a:noFill/>
@@ -11512,7 +11512,7 @@
             <a:r>
               <a:rPr sz="1950" b="1" i="0">
                 <a:solidFill>
-                  <a:srgbClr val="F79009"/>
+                  <a:srgbClr val="176BFF"/>
                 </a:solidFill>
                 <a:latin typeface="Microsoft YaHei"/>
                 <a:ea typeface="Microsoft YaHei"/>
@@ -12019,7 +12019,7 @@
           <p:nvPr/>
         </p:nvPicPr>
         <p:blipFill>
-          <a:blip xmlns:r="http://schemas.openxmlformats.org/officeDocument/2006/relationships" xmlns:a="http://schemas.openxmlformats.org/drawingml/2006/main" r:embed="Rceb58eff8a024b6f"/>
+          <a:blip xmlns:r="http://schemas.openxmlformats.org/officeDocument/2006/relationships" xmlns:a="http://schemas.openxmlformats.org/drawingml/2006/main" r:embed="R514fec8e6e244f16"/>
           <a:srcRect xmlns:a="http://schemas.openxmlformats.org/drawingml/2006/main" l="0" t="2671" r="0" b="2671"/>
           <a:stretch xmlns:a="http://schemas.openxmlformats.org/drawingml/2006/main">
             <a:fillRect l="0" t="0" r="0" b="0"/>
@@ -12751,7 +12751,7 @@
             </a:avLst>
           </a:prstGeom>
           <a:solidFill xmlns:a="http://schemas.openxmlformats.org/drawingml/2006/main">
-            <a:srgbClr val="176BFF"/>
+            <a:srgbClr val="F4F7FB"/>
           </a:solidFill>
           <a:ln xmlns:a="http://schemas.openxmlformats.org/drawingml/2006/main" w="0">
             <a:noFill/>
@@ -12805,7 +12805,7 @@
             <a:r>
               <a:rPr sz="1350" b="1" i="0">
                 <a:solidFill>
-                  <a:srgbClr val="FFFFFF"/>
+                  <a:srgbClr val="111827"/>
                 </a:solidFill>
                 <a:latin typeface="Microsoft YaHei"/>
                 <a:ea typeface="Microsoft YaHei"/>
@@ -12841,7 +12841,7 @@
             </a:avLst>
           </a:prstGeom>
           <a:solidFill xmlns:a="http://schemas.openxmlformats.org/drawingml/2006/main">
-            <a:srgbClr val="FFF6D6"/>
+            <a:srgbClr val="EAF2FF"/>
           </a:solidFill>
           <a:ln xmlns:a="http://schemas.openxmlformats.org/drawingml/2006/main" w="0">
             <a:noFill/>
@@ -13557,7 +13557,7 @@
             <a:avLst/>
           </a:prstGeom>
           <a:solidFill xmlns:a="http://schemas.openxmlformats.org/drawingml/2006/main">
-            <a:srgbClr val="F79009"/>
+            <a:srgbClr val="176BFF"/>
           </a:solidFill>
           <a:ln xmlns:a="http://schemas.openxmlformats.org/drawingml/2006/main" w="0">
             <a:noFill/>
@@ -13783,7 +13783,7 @@
             <a:avLst/>
           </a:prstGeom>
           <a:solidFill xmlns:a="http://schemas.openxmlformats.org/drawingml/2006/main">
-            <a:srgbClr val="17A673"/>
+            <a:srgbClr val="176BFF"/>
           </a:solidFill>
           <a:ln xmlns:a="http://schemas.openxmlformats.org/drawingml/2006/main" w="0">
             <a:noFill/>
@@ -14009,7 +14009,7 @@
             <a:avLst/>
           </a:prstGeom>
           <a:solidFill xmlns:a="http://schemas.openxmlformats.org/drawingml/2006/main">
-            <a:srgbClr val="E5484D"/>
+            <a:srgbClr val="176BFF"/>
           </a:solidFill>
           <a:ln xmlns:a="http://schemas.openxmlformats.org/drawingml/2006/main" w="0">
             <a:noFill/>
@@ -15204,7 +15204,7 @@
             </a:avLst>
           </a:prstGeom>
           <a:solidFill xmlns:a="http://schemas.openxmlformats.org/drawingml/2006/main">
-            <a:srgbClr val="176BFF"/>
+            <a:srgbClr val="F4F7FB"/>
           </a:solidFill>
           <a:ln xmlns:a="http://schemas.openxmlformats.org/drawingml/2006/main" w="0">
             <a:noFill/>
@@ -15258,7 +15258,7 @@
             <a:r>
               <a:rPr sz="1125" b="1" i="0">
                 <a:solidFill>
-                  <a:srgbClr val="FFFFFF"/>
+                  <a:srgbClr val="176BFF"/>
                 </a:solidFill>
                 <a:latin typeface="Microsoft YaHei"/>
                 <a:ea typeface="Microsoft YaHei"/>
@@ -15315,7 +15315,7 @@
             <a:r>
               <a:rPr sz="1650" b="1" i="0">
                 <a:solidFill>
-                  <a:srgbClr val="FFFFFF"/>
+                  <a:srgbClr val="111827"/>
                 </a:solidFill>
                 <a:latin typeface="Microsoft YaHei"/>
                 <a:ea typeface="Microsoft YaHei"/>
@@ -15372,7 +15372,7 @@
             <a:r>
               <a:rPr sz="1200" b="0" i="0">
                 <a:solidFill>
-                  <a:srgbClr val="FFFFFF"/>
+                  <a:srgbClr val="667085"/>
                 </a:solidFill>
                 <a:latin typeface="Microsoft YaHei"/>
                 <a:ea typeface="Microsoft YaHei"/>
@@ -16527,7 +16527,7 @@
             </a:avLst>
           </a:prstGeom>
           <a:solidFill xmlns:a="http://schemas.openxmlformats.org/drawingml/2006/main">
-            <a:srgbClr val="FFF0F0"/>
+            <a:srgbClr val="EAF2FF"/>
           </a:solidFill>
           <a:ln xmlns:a="http://schemas.openxmlformats.org/drawingml/2006/main" w="0">
             <a:noFill/>
@@ -16581,7 +16581,7 @@
             <a:r>
               <a:rPr sz="1050" b="1" i="0">
                 <a:solidFill>
-                  <a:srgbClr val="E5484D"/>
+                  <a:srgbClr val="176BFF"/>
                 </a:solidFill>
                 <a:latin typeface="Microsoft YaHei"/>
                 <a:ea typeface="Microsoft YaHei"/>
@@ -17318,7 +17318,7 @@
             </a:avLst>
           </a:prstGeom>
           <a:solidFill xmlns:a="http://schemas.openxmlformats.org/drawingml/2006/main">
-            <a:srgbClr val="176BFF"/>
+            <a:srgbClr val="F4F7FB"/>
           </a:solidFill>
           <a:ln xmlns:a="http://schemas.openxmlformats.org/drawingml/2006/main" w="0">
             <a:noFill/>
@@ -17372,31 +17372,31 @@
             <a:r>
               <a:rPr sz="1725" b="1" i="0">
                 <a:solidFill>
+                  <a:srgbClr val="111827"/>
+                </a:solidFill>
+                <a:latin typeface="Microsoft YaHei"/>
+                <a:ea typeface="Microsoft YaHei"/>
+                <a:cs typeface="Microsoft YaHei"/>
+              </a:rPr>
+              <a:t>可见 Agent</a:t>
+            </a:r>
+          </a:p>
+          <a:p xmlns:a="http://schemas.openxmlformats.org/drawingml/2006/main">
+            <a:pPr algn="ctr">
+              <a:buNone/>
+              <a:defRPr sz="1725" b="1" i="0">
+                <a:solidFill>
                   <a:srgbClr val="FFFFFF"/>
                 </a:solidFill>
                 <a:latin typeface="Microsoft YaHei"/>
                 <a:ea typeface="Microsoft YaHei"/>
                 <a:cs typeface="Microsoft YaHei"/>
-              </a:rPr>
-              <a:t>可见 Agent</a:t>
-            </a:r>
-          </a:p>
-          <a:p xmlns:a="http://schemas.openxmlformats.org/drawingml/2006/main">
-            <a:pPr algn="ctr">
-              <a:buNone/>
-              <a:defRPr sz="1725" b="1" i="0">
-                <a:solidFill>
-                  <a:srgbClr val="FFFFFF"/>
-                </a:solidFill>
-                <a:latin typeface="Microsoft YaHei"/>
-                <a:ea typeface="Microsoft YaHei"/>
-                <a:cs typeface="Microsoft YaHei"/>
               </a:defRPr>
             </a:pPr>
             <a:r>
               <a:rPr sz="1725" b="1" i="0">
                 <a:solidFill>
-                  <a:srgbClr val="FFFFFF"/>
+                  <a:srgbClr val="111827"/>
                 </a:solidFill>
                 <a:latin typeface="Microsoft YaHei"/>
                 <a:ea typeface="Microsoft YaHei"/>
@@ -17453,7 +17453,7 @@
             <a:r>
               <a:rPr sz="1275" b="0" i="0">
                 <a:solidFill>
-                  <a:srgbClr val="FFFFFF"/>
+                  <a:srgbClr val="667085"/>
                 </a:solidFill>
                 <a:latin typeface="Microsoft YaHei"/>
                 <a:ea typeface="Microsoft YaHei"/>
@@ -17783,7 +17783,7 @@
             </a:avLst>
           </a:prstGeom>
           <a:solidFill xmlns:a="http://schemas.openxmlformats.org/drawingml/2006/main">
-            <a:srgbClr val="176BFF"/>
+            <a:srgbClr val="F4F7FB"/>
           </a:solidFill>
           <a:ln xmlns:a="http://schemas.openxmlformats.org/drawingml/2006/main" w="0">
             <a:noFill/>
@@ -17837,7 +17837,7 @@
             <a:r>
               <a:rPr sz="1725" b="1" i="0">
                 <a:solidFill>
-                  <a:srgbClr val="FFFFFF"/>
+                  <a:srgbClr val="111827"/>
                 </a:solidFill>
                 <a:latin typeface="Microsoft YaHei"/>
                 <a:ea typeface="Microsoft YaHei"/>
@@ -17894,7 +17894,7 @@
             <a:r>
               <a:rPr sz="1275" b="0" i="0">
                 <a:solidFill>
-                  <a:srgbClr val="FFFFFF"/>
+                  <a:srgbClr val="667085"/>
                 </a:solidFill>
                 <a:latin typeface="Microsoft YaHei"/>
                 <a:ea typeface="Microsoft YaHei"/>
@@ -18081,7 +18081,7 @@
             </a:avLst>
           </a:prstGeom>
           <a:solidFill xmlns:a="http://schemas.openxmlformats.org/drawingml/2006/main">
-            <a:srgbClr val="FFF6D6"/>
+            <a:srgbClr val="EAF2FF"/>
           </a:solidFill>
           <a:ln xmlns:a="http://schemas.openxmlformats.org/drawingml/2006/main" w="0">
             <a:noFill/>
@@ -18137,7 +18137,7 @@
             <a:r>
               <a:rPr sz="1875" b="1" i="0">
                 <a:solidFill>
-                  <a:srgbClr val="FF8A00"/>
+                  <a:srgbClr val="176BFF"/>
                 </a:solidFill>
                 <a:latin typeface="Microsoft YaHei"/>
                 <a:ea typeface="Microsoft YaHei"/>
@@ -19788,7 +19788,7 @@
             <a:avLst/>
           </a:prstGeom>
           <a:solidFill xmlns:a="http://schemas.openxmlformats.org/drawingml/2006/main">
-            <a:srgbClr val="00A875"/>
+            <a:srgbClr val="176BFF"/>
           </a:solidFill>
           <a:ln xmlns:a="http://schemas.openxmlformats.org/drawingml/2006/main" w="0">
             <a:noFill/>
@@ -20664,7 +20664,7 @@
             <a:avLst/>
           </a:prstGeom>
           <a:solidFill xmlns:a="http://schemas.openxmlformats.org/drawingml/2006/main">
-            <a:srgbClr val="EAF2FF"/>
+            <a:srgbClr val="FFFFFF"/>
           </a:solidFill>
           <a:ln xmlns:a="http://schemas.openxmlformats.org/drawingml/2006/main" w="0">
             <a:noFill/>
@@ -20695,7 +20695,7 @@
             <a:avLst/>
           </a:prstGeom>
           <a:solidFill xmlns:a="http://schemas.openxmlformats.org/drawingml/2006/main">
-            <a:srgbClr val="EAF2FF"/>
+            <a:srgbClr val="FFFFFF"/>
           </a:solidFill>
           <a:ln xmlns:a="http://schemas.openxmlformats.org/drawingml/2006/main" w="0">
             <a:noFill/>
@@ -20726,7 +20726,7 @@
             <a:avLst/>
           </a:prstGeom>
           <a:solidFill xmlns:a="http://schemas.openxmlformats.org/drawingml/2006/main">
-            <a:srgbClr val="EAF2FF"/>
+            <a:srgbClr val="FFFFFF"/>
           </a:solidFill>
           <a:ln xmlns:a="http://schemas.openxmlformats.org/drawingml/2006/main" w="0">
             <a:noFill/>
@@ -20790,7 +20790,7 @@
             <a:avLst/>
           </a:prstGeom>
           <a:solidFill xmlns:a="http://schemas.openxmlformats.org/drawingml/2006/main">
-            <a:srgbClr val="00A875"/>
+            <a:srgbClr val="176BFF"/>
           </a:solidFill>
           <a:ln xmlns:a="http://schemas.openxmlformats.org/drawingml/2006/main" w="0">
             <a:noFill/>
@@ -20998,7 +20998,7 @@
             <a:avLst/>
           </a:prstGeom>
           <a:solidFill xmlns:a="http://schemas.openxmlformats.org/drawingml/2006/main">
-            <a:srgbClr val="EAF2FF"/>
+            <a:srgbClr val="FFFFFF"/>
           </a:solidFill>
           <a:ln xmlns:a="http://schemas.openxmlformats.org/drawingml/2006/main" w="0">
             <a:noFill/>
@@ -21029,7 +21029,7 @@
             <a:avLst/>
           </a:prstGeom>
           <a:solidFill xmlns:a="http://schemas.openxmlformats.org/drawingml/2006/main">
-            <a:srgbClr val="EAF2FF"/>
+            <a:srgbClr val="FFFFFF"/>
           </a:solidFill>
           <a:ln xmlns:a="http://schemas.openxmlformats.org/drawingml/2006/main" w="0">
             <a:noFill/>
@@ -21060,7 +21060,7 @@
             <a:avLst/>
           </a:prstGeom>
           <a:solidFill xmlns:a="http://schemas.openxmlformats.org/drawingml/2006/main">
-            <a:srgbClr val="EAF2FF"/>
+            <a:srgbClr val="FFFFFF"/>
           </a:solidFill>
           <a:ln xmlns:a="http://schemas.openxmlformats.org/drawingml/2006/main" w="0">
             <a:noFill/>
@@ -21124,7 +21124,7 @@
             <a:avLst/>
           </a:prstGeom>
           <a:solidFill xmlns:a="http://schemas.openxmlformats.org/drawingml/2006/main">
-            <a:srgbClr val="00A875"/>
+            <a:srgbClr val="176BFF"/>
           </a:solidFill>
           <a:ln xmlns:a="http://schemas.openxmlformats.org/drawingml/2006/main" w="0">
             <a:noFill/>
@@ -21332,7 +21332,7 @@
             <a:avLst/>
           </a:prstGeom>
           <a:solidFill xmlns:a="http://schemas.openxmlformats.org/drawingml/2006/main">
-            <a:srgbClr val="EAF2FF"/>
+            <a:srgbClr val="FFFFFF"/>
           </a:solidFill>
           <a:ln xmlns:a="http://schemas.openxmlformats.org/drawingml/2006/main" w="0">
             <a:noFill/>
@@ -21363,7 +21363,7 @@
             <a:avLst/>
           </a:prstGeom>
           <a:solidFill xmlns:a="http://schemas.openxmlformats.org/drawingml/2006/main">
-            <a:srgbClr val="EAF2FF"/>
+            <a:srgbClr val="FFFFFF"/>
           </a:solidFill>
           <a:ln xmlns:a="http://schemas.openxmlformats.org/drawingml/2006/main" w="0">
             <a:noFill/>
@@ -21394,7 +21394,7 @@
             <a:avLst/>
           </a:prstGeom>
           <a:solidFill xmlns:a="http://schemas.openxmlformats.org/drawingml/2006/main">
-            <a:srgbClr val="EAF2FF"/>
+            <a:srgbClr val="FFFFFF"/>
           </a:solidFill>
           <a:ln xmlns:a="http://schemas.openxmlformats.org/drawingml/2006/main" w="0">
             <a:noFill/>
@@ -21870,7 +21870,7 @@
             </a:avLst>
           </a:prstGeom>
           <a:solidFill xmlns:a="http://schemas.openxmlformats.org/drawingml/2006/main">
-            <a:srgbClr val="E9F8F2"/>
+            <a:srgbClr val="F4F7FB"/>
           </a:solidFill>
           <a:ln xmlns:a="http://schemas.openxmlformats.org/drawingml/2006/main" w="0">
             <a:noFill/>
@@ -22203,7 +22203,7 @@
             </a:avLst>
           </a:prstGeom>
           <a:solidFill xmlns:a="http://schemas.openxmlformats.org/drawingml/2006/main">
-            <a:srgbClr val="FFF0F0"/>
+            <a:srgbClr val="F4F7FB"/>
           </a:solidFill>
           <a:ln xmlns:a="http://schemas.openxmlformats.org/drawingml/2006/main" w="0">
             <a:noFill/>
@@ -22292,7 +22292,7 @@
             <a:r>
               <a:rPr sz="1050" b="1" i="0">
                 <a:solidFill>
-                  <a:srgbClr val="EF4444"/>
+                  <a:srgbClr val="176BFF"/>
                 </a:solidFill>
                 <a:latin typeface="Microsoft YaHei"/>
                 <a:ea typeface="Microsoft YaHei"/>
@@ -22491,7 +22491,7 @@
           <p:nvPr/>
         </p:nvPicPr>
         <p:blipFill>
-          <a:blip xmlns:r="http://schemas.openxmlformats.org/officeDocument/2006/relationships" xmlns:a="http://schemas.openxmlformats.org/drawingml/2006/main" r:embed="R38c2652f04874a18"/>
+          <a:blip xmlns:r="http://schemas.openxmlformats.org/officeDocument/2006/relationships" xmlns:a="http://schemas.openxmlformats.org/drawingml/2006/main" r:embed="R36aef438b1154455"/>
           <a:srcRect xmlns:a="http://schemas.openxmlformats.org/drawingml/2006/main" l="0" t="11290" r="0" b="11290"/>
           <a:stretch xmlns:a="http://schemas.openxmlformats.org/drawingml/2006/main">
             <a:fillRect l="0" t="0" r="0" b="0"/>

</xml_diff>